<commit_message>
Added e-value and PyMOL composite score terms to slides.
</commit_message>
<xml_diff>
--- a/reports/2026-08-28_projectUpdate_3/2026-08-28_projectUpdate_3_jmoran.pptx
+++ b/reports/2026-08-28_projectUpdate_3/2026-08-28_projectUpdate_3_jmoran.pptx
@@ -5,7 +5,7 @@
     <p:sldMasterId id="2147483648" r:id="rId1"/>
   </p:sldMasterIdLst>
   <p:notesMasterIdLst>
-    <p:notesMasterId r:id="rId8"/>
+    <p:notesMasterId r:id="rId9"/>
   </p:notesMasterIdLst>
   <p:sldIdLst>
     <p:sldId id="256" r:id="rId2"/>
@@ -13,7 +13,8 @@
     <p:sldId id="269" r:id="rId4"/>
     <p:sldId id="257" r:id="rId5"/>
     <p:sldId id="286" r:id="rId6"/>
-    <p:sldId id="284" r:id="rId7"/>
+    <p:sldId id="287" r:id="rId7"/>
+    <p:sldId id="284" r:id="rId8"/>
   </p:sldIdLst>
   <p:sldSz cx="12192000" cy="6858000"/>
   <p:notesSz cx="6858000" cy="9144000"/>
@@ -583,6 +584,135 @@
         <p:cNvPr id="1" name="">
           <a:extLst>
             <a:ext uri="{FF2B5EF4-FFF2-40B4-BE49-F238E27FC236}">
+              <a16:creationId xmlns:a16="http://schemas.microsoft.com/office/drawing/2014/main" id="{83655F3F-76AB-0354-CA7C-9628886BA5F6}"/>
+            </a:ext>
+          </a:extLst>
+        </p:cNvPr>
+        <p:cNvGrpSpPr/>
+        <p:nvPr/>
+      </p:nvGrpSpPr>
+      <p:grpSpPr>
+        <a:xfrm>
+          <a:off x="0" y="0"/>
+          <a:ext cx="0" cy="0"/>
+          <a:chOff x="0" y="0"/>
+          <a:chExt cx="0" cy="0"/>
+        </a:xfrm>
+      </p:grpSpPr>
+      <p:sp>
+        <p:nvSpPr>
+          <p:cNvPr id="2" name="Slide Image Placeholder 1">
+            <a:extLst>
+              <a:ext uri="{FF2B5EF4-FFF2-40B4-BE49-F238E27FC236}">
+                <a16:creationId xmlns:a16="http://schemas.microsoft.com/office/drawing/2014/main" id="{D948F906-9532-7048-34CE-BD7EACCCF796}"/>
+              </a:ext>
+            </a:extLst>
+          </p:cNvPr>
+          <p:cNvSpPr>
+            <a:spLocks noGrp="1" noRot="1" noChangeAspect="1"/>
+          </p:cNvSpPr>
+          <p:nvPr>
+            <p:ph type="sldImg"/>
+          </p:nvPr>
+        </p:nvSpPr>
+        <p:spPr/>
+        <p:txBody>
+          <a:bodyPr/>
+          <a:lstStyle/>
+          <a:p>
+            <a:endParaRPr lang="en-CA"/>
+          </a:p>
+        </p:txBody>
+      </p:sp>
+      <p:sp>
+        <p:nvSpPr>
+          <p:cNvPr id="3" name="Notes Placeholder 2">
+            <a:extLst>
+              <a:ext uri="{FF2B5EF4-FFF2-40B4-BE49-F238E27FC236}">
+                <a16:creationId xmlns:a16="http://schemas.microsoft.com/office/drawing/2014/main" id="{23BA2E69-9B93-34F9-362D-13C70A163FE3}"/>
+              </a:ext>
+            </a:extLst>
+          </p:cNvPr>
+          <p:cNvSpPr>
+            <a:spLocks noGrp="1"/>
+          </p:cNvSpPr>
+          <p:nvPr>
+            <p:ph type="body" idx="1"/>
+          </p:nvPr>
+        </p:nvSpPr>
+        <p:spPr/>
+        <p:txBody>
+          <a:bodyPr/>
+          <a:lstStyle/>
+          <a:p>
+            <a:r>
+              <a:rPr lang="en-US" dirty="0"/>
+              <a:t>Gene list is for C Marshall</a:t>
+            </a:r>
+          </a:p>
+          <a:p>
+            <a:r>
+              <a:rPr lang="en-US" dirty="0"/>
+              <a:t>Used for improving diagnostic yield</a:t>
+            </a:r>
+            <a:r>
+              <a:rPr lang="en-CA" dirty="0"/>
+              <a:t> for pre-existing </a:t>
+            </a:r>
+            <a:endParaRPr lang="en-US" dirty="0"/>
+          </a:p>
+        </p:txBody>
+      </p:sp>
+      <p:sp>
+        <p:nvSpPr>
+          <p:cNvPr id="4" name="Slide Number Placeholder 3">
+            <a:extLst>
+              <a:ext uri="{FF2B5EF4-FFF2-40B4-BE49-F238E27FC236}">
+                <a16:creationId xmlns:a16="http://schemas.microsoft.com/office/drawing/2014/main" id="{11ECE342-7832-5A30-0C3E-5879D380B5CC}"/>
+              </a:ext>
+            </a:extLst>
+          </p:cNvPr>
+          <p:cNvSpPr>
+            <a:spLocks noGrp="1"/>
+          </p:cNvSpPr>
+          <p:nvPr>
+            <p:ph type="sldNum" sz="quarter" idx="5"/>
+          </p:nvPr>
+        </p:nvSpPr>
+        <p:spPr/>
+        <p:txBody>
+          <a:bodyPr/>
+          <a:lstStyle/>
+          <a:p>
+            <a:fld id="{2E88BC55-598C-4AA3-BC46-22AAD297F918}" type="slidenum">
+              <a:rPr lang="en-CA" smtClean="0"/>
+              <a:t>6</a:t>
+            </a:fld>
+            <a:endParaRPr lang="en-CA"/>
+          </a:p>
+        </p:txBody>
+      </p:sp>
+    </p:spTree>
+    <p:extLst>
+      <p:ext uri="{BB962C8B-B14F-4D97-AF65-F5344CB8AC3E}">
+        <p14:creationId xmlns:p14="http://schemas.microsoft.com/office/powerpoint/2010/main" val="3844472671"/>
+      </p:ext>
+    </p:extLst>
+  </p:cSld>
+  <p:clrMapOvr>
+    <a:masterClrMapping/>
+  </p:clrMapOvr>
+</p:notes>
+</file>
+
+<file path=ppt/notesSlides/notesSlide3.xml><?xml version="1.0" encoding="utf-8"?>
+<p:notes xmlns:a="http://schemas.openxmlformats.org/drawingml/2006/main" xmlns:r="http://schemas.openxmlformats.org/officeDocument/2006/relationships" xmlns:p="http://schemas.openxmlformats.org/presentationml/2006/main">
+  <p:cSld>
+    <p:spTree>
+      <p:nvGrpSpPr>
+        <p:cNvPr id="1" name="">
+          <a:extLst>
+            <a:ext uri="{FF2B5EF4-FFF2-40B4-BE49-F238E27FC236}">
               <a16:creationId xmlns:a16="http://schemas.microsoft.com/office/drawing/2014/main" id="{A48FBD46-A852-83BD-0DE7-6BBA1991F663}"/>
             </a:ext>
           </a:extLst>
@@ -685,7 +815,7 @@
           <a:p>
             <a:fld id="{2E88BC55-598C-4AA3-BC46-22AAD297F918}" type="slidenum">
               <a:rPr lang="en-CA" smtClean="0"/>
-              <a:t>6</a:t>
+              <a:t>7</a:t>
             </a:fld>
             <a:endParaRPr lang="en-CA"/>
           </a:p>
@@ -4841,7 +4971,7 @@
               <a:rPr lang="en-US" dirty="0">
                 <a:latin typeface="Georgia Pro" panose="02040502050405020303" pitchFamily="18" charset="0"/>
               </a:rPr>
-              <a:t>Get gene list</a:t>
+              <a:t>Yield gene list</a:t>
             </a:r>
           </a:p>
           <a:p>
@@ -5861,25 +5991,7 @@
                 </a:solidFill>
                 <a:latin typeface="Georgia Pro" panose="02040502050405020303" pitchFamily="18" charset="0"/>
               </a:rPr>
-              <a:t>PyMOL-super and </a:t>
-            </a:r>
-            <a:r>
-              <a:rPr lang="en-US" sz="2600" b="1" dirty="0" err="1">
-                <a:solidFill>
-                  <a:schemeClr val="bg1"/>
-                </a:solidFill>
-                <a:latin typeface="Georgia Pro" panose="02040502050405020303" pitchFamily="18" charset="0"/>
-              </a:rPr>
-              <a:t>FoldSeek</a:t>
-            </a:r>
-            <a:r>
-              <a:rPr lang="en-US" sz="2600" b="1" dirty="0">
-                <a:solidFill>
-                  <a:schemeClr val="bg1"/>
-                </a:solidFill>
-                <a:latin typeface="Georgia Pro" panose="02040502050405020303" pitchFamily="18" charset="0"/>
-              </a:rPr>
-              <a:t> e-values</a:t>
+              <a:t>PyMOL-super and FoldSeek e-values</a:t>
             </a:r>
             <a:endParaRPr lang="en-CA" sz="2600" b="1" dirty="0">
               <a:solidFill>
@@ -6648,7 +6760,7 @@
         </p:nvSpPr>
         <p:spPr>
           <a:xfrm>
-            <a:off x="1072904" y="2312101"/>
+            <a:off x="7042384" y="4503211"/>
             <a:ext cx="4154878" cy="492443"/>
           </a:xfrm>
           <a:prstGeom prst="rect">
@@ -6662,6 +6774,7 @@
           </a:bodyPr>
           <a:lstStyle/>
           <a:p>
+            <a:pPr algn="r"/>
             <a:r>
               <a:rPr lang="en-US" sz="2600" b="1" dirty="0">
                 <a:solidFill>
@@ -6688,6 +6801,1651 @@
 </file>
 
 <file path=ppt/slides/slide6.xml><?xml version="1.0" encoding="utf-8"?>
+<p:sld xmlns:a="http://schemas.openxmlformats.org/drawingml/2006/main" xmlns:r="http://schemas.openxmlformats.org/officeDocument/2006/relationships" xmlns:p="http://schemas.openxmlformats.org/presentationml/2006/main">
+  <p:cSld>
+    <p:spTree>
+      <p:nvGrpSpPr>
+        <p:cNvPr id="1" name="">
+          <a:extLst>
+            <a:ext uri="{FF2B5EF4-FFF2-40B4-BE49-F238E27FC236}">
+              <a16:creationId xmlns:a16="http://schemas.microsoft.com/office/drawing/2014/main" id="{E506A85D-26CD-069B-AAFD-6258D37F9D12}"/>
+            </a:ext>
+          </a:extLst>
+        </p:cNvPr>
+        <p:cNvGrpSpPr/>
+        <p:nvPr/>
+      </p:nvGrpSpPr>
+      <p:grpSpPr>
+        <a:xfrm>
+          <a:off x="0" y="0"/>
+          <a:ext cx="0" cy="0"/>
+          <a:chOff x="0" y="0"/>
+          <a:chExt cx="0" cy="0"/>
+        </a:xfrm>
+      </p:grpSpPr>
+      <p:sp>
+        <p:nvSpPr>
+          <p:cNvPr id="7" name="Slide Number Placeholder 6">
+            <a:extLst>
+              <a:ext uri="{FF2B5EF4-FFF2-40B4-BE49-F238E27FC236}">
+                <a16:creationId xmlns:a16="http://schemas.microsoft.com/office/drawing/2014/main" id="{E48024B9-E03B-B5B3-A003-A8B6B8A052E9}"/>
+              </a:ext>
+            </a:extLst>
+          </p:cNvPr>
+          <p:cNvSpPr>
+            <a:spLocks noGrp="1"/>
+          </p:cNvSpPr>
+          <p:nvPr>
+            <p:ph type="sldNum" sz="quarter" idx="12"/>
+          </p:nvPr>
+        </p:nvSpPr>
+        <p:spPr/>
+        <p:txBody>
+          <a:bodyPr/>
+          <a:lstStyle/>
+          <a:p>
+            <a:fld id="{3899FC77-40C7-4C49-9A19-86BDE9B75E8A}" type="slidenum">
+              <a:rPr lang="en-CA" smtClean="0"/>
+              <a:pPr/>
+              <a:t>6</a:t>
+            </a:fld>
+            <a:endParaRPr lang="en-CA" sz="1400"/>
+          </a:p>
+        </p:txBody>
+      </p:sp>
+      <p:sp>
+        <p:nvSpPr>
+          <p:cNvPr id="3" name="Rectangle: Rounded Corners 2">
+            <a:extLst>
+              <a:ext uri="{FF2B5EF4-FFF2-40B4-BE49-F238E27FC236}">
+                <a16:creationId xmlns:a16="http://schemas.microsoft.com/office/drawing/2014/main" id="{D8210B37-EC49-7B10-214E-1549DEFEB3C3}"/>
+              </a:ext>
+            </a:extLst>
+          </p:cNvPr>
+          <p:cNvSpPr/>
+          <p:nvPr/>
+        </p:nvSpPr>
+        <p:spPr>
+          <a:xfrm>
+            <a:off x="315257" y="267370"/>
+            <a:ext cx="9363581" cy="628742"/>
+          </a:xfrm>
+          <a:prstGeom prst="roundRect">
+            <a:avLst/>
+          </a:prstGeom>
+          <a:solidFill>
+            <a:srgbClr val="0162B3"/>
+          </a:solidFill>
+          <a:ln>
+            <a:solidFill>
+              <a:srgbClr val="0162B3"/>
+            </a:solidFill>
+          </a:ln>
+        </p:spPr>
+        <p:style>
+          <a:lnRef idx="2">
+            <a:schemeClr val="accent1">
+              <a:shade val="50000"/>
+            </a:schemeClr>
+          </a:lnRef>
+          <a:fillRef idx="1">
+            <a:schemeClr val="accent1"/>
+          </a:fillRef>
+          <a:effectRef idx="0">
+            <a:schemeClr val="accent1"/>
+          </a:effectRef>
+          <a:fontRef idx="minor">
+            <a:schemeClr val="lt1"/>
+          </a:fontRef>
+        </p:style>
+        <p:txBody>
+          <a:bodyPr rtlCol="0" anchor="ctr"/>
+          <a:lstStyle>
+            <a:defPPr>
+              <a:defRPr lang="en-US"/>
+            </a:defPPr>
+            <a:lvl1pPr marL="0" algn="l" defTabSz="914400" rtl="0" eaLnBrk="1" latinLnBrk="0" hangingPunct="1">
+              <a:defRPr sz="1800" kern="1200">
+                <a:solidFill>
+                  <a:schemeClr val="lt1"/>
+                </a:solidFill>
+                <a:latin typeface="+mn-lt"/>
+                <a:ea typeface="+mn-ea"/>
+                <a:cs typeface="+mn-cs"/>
+              </a:defRPr>
+            </a:lvl1pPr>
+            <a:lvl2pPr marL="457200" algn="l" defTabSz="914400" rtl="0" eaLnBrk="1" latinLnBrk="0" hangingPunct="1">
+              <a:defRPr sz="1800" kern="1200">
+                <a:solidFill>
+                  <a:schemeClr val="lt1"/>
+                </a:solidFill>
+                <a:latin typeface="+mn-lt"/>
+                <a:ea typeface="+mn-ea"/>
+                <a:cs typeface="+mn-cs"/>
+              </a:defRPr>
+            </a:lvl2pPr>
+            <a:lvl3pPr marL="914400" algn="l" defTabSz="914400" rtl="0" eaLnBrk="1" latinLnBrk="0" hangingPunct="1">
+              <a:defRPr sz="1800" kern="1200">
+                <a:solidFill>
+                  <a:schemeClr val="lt1"/>
+                </a:solidFill>
+                <a:latin typeface="+mn-lt"/>
+                <a:ea typeface="+mn-ea"/>
+                <a:cs typeface="+mn-cs"/>
+              </a:defRPr>
+            </a:lvl3pPr>
+            <a:lvl4pPr marL="1371600" algn="l" defTabSz="914400" rtl="0" eaLnBrk="1" latinLnBrk="0" hangingPunct="1">
+              <a:defRPr sz="1800" kern="1200">
+                <a:solidFill>
+                  <a:schemeClr val="lt1"/>
+                </a:solidFill>
+                <a:latin typeface="+mn-lt"/>
+                <a:ea typeface="+mn-ea"/>
+                <a:cs typeface="+mn-cs"/>
+              </a:defRPr>
+            </a:lvl4pPr>
+            <a:lvl5pPr marL="1828800" algn="l" defTabSz="914400" rtl="0" eaLnBrk="1" latinLnBrk="0" hangingPunct="1">
+              <a:defRPr sz="1800" kern="1200">
+                <a:solidFill>
+                  <a:schemeClr val="lt1"/>
+                </a:solidFill>
+                <a:latin typeface="+mn-lt"/>
+                <a:ea typeface="+mn-ea"/>
+                <a:cs typeface="+mn-cs"/>
+              </a:defRPr>
+            </a:lvl5pPr>
+            <a:lvl6pPr marL="2286000" algn="l" defTabSz="914400" rtl="0" eaLnBrk="1" latinLnBrk="0" hangingPunct="1">
+              <a:defRPr sz="1800" kern="1200">
+                <a:solidFill>
+                  <a:schemeClr val="lt1"/>
+                </a:solidFill>
+                <a:latin typeface="+mn-lt"/>
+                <a:ea typeface="+mn-ea"/>
+                <a:cs typeface="+mn-cs"/>
+              </a:defRPr>
+            </a:lvl6pPr>
+            <a:lvl7pPr marL="2743200" algn="l" defTabSz="914400" rtl="0" eaLnBrk="1" latinLnBrk="0" hangingPunct="1">
+              <a:defRPr sz="1800" kern="1200">
+                <a:solidFill>
+                  <a:schemeClr val="lt1"/>
+                </a:solidFill>
+                <a:latin typeface="+mn-lt"/>
+                <a:ea typeface="+mn-ea"/>
+                <a:cs typeface="+mn-cs"/>
+              </a:defRPr>
+            </a:lvl7pPr>
+            <a:lvl8pPr marL="3200400" algn="l" defTabSz="914400" rtl="0" eaLnBrk="1" latinLnBrk="0" hangingPunct="1">
+              <a:defRPr sz="1800" kern="1200">
+                <a:solidFill>
+                  <a:schemeClr val="lt1"/>
+                </a:solidFill>
+                <a:latin typeface="+mn-lt"/>
+                <a:ea typeface="+mn-ea"/>
+                <a:cs typeface="+mn-cs"/>
+              </a:defRPr>
+            </a:lvl8pPr>
+            <a:lvl9pPr marL="3657600" algn="l" defTabSz="914400" rtl="0" eaLnBrk="1" latinLnBrk="0" hangingPunct="1">
+              <a:defRPr sz="1800" kern="1200">
+                <a:solidFill>
+                  <a:schemeClr val="lt1"/>
+                </a:solidFill>
+                <a:latin typeface="+mn-lt"/>
+                <a:ea typeface="+mn-ea"/>
+                <a:cs typeface="+mn-cs"/>
+              </a:defRPr>
+            </a:lvl9pPr>
+          </a:lstStyle>
+          <a:p>
+            <a:pPr algn="ctr"/>
+            <a:endParaRPr lang="en-CA"/>
+          </a:p>
+        </p:txBody>
+      </p:sp>
+      <p:sp>
+        <p:nvSpPr>
+          <p:cNvPr id="5" name="TextBox 4">
+            <a:extLst>
+              <a:ext uri="{FF2B5EF4-FFF2-40B4-BE49-F238E27FC236}">
+                <a16:creationId xmlns:a16="http://schemas.microsoft.com/office/drawing/2014/main" id="{318DA659-010C-17FB-BE6D-EBC2AE29CF9A}"/>
+              </a:ext>
+            </a:extLst>
+          </p:cNvPr>
+          <p:cNvSpPr txBox="1"/>
+          <p:nvPr/>
+        </p:nvSpPr>
+        <p:spPr>
+          <a:xfrm>
+            <a:off x="527959" y="335519"/>
+            <a:ext cx="8710932" cy="492443"/>
+          </a:xfrm>
+          <a:prstGeom prst="rect">
+            <a:avLst/>
+          </a:prstGeom>
+          <a:noFill/>
+        </p:spPr>
+        <p:txBody>
+          <a:bodyPr wrap="square" rtlCol="0">
+            <a:spAutoFit/>
+          </a:bodyPr>
+          <a:lstStyle/>
+          <a:p>
+            <a:r>
+              <a:rPr lang="en-US" sz="2600" b="1" dirty="0">
+                <a:solidFill>
+                  <a:schemeClr val="bg1"/>
+                </a:solidFill>
+                <a:latin typeface="Georgia Pro" panose="02040502050405020303" pitchFamily="18" charset="0"/>
+              </a:rPr>
+              <a:t>Composite score: FoldSeek e-value term</a:t>
+            </a:r>
+            <a:endParaRPr lang="en-CA" sz="2600" b="1" dirty="0">
+              <a:solidFill>
+                <a:schemeClr val="bg1"/>
+              </a:solidFill>
+              <a:latin typeface="Georgia Pro" panose="02040502050405020303" pitchFamily="18" charset="0"/>
+            </a:endParaRPr>
+          </a:p>
+        </p:txBody>
+      </p:sp>
+      <mc:AlternateContent xmlns:mc="http://schemas.openxmlformats.org/markup-compatibility/2006">
+        <mc:Choice xmlns:a14="http://schemas.microsoft.com/office/drawing/2010/main" Requires="a14">
+          <p:graphicFrame>
+            <p:nvGraphicFramePr>
+              <p:cNvPr id="6" name="Table 5">
+                <a:extLst>
+                  <a:ext uri="{FF2B5EF4-FFF2-40B4-BE49-F238E27FC236}">
+                    <a16:creationId xmlns:a16="http://schemas.microsoft.com/office/drawing/2014/main" id="{BDB10604-1415-D8DC-3E0A-FB7A8B02A17C}"/>
+                  </a:ext>
+                </a:extLst>
+              </p:cNvPr>
+              <p:cNvGraphicFramePr>
+                <a:graphicFrameLocks noGrp="1"/>
+              </p:cNvGraphicFramePr>
+              <p:nvPr>
+                <p:extLst>
+                  <p:ext uri="{D42A27DB-BD31-4B8C-83A1-F6EECF244321}">
+                    <p14:modId xmlns:p14="http://schemas.microsoft.com/office/powerpoint/2010/main" val="4236945891"/>
+                  </p:ext>
+                </p:extLst>
+              </p:nvPr>
+            </p:nvGraphicFramePr>
+            <p:xfrm>
+              <a:off x="1190445" y="1261081"/>
+              <a:ext cx="2960626" cy="1828800"/>
+            </p:xfrm>
+            <a:graphic>
+              <a:graphicData uri="http://schemas.openxmlformats.org/drawingml/2006/table">
+                <a:tbl>
+                  <a:tblPr firstRow="1" bandRow="1">
+                    <a:tableStyleId>{5940675A-B579-460E-94D1-54222C63F5DA}</a:tableStyleId>
+                  </a:tblPr>
+                  <a:tblGrid>
+                    <a:gridCol w="1480313">
+                      <a:extLst>
+                        <a:ext uri="{9D8B030D-6E8A-4147-A177-3AD203B41FA5}">
+                          <a16:colId xmlns:a16="http://schemas.microsoft.com/office/drawing/2014/main" val="1869778181"/>
+                        </a:ext>
+                      </a:extLst>
+                    </a:gridCol>
+                    <a:gridCol w="1480313">
+                      <a:extLst>
+                        <a:ext uri="{9D8B030D-6E8A-4147-A177-3AD203B41FA5}">
+                          <a16:colId xmlns:a16="http://schemas.microsoft.com/office/drawing/2014/main" val="2700513838"/>
+                        </a:ext>
+                      </a:extLst>
+                    </a:gridCol>
+                  </a:tblGrid>
+                  <a:tr h="180542">
+                    <a:tc>
+                      <a:txBody>
+                        <a:bodyPr/>
+                        <a:lstStyle/>
+                        <a:p>
+                          <a:pPr/>
+                          <a14:m>
+                            <m:oMathPara xmlns:m="http://schemas.openxmlformats.org/officeDocument/2006/math">
+                              <m:oMath>
+                                <m:r>
+                                  <a:rPr lang="en-US" sz="1400" b="0" i="1" smtClean="0">
+                                    <a:latin typeface="Cambria Math" panose="02040503050406030204" pitchFamily="18" charset="0"/>
+                                  </a:rPr>
+                                  <m:t>−</m:t>
+                                </m:r>
+                                <m:func>
+                                  <m:funcPr>
+                                    <m:ctrlPr>
+                                      <a:rPr lang="en-US" sz="1400" b="0" i="1" smtClean="0">
+                                        <a:latin typeface="Cambria Math" panose="02040503050406030204" pitchFamily="18" charset="0"/>
+                                      </a:rPr>
+                                    </m:ctrlPr>
+                                  </m:funcPr>
+                                  <m:fName>
+                                    <m:sSub>
+                                      <m:sSubPr>
+                                        <m:ctrlPr>
+                                          <a:rPr lang="en-US" sz="1400" b="0" i="0" smtClean="0">
+                                            <a:latin typeface="Cambria Math" panose="02040503050406030204" pitchFamily="18" charset="0"/>
+                                          </a:rPr>
+                                        </m:ctrlPr>
+                                      </m:sSubPr>
+                                      <m:e>
+                                        <m:r>
+                                          <m:rPr>
+                                            <m:sty m:val="p"/>
+                                          </m:rPr>
+                                          <a:rPr lang="en-US" sz="1400" b="0" i="0" smtClean="0">
+                                            <a:latin typeface="Cambria Math" panose="02040503050406030204" pitchFamily="18" charset="0"/>
+                                          </a:rPr>
+                                          <m:t>log</m:t>
+                                        </m:r>
+                                      </m:e>
+                                      <m:sub>
+                                        <m:r>
+                                          <a:rPr lang="en-US" sz="1400" b="0" i="1" smtClean="0">
+                                            <a:latin typeface="Cambria Math" panose="02040503050406030204" pitchFamily="18" charset="0"/>
+                                          </a:rPr>
+                                          <m:t>10</m:t>
+                                        </m:r>
+                                      </m:sub>
+                                    </m:sSub>
+                                  </m:fName>
+                                  <m:e>
+                                    <m:d>
+                                      <m:dPr>
+                                        <m:ctrlPr>
+                                          <a:rPr lang="en-US" sz="1400" b="0" i="1" smtClean="0">
+                                            <a:latin typeface="Cambria Math" panose="02040503050406030204" pitchFamily="18" charset="0"/>
+                                          </a:rPr>
+                                        </m:ctrlPr>
+                                      </m:dPr>
+                                      <m:e>
+                                        <m:r>
+                                          <a:rPr lang="en-US" sz="1400" b="0" i="1" smtClean="0">
+                                            <a:latin typeface="Cambria Math" panose="02040503050406030204" pitchFamily="18" charset="0"/>
+                                          </a:rPr>
+                                          <m:t>𝑒</m:t>
+                                        </m:r>
+                                        <m:r>
+                                          <a:rPr lang="en-US" sz="1400" b="0" i="1" smtClean="0">
+                                            <a:latin typeface="Cambria Math" panose="02040503050406030204" pitchFamily="18" charset="0"/>
+                                          </a:rPr>
+                                          <m:t>_</m:t>
+                                        </m:r>
+                                        <m:r>
+                                          <a:rPr lang="en-US" sz="1400" b="0" i="1" smtClean="0">
+                                            <a:latin typeface="Cambria Math" panose="02040503050406030204" pitchFamily="18" charset="0"/>
+                                          </a:rPr>
+                                          <m:t>𝑣𝑎𝑙𝑢𝑒</m:t>
+                                        </m:r>
+                                      </m:e>
+                                    </m:d>
+                                  </m:e>
+                                </m:func>
+                              </m:oMath>
+                            </m:oMathPara>
+                          </a14:m>
+                          <a:endParaRPr lang="en-CA" sz="1400" dirty="0">
+                            <a:latin typeface="Verdana Pro" panose="020B0604030504040204" pitchFamily="34" charset="0"/>
+                          </a:endParaRPr>
+                        </a:p>
+                      </a:txBody>
+                      <a:tcPr marL="45720" marR="45720"/>
+                    </a:tc>
+                    <a:tc>
+                      <a:txBody>
+                        <a:bodyPr/>
+                        <a:lstStyle/>
+                        <a:p>
+                          <a:pPr algn="ctr"/>
+                          <a:r>
+                            <a:rPr lang="en-US" sz="1400" dirty="0">
+                              <a:latin typeface="Verdana Pro" panose="020B0604030504040204" pitchFamily="34" charset="0"/>
+                            </a:rPr>
+                            <a:t>Score</a:t>
+                          </a:r>
+                          <a:endParaRPr lang="en-CA" sz="1400" dirty="0">
+                            <a:latin typeface="Verdana Pro" panose="020B0604030504040204" pitchFamily="34" charset="0"/>
+                          </a:endParaRPr>
+                        </a:p>
+                      </a:txBody>
+                      <a:tcPr marL="45720" marR="45720"/>
+                    </a:tc>
+                    <a:extLst>
+                      <a:ext uri="{0D108BD9-81ED-4DB2-BD59-A6C34878D82A}">
+                        <a16:rowId xmlns:a16="http://schemas.microsoft.com/office/drawing/2014/main" val="2202861222"/>
+                      </a:ext>
+                    </a:extLst>
+                  </a:tr>
+                  <a:tr h="180542">
+                    <a:tc>
+                      <a:txBody>
+                        <a:bodyPr/>
+                        <a:lstStyle/>
+                        <a:p>
+                          <a:r>
+                            <a:rPr lang="en-US" sz="1400" dirty="0">
+                              <a:latin typeface="Verdana Pro" panose="020B0604030504040204" pitchFamily="34" charset="0"/>
+                            </a:rPr>
+                            <a:t>0.0</a:t>
+                          </a:r>
+                          <a:endParaRPr lang="en-CA" sz="1400" dirty="0">
+                            <a:latin typeface="Verdana Pro" panose="020B0604030504040204" pitchFamily="34" charset="0"/>
+                          </a:endParaRPr>
+                        </a:p>
+                      </a:txBody>
+                      <a:tcPr marL="45720" marR="45720"/>
+                    </a:tc>
+                    <a:tc>
+                      <a:txBody>
+                        <a:bodyPr/>
+                        <a:lstStyle/>
+                        <a:p>
+                          <a:r>
+                            <a:rPr lang="en-US" sz="1400" dirty="0">
+                              <a:latin typeface="Verdana Pro" panose="020B0604030504040204" pitchFamily="34" charset="0"/>
+                            </a:rPr>
+                            <a:t>0.00</a:t>
+                          </a:r>
+                          <a:endParaRPr lang="en-CA" sz="1400" dirty="0">
+                            <a:latin typeface="Verdana Pro" panose="020B0604030504040204" pitchFamily="34" charset="0"/>
+                          </a:endParaRPr>
+                        </a:p>
+                      </a:txBody>
+                      <a:tcPr marL="45720" marR="45720"/>
+                    </a:tc>
+                    <a:extLst>
+                      <a:ext uri="{0D108BD9-81ED-4DB2-BD59-A6C34878D82A}">
+                        <a16:rowId xmlns:a16="http://schemas.microsoft.com/office/drawing/2014/main" val="4031372816"/>
+                      </a:ext>
+                    </a:extLst>
+                  </a:tr>
+                  <a:tr h="180542">
+                    <a:tc>
+                      <a:txBody>
+                        <a:bodyPr/>
+                        <a:lstStyle/>
+                        <a:p>
+                          <a:r>
+                            <a:rPr lang="en-US" sz="1400" dirty="0">
+                              <a:latin typeface="Verdana Pro" panose="020B0604030504040204" pitchFamily="34" charset="0"/>
+                            </a:rPr>
+                            <a:t>0.4</a:t>
+                          </a:r>
+                          <a:endParaRPr lang="en-CA" sz="1400" dirty="0">
+                            <a:latin typeface="Verdana Pro" panose="020B0604030504040204" pitchFamily="34" charset="0"/>
+                          </a:endParaRPr>
+                        </a:p>
+                      </a:txBody>
+                      <a:tcPr marL="45720" marR="45720"/>
+                    </a:tc>
+                    <a:tc>
+                      <a:txBody>
+                        <a:bodyPr/>
+                        <a:lstStyle/>
+                        <a:p>
+                          <a:r>
+                            <a:rPr lang="en-US" sz="1400" dirty="0">
+                              <a:latin typeface="Verdana Pro" panose="020B0604030504040204" pitchFamily="34" charset="0"/>
+                            </a:rPr>
+                            <a:t>0.10</a:t>
+                          </a:r>
+                          <a:endParaRPr lang="en-CA" sz="1400" dirty="0">
+                            <a:latin typeface="Verdana Pro" panose="020B0604030504040204" pitchFamily="34" charset="0"/>
+                          </a:endParaRPr>
+                        </a:p>
+                      </a:txBody>
+                      <a:tcPr marL="45720" marR="45720"/>
+                    </a:tc>
+                    <a:extLst>
+                      <a:ext uri="{0D108BD9-81ED-4DB2-BD59-A6C34878D82A}">
+                        <a16:rowId xmlns:a16="http://schemas.microsoft.com/office/drawing/2014/main" val="3424690894"/>
+                      </a:ext>
+                    </a:extLst>
+                  </a:tr>
+                  <a:tr h="180542">
+                    <a:tc>
+                      <a:txBody>
+                        <a:bodyPr/>
+                        <a:lstStyle/>
+                        <a:p>
+                          <a:r>
+                            <a:rPr lang="en-US" sz="1400" dirty="0">
+                              <a:latin typeface="Verdana Pro" panose="020B0604030504040204" pitchFamily="34" charset="0"/>
+                            </a:rPr>
+                            <a:t>6.0</a:t>
+                          </a:r>
+                          <a:endParaRPr lang="en-CA" sz="1400" dirty="0">
+                            <a:latin typeface="Verdana Pro" panose="020B0604030504040204" pitchFamily="34" charset="0"/>
+                          </a:endParaRPr>
+                        </a:p>
+                      </a:txBody>
+                      <a:tcPr marL="45720" marR="45720"/>
+                    </a:tc>
+                    <a:tc>
+                      <a:txBody>
+                        <a:bodyPr/>
+                        <a:lstStyle/>
+                        <a:p>
+                          <a:r>
+                            <a:rPr lang="en-US" sz="1400" dirty="0">
+                              <a:latin typeface="Verdana Pro" panose="020B0604030504040204" pitchFamily="34" charset="0"/>
+                            </a:rPr>
+                            <a:t>0.70</a:t>
+                          </a:r>
+                          <a:endParaRPr lang="en-CA" sz="1400" dirty="0">
+                            <a:latin typeface="Verdana Pro" panose="020B0604030504040204" pitchFamily="34" charset="0"/>
+                          </a:endParaRPr>
+                        </a:p>
+                      </a:txBody>
+                      <a:tcPr marL="45720" marR="45720"/>
+                    </a:tc>
+                    <a:extLst>
+                      <a:ext uri="{0D108BD9-81ED-4DB2-BD59-A6C34878D82A}">
+                        <a16:rowId xmlns:a16="http://schemas.microsoft.com/office/drawing/2014/main" val="3156004181"/>
+                      </a:ext>
+                    </a:extLst>
+                  </a:tr>
+                  <a:tr h="180542">
+                    <a:tc>
+                      <a:txBody>
+                        <a:bodyPr/>
+                        <a:lstStyle/>
+                        <a:p>
+                          <a:r>
+                            <a:rPr lang="en-US" sz="1400" dirty="0">
+                              <a:latin typeface="Verdana Pro" panose="020B0604030504040204" pitchFamily="34" charset="0"/>
+                            </a:rPr>
+                            <a:t>10.0</a:t>
+                          </a:r>
+                          <a:endParaRPr lang="en-CA" sz="1400" dirty="0">
+                            <a:latin typeface="Verdana Pro" panose="020B0604030504040204" pitchFamily="34" charset="0"/>
+                          </a:endParaRPr>
+                        </a:p>
+                      </a:txBody>
+                      <a:tcPr marL="45720" marR="45720"/>
+                    </a:tc>
+                    <a:tc>
+                      <a:txBody>
+                        <a:bodyPr/>
+                        <a:lstStyle/>
+                        <a:p>
+                          <a:r>
+                            <a:rPr lang="en-US" sz="1400" dirty="0">
+                              <a:latin typeface="Verdana Pro" panose="020B0604030504040204" pitchFamily="34" charset="0"/>
+                            </a:rPr>
+                            <a:t>0.90</a:t>
+                          </a:r>
+                          <a:endParaRPr lang="en-CA" sz="1400" dirty="0">
+                            <a:latin typeface="Verdana Pro" panose="020B0604030504040204" pitchFamily="34" charset="0"/>
+                          </a:endParaRPr>
+                        </a:p>
+                      </a:txBody>
+                      <a:tcPr marL="45720" marR="45720"/>
+                    </a:tc>
+                    <a:extLst>
+                      <a:ext uri="{0D108BD9-81ED-4DB2-BD59-A6C34878D82A}">
+                        <a16:rowId xmlns:a16="http://schemas.microsoft.com/office/drawing/2014/main" val="1804626572"/>
+                      </a:ext>
+                    </a:extLst>
+                  </a:tr>
+                  <a:tr h="180542">
+                    <a:tc>
+                      <a:txBody>
+                        <a:bodyPr/>
+                        <a:lstStyle/>
+                        <a:p>
+                          <a:r>
+                            <a:rPr lang="en-US" sz="1400" dirty="0">
+                              <a:latin typeface="Verdana Pro" panose="020B0604030504040204" pitchFamily="34" charset="0"/>
+                            </a:rPr>
+                            <a:t>15.0</a:t>
+                          </a:r>
+                          <a:endParaRPr lang="en-CA" sz="1400" dirty="0">
+                            <a:latin typeface="Verdana Pro" panose="020B0604030504040204" pitchFamily="34" charset="0"/>
+                          </a:endParaRPr>
+                        </a:p>
+                      </a:txBody>
+                      <a:tcPr marL="45720" marR="45720"/>
+                    </a:tc>
+                    <a:tc>
+                      <a:txBody>
+                        <a:bodyPr/>
+                        <a:lstStyle/>
+                        <a:p>
+                          <a:r>
+                            <a:rPr lang="en-US" sz="1400" dirty="0">
+                              <a:latin typeface="Verdana Pro" panose="020B0604030504040204" pitchFamily="34" charset="0"/>
+                            </a:rPr>
+                            <a:t>0.99</a:t>
+                          </a:r>
+                          <a:endParaRPr lang="en-CA" sz="1400" dirty="0">
+                            <a:latin typeface="Verdana Pro" panose="020B0604030504040204" pitchFamily="34" charset="0"/>
+                          </a:endParaRPr>
+                        </a:p>
+                      </a:txBody>
+                      <a:tcPr marL="45720" marR="45720"/>
+                    </a:tc>
+                    <a:extLst>
+                      <a:ext uri="{0D108BD9-81ED-4DB2-BD59-A6C34878D82A}">
+                        <a16:rowId xmlns:a16="http://schemas.microsoft.com/office/drawing/2014/main" val="1030796854"/>
+                      </a:ext>
+                    </a:extLst>
+                  </a:tr>
+                </a:tbl>
+              </a:graphicData>
+            </a:graphic>
+          </p:graphicFrame>
+        </mc:Choice>
+        <mc:Fallback>
+          <p:graphicFrame>
+            <p:nvGraphicFramePr>
+              <p:cNvPr id="6" name="Table 5">
+                <a:extLst>
+                  <a:ext uri="{FF2B5EF4-FFF2-40B4-BE49-F238E27FC236}">
+                    <a16:creationId xmlns:a16="http://schemas.microsoft.com/office/drawing/2014/main" id="{BDB10604-1415-D8DC-3E0A-FB7A8B02A17C}"/>
+                  </a:ext>
+                </a:extLst>
+              </p:cNvPr>
+              <p:cNvGraphicFramePr>
+                <a:graphicFrameLocks noGrp="1"/>
+              </p:cNvGraphicFramePr>
+              <p:nvPr>
+                <p:extLst>
+                  <p:ext uri="{D42A27DB-BD31-4B8C-83A1-F6EECF244321}">
+                    <p14:modId xmlns:p14="http://schemas.microsoft.com/office/powerpoint/2010/main" val="4236945891"/>
+                  </p:ext>
+                </p:extLst>
+              </p:nvPr>
+            </p:nvGraphicFramePr>
+            <p:xfrm>
+              <a:off x="1190445" y="1261081"/>
+              <a:ext cx="2960626" cy="1828800"/>
+            </p:xfrm>
+            <a:graphic>
+              <a:graphicData uri="http://schemas.openxmlformats.org/drawingml/2006/table">
+                <a:tbl>
+                  <a:tblPr firstRow="1" bandRow="1">
+                    <a:tableStyleId>{5940675A-B579-460E-94D1-54222C63F5DA}</a:tableStyleId>
+                  </a:tblPr>
+                  <a:tblGrid>
+                    <a:gridCol w="1480313">
+                      <a:extLst>
+                        <a:ext uri="{9D8B030D-6E8A-4147-A177-3AD203B41FA5}">
+                          <a16:colId xmlns:a16="http://schemas.microsoft.com/office/drawing/2014/main" val="1869778181"/>
+                        </a:ext>
+                      </a:extLst>
+                    </a:gridCol>
+                    <a:gridCol w="1480313">
+                      <a:extLst>
+                        <a:ext uri="{9D8B030D-6E8A-4147-A177-3AD203B41FA5}">
+                          <a16:colId xmlns:a16="http://schemas.microsoft.com/office/drawing/2014/main" val="2700513838"/>
+                        </a:ext>
+                      </a:extLst>
+                    </a:gridCol>
+                  </a:tblGrid>
+                  <a:tr h="304800">
+                    <a:tc>
+                      <a:txBody>
+                        <a:bodyPr/>
+                        <a:lstStyle/>
+                        <a:p>
+                          <a:endParaRPr lang="en-US"/>
+                        </a:p>
+                      </a:txBody>
+                      <a:tcPr marL="45720" marR="45720">
+                        <a:blipFill>
+                          <a:blip r:embed="rId3"/>
+                          <a:stretch>
+                            <a:fillRect l="-412" t="-2000" r="-101235" b="-522000"/>
+                          </a:stretch>
+                        </a:blipFill>
+                      </a:tcPr>
+                    </a:tc>
+                    <a:tc>
+                      <a:txBody>
+                        <a:bodyPr/>
+                        <a:lstStyle/>
+                        <a:p>
+                          <a:pPr algn="ctr"/>
+                          <a:r>
+                            <a:rPr lang="en-US" sz="1400" dirty="0">
+                              <a:latin typeface="Verdana Pro" panose="020B0604030504040204" pitchFamily="34" charset="0"/>
+                            </a:rPr>
+                            <a:t>Score</a:t>
+                          </a:r>
+                          <a:endParaRPr lang="en-CA" sz="1400" dirty="0">
+                            <a:latin typeface="Verdana Pro" panose="020B0604030504040204" pitchFamily="34" charset="0"/>
+                          </a:endParaRPr>
+                        </a:p>
+                      </a:txBody>
+                      <a:tcPr marL="45720" marR="45720"/>
+                    </a:tc>
+                    <a:extLst>
+                      <a:ext uri="{0D108BD9-81ED-4DB2-BD59-A6C34878D82A}">
+                        <a16:rowId xmlns:a16="http://schemas.microsoft.com/office/drawing/2014/main" val="2202861222"/>
+                      </a:ext>
+                    </a:extLst>
+                  </a:tr>
+                  <a:tr h="304800">
+                    <a:tc>
+                      <a:txBody>
+                        <a:bodyPr/>
+                        <a:lstStyle/>
+                        <a:p>
+                          <a:r>
+                            <a:rPr lang="en-US" sz="1400" dirty="0">
+                              <a:latin typeface="Verdana Pro" panose="020B0604030504040204" pitchFamily="34" charset="0"/>
+                            </a:rPr>
+                            <a:t>0.0</a:t>
+                          </a:r>
+                          <a:endParaRPr lang="en-CA" sz="1400" dirty="0">
+                            <a:latin typeface="Verdana Pro" panose="020B0604030504040204" pitchFamily="34" charset="0"/>
+                          </a:endParaRPr>
+                        </a:p>
+                      </a:txBody>
+                      <a:tcPr marL="45720" marR="45720"/>
+                    </a:tc>
+                    <a:tc>
+                      <a:txBody>
+                        <a:bodyPr/>
+                        <a:lstStyle/>
+                        <a:p>
+                          <a:r>
+                            <a:rPr lang="en-US" sz="1400" dirty="0">
+                              <a:latin typeface="Verdana Pro" panose="020B0604030504040204" pitchFamily="34" charset="0"/>
+                            </a:rPr>
+                            <a:t>0.00</a:t>
+                          </a:r>
+                          <a:endParaRPr lang="en-CA" sz="1400" dirty="0">
+                            <a:latin typeface="Verdana Pro" panose="020B0604030504040204" pitchFamily="34" charset="0"/>
+                          </a:endParaRPr>
+                        </a:p>
+                      </a:txBody>
+                      <a:tcPr marL="45720" marR="45720"/>
+                    </a:tc>
+                    <a:extLst>
+                      <a:ext uri="{0D108BD9-81ED-4DB2-BD59-A6C34878D82A}">
+                        <a16:rowId xmlns:a16="http://schemas.microsoft.com/office/drawing/2014/main" val="4031372816"/>
+                      </a:ext>
+                    </a:extLst>
+                  </a:tr>
+                  <a:tr h="304800">
+                    <a:tc>
+                      <a:txBody>
+                        <a:bodyPr/>
+                        <a:lstStyle/>
+                        <a:p>
+                          <a:r>
+                            <a:rPr lang="en-US" sz="1400" dirty="0">
+                              <a:latin typeface="Verdana Pro" panose="020B0604030504040204" pitchFamily="34" charset="0"/>
+                            </a:rPr>
+                            <a:t>0.4</a:t>
+                          </a:r>
+                          <a:endParaRPr lang="en-CA" sz="1400" dirty="0">
+                            <a:latin typeface="Verdana Pro" panose="020B0604030504040204" pitchFamily="34" charset="0"/>
+                          </a:endParaRPr>
+                        </a:p>
+                      </a:txBody>
+                      <a:tcPr marL="45720" marR="45720"/>
+                    </a:tc>
+                    <a:tc>
+                      <a:txBody>
+                        <a:bodyPr/>
+                        <a:lstStyle/>
+                        <a:p>
+                          <a:r>
+                            <a:rPr lang="en-US" sz="1400" dirty="0">
+                              <a:latin typeface="Verdana Pro" panose="020B0604030504040204" pitchFamily="34" charset="0"/>
+                            </a:rPr>
+                            <a:t>0.10</a:t>
+                          </a:r>
+                          <a:endParaRPr lang="en-CA" sz="1400" dirty="0">
+                            <a:latin typeface="Verdana Pro" panose="020B0604030504040204" pitchFamily="34" charset="0"/>
+                          </a:endParaRPr>
+                        </a:p>
+                      </a:txBody>
+                      <a:tcPr marL="45720" marR="45720"/>
+                    </a:tc>
+                    <a:extLst>
+                      <a:ext uri="{0D108BD9-81ED-4DB2-BD59-A6C34878D82A}">
+                        <a16:rowId xmlns:a16="http://schemas.microsoft.com/office/drawing/2014/main" val="3424690894"/>
+                      </a:ext>
+                    </a:extLst>
+                  </a:tr>
+                  <a:tr h="304800">
+                    <a:tc>
+                      <a:txBody>
+                        <a:bodyPr/>
+                        <a:lstStyle/>
+                        <a:p>
+                          <a:r>
+                            <a:rPr lang="en-US" sz="1400" dirty="0">
+                              <a:latin typeface="Verdana Pro" panose="020B0604030504040204" pitchFamily="34" charset="0"/>
+                            </a:rPr>
+                            <a:t>6.0</a:t>
+                          </a:r>
+                          <a:endParaRPr lang="en-CA" sz="1400" dirty="0">
+                            <a:latin typeface="Verdana Pro" panose="020B0604030504040204" pitchFamily="34" charset="0"/>
+                          </a:endParaRPr>
+                        </a:p>
+                      </a:txBody>
+                      <a:tcPr marL="45720" marR="45720"/>
+                    </a:tc>
+                    <a:tc>
+                      <a:txBody>
+                        <a:bodyPr/>
+                        <a:lstStyle/>
+                        <a:p>
+                          <a:r>
+                            <a:rPr lang="en-US" sz="1400" dirty="0">
+                              <a:latin typeface="Verdana Pro" panose="020B0604030504040204" pitchFamily="34" charset="0"/>
+                            </a:rPr>
+                            <a:t>0.70</a:t>
+                          </a:r>
+                          <a:endParaRPr lang="en-CA" sz="1400" dirty="0">
+                            <a:latin typeface="Verdana Pro" panose="020B0604030504040204" pitchFamily="34" charset="0"/>
+                          </a:endParaRPr>
+                        </a:p>
+                      </a:txBody>
+                      <a:tcPr marL="45720" marR="45720"/>
+                    </a:tc>
+                    <a:extLst>
+                      <a:ext uri="{0D108BD9-81ED-4DB2-BD59-A6C34878D82A}">
+                        <a16:rowId xmlns:a16="http://schemas.microsoft.com/office/drawing/2014/main" val="3156004181"/>
+                      </a:ext>
+                    </a:extLst>
+                  </a:tr>
+                  <a:tr h="304800">
+                    <a:tc>
+                      <a:txBody>
+                        <a:bodyPr/>
+                        <a:lstStyle/>
+                        <a:p>
+                          <a:r>
+                            <a:rPr lang="en-US" sz="1400" dirty="0">
+                              <a:latin typeface="Verdana Pro" panose="020B0604030504040204" pitchFamily="34" charset="0"/>
+                            </a:rPr>
+                            <a:t>10.0</a:t>
+                          </a:r>
+                          <a:endParaRPr lang="en-CA" sz="1400" dirty="0">
+                            <a:latin typeface="Verdana Pro" panose="020B0604030504040204" pitchFamily="34" charset="0"/>
+                          </a:endParaRPr>
+                        </a:p>
+                      </a:txBody>
+                      <a:tcPr marL="45720" marR="45720"/>
+                    </a:tc>
+                    <a:tc>
+                      <a:txBody>
+                        <a:bodyPr/>
+                        <a:lstStyle/>
+                        <a:p>
+                          <a:r>
+                            <a:rPr lang="en-US" sz="1400" dirty="0">
+                              <a:latin typeface="Verdana Pro" panose="020B0604030504040204" pitchFamily="34" charset="0"/>
+                            </a:rPr>
+                            <a:t>0.90</a:t>
+                          </a:r>
+                          <a:endParaRPr lang="en-CA" sz="1400" dirty="0">
+                            <a:latin typeface="Verdana Pro" panose="020B0604030504040204" pitchFamily="34" charset="0"/>
+                          </a:endParaRPr>
+                        </a:p>
+                      </a:txBody>
+                      <a:tcPr marL="45720" marR="45720"/>
+                    </a:tc>
+                    <a:extLst>
+                      <a:ext uri="{0D108BD9-81ED-4DB2-BD59-A6C34878D82A}">
+                        <a16:rowId xmlns:a16="http://schemas.microsoft.com/office/drawing/2014/main" val="1804626572"/>
+                      </a:ext>
+                    </a:extLst>
+                  </a:tr>
+                  <a:tr h="304800">
+                    <a:tc>
+                      <a:txBody>
+                        <a:bodyPr/>
+                        <a:lstStyle/>
+                        <a:p>
+                          <a:r>
+                            <a:rPr lang="en-US" sz="1400" dirty="0">
+                              <a:latin typeface="Verdana Pro" panose="020B0604030504040204" pitchFamily="34" charset="0"/>
+                            </a:rPr>
+                            <a:t>15.0</a:t>
+                          </a:r>
+                          <a:endParaRPr lang="en-CA" sz="1400" dirty="0">
+                            <a:latin typeface="Verdana Pro" panose="020B0604030504040204" pitchFamily="34" charset="0"/>
+                          </a:endParaRPr>
+                        </a:p>
+                      </a:txBody>
+                      <a:tcPr marL="45720" marR="45720"/>
+                    </a:tc>
+                    <a:tc>
+                      <a:txBody>
+                        <a:bodyPr/>
+                        <a:lstStyle/>
+                        <a:p>
+                          <a:r>
+                            <a:rPr lang="en-US" sz="1400" dirty="0">
+                              <a:latin typeface="Verdana Pro" panose="020B0604030504040204" pitchFamily="34" charset="0"/>
+                            </a:rPr>
+                            <a:t>0.99</a:t>
+                          </a:r>
+                          <a:endParaRPr lang="en-CA" sz="1400" dirty="0">
+                            <a:latin typeface="Verdana Pro" panose="020B0604030504040204" pitchFamily="34" charset="0"/>
+                          </a:endParaRPr>
+                        </a:p>
+                      </a:txBody>
+                      <a:tcPr marL="45720" marR="45720"/>
+                    </a:tc>
+                    <a:extLst>
+                      <a:ext uri="{0D108BD9-81ED-4DB2-BD59-A6C34878D82A}">
+                        <a16:rowId xmlns:a16="http://schemas.microsoft.com/office/drawing/2014/main" val="1030796854"/>
+                      </a:ext>
+                    </a:extLst>
+                  </a:tr>
+                </a:tbl>
+              </a:graphicData>
+            </a:graphic>
+          </p:graphicFrame>
+        </mc:Fallback>
+      </mc:AlternateContent>
+      <p:grpSp>
+        <p:nvGrpSpPr>
+          <p:cNvPr id="13" name="Group 12">
+            <a:extLst>
+              <a:ext uri="{FF2B5EF4-FFF2-40B4-BE49-F238E27FC236}">
+                <a16:creationId xmlns:a16="http://schemas.microsoft.com/office/drawing/2014/main" id="{8B2BEAC5-D45D-56F2-727E-2D5992767AF5}"/>
+              </a:ext>
+            </a:extLst>
+          </p:cNvPr>
+          <p:cNvGrpSpPr/>
+          <p:nvPr/>
+        </p:nvGrpSpPr>
+        <p:grpSpPr>
+          <a:xfrm>
+            <a:off x="558736" y="3301586"/>
+            <a:ext cx="3695668" cy="2953751"/>
+            <a:chOff x="374070" y="3300621"/>
+            <a:chExt cx="3695668" cy="2953751"/>
+          </a:xfrm>
+        </p:grpSpPr>
+        <p:pic>
+          <p:nvPicPr>
+            <p:cNvPr id="9" name="Picture 8">
+              <a:extLst>
+                <a:ext uri="{FF2B5EF4-FFF2-40B4-BE49-F238E27FC236}">
+                  <a16:creationId xmlns:a16="http://schemas.microsoft.com/office/drawing/2014/main" id="{115449BC-DD85-3BE0-7B8C-0B354D8CAEDD}"/>
+                </a:ext>
+              </a:extLst>
+            </p:cNvPr>
+            <p:cNvPicPr>
+              <a:picLocks noChangeAspect="1"/>
+            </p:cNvPicPr>
+            <p:nvPr/>
+          </p:nvPicPr>
+          <p:blipFill>
+            <a:blip r:embed="rId4">
+              <a:extLst>
+                <a:ext uri="{28A0092B-C50C-407E-A947-70E740481C1C}">
+                  <a14:useLocalDpi xmlns:a14="http://schemas.microsoft.com/office/drawing/2010/main" val="0"/>
+                </a:ext>
+              </a:extLst>
+            </a:blip>
+            <a:srcRect l="6122" t="8432" r="7031" b="3714"/>
+            <a:stretch>
+              <a:fillRect/>
+            </a:stretch>
+          </p:blipFill>
+          <p:spPr>
+            <a:xfrm>
+              <a:off x="762801" y="3429000"/>
+              <a:ext cx="3306937" cy="2508969"/>
+            </a:xfrm>
+            <a:prstGeom prst="rect">
+              <a:avLst/>
+            </a:prstGeom>
+          </p:spPr>
+        </p:pic>
+        <mc:AlternateContent xmlns:mc="http://schemas.openxmlformats.org/markup-compatibility/2006">
+          <mc:Choice xmlns:a14="http://schemas.microsoft.com/office/drawing/2010/main" Requires="a14">
+            <p:sp>
+              <p:nvSpPr>
+                <p:cNvPr id="10" name="TextBox 9">
+                  <a:extLst>
+                    <a:ext uri="{FF2B5EF4-FFF2-40B4-BE49-F238E27FC236}">
+                      <a16:creationId xmlns:a16="http://schemas.microsoft.com/office/drawing/2014/main" id="{9511F9B6-4A3A-EE5C-C82E-65BF9A010391}"/>
+                    </a:ext>
+                  </a:extLst>
+                </p:cNvPr>
+                <p:cNvSpPr txBox="1"/>
+                <p:nvPr/>
+              </p:nvSpPr>
+              <p:spPr>
+                <a:xfrm>
+                  <a:off x="1138686" y="5946595"/>
+                  <a:ext cx="2406770" cy="307777"/>
+                </a:xfrm>
+                <a:prstGeom prst="rect">
+                  <a:avLst/>
+                </a:prstGeom>
+                <a:noFill/>
+              </p:spPr>
+              <p:txBody>
+                <a:bodyPr wrap="square" rtlCol="0">
+                  <a:spAutoFit/>
+                </a:bodyPr>
+                <a:lstStyle/>
+                <a:p>
+                  <a14:m>
+                    <m:oMathPara xmlns:m="http://schemas.openxmlformats.org/officeDocument/2006/math">
+                      <m:oMath>
+                        <m:r>
+                          <a:rPr lang="en-US" sz="1400" i="1">
+                            <a:latin typeface="Cambria Math" panose="02040503050406030204" pitchFamily="18" charset="0"/>
+                          </a:rPr>
+                          <m:t>−</m:t>
+                        </m:r>
+                        <m:func>
+                          <m:funcPr>
+                            <m:ctrlPr>
+                              <a:rPr lang="en-US" sz="1400" i="1">
+                                <a:latin typeface="Cambria Math" panose="02040503050406030204" pitchFamily="18" charset="0"/>
+                              </a:rPr>
+                            </m:ctrlPr>
+                          </m:funcPr>
+                          <m:fName>
+                            <m:sSub>
+                              <m:sSubPr>
+                                <m:ctrlPr>
+                                  <a:rPr lang="en-US" sz="1400">
+                                    <a:latin typeface="Cambria Math" panose="02040503050406030204" pitchFamily="18" charset="0"/>
+                                  </a:rPr>
+                                </m:ctrlPr>
+                              </m:sSubPr>
+                              <m:e>
+                                <m:r>
+                                  <m:rPr>
+                                    <m:sty m:val="p"/>
+                                  </m:rPr>
+                                  <a:rPr lang="en-US" sz="1400">
+                                    <a:latin typeface="Cambria Math" panose="02040503050406030204" pitchFamily="18" charset="0"/>
+                                  </a:rPr>
+                                  <m:t>log</m:t>
+                                </m:r>
+                              </m:e>
+                              <m:sub>
+                                <m:r>
+                                  <a:rPr lang="en-US" sz="1400" i="1">
+                                    <a:latin typeface="Cambria Math" panose="02040503050406030204" pitchFamily="18" charset="0"/>
+                                  </a:rPr>
+                                  <m:t>10</m:t>
+                                </m:r>
+                              </m:sub>
+                            </m:sSub>
+                          </m:fName>
+                          <m:e>
+                            <m:d>
+                              <m:dPr>
+                                <m:ctrlPr>
+                                  <a:rPr lang="en-US" sz="1400" i="1">
+                                    <a:latin typeface="Cambria Math" panose="02040503050406030204" pitchFamily="18" charset="0"/>
+                                  </a:rPr>
+                                </m:ctrlPr>
+                              </m:dPr>
+                              <m:e>
+                                <m:r>
+                                  <a:rPr lang="en-US" sz="1400" i="1">
+                                    <a:latin typeface="Cambria Math" panose="02040503050406030204" pitchFamily="18" charset="0"/>
+                                  </a:rPr>
+                                  <m:t>𝑒</m:t>
+                                </m:r>
+                                <m:r>
+                                  <a:rPr lang="en-US" sz="1400" i="1">
+                                    <a:latin typeface="Cambria Math" panose="02040503050406030204" pitchFamily="18" charset="0"/>
+                                  </a:rPr>
+                                  <m:t>_</m:t>
+                                </m:r>
+                                <m:r>
+                                  <a:rPr lang="en-US" sz="1400" i="1">
+                                    <a:latin typeface="Cambria Math" panose="02040503050406030204" pitchFamily="18" charset="0"/>
+                                  </a:rPr>
+                                  <m:t>𝑣𝑎𝑙𝑢𝑒</m:t>
+                                </m:r>
+                              </m:e>
+                            </m:d>
+                          </m:e>
+                        </m:func>
+                      </m:oMath>
+                    </m:oMathPara>
+                  </a14:m>
+                  <a:endParaRPr lang="en-CA" sz="1400" dirty="0">
+                    <a:latin typeface="Verdana Pro" panose="020B0604030504040204" pitchFamily="34" charset="0"/>
+                  </a:endParaRPr>
+                </a:p>
+              </p:txBody>
+            </p:sp>
+          </mc:Choice>
+          <mc:Fallback>
+            <p:sp>
+              <p:nvSpPr>
+                <p:cNvPr id="10" name="TextBox 9">
+                  <a:extLst>
+                    <a:ext uri="{FF2B5EF4-FFF2-40B4-BE49-F238E27FC236}">
+                      <a16:creationId xmlns:a16="http://schemas.microsoft.com/office/drawing/2014/main" id="{9511F9B6-4A3A-EE5C-C82E-65BF9A010391}"/>
+                    </a:ext>
+                  </a:extLst>
+                </p:cNvPr>
+                <p:cNvSpPr txBox="1">
+                  <a:spLocks noRot="1" noChangeAspect="1" noMove="1" noResize="1" noEditPoints="1" noAdjustHandles="1" noChangeArrowheads="1" noChangeShapeType="1" noTextEdit="1"/>
+                </p:cNvSpPr>
+                <p:nvPr/>
+              </p:nvSpPr>
+              <p:spPr>
+                <a:xfrm>
+                  <a:off x="1138686" y="5946595"/>
+                  <a:ext cx="2406770" cy="307777"/>
+                </a:xfrm>
+                <a:prstGeom prst="rect">
+                  <a:avLst/>
+                </a:prstGeom>
+                <a:blipFill>
+                  <a:blip r:embed="rId5"/>
+                  <a:stretch>
+                    <a:fillRect b="-12000"/>
+                  </a:stretch>
+                </a:blipFill>
+              </p:spPr>
+              <p:txBody>
+                <a:bodyPr/>
+                <a:lstStyle/>
+                <a:p>
+                  <a:r>
+                    <a:rPr lang="en-CA">
+                      <a:noFill/>
+                    </a:rPr>
+                    <a:t> </a:t>
+                  </a:r>
+                </a:p>
+              </p:txBody>
+            </p:sp>
+          </mc:Fallback>
+        </mc:AlternateContent>
+        <p:sp>
+          <p:nvSpPr>
+            <p:cNvPr id="12" name="TextBox 11">
+              <a:extLst>
+                <a:ext uri="{FF2B5EF4-FFF2-40B4-BE49-F238E27FC236}">
+                  <a16:creationId xmlns:a16="http://schemas.microsoft.com/office/drawing/2014/main" id="{322D70E0-5AED-1F5F-1BFD-A91F3DBB6AC6}"/>
+                </a:ext>
+              </a:extLst>
+            </p:cNvPr>
+            <p:cNvSpPr txBox="1"/>
+            <p:nvPr/>
+          </p:nvSpPr>
+          <p:spPr>
+            <a:xfrm rot="16200000">
+              <a:off x="-675426" y="4350117"/>
+              <a:ext cx="2406770" cy="307777"/>
+            </a:xfrm>
+            <a:prstGeom prst="rect">
+              <a:avLst/>
+            </a:prstGeom>
+            <a:noFill/>
+          </p:spPr>
+          <p:txBody>
+            <a:bodyPr wrap="square" rtlCol="0">
+              <a:spAutoFit/>
+            </a:bodyPr>
+            <a:lstStyle/>
+            <a:p>
+              <a:pPr algn="ctr"/>
+              <a:r>
+                <a:rPr lang="en-US" sz="1400" dirty="0">
+                  <a:latin typeface="Verdana Pro" panose="020B0604030504040204" pitchFamily="34" charset="0"/>
+                </a:rPr>
+                <a:t>Score</a:t>
+              </a:r>
+              <a:endParaRPr lang="en-CA" sz="1400" dirty="0">
+                <a:latin typeface="Verdana Pro" panose="020B0604030504040204" pitchFamily="34" charset="0"/>
+              </a:endParaRPr>
+            </a:p>
+          </p:txBody>
+        </p:sp>
+      </p:grpSp>
+      <p:pic>
+        <p:nvPicPr>
+          <p:cNvPr id="15" name="Graphic 14">
+            <a:extLst>
+              <a:ext uri="{FF2B5EF4-FFF2-40B4-BE49-F238E27FC236}">
+                <a16:creationId xmlns:a16="http://schemas.microsoft.com/office/drawing/2014/main" id="{85159B43-7FAA-3050-20C1-2BD0740C639B}"/>
+              </a:ext>
+            </a:extLst>
+          </p:cNvPr>
+          <p:cNvPicPr>
+            <a:picLocks noChangeAspect="1"/>
+          </p:cNvPicPr>
+          <p:nvPr/>
+        </p:nvPicPr>
+        <p:blipFill>
+          <a:blip>
+            <a:extLst>
+              <a:ext uri="{96DAC541-7B7A-43D3-8B79-37D633B846F1}">
+                <asvg:svgBlip xmlns:asvg="http://schemas.microsoft.com/office/drawing/2016/SVG/main" r:embed="rId6"/>
+              </a:ext>
+            </a:extLst>
+          </a:blip>
+          <a:srcRect l="4777" t="9000" r="7469" b="5168"/>
+          <a:stretch>
+            <a:fillRect/>
+          </a:stretch>
+        </p:blipFill>
+        <p:spPr>
+          <a:xfrm>
+            <a:off x="4859026" y="1041918"/>
+            <a:ext cx="6850844" cy="5031078"/>
+          </a:xfrm>
+          <a:prstGeom prst="rect">
+            <a:avLst/>
+          </a:prstGeom>
+        </p:spPr>
+      </p:pic>
+      <p:sp>
+        <p:nvSpPr>
+          <p:cNvPr id="17" name="TextBox 16">
+            <a:extLst>
+              <a:ext uri="{FF2B5EF4-FFF2-40B4-BE49-F238E27FC236}">
+                <a16:creationId xmlns:a16="http://schemas.microsoft.com/office/drawing/2014/main" id="{6056E8C2-A92D-9CF7-5929-4D33C5FAA0A5}"/>
+              </a:ext>
+            </a:extLst>
+          </p:cNvPr>
+          <p:cNvSpPr txBox="1"/>
+          <p:nvPr/>
+        </p:nvSpPr>
+        <p:spPr>
+          <a:xfrm rot="16200000">
+            <a:off x="3495374" y="3040720"/>
+            <a:ext cx="2406770" cy="369332"/>
+          </a:xfrm>
+          <a:prstGeom prst="rect">
+            <a:avLst/>
+          </a:prstGeom>
+          <a:noFill/>
+        </p:spPr>
+        <p:txBody>
+          <a:bodyPr wrap="square" rtlCol="0">
+            <a:spAutoFit/>
+          </a:bodyPr>
+          <a:lstStyle/>
+          <a:p>
+            <a:pPr algn="ctr"/>
+            <a:r>
+              <a:rPr lang="en-US" dirty="0">
+                <a:latin typeface="Verdana Pro" panose="020B0604030504040204" pitchFamily="34" charset="0"/>
+              </a:rPr>
+              <a:t>Score</a:t>
+            </a:r>
+            <a:endParaRPr lang="en-CA" dirty="0">
+              <a:latin typeface="Verdana Pro" panose="020B0604030504040204" pitchFamily="34" charset="0"/>
+            </a:endParaRPr>
+          </a:p>
+        </p:txBody>
+      </p:sp>
+      <mc:AlternateContent xmlns:mc="http://schemas.openxmlformats.org/markup-compatibility/2006">
+        <mc:Choice xmlns:a14="http://schemas.microsoft.com/office/drawing/2010/main" Requires="a14">
+          <p:sp>
+            <p:nvSpPr>
+              <p:cNvPr id="19" name="TextBox 18">
+                <a:extLst>
+                  <a:ext uri="{FF2B5EF4-FFF2-40B4-BE49-F238E27FC236}">
+                    <a16:creationId xmlns:a16="http://schemas.microsoft.com/office/drawing/2014/main" id="{AF962D13-3D6D-86D5-2CFA-9FCF9A9287AB}"/>
+                  </a:ext>
+                </a:extLst>
+              </p:cNvPr>
+              <p:cNvSpPr txBox="1"/>
+              <p:nvPr/>
+            </p:nvSpPr>
+            <p:spPr>
+              <a:xfrm>
+                <a:off x="7407215" y="5987018"/>
+                <a:ext cx="2406770" cy="369332"/>
+              </a:xfrm>
+              <a:prstGeom prst="rect">
+                <a:avLst/>
+              </a:prstGeom>
+              <a:noFill/>
+            </p:spPr>
+            <p:txBody>
+              <a:bodyPr wrap="square" rtlCol="0">
+                <a:spAutoFit/>
+              </a:bodyPr>
+              <a:lstStyle/>
+              <a:p>
+                <a:pPr/>
+                <a14:m>
+                  <m:oMathPara xmlns:m="http://schemas.openxmlformats.org/officeDocument/2006/math">
+                    <m:oMath>
+                      <m:r>
+                        <a:rPr lang="en-US" i="1">
+                          <a:latin typeface="Cambria Math" panose="02040503050406030204" pitchFamily="18" charset="0"/>
+                        </a:rPr>
+                        <m:t>−</m:t>
+                      </m:r>
+                      <m:func>
+                        <m:funcPr>
+                          <m:ctrlPr>
+                            <a:rPr lang="en-US" i="1">
+                              <a:latin typeface="Cambria Math" panose="02040503050406030204" pitchFamily="18" charset="0"/>
+                            </a:rPr>
+                          </m:ctrlPr>
+                        </m:funcPr>
+                        <m:fName>
+                          <m:sSub>
+                            <m:sSubPr>
+                              <m:ctrlPr>
+                                <a:rPr lang="en-US">
+                                  <a:latin typeface="Cambria Math" panose="02040503050406030204" pitchFamily="18" charset="0"/>
+                                </a:rPr>
+                              </m:ctrlPr>
+                            </m:sSubPr>
+                            <m:e>
+                              <m:r>
+                                <m:rPr>
+                                  <m:sty m:val="p"/>
+                                </m:rPr>
+                                <a:rPr lang="en-US">
+                                  <a:latin typeface="Cambria Math" panose="02040503050406030204" pitchFamily="18" charset="0"/>
+                                </a:rPr>
+                                <m:t>log</m:t>
+                              </m:r>
+                            </m:e>
+                            <m:sub>
+                              <m:r>
+                                <a:rPr lang="en-US" i="1">
+                                  <a:latin typeface="Cambria Math" panose="02040503050406030204" pitchFamily="18" charset="0"/>
+                                </a:rPr>
+                                <m:t>10</m:t>
+                              </m:r>
+                            </m:sub>
+                          </m:sSub>
+                        </m:fName>
+                        <m:e>
+                          <m:d>
+                            <m:dPr>
+                              <m:ctrlPr>
+                                <a:rPr lang="en-US" i="1">
+                                  <a:latin typeface="Cambria Math" panose="02040503050406030204" pitchFamily="18" charset="0"/>
+                                </a:rPr>
+                              </m:ctrlPr>
+                            </m:dPr>
+                            <m:e>
+                              <m:r>
+                                <a:rPr lang="en-US" i="1">
+                                  <a:latin typeface="Cambria Math" panose="02040503050406030204" pitchFamily="18" charset="0"/>
+                                </a:rPr>
+                                <m:t>𝑒</m:t>
+                              </m:r>
+                              <m:r>
+                                <a:rPr lang="en-US" i="1">
+                                  <a:latin typeface="Cambria Math" panose="02040503050406030204" pitchFamily="18" charset="0"/>
+                                </a:rPr>
+                                <m:t>_</m:t>
+                              </m:r>
+                              <m:r>
+                                <a:rPr lang="en-US" i="1">
+                                  <a:latin typeface="Cambria Math" panose="02040503050406030204" pitchFamily="18" charset="0"/>
+                                </a:rPr>
+                                <m:t>𝑣𝑎𝑙𝑢𝑒</m:t>
+                              </m:r>
+                            </m:e>
+                          </m:d>
+                        </m:e>
+                      </m:func>
+                    </m:oMath>
+                  </m:oMathPara>
+                </a14:m>
+                <a:endParaRPr lang="en-CA" dirty="0">
+                  <a:latin typeface="Verdana Pro" panose="020B0604030504040204" pitchFamily="34" charset="0"/>
+                </a:endParaRPr>
+              </a:p>
+            </p:txBody>
+          </p:sp>
+        </mc:Choice>
+        <mc:Fallback>
+          <p:sp>
+            <p:nvSpPr>
+              <p:cNvPr id="19" name="TextBox 18">
+                <a:extLst>
+                  <a:ext uri="{FF2B5EF4-FFF2-40B4-BE49-F238E27FC236}">
+                    <a16:creationId xmlns:a16="http://schemas.microsoft.com/office/drawing/2014/main" id="{AF962D13-3D6D-86D5-2CFA-9FCF9A9287AB}"/>
+                  </a:ext>
+                </a:extLst>
+              </p:cNvPr>
+              <p:cNvSpPr txBox="1">
+                <a:spLocks noRot="1" noChangeAspect="1" noMove="1" noResize="1" noEditPoints="1" noAdjustHandles="1" noChangeArrowheads="1" noChangeShapeType="1" noTextEdit="1"/>
+              </p:cNvSpPr>
+              <p:nvPr/>
+            </p:nvSpPr>
+            <p:spPr>
+              <a:xfrm>
+                <a:off x="7407215" y="5987018"/>
+                <a:ext cx="2406770" cy="369332"/>
+              </a:xfrm>
+              <a:prstGeom prst="rect">
+                <a:avLst/>
+              </a:prstGeom>
+              <a:blipFill>
+                <a:blip r:embed="rId7"/>
+                <a:stretch>
+                  <a:fillRect b="-16393"/>
+                </a:stretch>
+              </a:blipFill>
+            </p:spPr>
+            <p:txBody>
+              <a:bodyPr/>
+              <a:lstStyle/>
+              <a:p>
+                <a:r>
+                  <a:rPr lang="en-CA">
+                    <a:noFill/>
+                  </a:rPr>
+                  <a:t> </a:t>
+                </a:r>
+              </a:p>
+            </p:txBody>
+          </p:sp>
+        </mc:Fallback>
+      </mc:AlternateContent>
+      <mc:AlternateContent xmlns:mc="http://schemas.openxmlformats.org/markup-compatibility/2006">
+        <mc:Choice xmlns:a14="http://schemas.microsoft.com/office/drawing/2010/main" Requires="a14">
+          <p:sp>
+            <p:nvSpPr>
+              <p:cNvPr id="2" name="TextBox 1">
+                <a:extLst>
+                  <a:ext uri="{FF2B5EF4-FFF2-40B4-BE49-F238E27FC236}">
+                    <a16:creationId xmlns:a16="http://schemas.microsoft.com/office/drawing/2014/main" id="{DD36C8DD-1C3C-806D-F870-DD8422DDA852}"/>
+                  </a:ext>
+                </a:extLst>
+              </p:cNvPr>
+              <p:cNvSpPr txBox="1"/>
+              <p:nvPr/>
+            </p:nvSpPr>
+            <p:spPr>
+              <a:xfrm>
+                <a:off x="8500227" y="2408915"/>
+                <a:ext cx="1781834" cy="436017"/>
+              </a:xfrm>
+              <a:prstGeom prst="rect">
+                <a:avLst/>
+              </a:prstGeom>
+              <a:noFill/>
+            </p:spPr>
+            <p:txBody>
+              <a:bodyPr wrap="none" lIns="0" tIns="0" rIns="0" bIns="0" rtlCol="0">
+                <a:spAutoFit/>
+              </a:bodyPr>
+              <a:lstStyle/>
+              <a:p>
+                <a14:m>
+                  <m:oMath xmlns:m="http://schemas.openxmlformats.org/officeDocument/2006/math">
+                    <m:r>
+                      <a:rPr lang="en-US" b="0" i="1" smtClean="0">
+                        <a:latin typeface="Cambria Math" panose="02040503050406030204" pitchFamily="18" charset="0"/>
+                      </a:rPr>
+                      <m:t>𝑦</m:t>
+                    </m:r>
+                    <m:r>
+                      <a:rPr lang="en-US" b="0" i="1" smtClean="0">
+                        <a:latin typeface="Cambria Math" panose="02040503050406030204" pitchFamily="18" charset="0"/>
+                      </a:rPr>
+                      <m:t>=1−</m:t>
+                    </m:r>
+                    <m:sSup>
+                      <m:sSupPr>
+                        <m:ctrlPr>
+                          <a:rPr lang="en-US" b="0" i="1" smtClean="0">
+                            <a:latin typeface="Cambria Math" panose="02040503050406030204" pitchFamily="18" charset="0"/>
+                          </a:rPr>
+                        </m:ctrlPr>
+                      </m:sSupPr>
+                      <m:e>
+                        <m:r>
+                          <a:rPr lang="en-US" b="0" i="1" smtClean="0">
+                            <a:latin typeface="Cambria Math" panose="02040503050406030204" pitchFamily="18" charset="0"/>
+                          </a:rPr>
+                          <m:t>𝑒</m:t>
+                        </m:r>
+                      </m:e>
+                      <m:sup>
+                        <m:sSup>
+                          <m:sSupPr>
+                            <m:ctrlPr>
+                              <a:rPr lang="en-US" b="0" i="1" smtClean="0">
+                                <a:latin typeface="Cambria Math" panose="02040503050406030204" pitchFamily="18" charset="0"/>
+                              </a:rPr>
+                            </m:ctrlPr>
+                          </m:sSupPr>
+                          <m:e>
+                            <m:r>
+                              <a:rPr lang="en-US" b="0" i="1" smtClean="0">
+                                <a:latin typeface="Cambria Math" panose="02040503050406030204" pitchFamily="18" charset="0"/>
+                              </a:rPr>
+                              <m:t>−</m:t>
+                            </m:r>
+                            <m:d>
+                              <m:dPr>
+                                <m:ctrlPr>
+                                  <a:rPr lang="en-US" i="1">
+                                    <a:latin typeface="Cambria Math" panose="02040503050406030204" pitchFamily="18" charset="0"/>
+                                  </a:rPr>
+                                </m:ctrlPr>
+                              </m:dPr>
+                              <m:e>
+                                <m:f>
+                                  <m:fPr>
+                                    <m:ctrlPr>
+                                      <a:rPr lang="en-US" i="1">
+                                        <a:latin typeface="Cambria Math" panose="02040503050406030204" pitchFamily="18" charset="0"/>
+                                      </a:rPr>
+                                    </m:ctrlPr>
+                                  </m:fPr>
+                                  <m:num>
+                                    <m:r>
+                                      <a:rPr lang="en-US" i="1">
+                                        <a:latin typeface="Cambria Math" panose="02040503050406030204" pitchFamily="18" charset="0"/>
+                                      </a:rPr>
+                                      <m:t>𝑥</m:t>
+                                    </m:r>
+                                  </m:num>
+                                  <m:den>
+                                    <m:r>
+                                      <a:rPr lang="en-US" i="1">
+                                        <a:latin typeface="Cambria Math" panose="02040503050406030204" pitchFamily="18" charset="0"/>
+                                      </a:rPr>
+                                      <m:t>4.7</m:t>
+                                    </m:r>
+                                  </m:den>
+                                </m:f>
+                              </m:e>
+                            </m:d>
+                          </m:e>
+                          <m:sup>
+                            <m:r>
+                              <a:rPr lang="en-US" i="1">
+                                <a:latin typeface="Cambria Math" panose="02040503050406030204" pitchFamily="18" charset="0"/>
+                              </a:rPr>
+                              <m:t>1.03</m:t>
+                            </m:r>
+                          </m:sup>
+                        </m:sSup>
+                      </m:sup>
+                    </m:sSup>
+                  </m:oMath>
+                </a14:m>
+                <a:r>
+                  <a:rPr lang="en-CA" dirty="0"/>
+                  <a:t> </a:t>
+                </a:r>
+              </a:p>
+            </p:txBody>
+          </p:sp>
+        </mc:Choice>
+        <mc:Fallback>
+          <p:sp>
+            <p:nvSpPr>
+              <p:cNvPr id="2" name="TextBox 1">
+                <a:extLst>
+                  <a:ext uri="{FF2B5EF4-FFF2-40B4-BE49-F238E27FC236}">
+                    <a16:creationId xmlns:a16="http://schemas.microsoft.com/office/drawing/2014/main" id="{DD36C8DD-1C3C-806D-F870-DD8422DDA852}"/>
+                  </a:ext>
+                </a:extLst>
+              </p:cNvPr>
+              <p:cNvSpPr txBox="1">
+                <a:spLocks noRot="1" noChangeAspect="1" noMove="1" noResize="1" noEditPoints="1" noAdjustHandles="1" noChangeArrowheads="1" noChangeShapeType="1" noTextEdit="1"/>
+              </p:cNvSpPr>
+              <p:nvPr/>
+            </p:nvSpPr>
+            <p:spPr>
+              <a:xfrm>
+                <a:off x="8500227" y="2408915"/>
+                <a:ext cx="1781834" cy="436017"/>
+              </a:xfrm>
+              <a:prstGeom prst="rect">
+                <a:avLst/>
+              </a:prstGeom>
+              <a:blipFill>
+                <a:blip r:embed="rId8"/>
+                <a:stretch>
+                  <a:fillRect/>
+                </a:stretch>
+              </a:blipFill>
+            </p:spPr>
+            <p:txBody>
+              <a:bodyPr/>
+              <a:lstStyle/>
+              <a:p>
+                <a:r>
+                  <a:rPr lang="en-CA">
+                    <a:noFill/>
+                  </a:rPr>
+                  <a:t> </a:t>
+                </a:r>
+              </a:p>
+            </p:txBody>
+          </p:sp>
+        </mc:Fallback>
+      </mc:AlternateContent>
+    </p:spTree>
+    <p:extLst>
+      <p:ext uri="{BB962C8B-B14F-4D97-AF65-F5344CB8AC3E}">
+        <p14:creationId xmlns:p14="http://schemas.microsoft.com/office/powerpoint/2010/main" val="504730379"/>
+      </p:ext>
+    </p:extLst>
+  </p:cSld>
+  <p:clrMapOvr>
+    <a:masterClrMapping/>
+  </p:clrMapOvr>
+</p:sld>
+</file>
+
+<file path=ppt/slides/slide7.xml><?xml version="1.0" encoding="utf-8"?>
 <p:sld xmlns:a="http://schemas.openxmlformats.org/drawingml/2006/main" xmlns:r="http://schemas.openxmlformats.org/officeDocument/2006/relationships" xmlns:p="http://schemas.openxmlformats.org/presentationml/2006/main">
   <p:cSld>
     <p:spTree>
@@ -6710,6 +8468,43 @@
           <a:chExt cx="0" cy="0"/>
         </a:xfrm>
       </p:grpSpPr>
+      <p:pic>
+        <p:nvPicPr>
+          <p:cNvPr id="23" name="Graphic 22">
+            <a:extLst>
+              <a:ext uri="{FF2B5EF4-FFF2-40B4-BE49-F238E27FC236}">
+                <a16:creationId xmlns:a16="http://schemas.microsoft.com/office/drawing/2014/main" id="{967A8068-B353-1CDC-3C7C-DFC8F8FDF603}"/>
+              </a:ext>
+            </a:extLst>
+          </p:cNvPr>
+          <p:cNvPicPr>
+            <a:picLocks noChangeAspect="1"/>
+          </p:cNvPicPr>
+          <p:nvPr/>
+        </p:nvPicPr>
+        <p:blipFill>
+          <a:blip>
+            <a:extLst>
+              <a:ext uri="{96DAC541-7B7A-43D3-8B79-37D633B846F1}">
+                <asvg:svgBlip xmlns:asvg="http://schemas.microsoft.com/office/drawing/2016/SVG/main" r:embed="rId3"/>
+              </a:ext>
+            </a:extLst>
+          </a:blip>
+          <a:srcRect l="6241" t="9629" r="8503" b="4913"/>
+          <a:stretch>
+            <a:fillRect/>
+          </a:stretch>
+        </p:blipFill>
+        <p:spPr>
+          <a:xfrm>
+            <a:off x="4793645" y="1139403"/>
+            <a:ext cx="6655041" cy="5008551"/>
+          </a:xfrm>
+          <a:prstGeom prst="rect">
+            <a:avLst/>
+          </a:prstGeom>
+        </p:spPr>
+      </p:pic>
       <p:sp>
         <p:nvSpPr>
           <p:cNvPr id="7" name="Slide Number Placeholder 6">
@@ -6734,12 +8529,994 @@
             <a:fld id="{3899FC77-40C7-4C49-9A19-86BDE9B75E8A}" type="slidenum">
               <a:rPr lang="en-CA" smtClean="0"/>
               <a:pPr/>
-              <a:t>6</a:t>
+              <a:t>7</a:t>
             </a:fld>
             <a:endParaRPr lang="en-CA" sz="1400"/>
           </a:p>
         </p:txBody>
       </p:sp>
+      <p:sp>
+        <p:nvSpPr>
+          <p:cNvPr id="3" name="Rectangle: Rounded Corners 2">
+            <a:extLst>
+              <a:ext uri="{FF2B5EF4-FFF2-40B4-BE49-F238E27FC236}">
+                <a16:creationId xmlns:a16="http://schemas.microsoft.com/office/drawing/2014/main" id="{442B14E4-856D-402A-DFFD-8A5A8E43FDB7}"/>
+              </a:ext>
+            </a:extLst>
+          </p:cNvPr>
+          <p:cNvSpPr/>
+          <p:nvPr/>
+        </p:nvSpPr>
+        <p:spPr>
+          <a:xfrm>
+            <a:off x="315257" y="267370"/>
+            <a:ext cx="9363581" cy="628742"/>
+          </a:xfrm>
+          <a:prstGeom prst="roundRect">
+            <a:avLst/>
+          </a:prstGeom>
+          <a:solidFill>
+            <a:srgbClr val="0162B3"/>
+          </a:solidFill>
+          <a:ln>
+            <a:solidFill>
+              <a:srgbClr val="0162B3"/>
+            </a:solidFill>
+          </a:ln>
+        </p:spPr>
+        <p:style>
+          <a:lnRef idx="2">
+            <a:schemeClr val="accent1">
+              <a:shade val="50000"/>
+            </a:schemeClr>
+          </a:lnRef>
+          <a:fillRef idx="1">
+            <a:schemeClr val="accent1"/>
+          </a:fillRef>
+          <a:effectRef idx="0">
+            <a:schemeClr val="accent1"/>
+          </a:effectRef>
+          <a:fontRef idx="minor">
+            <a:schemeClr val="lt1"/>
+          </a:fontRef>
+        </p:style>
+        <p:txBody>
+          <a:bodyPr rtlCol="0" anchor="ctr"/>
+          <a:lstStyle>
+            <a:defPPr>
+              <a:defRPr lang="en-US"/>
+            </a:defPPr>
+            <a:lvl1pPr marL="0" algn="l" defTabSz="914400" rtl="0" eaLnBrk="1" latinLnBrk="0" hangingPunct="1">
+              <a:defRPr sz="1800" kern="1200">
+                <a:solidFill>
+                  <a:schemeClr val="lt1"/>
+                </a:solidFill>
+                <a:latin typeface="+mn-lt"/>
+                <a:ea typeface="+mn-ea"/>
+                <a:cs typeface="+mn-cs"/>
+              </a:defRPr>
+            </a:lvl1pPr>
+            <a:lvl2pPr marL="457200" algn="l" defTabSz="914400" rtl="0" eaLnBrk="1" latinLnBrk="0" hangingPunct="1">
+              <a:defRPr sz="1800" kern="1200">
+                <a:solidFill>
+                  <a:schemeClr val="lt1"/>
+                </a:solidFill>
+                <a:latin typeface="+mn-lt"/>
+                <a:ea typeface="+mn-ea"/>
+                <a:cs typeface="+mn-cs"/>
+              </a:defRPr>
+            </a:lvl2pPr>
+            <a:lvl3pPr marL="914400" algn="l" defTabSz="914400" rtl="0" eaLnBrk="1" latinLnBrk="0" hangingPunct="1">
+              <a:defRPr sz="1800" kern="1200">
+                <a:solidFill>
+                  <a:schemeClr val="lt1"/>
+                </a:solidFill>
+                <a:latin typeface="+mn-lt"/>
+                <a:ea typeface="+mn-ea"/>
+                <a:cs typeface="+mn-cs"/>
+              </a:defRPr>
+            </a:lvl3pPr>
+            <a:lvl4pPr marL="1371600" algn="l" defTabSz="914400" rtl="0" eaLnBrk="1" latinLnBrk="0" hangingPunct="1">
+              <a:defRPr sz="1800" kern="1200">
+                <a:solidFill>
+                  <a:schemeClr val="lt1"/>
+                </a:solidFill>
+                <a:latin typeface="+mn-lt"/>
+                <a:ea typeface="+mn-ea"/>
+                <a:cs typeface="+mn-cs"/>
+              </a:defRPr>
+            </a:lvl4pPr>
+            <a:lvl5pPr marL="1828800" algn="l" defTabSz="914400" rtl="0" eaLnBrk="1" latinLnBrk="0" hangingPunct="1">
+              <a:defRPr sz="1800" kern="1200">
+                <a:solidFill>
+                  <a:schemeClr val="lt1"/>
+                </a:solidFill>
+                <a:latin typeface="+mn-lt"/>
+                <a:ea typeface="+mn-ea"/>
+                <a:cs typeface="+mn-cs"/>
+              </a:defRPr>
+            </a:lvl5pPr>
+            <a:lvl6pPr marL="2286000" algn="l" defTabSz="914400" rtl="0" eaLnBrk="1" latinLnBrk="0" hangingPunct="1">
+              <a:defRPr sz="1800" kern="1200">
+                <a:solidFill>
+                  <a:schemeClr val="lt1"/>
+                </a:solidFill>
+                <a:latin typeface="+mn-lt"/>
+                <a:ea typeface="+mn-ea"/>
+                <a:cs typeface="+mn-cs"/>
+              </a:defRPr>
+            </a:lvl6pPr>
+            <a:lvl7pPr marL="2743200" algn="l" defTabSz="914400" rtl="0" eaLnBrk="1" latinLnBrk="0" hangingPunct="1">
+              <a:defRPr sz="1800" kern="1200">
+                <a:solidFill>
+                  <a:schemeClr val="lt1"/>
+                </a:solidFill>
+                <a:latin typeface="+mn-lt"/>
+                <a:ea typeface="+mn-ea"/>
+                <a:cs typeface="+mn-cs"/>
+              </a:defRPr>
+            </a:lvl7pPr>
+            <a:lvl8pPr marL="3200400" algn="l" defTabSz="914400" rtl="0" eaLnBrk="1" latinLnBrk="0" hangingPunct="1">
+              <a:defRPr sz="1800" kern="1200">
+                <a:solidFill>
+                  <a:schemeClr val="lt1"/>
+                </a:solidFill>
+                <a:latin typeface="+mn-lt"/>
+                <a:ea typeface="+mn-ea"/>
+                <a:cs typeface="+mn-cs"/>
+              </a:defRPr>
+            </a:lvl8pPr>
+            <a:lvl9pPr marL="3657600" algn="l" defTabSz="914400" rtl="0" eaLnBrk="1" latinLnBrk="0" hangingPunct="1">
+              <a:defRPr sz="1800" kern="1200">
+                <a:solidFill>
+                  <a:schemeClr val="lt1"/>
+                </a:solidFill>
+                <a:latin typeface="+mn-lt"/>
+                <a:ea typeface="+mn-ea"/>
+                <a:cs typeface="+mn-cs"/>
+              </a:defRPr>
+            </a:lvl9pPr>
+          </a:lstStyle>
+          <a:p>
+            <a:pPr algn="ctr"/>
+            <a:endParaRPr lang="en-CA"/>
+          </a:p>
+        </p:txBody>
+      </p:sp>
+      <p:sp>
+        <p:nvSpPr>
+          <p:cNvPr id="5" name="TextBox 4">
+            <a:extLst>
+              <a:ext uri="{FF2B5EF4-FFF2-40B4-BE49-F238E27FC236}">
+                <a16:creationId xmlns:a16="http://schemas.microsoft.com/office/drawing/2014/main" id="{590F4D52-2E6A-8BEB-1540-5BF836ADC76F}"/>
+              </a:ext>
+            </a:extLst>
+          </p:cNvPr>
+          <p:cNvSpPr txBox="1"/>
+          <p:nvPr/>
+        </p:nvSpPr>
+        <p:spPr>
+          <a:xfrm>
+            <a:off x="527959" y="335519"/>
+            <a:ext cx="8710932" cy="492443"/>
+          </a:xfrm>
+          <a:prstGeom prst="rect">
+            <a:avLst/>
+          </a:prstGeom>
+          <a:noFill/>
+        </p:spPr>
+        <p:txBody>
+          <a:bodyPr wrap="square" rtlCol="0">
+            <a:spAutoFit/>
+          </a:bodyPr>
+          <a:lstStyle/>
+          <a:p>
+            <a:r>
+              <a:rPr lang="en-US" sz="2600" b="1" dirty="0">
+                <a:solidFill>
+                  <a:schemeClr val="bg1"/>
+                </a:solidFill>
+                <a:latin typeface="Georgia Pro" panose="02040502050405020303" pitchFamily="18" charset="0"/>
+              </a:rPr>
+              <a:t>Composite score: PyMOL RMSD term</a:t>
+            </a:r>
+            <a:endParaRPr lang="en-CA" sz="2600" b="1" dirty="0">
+              <a:solidFill>
+                <a:schemeClr val="bg1"/>
+              </a:solidFill>
+              <a:latin typeface="Georgia Pro" panose="02040502050405020303" pitchFamily="18" charset="0"/>
+            </a:endParaRPr>
+          </a:p>
+        </p:txBody>
+      </p:sp>
+      <p:graphicFrame>
+        <p:nvGraphicFramePr>
+          <p:cNvPr id="6" name="Table 5">
+            <a:extLst>
+              <a:ext uri="{FF2B5EF4-FFF2-40B4-BE49-F238E27FC236}">
+                <a16:creationId xmlns:a16="http://schemas.microsoft.com/office/drawing/2014/main" id="{5961428E-01B6-1C03-00A6-2B882249CA4B}"/>
+              </a:ext>
+            </a:extLst>
+          </p:cNvPr>
+          <p:cNvGraphicFramePr>
+            <a:graphicFrameLocks noGrp="1"/>
+          </p:cNvGraphicFramePr>
+          <p:nvPr>
+            <p:extLst>
+              <p:ext uri="{D42A27DB-BD31-4B8C-83A1-F6EECF244321}">
+                <p14:modId xmlns:p14="http://schemas.microsoft.com/office/powerpoint/2010/main" val="2945173442"/>
+              </p:ext>
+            </p:extLst>
+          </p:nvPr>
+        </p:nvGraphicFramePr>
+        <p:xfrm>
+          <a:off x="1190445" y="1261081"/>
+          <a:ext cx="2960626" cy="2133600"/>
+        </p:xfrm>
+        <a:graphic>
+          <a:graphicData uri="http://schemas.openxmlformats.org/drawingml/2006/table">
+            <a:tbl>
+              <a:tblPr firstRow="1" bandRow="1">
+                <a:tableStyleId>{5940675A-B579-460E-94D1-54222C63F5DA}</a:tableStyleId>
+              </a:tblPr>
+              <a:tblGrid>
+                <a:gridCol w="1725283">
+                  <a:extLst>
+                    <a:ext uri="{9D8B030D-6E8A-4147-A177-3AD203B41FA5}">
+                      <a16:colId xmlns:a16="http://schemas.microsoft.com/office/drawing/2014/main" val="1869778181"/>
+                    </a:ext>
+                  </a:extLst>
+                </a:gridCol>
+                <a:gridCol w="1235343">
+                  <a:extLst>
+                    <a:ext uri="{9D8B030D-6E8A-4147-A177-3AD203B41FA5}">
+                      <a16:colId xmlns:a16="http://schemas.microsoft.com/office/drawing/2014/main" val="2700513838"/>
+                    </a:ext>
+                  </a:extLst>
+                </a:gridCol>
+              </a:tblGrid>
+              <a:tr h="180542">
+                <a:tc>
+                  <a:txBody>
+                    <a:bodyPr/>
+                    <a:lstStyle/>
+                    <a:p>
+                      <a:r>
+                        <a:rPr lang="en-US" sz="1400" dirty="0">
+                          <a:latin typeface="Verdana Pro" panose="020B0604030504040204" pitchFamily="34" charset="0"/>
+                        </a:rPr>
+                        <a:t>PyMOL RMSD (Å)</a:t>
+                      </a:r>
+                      <a:endParaRPr lang="en-CA" sz="1400" dirty="0">
+                        <a:latin typeface="Verdana Pro" panose="020B0604030504040204" pitchFamily="34" charset="0"/>
+                      </a:endParaRPr>
+                    </a:p>
+                  </a:txBody>
+                  <a:tcPr marL="45720" marR="45720"/>
+                </a:tc>
+                <a:tc>
+                  <a:txBody>
+                    <a:bodyPr/>
+                    <a:lstStyle/>
+                    <a:p>
+                      <a:pPr algn="ctr"/>
+                      <a:r>
+                        <a:rPr lang="en-US" sz="1400" dirty="0">
+                          <a:latin typeface="Verdana Pro" panose="020B0604030504040204" pitchFamily="34" charset="0"/>
+                        </a:rPr>
+                        <a:t>Score</a:t>
+                      </a:r>
+                      <a:endParaRPr lang="en-CA" sz="1400" dirty="0">
+                        <a:latin typeface="Verdana Pro" panose="020B0604030504040204" pitchFamily="34" charset="0"/>
+                      </a:endParaRPr>
+                    </a:p>
+                  </a:txBody>
+                  <a:tcPr marL="45720" marR="45720"/>
+                </a:tc>
+                <a:extLst>
+                  <a:ext uri="{0D108BD9-81ED-4DB2-BD59-A6C34878D82A}">
+                    <a16:rowId xmlns:a16="http://schemas.microsoft.com/office/drawing/2014/main" val="2202861222"/>
+                  </a:ext>
+                </a:extLst>
+              </a:tr>
+              <a:tr h="180542">
+                <a:tc>
+                  <a:txBody>
+                    <a:bodyPr/>
+                    <a:lstStyle/>
+                    <a:p>
+                      <a:r>
+                        <a:rPr lang="en-US" sz="1400" dirty="0">
+                          <a:latin typeface="Verdana Pro" panose="020B0604030504040204" pitchFamily="34" charset="0"/>
+                        </a:rPr>
+                        <a:t>0.0</a:t>
+                      </a:r>
+                      <a:endParaRPr lang="en-CA" sz="1400" dirty="0">
+                        <a:latin typeface="Verdana Pro" panose="020B0604030504040204" pitchFamily="34" charset="0"/>
+                      </a:endParaRPr>
+                    </a:p>
+                  </a:txBody>
+                  <a:tcPr marL="45720" marR="45720"/>
+                </a:tc>
+                <a:tc>
+                  <a:txBody>
+                    <a:bodyPr/>
+                    <a:lstStyle/>
+                    <a:p>
+                      <a:r>
+                        <a:rPr lang="en-US" sz="1400" dirty="0">
+                          <a:latin typeface="Verdana Pro" panose="020B0604030504040204" pitchFamily="34" charset="0"/>
+                        </a:rPr>
+                        <a:t>1.0</a:t>
+                      </a:r>
+                      <a:endParaRPr lang="en-CA" sz="1400" dirty="0">
+                        <a:latin typeface="Verdana Pro" panose="020B0604030504040204" pitchFamily="34" charset="0"/>
+                      </a:endParaRPr>
+                    </a:p>
+                  </a:txBody>
+                  <a:tcPr marL="45720" marR="45720"/>
+                </a:tc>
+                <a:extLst>
+                  <a:ext uri="{0D108BD9-81ED-4DB2-BD59-A6C34878D82A}">
+                    <a16:rowId xmlns:a16="http://schemas.microsoft.com/office/drawing/2014/main" val="4031372816"/>
+                  </a:ext>
+                </a:extLst>
+              </a:tr>
+              <a:tr h="180542">
+                <a:tc>
+                  <a:txBody>
+                    <a:bodyPr/>
+                    <a:lstStyle/>
+                    <a:p>
+                      <a:r>
+                        <a:rPr lang="en-US" sz="1400" dirty="0">
+                          <a:latin typeface="Verdana Pro" panose="020B0604030504040204" pitchFamily="34" charset="0"/>
+                        </a:rPr>
+                        <a:t>1.0</a:t>
+                      </a:r>
+                      <a:endParaRPr lang="en-CA" sz="1400" dirty="0">
+                        <a:latin typeface="Verdana Pro" panose="020B0604030504040204" pitchFamily="34" charset="0"/>
+                      </a:endParaRPr>
+                    </a:p>
+                  </a:txBody>
+                  <a:tcPr marL="45720" marR="45720"/>
+                </a:tc>
+                <a:tc>
+                  <a:txBody>
+                    <a:bodyPr/>
+                    <a:lstStyle/>
+                    <a:p>
+                      <a:r>
+                        <a:rPr lang="en-US" sz="1400" dirty="0">
+                          <a:latin typeface="Verdana Pro" panose="020B0604030504040204" pitchFamily="34" charset="0"/>
+                        </a:rPr>
+                        <a:t>0.99</a:t>
+                      </a:r>
+                      <a:endParaRPr lang="en-CA" sz="1400" dirty="0">
+                        <a:latin typeface="Verdana Pro" panose="020B0604030504040204" pitchFamily="34" charset="0"/>
+                      </a:endParaRPr>
+                    </a:p>
+                  </a:txBody>
+                  <a:tcPr marL="45720" marR="45720"/>
+                </a:tc>
+                <a:extLst>
+                  <a:ext uri="{0D108BD9-81ED-4DB2-BD59-A6C34878D82A}">
+                    <a16:rowId xmlns:a16="http://schemas.microsoft.com/office/drawing/2014/main" val="3424690894"/>
+                  </a:ext>
+                </a:extLst>
+              </a:tr>
+              <a:tr h="180542">
+                <a:tc>
+                  <a:txBody>
+                    <a:bodyPr/>
+                    <a:lstStyle/>
+                    <a:p>
+                      <a:r>
+                        <a:rPr lang="en-US" sz="1400" dirty="0">
+                          <a:latin typeface="Verdana Pro" panose="020B0604030504040204" pitchFamily="34" charset="0"/>
+                        </a:rPr>
+                        <a:t>2.9</a:t>
+                      </a:r>
+                      <a:endParaRPr lang="en-CA" sz="1400" dirty="0">
+                        <a:latin typeface="Verdana Pro" panose="020B0604030504040204" pitchFamily="34" charset="0"/>
+                      </a:endParaRPr>
+                    </a:p>
+                  </a:txBody>
+                  <a:tcPr marL="45720" marR="45720"/>
+                </a:tc>
+                <a:tc>
+                  <a:txBody>
+                    <a:bodyPr/>
+                    <a:lstStyle/>
+                    <a:p>
+                      <a:r>
+                        <a:rPr lang="en-US" sz="1400" dirty="0">
+                          <a:latin typeface="Verdana Pro" panose="020B0604030504040204" pitchFamily="34" charset="0"/>
+                        </a:rPr>
+                        <a:t>0.85</a:t>
+                      </a:r>
+                      <a:endParaRPr lang="en-CA" sz="1400" dirty="0">
+                        <a:latin typeface="Verdana Pro" panose="020B0604030504040204" pitchFamily="34" charset="0"/>
+                      </a:endParaRPr>
+                    </a:p>
+                  </a:txBody>
+                  <a:tcPr marL="45720" marR="45720"/>
+                </a:tc>
+                <a:extLst>
+                  <a:ext uri="{0D108BD9-81ED-4DB2-BD59-A6C34878D82A}">
+                    <a16:rowId xmlns:a16="http://schemas.microsoft.com/office/drawing/2014/main" val="3156004181"/>
+                  </a:ext>
+                </a:extLst>
+              </a:tr>
+              <a:tr h="180542">
+                <a:tc>
+                  <a:txBody>
+                    <a:bodyPr/>
+                    <a:lstStyle/>
+                    <a:p>
+                      <a:r>
+                        <a:rPr lang="en-US" sz="1400" dirty="0">
+                          <a:latin typeface="Verdana Pro" panose="020B0604030504040204" pitchFamily="34" charset="0"/>
+                        </a:rPr>
+                        <a:t>4.0</a:t>
+                      </a:r>
+                      <a:endParaRPr lang="en-CA" sz="1400" dirty="0">
+                        <a:latin typeface="Verdana Pro" panose="020B0604030504040204" pitchFamily="34" charset="0"/>
+                      </a:endParaRPr>
+                    </a:p>
+                  </a:txBody>
+                  <a:tcPr marL="45720" marR="45720"/>
+                </a:tc>
+                <a:tc>
+                  <a:txBody>
+                    <a:bodyPr/>
+                    <a:lstStyle/>
+                    <a:p>
+                      <a:r>
+                        <a:rPr lang="en-US" sz="1400" dirty="0">
+                          <a:latin typeface="Verdana Pro" panose="020B0604030504040204" pitchFamily="34" charset="0"/>
+                        </a:rPr>
+                        <a:t>0.70</a:t>
+                      </a:r>
+                      <a:endParaRPr lang="en-CA" sz="1400" dirty="0">
+                        <a:latin typeface="Verdana Pro" panose="020B0604030504040204" pitchFamily="34" charset="0"/>
+                      </a:endParaRPr>
+                    </a:p>
+                  </a:txBody>
+                  <a:tcPr marL="45720" marR="45720"/>
+                </a:tc>
+                <a:extLst>
+                  <a:ext uri="{0D108BD9-81ED-4DB2-BD59-A6C34878D82A}">
+                    <a16:rowId xmlns:a16="http://schemas.microsoft.com/office/drawing/2014/main" val="1804626572"/>
+                  </a:ext>
+                </a:extLst>
+              </a:tr>
+              <a:tr h="180542">
+                <a:tc>
+                  <a:txBody>
+                    <a:bodyPr/>
+                    <a:lstStyle/>
+                    <a:p>
+                      <a:r>
+                        <a:rPr lang="en-US" sz="1400" dirty="0">
+                          <a:latin typeface="Verdana Pro" panose="020B0604030504040204" pitchFamily="34" charset="0"/>
+                        </a:rPr>
+                        <a:t>5.0</a:t>
+                      </a:r>
+                      <a:endParaRPr lang="en-CA" sz="1400" dirty="0">
+                        <a:latin typeface="Verdana Pro" panose="020B0604030504040204" pitchFamily="34" charset="0"/>
+                      </a:endParaRPr>
+                    </a:p>
+                  </a:txBody>
+                  <a:tcPr marL="45720" marR="45720"/>
+                </a:tc>
+                <a:tc>
+                  <a:txBody>
+                    <a:bodyPr/>
+                    <a:lstStyle/>
+                    <a:p>
+                      <a:r>
+                        <a:rPr lang="en-US" sz="1400" dirty="0">
+                          <a:latin typeface="Verdana Pro" panose="020B0604030504040204" pitchFamily="34" charset="0"/>
+                        </a:rPr>
+                        <a:t>0.50</a:t>
+                      </a:r>
+                      <a:endParaRPr lang="en-CA" sz="1400" dirty="0">
+                        <a:latin typeface="Verdana Pro" panose="020B0604030504040204" pitchFamily="34" charset="0"/>
+                      </a:endParaRPr>
+                    </a:p>
+                  </a:txBody>
+                  <a:tcPr marL="45720" marR="45720"/>
+                </a:tc>
+                <a:extLst>
+                  <a:ext uri="{0D108BD9-81ED-4DB2-BD59-A6C34878D82A}">
+                    <a16:rowId xmlns:a16="http://schemas.microsoft.com/office/drawing/2014/main" val="1030796854"/>
+                  </a:ext>
+                </a:extLst>
+              </a:tr>
+              <a:tr h="180542">
+                <a:tc>
+                  <a:txBody>
+                    <a:bodyPr/>
+                    <a:lstStyle/>
+                    <a:p>
+                      <a:r>
+                        <a:rPr lang="en-US" sz="1400" dirty="0">
+                          <a:latin typeface="Verdana Pro" panose="020B0604030504040204" pitchFamily="34" charset="0"/>
+                        </a:rPr>
+                        <a:t>10.0</a:t>
+                      </a:r>
+                      <a:endParaRPr lang="en-CA" sz="1400" dirty="0">
+                        <a:latin typeface="Verdana Pro" panose="020B0604030504040204" pitchFamily="34" charset="0"/>
+                      </a:endParaRPr>
+                    </a:p>
+                  </a:txBody>
+                  <a:tcPr marL="45720" marR="45720"/>
+                </a:tc>
+                <a:tc>
+                  <a:txBody>
+                    <a:bodyPr/>
+                    <a:lstStyle/>
+                    <a:p>
+                      <a:r>
+                        <a:rPr lang="en-US" sz="1400" dirty="0">
+                          <a:latin typeface="Verdana Pro" panose="020B0604030504040204" pitchFamily="34" charset="0"/>
+                        </a:rPr>
+                        <a:t>0.10</a:t>
+                      </a:r>
+                      <a:endParaRPr lang="en-CA" sz="1400" dirty="0">
+                        <a:latin typeface="Verdana Pro" panose="020B0604030504040204" pitchFamily="34" charset="0"/>
+                      </a:endParaRPr>
+                    </a:p>
+                  </a:txBody>
+                  <a:tcPr marL="45720" marR="45720"/>
+                </a:tc>
+                <a:extLst>
+                  <a:ext uri="{0D108BD9-81ED-4DB2-BD59-A6C34878D82A}">
+                    <a16:rowId xmlns:a16="http://schemas.microsoft.com/office/drawing/2014/main" val="430053759"/>
+                  </a:ext>
+                </a:extLst>
+              </a:tr>
+            </a:tbl>
+          </a:graphicData>
+        </a:graphic>
+      </p:graphicFrame>
+      <p:grpSp>
+        <p:nvGrpSpPr>
+          <p:cNvPr id="13" name="Group 12">
+            <a:extLst>
+              <a:ext uri="{FF2B5EF4-FFF2-40B4-BE49-F238E27FC236}">
+                <a16:creationId xmlns:a16="http://schemas.microsoft.com/office/drawing/2014/main" id="{36B914A4-20DD-0D31-9993-BBB41C5593B5}"/>
+              </a:ext>
+            </a:extLst>
+          </p:cNvPr>
+          <p:cNvGrpSpPr/>
+          <p:nvPr/>
+        </p:nvGrpSpPr>
+        <p:grpSpPr>
+          <a:xfrm>
+            <a:off x="527959" y="3301586"/>
+            <a:ext cx="3337558" cy="3001835"/>
+            <a:chOff x="343293" y="3300621"/>
+            <a:chExt cx="3337558" cy="3001835"/>
+          </a:xfrm>
+        </p:grpSpPr>
+        <p:sp>
+          <p:nvSpPr>
+            <p:cNvPr id="10" name="TextBox 9">
+              <a:extLst>
+                <a:ext uri="{FF2B5EF4-FFF2-40B4-BE49-F238E27FC236}">
+                  <a16:creationId xmlns:a16="http://schemas.microsoft.com/office/drawing/2014/main" id="{06D282AF-44C7-0962-2088-56007AE8F1E1}"/>
+                </a:ext>
+              </a:extLst>
+            </p:cNvPr>
+            <p:cNvSpPr txBox="1"/>
+            <p:nvPr/>
+          </p:nvSpPr>
+          <p:spPr>
+            <a:xfrm>
+              <a:off x="1274081" y="5994679"/>
+              <a:ext cx="2406770" cy="307777"/>
+            </a:xfrm>
+            <a:prstGeom prst="rect">
+              <a:avLst/>
+            </a:prstGeom>
+            <a:noFill/>
+          </p:spPr>
+          <p:txBody>
+            <a:bodyPr wrap="square" rtlCol="0">
+              <a:spAutoFit/>
+            </a:bodyPr>
+            <a:lstStyle/>
+            <a:p>
+              <a:pPr algn="ctr"/>
+              <a:r>
+                <a:rPr lang="en-US" sz="1400" dirty="0">
+                  <a:latin typeface="Verdana Pro" panose="020B0604030504040204" pitchFamily="34" charset="0"/>
+                </a:rPr>
+                <a:t>PyMOL RMSD (Å)</a:t>
+              </a:r>
+            </a:p>
+          </p:txBody>
+        </p:sp>
+        <p:sp>
+          <p:nvSpPr>
+            <p:cNvPr id="12" name="TextBox 11">
+              <a:extLst>
+                <a:ext uri="{FF2B5EF4-FFF2-40B4-BE49-F238E27FC236}">
+                  <a16:creationId xmlns:a16="http://schemas.microsoft.com/office/drawing/2014/main" id="{54B2B035-6C0B-348D-D20D-4473D607D0D5}"/>
+                </a:ext>
+              </a:extLst>
+            </p:cNvPr>
+            <p:cNvSpPr txBox="1"/>
+            <p:nvPr/>
+          </p:nvSpPr>
+          <p:spPr>
+            <a:xfrm rot="16200000">
+              <a:off x="-675426" y="4319340"/>
+              <a:ext cx="2406770" cy="369332"/>
+            </a:xfrm>
+            <a:prstGeom prst="rect">
+              <a:avLst/>
+            </a:prstGeom>
+            <a:noFill/>
+          </p:spPr>
+          <p:txBody>
+            <a:bodyPr wrap="square" rtlCol="0">
+              <a:spAutoFit/>
+            </a:bodyPr>
+            <a:lstStyle/>
+            <a:p>
+              <a:pPr algn="ctr"/>
+              <a:r>
+                <a:rPr lang="en-US" dirty="0">
+                  <a:latin typeface="Verdana Pro" panose="020B0604030504040204" pitchFamily="34" charset="0"/>
+                </a:rPr>
+                <a:t>Score</a:t>
+              </a:r>
+              <a:endParaRPr lang="en-CA" dirty="0">
+                <a:latin typeface="Verdana Pro" panose="020B0604030504040204" pitchFamily="34" charset="0"/>
+              </a:endParaRPr>
+            </a:p>
+          </p:txBody>
+        </p:sp>
+      </p:grpSp>
+      <p:sp>
+        <p:nvSpPr>
+          <p:cNvPr id="17" name="TextBox 16">
+            <a:extLst>
+              <a:ext uri="{FF2B5EF4-FFF2-40B4-BE49-F238E27FC236}">
+                <a16:creationId xmlns:a16="http://schemas.microsoft.com/office/drawing/2014/main" id="{A91EED7C-D74A-CD8A-5951-A8369EB6ECC3}"/>
+              </a:ext>
+            </a:extLst>
+          </p:cNvPr>
+          <p:cNvSpPr txBox="1"/>
+          <p:nvPr/>
+        </p:nvSpPr>
+        <p:spPr>
+          <a:xfrm rot="16200000">
+            <a:off x="3495374" y="3040720"/>
+            <a:ext cx="2406770" cy="369332"/>
+          </a:xfrm>
+          <a:prstGeom prst="rect">
+            <a:avLst/>
+          </a:prstGeom>
+          <a:noFill/>
+        </p:spPr>
+        <p:txBody>
+          <a:bodyPr wrap="square" rtlCol="0">
+            <a:spAutoFit/>
+          </a:bodyPr>
+          <a:lstStyle/>
+          <a:p>
+            <a:pPr algn="ctr"/>
+            <a:r>
+              <a:rPr lang="en-US" dirty="0">
+                <a:latin typeface="Verdana Pro" panose="020B0604030504040204" pitchFamily="34" charset="0"/>
+              </a:rPr>
+              <a:t>Score</a:t>
+            </a:r>
+            <a:endParaRPr lang="en-CA" dirty="0">
+              <a:latin typeface="Verdana Pro" panose="020B0604030504040204" pitchFamily="34" charset="0"/>
+            </a:endParaRPr>
+          </a:p>
+        </p:txBody>
+      </p:sp>
+      <mc:AlternateContent xmlns:mc="http://schemas.openxmlformats.org/markup-compatibility/2006">
+        <mc:Choice xmlns:a14="http://schemas.microsoft.com/office/drawing/2010/main" Requires="a14">
+          <p:sp>
+            <p:nvSpPr>
+              <p:cNvPr id="19" name="TextBox 18">
+                <a:extLst>
+                  <a:ext uri="{FF2B5EF4-FFF2-40B4-BE49-F238E27FC236}">
+                    <a16:creationId xmlns:a16="http://schemas.microsoft.com/office/drawing/2014/main" id="{8ED2AD62-7D1A-8501-E1B2-BFFD6ECC1704}"/>
+                  </a:ext>
+                </a:extLst>
+              </p:cNvPr>
+              <p:cNvSpPr txBox="1"/>
+              <p:nvPr/>
+            </p:nvSpPr>
+            <p:spPr>
+              <a:xfrm>
+                <a:off x="7103180" y="6047961"/>
+                <a:ext cx="2406770" cy="408382"/>
+              </a:xfrm>
+              <a:prstGeom prst="rect">
+                <a:avLst/>
+              </a:prstGeom>
+              <a:noFill/>
+            </p:spPr>
+            <p:txBody>
+              <a:bodyPr wrap="square" rtlCol="0">
+                <a:spAutoFit/>
+              </a:bodyPr>
+              <a:lstStyle/>
+              <a:p>
+                <a:pPr algn="ctr"/>
+                <a14:m>
+                  <m:oMathPara xmlns:m="http://schemas.openxmlformats.org/officeDocument/2006/math">
+                    <m:oMath>
+                      <m:r>
+                        <m:rPr>
+                          <m:nor/>
+                        </m:rPr>
+                        <a:rPr lang="en-US" dirty="0">
+                          <a:latin typeface="Verdana Pro" panose="020B0604030504040204" pitchFamily="34" charset="0"/>
+                        </a:rPr>
+                        <m:t>PyMOL RMSD (Å)</m:t>
+                      </m:r>
+                    </m:oMath>
+                  </m:oMathPara>
+                </a14:m>
+                <a:endParaRPr lang="en-US" dirty="0">
+                  <a:latin typeface="Verdana Pro" panose="020B0604030504040204" pitchFamily="34" charset="0"/>
+                </a:endParaRPr>
+              </a:p>
+            </p:txBody>
+          </p:sp>
+        </mc:Choice>
+        <mc:Fallback>
+          <p:sp>
+            <p:nvSpPr>
+              <p:cNvPr id="19" name="TextBox 18">
+                <a:extLst>
+                  <a:ext uri="{FF2B5EF4-FFF2-40B4-BE49-F238E27FC236}">
+                    <a16:creationId xmlns:a16="http://schemas.microsoft.com/office/drawing/2014/main" id="{8ED2AD62-7D1A-8501-E1B2-BFFD6ECC1704}"/>
+                  </a:ext>
+                </a:extLst>
+              </p:cNvPr>
+              <p:cNvSpPr txBox="1">
+                <a:spLocks noRot="1" noChangeAspect="1" noMove="1" noResize="1" noEditPoints="1" noAdjustHandles="1" noChangeArrowheads="1" noChangeShapeType="1" noTextEdit="1"/>
+              </p:cNvSpPr>
+              <p:nvPr/>
+            </p:nvSpPr>
+            <p:spPr>
+              <a:xfrm>
+                <a:off x="7103180" y="6047961"/>
+                <a:ext cx="2406770" cy="408382"/>
+              </a:xfrm>
+              <a:prstGeom prst="rect">
+                <a:avLst/>
+              </a:prstGeom>
+              <a:blipFill>
+                <a:blip r:embed="rId4"/>
+                <a:stretch>
+                  <a:fillRect b="-22388"/>
+                </a:stretch>
+              </a:blipFill>
+            </p:spPr>
+            <p:txBody>
+              <a:bodyPr/>
+              <a:lstStyle/>
+              <a:p>
+                <a:r>
+                  <a:rPr lang="en-CA">
+                    <a:noFill/>
+                  </a:rPr>
+                  <a:t> </a:t>
+                </a:r>
+              </a:p>
+            </p:txBody>
+          </p:sp>
+        </mc:Fallback>
+      </mc:AlternateContent>
+      <p:pic>
+        <p:nvPicPr>
+          <p:cNvPr id="21" name="Graphic 20">
+            <a:extLst>
+              <a:ext uri="{FF2B5EF4-FFF2-40B4-BE49-F238E27FC236}">
+                <a16:creationId xmlns:a16="http://schemas.microsoft.com/office/drawing/2014/main" id="{83B545E8-BFCA-1657-95A6-E53E8B798FAE}"/>
+              </a:ext>
+            </a:extLst>
+          </p:cNvPr>
+          <p:cNvPicPr>
+            <a:picLocks noChangeAspect="1"/>
+          </p:cNvPicPr>
+          <p:nvPr/>
+        </p:nvPicPr>
+        <p:blipFill>
+          <a:blip>
+            <a:extLst>
+              <a:ext uri="{96DAC541-7B7A-43D3-8B79-37D633B846F1}">
+                <asvg:svgBlip xmlns:asvg="http://schemas.microsoft.com/office/drawing/2016/SVG/main" r:embed="rId5"/>
+              </a:ext>
+            </a:extLst>
+          </a:blip>
+          <a:srcRect l="5651" t="9825" r="8650" b="5109"/>
+          <a:stretch>
+            <a:fillRect/>
+          </a:stretch>
+        </p:blipFill>
+        <p:spPr>
+          <a:xfrm>
+            <a:off x="897291" y="3532163"/>
+            <a:ext cx="3288284" cy="2450649"/>
+          </a:xfrm>
+          <a:prstGeom prst="rect">
+            <a:avLst/>
+          </a:prstGeom>
+        </p:spPr>
+      </p:pic>
+      <mc:AlternateContent xmlns:mc="http://schemas.openxmlformats.org/markup-compatibility/2006">
+        <mc:Choice xmlns:a14="http://schemas.microsoft.com/office/drawing/2010/main" Requires="a14">
+          <p:sp>
+            <p:nvSpPr>
+              <p:cNvPr id="27" name="TextBox 26">
+                <a:extLst>
+                  <a:ext uri="{FF2B5EF4-FFF2-40B4-BE49-F238E27FC236}">
+                    <a16:creationId xmlns:a16="http://schemas.microsoft.com/office/drawing/2014/main" id="{B952C860-2C6C-FCA5-EA33-E45A7CA9331A}"/>
+                  </a:ext>
+                </a:extLst>
+              </p:cNvPr>
+              <p:cNvSpPr txBox="1"/>
+              <p:nvPr/>
+            </p:nvSpPr>
+            <p:spPr>
+              <a:xfrm>
+                <a:off x="8500227" y="2408915"/>
+                <a:ext cx="2138342" cy="529697"/>
+              </a:xfrm>
+              <a:prstGeom prst="rect">
+                <a:avLst/>
+              </a:prstGeom>
+              <a:noFill/>
+            </p:spPr>
+            <p:txBody>
+              <a:bodyPr wrap="none" lIns="0" tIns="0" rIns="0" bIns="0" rtlCol="0">
+                <a:spAutoFit/>
+              </a:bodyPr>
+              <a:lstStyle/>
+              <a:p>
+                <a14:m>
+                  <m:oMathPara xmlns:m="http://schemas.openxmlformats.org/officeDocument/2006/math">
+                    <m:oMath>
+                      <m:r>
+                        <a:rPr lang="en-US" b="0" i="1" smtClean="0">
+                          <a:latin typeface="Cambria Math" panose="02040503050406030204" pitchFamily="18" charset="0"/>
+                        </a:rPr>
+                        <m:t>𝑦</m:t>
+                      </m:r>
+                      <m:r>
+                        <a:rPr lang="en-US" b="0" i="1" smtClean="0">
+                          <a:latin typeface="Cambria Math" panose="02040503050406030204" pitchFamily="18" charset="0"/>
+                        </a:rPr>
+                        <m:t>=</m:t>
+                      </m:r>
+                      <m:f>
+                        <m:fPr>
+                          <m:ctrlPr>
+                            <a:rPr lang="en-US" b="0" i="1" smtClean="0">
+                              <a:latin typeface="Cambria Math" panose="02040503050406030204" pitchFamily="18" charset="0"/>
+                            </a:rPr>
+                          </m:ctrlPr>
+                        </m:fPr>
+                        <m:num>
+                          <m:r>
+                            <a:rPr lang="en-US" b="0" i="1" smtClean="0">
+                              <a:latin typeface="Cambria Math" panose="02040503050406030204" pitchFamily="18" charset="0"/>
+                            </a:rPr>
+                            <m:t>1.06</m:t>
+                          </m:r>
+                        </m:num>
+                        <m:den>
+                          <m:r>
+                            <a:rPr lang="en-US" b="0" i="1" smtClean="0">
+                              <a:latin typeface="Cambria Math" panose="02040503050406030204" pitchFamily="18" charset="0"/>
+                            </a:rPr>
+                            <m:t>1+</m:t>
+                          </m:r>
+                          <m:sSup>
+                            <m:sSupPr>
+                              <m:ctrlPr>
+                                <a:rPr lang="en-US" b="0" i="1" smtClean="0">
+                                  <a:latin typeface="Cambria Math" panose="02040503050406030204" pitchFamily="18" charset="0"/>
+                                </a:rPr>
+                              </m:ctrlPr>
+                            </m:sSupPr>
+                            <m:e>
+                              <m:r>
+                                <a:rPr lang="en-US" b="0" i="1" smtClean="0">
+                                  <a:latin typeface="Cambria Math" panose="02040503050406030204" pitchFamily="18" charset="0"/>
+                                </a:rPr>
+                                <m:t>𝑒</m:t>
+                              </m:r>
+                            </m:e>
+                            <m:sup>
+                              <m:r>
+                                <a:rPr lang="en-US" b="0" i="1" smtClean="0">
+                                  <a:latin typeface="Cambria Math" panose="02040503050406030204" pitchFamily="18" charset="0"/>
+                                </a:rPr>
+                                <m:t>0.635(</m:t>
+                              </m:r>
+                              <m:r>
+                                <a:rPr lang="en-US" b="0" i="1" smtClean="0">
+                                  <a:latin typeface="Cambria Math" panose="02040503050406030204" pitchFamily="18" charset="0"/>
+                                </a:rPr>
+                                <m:t>𝑥</m:t>
+                              </m:r>
+                              <m:r>
+                                <a:rPr lang="en-US" b="0" i="1" smtClean="0">
+                                  <a:latin typeface="Cambria Math" panose="02040503050406030204" pitchFamily="18" charset="0"/>
+                                </a:rPr>
+                                <m:t>−4.94)</m:t>
+                              </m:r>
+                            </m:sup>
+                          </m:sSup>
+                        </m:den>
+                      </m:f>
+                    </m:oMath>
+                  </m:oMathPara>
+                </a14:m>
+                <a:endParaRPr lang="en-CA" dirty="0"/>
+              </a:p>
+            </p:txBody>
+          </p:sp>
+        </mc:Choice>
+        <mc:Fallback>
+          <p:sp>
+            <p:nvSpPr>
+              <p:cNvPr id="27" name="TextBox 26">
+                <a:extLst>
+                  <a:ext uri="{FF2B5EF4-FFF2-40B4-BE49-F238E27FC236}">
+                    <a16:creationId xmlns:a16="http://schemas.microsoft.com/office/drawing/2014/main" id="{B952C860-2C6C-FCA5-EA33-E45A7CA9331A}"/>
+                  </a:ext>
+                </a:extLst>
+              </p:cNvPr>
+              <p:cNvSpPr txBox="1">
+                <a:spLocks noRot="1" noChangeAspect="1" noMove="1" noResize="1" noEditPoints="1" noAdjustHandles="1" noChangeArrowheads="1" noChangeShapeType="1" noTextEdit="1"/>
+              </p:cNvSpPr>
+              <p:nvPr/>
+            </p:nvSpPr>
+            <p:spPr>
+              <a:xfrm>
+                <a:off x="8500227" y="2408915"/>
+                <a:ext cx="2138342" cy="529697"/>
+              </a:xfrm>
+              <a:prstGeom prst="rect">
+                <a:avLst/>
+              </a:prstGeom>
+              <a:blipFill>
+                <a:blip r:embed="rId6"/>
+                <a:stretch>
+                  <a:fillRect/>
+                </a:stretch>
+              </a:blipFill>
+            </p:spPr>
+            <p:txBody>
+              <a:bodyPr/>
+              <a:lstStyle/>
+              <a:p>
+                <a:r>
+                  <a:rPr lang="en-CA">
+                    <a:noFill/>
+                  </a:rPr>
+                  <a:t> </a:t>
+                </a:r>
+              </a:p>
+            </p:txBody>
+          </p:sp>
+        </mc:Fallback>
+      </mc:AlternateContent>
     </p:spTree>
     <p:extLst>
       <p:ext uri="{BB962C8B-B14F-4D97-AF65-F5344CB8AC3E}">

</xml_diff>

<commit_message>
Added slide about composite scoring term weights.
</commit_message>
<xml_diff>
--- a/reports/2026-08-28_projectUpdate_3/2026-08-28_projectUpdate_3_jmoran.pptx
+++ b/reports/2026-08-28_projectUpdate_3/2026-08-28_projectUpdate_3_jmoran.pptx
@@ -5,16 +5,20 @@
     <p:sldMasterId id="2147483648" r:id="rId1"/>
   </p:sldMasterIdLst>
   <p:notesMasterIdLst>
-    <p:notesMasterId r:id="rId9"/>
+    <p:notesMasterId r:id="rId13"/>
   </p:notesMasterIdLst>
   <p:sldIdLst>
     <p:sldId id="256" r:id="rId2"/>
-    <p:sldId id="266" r:id="rId3"/>
-    <p:sldId id="269" r:id="rId4"/>
-    <p:sldId id="257" r:id="rId5"/>
-    <p:sldId id="286" r:id="rId6"/>
-    <p:sldId id="287" r:id="rId7"/>
-    <p:sldId id="284" r:id="rId8"/>
+    <p:sldId id="291" r:id="rId3"/>
+    <p:sldId id="266" r:id="rId4"/>
+    <p:sldId id="269" r:id="rId5"/>
+    <p:sldId id="257" r:id="rId6"/>
+    <p:sldId id="286" r:id="rId7"/>
+    <p:sldId id="287" r:id="rId8"/>
+    <p:sldId id="284" r:id="rId9"/>
+    <p:sldId id="288" r:id="rId10"/>
+    <p:sldId id="289" r:id="rId11"/>
+    <p:sldId id="290" r:id="rId12"/>
   </p:sldIdLst>
   <p:sldSz cx="12192000" cy="6858000"/>
   <p:notesSz cx="6858000" cy="9144000"/>
@@ -557,7 +561,7 @@
           <a:p>
             <a:fld id="{2E88BC55-598C-4AA3-BC46-22AAD297F918}" type="slidenum">
               <a:rPr lang="en-CA" smtClean="0"/>
-              <a:t>2</a:t>
+              <a:t>3</a:t>
             </a:fld>
             <a:endParaRPr lang="en-CA"/>
           </a:p>
@@ -686,7 +690,7 @@
           <a:p>
             <a:fld id="{2E88BC55-598C-4AA3-BC46-22AAD297F918}" type="slidenum">
               <a:rPr lang="en-CA" smtClean="0"/>
-              <a:t>6</a:t>
+              <a:t>7</a:t>
             </a:fld>
             <a:endParaRPr lang="en-CA"/>
           </a:p>
@@ -815,7 +819,7 @@
           <a:p>
             <a:fld id="{2E88BC55-598C-4AA3-BC46-22AAD297F918}" type="slidenum">
               <a:rPr lang="en-CA" smtClean="0"/>
-              <a:t>7</a:t>
+              <a:t>8</a:t>
             </a:fld>
             <a:endParaRPr lang="en-CA"/>
           </a:p>
@@ -825,6 +829,135 @@
     <p:extLst>
       <p:ext uri="{BB962C8B-B14F-4D97-AF65-F5344CB8AC3E}">
         <p14:creationId xmlns:p14="http://schemas.microsoft.com/office/powerpoint/2010/main" val="1058320145"/>
+      </p:ext>
+    </p:extLst>
+  </p:cSld>
+  <p:clrMapOvr>
+    <a:masterClrMapping/>
+  </p:clrMapOvr>
+</p:notes>
+</file>
+
+<file path=ppt/notesSlides/notesSlide4.xml><?xml version="1.0" encoding="utf-8"?>
+<p:notes xmlns:a="http://schemas.openxmlformats.org/drawingml/2006/main" xmlns:r="http://schemas.openxmlformats.org/officeDocument/2006/relationships" xmlns:p="http://schemas.openxmlformats.org/presentationml/2006/main">
+  <p:cSld>
+    <p:spTree>
+      <p:nvGrpSpPr>
+        <p:cNvPr id="1" name="">
+          <a:extLst>
+            <a:ext uri="{FF2B5EF4-FFF2-40B4-BE49-F238E27FC236}">
+              <a16:creationId xmlns:a16="http://schemas.microsoft.com/office/drawing/2014/main" id="{B999B410-5F38-DE54-2B45-90055E862AF9}"/>
+            </a:ext>
+          </a:extLst>
+        </p:cNvPr>
+        <p:cNvGrpSpPr/>
+        <p:nvPr/>
+      </p:nvGrpSpPr>
+      <p:grpSpPr>
+        <a:xfrm>
+          <a:off x="0" y="0"/>
+          <a:ext cx="0" cy="0"/>
+          <a:chOff x="0" y="0"/>
+          <a:chExt cx="0" cy="0"/>
+        </a:xfrm>
+      </p:grpSpPr>
+      <p:sp>
+        <p:nvSpPr>
+          <p:cNvPr id="2" name="Slide Image Placeholder 1">
+            <a:extLst>
+              <a:ext uri="{FF2B5EF4-FFF2-40B4-BE49-F238E27FC236}">
+                <a16:creationId xmlns:a16="http://schemas.microsoft.com/office/drawing/2014/main" id="{98EEEED9-4045-BC4E-CF09-5367B8E72E54}"/>
+              </a:ext>
+            </a:extLst>
+          </p:cNvPr>
+          <p:cNvSpPr>
+            <a:spLocks noGrp="1" noRot="1" noChangeAspect="1"/>
+          </p:cNvSpPr>
+          <p:nvPr>
+            <p:ph type="sldImg"/>
+          </p:nvPr>
+        </p:nvSpPr>
+        <p:spPr/>
+        <p:txBody>
+          <a:bodyPr/>
+          <a:lstStyle/>
+          <a:p>
+            <a:endParaRPr lang="en-CA"/>
+          </a:p>
+        </p:txBody>
+      </p:sp>
+      <p:sp>
+        <p:nvSpPr>
+          <p:cNvPr id="3" name="Notes Placeholder 2">
+            <a:extLst>
+              <a:ext uri="{FF2B5EF4-FFF2-40B4-BE49-F238E27FC236}">
+                <a16:creationId xmlns:a16="http://schemas.microsoft.com/office/drawing/2014/main" id="{175FFDC1-2A47-6906-89D6-FE3D30FC66DC}"/>
+              </a:ext>
+            </a:extLst>
+          </p:cNvPr>
+          <p:cNvSpPr>
+            <a:spLocks noGrp="1"/>
+          </p:cNvSpPr>
+          <p:nvPr>
+            <p:ph type="body" idx="1"/>
+          </p:nvPr>
+        </p:nvSpPr>
+        <p:spPr/>
+        <p:txBody>
+          <a:bodyPr/>
+          <a:lstStyle/>
+          <a:p>
+            <a:r>
+              <a:rPr lang="en-US" dirty="0"/>
+              <a:t>Gene list is for C Marshall</a:t>
+            </a:r>
+          </a:p>
+          <a:p>
+            <a:r>
+              <a:rPr lang="en-US" dirty="0"/>
+              <a:t>Used for improving diagnostic yield</a:t>
+            </a:r>
+            <a:r>
+              <a:rPr lang="en-CA" dirty="0"/>
+              <a:t> for pre-existing </a:t>
+            </a:r>
+            <a:endParaRPr lang="en-US" dirty="0"/>
+          </a:p>
+        </p:txBody>
+      </p:sp>
+      <p:sp>
+        <p:nvSpPr>
+          <p:cNvPr id="4" name="Slide Number Placeholder 3">
+            <a:extLst>
+              <a:ext uri="{FF2B5EF4-FFF2-40B4-BE49-F238E27FC236}">
+                <a16:creationId xmlns:a16="http://schemas.microsoft.com/office/drawing/2014/main" id="{3ED2C652-75D6-5357-36A2-CF2BCCAD9A58}"/>
+              </a:ext>
+            </a:extLst>
+          </p:cNvPr>
+          <p:cNvSpPr>
+            <a:spLocks noGrp="1"/>
+          </p:cNvSpPr>
+          <p:nvPr>
+            <p:ph type="sldNum" sz="quarter" idx="5"/>
+          </p:nvPr>
+        </p:nvSpPr>
+        <p:spPr/>
+        <p:txBody>
+          <a:bodyPr/>
+          <a:lstStyle/>
+          <a:p>
+            <a:fld id="{2E88BC55-598C-4AA3-BC46-22AAD297F918}" type="slidenum">
+              <a:rPr lang="en-CA" smtClean="0"/>
+              <a:t>9</a:t>
+            </a:fld>
+            <a:endParaRPr lang="en-CA"/>
+          </a:p>
+        </p:txBody>
+      </p:sp>
+    </p:spTree>
+    <p:extLst>
+      <p:ext uri="{BB962C8B-B14F-4D97-AF65-F5344CB8AC3E}">
+        <p14:creationId xmlns:p14="http://schemas.microsoft.com/office/powerpoint/2010/main" val="905556161"/>
       </p:ext>
     </p:extLst>
   </p:cSld>
@@ -4811,7 +4944,207 @@
 </p:sld>
 </file>
 
+<file path=ppt/slides/slide10.xml><?xml version="1.0" encoding="utf-8"?>
+<p:sld xmlns:a="http://schemas.openxmlformats.org/drawingml/2006/main" xmlns:r="http://schemas.openxmlformats.org/officeDocument/2006/relationships" xmlns:p="http://schemas.openxmlformats.org/presentationml/2006/main">
+  <p:cSld>
+    <p:bg>
+      <p:bgPr>
+        <a:solidFill>
+          <a:srgbClr val="0162B3"/>
+        </a:solidFill>
+        <a:effectLst/>
+      </p:bgPr>
+    </p:bg>
+    <p:spTree>
+      <p:nvGrpSpPr>
+        <p:cNvPr id="1" name="">
+          <a:extLst>
+            <a:ext uri="{FF2B5EF4-FFF2-40B4-BE49-F238E27FC236}">
+              <a16:creationId xmlns:a16="http://schemas.microsoft.com/office/drawing/2014/main" id="{9282B96F-B730-1DA5-EB18-8FC579142F9E}"/>
+            </a:ext>
+          </a:extLst>
+        </p:cNvPr>
+        <p:cNvGrpSpPr/>
+        <p:nvPr/>
+      </p:nvGrpSpPr>
+      <p:grpSpPr>
+        <a:xfrm>
+          <a:off x="0" y="0"/>
+          <a:ext cx="0" cy="0"/>
+          <a:chOff x="0" y="0"/>
+          <a:chExt cx="0" cy="0"/>
+        </a:xfrm>
+      </p:grpSpPr>
+      <p:sp>
+        <p:nvSpPr>
+          <p:cNvPr id="5" name="TextBox 4">
+            <a:extLst>
+              <a:ext uri="{FF2B5EF4-FFF2-40B4-BE49-F238E27FC236}">
+                <a16:creationId xmlns:a16="http://schemas.microsoft.com/office/drawing/2014/main" id="{62CC1444-5E77-21AF-0D9D-5AE735660034}"/>
+              </a:ext>
+            </a:extLst>
+          </p:cNvPr>
+          <p:cNvSpPr txBox="1"/>
+          <p:nvPr/>
+        </p:nvSpPr>
+        <p:spPr>
+          <a:xfrm>
+            <a:off x="7042384" y="4503211"/>
+            <a:ext cx="4154878" cy="892552"/>
+          </a:xfrm>
+          <a:prstGeom prst="rect">
+            <a:avLst/>
+          </a:prstGeom>
+          <a:noFill/>
+        </p:spPr>
+        <p:txBody>
+          <a:bodyPr wrap="square" rtlCol="0">
+            <a:spAutoFit/>
+          </a:bodyPr>
+          <a:lstStyle/>
+          <a:p>
+            <a:pPr algn="r"/>
+            <a:r>
+              <a:rPr lang="en-US" sz="2600" b="1" dirty="0">
+                <a:solidFill>
+                  <a:schemeClr val="bg1"/>
+                </a:solidFill>
+                <a:latin typeface="Georgia Pro" panose="02040502050405020303" pitchFamily="18" charset="0"/>
+              </a:rPr>
+              <a:t>Composite scoring results</a:t>
+            </a:r>
+          </a:p>
+        </p:txBody>
+      </p:sp>
+    </p:spTree>
+    <p:extLst>
+      <p:ext uri="{BB962C8B-B14F-4D97-AF65-F5344CB8AC3E}">
+        <p14:creationId xmlns:p14="http://schemas.microsoft.com/office/powerpoint/2010/main" val="517790691"/>
+      </p:ext>
+    </p:extLst>
+  </p:cSld>
+  <p:clrMapOvr>
+    <a:masterClrMapping/>
+  </p:clrMapOvr>
+</p:sld>
+</file>
+
+<file path=ppt/slides/slide11.xml><?xml version="1.0" encoding="utf-8"?>
+<p:sld xmlns:a="http://schemas.openxmlformats.org/drawingml/2006/main" xmlns:r="http://schemas.openxmlformats.org/officeDocument/2006/relationships" xmlns:p="http://schemas.openxmlformats.org/presentationml/2006/main">
+  <p:cSld>
+    <p:spTree>
+      <p:nvGrpSpPr>
+        <p:cNvPr id="1" name=""/>
+        <p:cNvGrpSpPr/>
+        <p:nvPr/>
+      </p:nvGrpSpPr>
+      <p:grpSpPr>
+        <a:xfrm>
+          <a:off x="0" y="0"/>
+          <a:ext cx="0" cy="0"/>
+          <a:chOff x="0" y="0"/>
+          <a:chExt cx="0" cy="0"/>
+        </a:xfrm>
+      </p:grpSpPr>
+    </p:spTree>
+    <p:extLst>
+      <p:ext uri="{BB962C8B-B14F-4D97-AF65-F5344CB8AC3E}">
+        <p14:creationId xmlns:p14="http://schemas.microsoft.com/office/powerpoint/2010/main" val="485302257"/>
+      </p:ext>
+    </p:extLst>
+  </p:cSld>
+  <p:clrMapOvr>
+    <a:masterClrMapping/>
+  </p:clrMapOvr>
+</p:sld>
+</file>
+
 <file path=ppt/slides/slide2.xml><?xml version="1.0" encoding="utf-8"?>
+<p:sld xmlns:a="http://schemas.openxmlformats.org/drawingml/2006/main" xmlns:r="http://schemas.openxmlformats.org/officeDocument/2006/relationships" xmlns:p="http://schemas.openxmlformats.org/presentationml/2006/main">
+  <p:cSld>
+    <p:bg>
+      <p:bgPr>
+        <a:solidFill>
+          <a:srgbClr val="0162B3"/>
+        </a:solidFill>
+        <a:effectLst/>
+      </p:bgPr>
+    </p:bg>
+    <p:spTree>
+      <p:nvGrpSpPr>
+        <p:cNvPr id="1" name="">
+          <a:extLst>
+            <a:ext uri="{FF2B5EF4-FFF2-40B4-BE49-F238E27FC236}">
+              <a16:creationId xmlns:a16="http://schemas.microsoft.com/office/drawing/2014/main" id="{5290DC9F-C527-472F-5002-FBB13CF43F3F}"/>
+            </a:ext>
+          </a:extLst>
+        </p:cNvPr>
+        <p:cNvGrpSpPr/>
+        <p:nvPr/>
+      </p:nvGrpSpPr>
+      <p:grpSpPr>
+        <a:xfrm>
+          <a:off x="0" y="0"/>
+          <a:ext cx="0" cy="0"/>
+          <a:chOff x="0" y="0"/>
+          <a:chExt cx="0" cy="0"/>
+        </a:xfrm>
+      </p:grpSpPr>
+      <p:sp>
+        <p:nvSpPr>
+          <p:cNvPr id="5" name="TextBox 4">
+            <a:extLst>
+              <a:ext uri="{FF2B5EF4-FFF2-40B4-BE49-F238E27FC236}">
+                <a16:creationId xmlns:a16="http://schemas.microsoft.com/office/drawing/2014/main" id="{0B256F2C-0357-EAC9-8B29-932635B28198}"/>
+              </a:ext>
+            </a:extLst>
+          </p:cNvPr>
+          <p:cNvSpPr txBox="1"/>
+          <p:nvPr/>
+        </p:nvSpPr>
+        <p:spPr>
+          <a:xfrm>
+            <a:off x="7042384" y="4503211"/>
+            <a:ext cx="4154878" cy="492443"/>
+          </a:xfrm>
+          <a:prstGeom prst="rect">
+            <a:avLst/>
+          </a:prstGeom>
+          <a:noFill/>
+        </p:spPr>
+        <p:txBody>
+          <a:bodyPr wrap="square" rtlCol="0">
+            <a:spAutoFit/>
+          </a:bodyPr>
+          <a:lstStyle/>
+          <a:p>
+            <a:pPr algn="r"/>
+            <a:r>
+              <a:rPr lang="en-US" sz="2600" b="1" dirty="0">
+                <a:solidFill>
+                  <a:schemeClr val="bg1"/>
+                </a:solidFill>
+                <a:latin typeface="Georgia Pro" panose="02040502050405020303" pitchFamily="18" charset="0"/>
+              </a:rPr>
+              <a:t>Background</a:t>
+            </a:r>
+          </a:p>
+        </p:txBody>
+      </p:sp>
+    </p:spTree>
+    <p:extLst>
+      <p:ext uri="{BB962C8B-B14F-4D97-AF65-F5344CB8AC3E}">
+        <p14:creationId xmlns:p14="http://schemas.microsoft.com/office/powerpoint/2010/main" val="3333967294"/>
+      </p:ext>
+    </p:extLst>
+  </p:cSld>
+  <p:clrMapOvr>
+    <a:masterClrMapping/>
+  </p:clrMapOvr>
+</p:sld>
+</file>
+
+<file path=ppt/slides/slide3.xml><?xml version="1.0" encoding="utf-8"?>
 <p:sld xmlns:a="http://schemas.openxmlformats.org/drawingml/2006/main" xmlns:r="http://schemas.openxmlformats.org/officeDocument/2006/relationships" xmlns:p="http://schemas.openxmlformats.org/presentationml/2006/main">
   <p:cSld>
     <p:spTree>
@@ -4858,7 +5191,7 @@
             <a:fld id="{3899FC77-40C7-4C49-9A19-86BDE9B75E8A}" type="slidenum">
               <a:rPr lang="en-CA" smtClean="0"/>
               <a:pPr/>
-              <a:t>2</a:t>
+              <a:t>3</a:t>
             </a:fld>
             <a:endParaRPr lang="en-CA" sz="1400"/>
           </a:p>
@@ -5025,7 +5358,7 @@
         </p:nvSpPr>
         <p:spPr>
           <a:xfrm>
-            <a:off x="315257" y="267370"/>
+            <a:off x="315257" y="8585"/>
             <a:ext cx="6204416" cy="628742"/>
           </a:xfrm>
           <a:prstGeom prst="roundRect">
@@ -5173,7 +5506,7 @@
         </p:nvSpPr>
         <p:spPr>
           <a:xfrm>
-            <a:off x="527960" y="335519"/>
+            <a:off x="527960" y="76734"/>
             <a:ext cx="5779009" cy="492443"/>
           </a:xfrm>
           <a:prstGeom prst="rect">
@@ -5218,7 +5551,7 @@
 </p:sld>
 </file>
 
-<file path=ppt/slides/slide3.xml><?xml version="1.0" encoding="utf-8"?>
+<file path=ppt/slides/slide4.xml><?xml version="1.0" encoding="utf-8"?>
 <p:sld xmlns:a="http://schemas.openxmlformats.org/drawingml/2006/main" xmlns:r="http://schemas.openxmlformats.org/officeDocument/2006/relationships" xmlns:p="http://schemas.openxmlformats.org/presentationml/2006/main">
   <p:cSld>
     <p:spTree>
@@ -5327,7 +5660,7 @@
         </p:nvSpPr>
         <p:spPr>
           <a:xfrm>
-            <a:off x="315257" y="267370"/>
+            <a:off x="315257" y="8582"/>
             <a:ext cx="9363581" cy="628742"/>
           </a:xfrm>
           <a:prstGeom prst="roundRect">
@@ -5475,7 +5808,7 @@
         </p:nvSpPr>
         <p:spPr>
           <a:xfrm>
-            <a:off x="527959" y="335519"/>
+            <a:off x="527959" y="76731"/>
             <a:ext cx="8710932" cy="492443"/>
           </a:xfrm>
           <a:prstGeom prst="rect">
@@ -5613,8 +5946,8 @@
           </a:p>
         </p:txBody>
       </p:sp>
-      <mc:AlternateContent xmlns:mc="http://schemas.openxmlformats.org/markup-compatibility/2006" xmlns:a14="http://schemas.microsoft.com/office/drawing/2010/main">
-        <mc:Choice Requires="a14">
+      <mc:AlternateContent xmlns:mc="http://schemas.openxmlformats.org/markup-compatibility/2006">
+        <mc:Choice xmlns:a14="http://schemas.microsoft.com/office/drawing/2010/main" Requires="a14">
           <p:sp>
             <p:nvSpPr>
               <p:cNvPr id="13" name="TextBox 12">
@@ -5682,6 +6015,18 @@
                       <a:rPr lang="en-US" b="0" i="1" smtClean="0">
                         <a:latin typeface="Cambria Math" panose="02040503050406030204" pitchFamily="18" charset="0"/>
                       </a:rPr>
+                      <m:t>_</m:t>
+                    </m:r>
+                    <m:r>
+                      <a:rPr lang="en-US" b="0" i="1" smtClean="0">
+                        <a:latin typeface="Cambria Math" panose="02040503050406030204" pitchFamily="18" charset="0"/>
+                      </a:rPr>
+                      <m:t>𝑣𝑎𝑙𝑢𝑒</m:t>
+                    </m:r>
+                    <m:r>
+                      <a:rPr lang="en-US" b="0" i="1" smtClean="0">
+                        <a:latin typeface="Cambria Math" panose="02040503050406030204" pitchFamily="18" charset="0"/>
+                      </a:rPr>
                       <m:t>&lt;0.05</m:t>
                     </m:r>
                   </m:oMath>
@@ -5696,7 +6041,7 @@
             </p:txBody>
           </p:sp>
         </mc:Choice>
-        <mc:Fallback xmlns="">
+        <mc:Fallback>
           <p:sp>
             <p:nvSpPr>
               <p:cNvPr id="13" name="TextBox 12">
@@ -5754,7 +6099,7 @@
 </p:sld>
 </file>
 
-<file path=ppt/slides/slide4.xml><?xml version="1.0" encoding="utf-8"?>
+<file path=ppt/slides/slide5.xml><?xml version="1.0" encoding="utf-8"?>
 <p:sld xmlns:a="http://schemas.openxmlformats.org/drawingml/2006/main" xmlns:r="http://schemas.openxmlformats.org/officeDocument/2006/relationships" xmlns:p="http://schemas.openxmlformats.org/presentationml/2006/main">
   <p:cSld>
     <p:spTree>
@@ -5822,7 +6167,7 @@
         </p:nvSpPr>
         <p:spPr>
           <a:xfrm>
-            <a:off x="315257" y="267370"/>
+            <a:off x="315257" y="8584"/>
             <a:ext cx="9363581" cy="628742"/>
           </a:xfrm>
           <a:prstGeom prst="roundRect">
@@ -5970,7 +6315,7 @@
         </p:nvSpPr>
         <p:spPr>
           <a:xfrm>
-            <a:off x="527959" y="335519"/>
+            <a:off x="527959" y="76733"/>
             <a:ext cx="8710932" cy="492443"/>
           </a:xfrm>
           <a:prstGeom prst="rect">
@@ -6715,7 +7060,7 @@
 </p:sld>
 </file>
 
-<file path=ppt/slides/slide5.xml><?xml version="1.0" encoding="utf-8"?>
+<file path=ppt/slides/slide6.xml><?xml version="1.0" encoding="utf-8"?>
 <p:sld xmlns:a="http://schemas.openxmlformats.org/drawingml/2006/main" xmlns:r="http://schemas.openxmlformats.org/officeDocument/2006/relationships" xmlns:p="http://schemas.openxmlformats.org/presentationml/2006/main">
   <p:cSld>
     <p:bg>
@@ -6761,7 +7106,7 @@
         <p:spPr>
           <a:xfrm>
             <a:off x="7042384" y="4503211"/>
-            <a:ext cx="4154878" cy="492443"/>
+            <a:ext cx="4154878" cy="892552"/>
           </a:xfrm>
           <a:prstGeom prst="rect">
             <a:avLst/>
@@ -6782,7 +7127,19 @@
                 </a:solidFill>
                 <a:latin typeface="Georgia Pro" panose="02040502050405020303" pitchFamily="18" charset="0"/>
               </a:rPr>
-              <a:t>Composite score</a:t>
+              <a:t>Composite scoring</a:t>
+            </a:r>
+          </a:p>
+          <a:p>
+            <a:pPr algn="r"/>
+            <a:r>
+              <a:rPr lang="en-US" sz="2600" b="1" dirty="0">
+                <a:solidFill>
+                  <a:schemeClr val="bg1"/>
+                </a:solidFill>
+                <a:latin typeface="Georgia Pro" panose="02040502050405020303" pitchFamily="18" charset="0"/>
+              </a:rPr>
+              <a:t>method</a:t>
             </a:r>
           </a:p>
         </p:txBody>
@@ -6800,7 +7157,7 @@
 </p:sld>
 </file>
 
-<file path=ppt/slides/slide6.xml><?xml version="1.0" encoding="utf-8"?>
+<file path=ppt/slides/slide7.xml><?xml version="1.0" encoding="utf-8"?>
 <p:sld xmlns:a="http://schemas.openxmlformats.org/drawingml/2006/main" xmlns:r="http://schemas.openxmlformats.org/officeDocument/2006/relationships" xmlns:p="http://schemas.openxmlformats.org/presentationml/2006/main">
   <p:cSld>
     <p:spTree>
@@ -6847,7 +7204,7 @@
             <a:fld id="{3899FC77-40C7-4C49-9A19-86BDE9B75E8A}" type="slidenum">
               <a:rPr lang="en-CA" smtClean="0"/>
               <a:pPr/>
-              <a:t>6</a:t>
+              <a:t>7</a:t>
             </a:fld>
             <a:endParaRPr lang="en-CA" sz="1400"/>
           </a:p>
@@ -6867,7 +7224,7 @@
         </p:nvSpPr>
         <p:spPr>
           <a:xfrm>
-            <a:off x="315257" y="267370"/>
+            <a:off x="315257" y="8582"/>
             <a:ext cx="9363581" cy="628742"/>
           </a:xfrm>
           <a:prstGeom prst="roundRect">
@@ -7015,7 +7372,7 @@
         </p:nvSpPr>
         <p:spPr>
           <a:xfrm>
-            <a:off x="527959" y="335519"/>
+            <a:off x="527959" y="76731"/>
             <a:ext cx="8710932" cy="492443"/>
           </a:xfrm>
           <a:prstGeom prst="rect">
@@ -8001,7 +8358,7 @@
                 <a:rPr lang="en-US" sz="1400" dirty="0">
                   <a:latin typeface="Verdana Pro" panose="020B0604030504040204" pitchFamily="34" charset="0"/>
                 </a:rPr>
-                <a:t>Score</a:t>
+                <a:t>E-value score term</a:t>
               </a:r>
               <a:endParaRPr lang="en-CA" sz="1400" dirty="0">
                 <a:latin typeface="Verdana Pro" panose="020B0604030504040204" pitchFamily="34" charset="0"/>
@@ -8080,7 +8437,7 @@
               <a:rPr lang="en-US" dirty="0">
                 <a:latin typeface="Verdana Pro" panose="020B0604030504040204" pitchFamily="34" charset="0"/>
               </a:rPr>
-              <a:t>Score</a:t>
+              <a:t>E-value score term</a:t>
             </a:r>
             <a:endParaRPr lang="en-CA" dirty="0">
               <a:latin typeface="Verdana Pro" panose="020B0604030504040204" pitchFamily="34" charset="0"/>
@@ -8445,7 +8802,7 @@
 </p:sld>
 </file>
 
-<file path=ppt/slides/slide7.xml><?xml version="1.0" encoding="utf-8"?>
+<file path=ppt/slides/slide8.xml><?xml version="1.0" encoding="utf-8"?>
 <p:sld xmlns:a="http://schemas.openxmlformats.org/drawingml/2006/main" xmlns:r="http://schemas.openxmlformats.org/officeDocument/2006/relationships" xmlns:p="http://schemas.openxmlformats.org/presentationml/2006/main">
   <p:cSld>
     <p:spTree>
@@ -8529,7 +8886,7 @@
             <a:fld id="{3899FC77-40C7-4C49-9A19-86BDE9B75E8A}" type="slidenum">
               <a:rPr lang="en-CA" smtClean="0"/>
               <a:pPr/>
-              <a:t>7</a:t>
+              <a:t>8</a:t>
             </a:fld>
             <a:endParaRPr lang="en-CA" sz="1400"/>
           </a:p>
@@ -8549,7 +8906,7 @@
         </p:nvSpPr>
         <p:spPr>
           <a:xfrm>
-            <a:off x="315257" y="267370"/>
+            <a:off x="315257" y="8580"/>
             <a:ext cx="9363581" cy="628742"/>
           </a:xfrm>
           <a:prstGeom prst="roundRect">
@@ -8697,7 +9054,7 @@
         </p:nvSpPr>
         <p:spPr>
           <a:xfrm>
-            <a:off x="527959" y="335519"/>
+            <a:off x="527959" y="76729"/>
             <a:ext cx="8710932" cy="492443"/>
           </a:xfrm>
           <a:prstGeom prst="rect">
@@ -8744,7 +9101,7 @@
           <p:nvPr>
             <p:extLst>
               <p:ext uri="{D42A27DB-BD31-4B8C-83A1-F6EECF244321}">
-                <p14:modId xmlns:p14="http://schemas.microsoft.com/office/powerpoint/2010/main" val="2945173442"/>
+                <p14:modId xmlns:p14="http://schemas.microsoft.com/office/powerpoint/2010/main" val="3037340139"/>
               </p:ext>
             </p:extLst>
           </p:nvPr>
@@ -9172,7 +9529,7 @@
                 <a:rPr lang="en-US" dirty="0">
                   <a:latin typeface="Verdana Pro" panose="020B0604030504040204" pitchFamily="34" charset="0"/>
                 </a:rPr>
-                <a:t>Score</a:t>
+                <a:t>PyMOL score term</a:t>
               </a:r>
               <a:endParaRPr lang="en-CA" dirty="0">
                 <a:latin typeface="Verdana Pro" panose="020B0604030504040204" pitchFamily="34" charset="0"/>
@@ -9195,7 +9552,7 @@
         </p:nvSpPr>
         <p:spPr>
           <a:xfrm rot="16200000">
-            <a:off x="3495374" y="3040720"/>
+            <a:off x="3495374" y="3325386"/>
             <a:ext cx="2406770" cy="369332"/>
           </a:xfrm>
           <a:prstGeom prst="rect">
@@ -9214,7 +9571,7 @@
               <a:rPr lang="en-US" dirty="0">
                 <a:latin typeface="Verdana Pro" panose="020B0604030504040204" pitchFamily="34" charset="0"/>
               </a:rPr>
-              <a:t>Score</a:t>
+              <a:t>PyMOL score term</a:t>
             </a:r>
             <a:endParaRPr lang="en-CA" dirty="0">
               <a:latin typeface="Verdana Pro" panose="020B0604030504040204" pitchFamily="34" charset="0"/>
@@ -9521,6 +9878,1878 @@
     <p:extLst>
       <p:ext uri="{BB962C8B-B14F-4D97-AF65-F5344CB8AC3E}">
         <p14:creationId xmlns:p14="http://schemas.microsoft.com/office/powerpoint/2010/main" val="1727129599"/>
+      </p:ext>
+    </p:extLst>
+  </p:cSld>
+  <p:clrMapOvr>
+    <a:masterClrMapping/>
+  </p:clrMapOvr>
+</p:sld>
+</file>
+
+<file path=ppt/slides/slide9.xml><?xml version="1.0" encoding="utf-8"?>
+<p:sld xmlns:a="http://schemas.openxmlformats.org/drawingml/2006/main" xmlns:r="http://schemas.openxmlformats.org/officeDocument/2006/relationships" xmlns:p="http://schemas.openxmlformats.org/presentationml/2006/main">
+  <p:cSld>
+    <p:spTree>
+      <p:nvGrpSpPr>
+        <p:cNvPr id="1" name="">
+          <a:extLst>
+            <a:ext uri="{FF2B5EF4-FFF2-40B4-BE49-F238E27FC236}">
+              <a16:creationId xmlns:a16="http://schemas.microsoft.com/office/drawing/2014/main" id="{CC45B665-2D1C-BE92-D560-316708F8D136}"/>
+            </a:ext>
+          </a:extLst>
+        </p:cNvPr>
+        <p:cNvGrpSpPr/>
+        <p:nvPr/>
+      </p:nvGrpSpPr>
+      <p:grpSpPr>
+        <a:xfrm>
+          <a:off x="0" y="0"/>
+          <a:ext cx="0" cy="0"/>
+          <a:chOff x="0" y="0"/>
+          <a:chExt cx="0" cy="0"/>
+        </a:xfrm>
+      </p:grpSpPr>
+      <p:sp>
+        <p:nvSpPr>
+          <p:cNvPr id="7" name="Slide Number Placeholder 6">
+            <a:extLst>
+              <a:ext uri="{FF2B5EF4-FFF2-40B4-BE49-F238E27FC236}">
+                <a16:creationId xmlns:a16="http://schemas.microsoft.com/office/drawing/2014/main" id="{28233E5B-9FB7-B156-5DBA-C9C55E8424A9}"/>
+              </a:ext>
+            </a:extLst>
+          </p:cNvPr>
+          <p:cNvSpPr>
+            <a:spLocks noGrp="1"/>
+          </p:cNvSpPr>
+          <p:nvPr>
+            <p:ph type="sldNum" sz="quarter" idx="12"/>
+          </p:nvPr>
+        </p:nvSpPr>
+        <p:spPr/>
+        <p:txBody>
+          <a:bodyPr/>
+          <a:lstStyle/>
+          <a:p>
+            <a:fld id="{3899FC77-40C7-4C49-9A19-86BDE9B75E8A}" type="slidenum">
+              <a:rPr lang="en-CA" smtClean="0"/>
+              <a:pPr/>
+              <a:t>9</a:t>
+            </a:fld>
+            <a:endParaRPr lang="en-CA" sz="1400"/>
+          </a:p>
+        </p:txBody>
+      </p:sp>
+      <p:sp>
+        <p:nvSpPr>
+          <p:cNvPr id="3" name="Rectangle: Rounded Corners 2">
+            <a:extLst>
+              <a:ext uri="{FF2B5EF4-FFF2-40B4-BE49-F238E27FC236}">
+                <a16:creationId xmlns:a16="http://schemas.microsoft.com/office/drawing/2014/main" id="{F8974DA8-9E7C-193C-029D-F2C24289D4A9}"/>
+              </a:ext>
+            </a:extLst>
+          </p:cNvPr>
+          <p:cNvSpPr/>
+          <p:nvPr/>
+        </p:nvSpPr>
+        <p:spPr>
+          <a:xfrm>
+            <a:off x="315257" y="8582"/>
+            <a:ext cx="9363581" cy="628742"/>
+          </a:xfrm>
+          <a:prstGeom prst="roundRect">
+            <a:avLst/>
+          </a:prstGeom>
+          <a:solidFill>
+            <a:srgbClr val="0162B3"/>
+          </a:solidFill>
+          <a:ln>
+            <a:solidFill>
+              <a:srgbClr val="0162B3"/>
+            </a:solidFill>
+          </a:ln>
+        </p:spPr>
+        <p:style>
+          <a:lnRef idx="2">
+            <a:schemeClr val="accent1">
+              <a:shade val="50000"/>
+            </a:schemeClr>
+          </a:lnRef>
+          <a:fillRef idx="1">
+            <a:schemeClr val="accent1"/>
+          </a:fillRef>
+          <a:effectRef idx="0">
+            <a:schemeClr val="accent1"/>
+          </a:effectRef>
+          <a:fontRef idx="minor">
+            <a:schemeClr val="lt1"/>
+          </a:fontRef>
+        </p:style>
+        <p:txBody>
+          <a:bodyPr rtlCol="0" anchor="ctr"/>
+          <a:lstStyle>
+            <a:defPPr>
+              <a:defRPr lang="en-US"/>
+            </a:defPPr>
+            <a:lvl1pPr marL="0" algn="l" defTabSz="914400" rtl="0" eaLnBrk="1" latinLnBrk="0" hangingPunct="1">
+              <a:defRPr sz="1800" kern="1200">
+                <a:solidFill>
+                  <a:schemeClr val="lt1"/>
+                </a:solidFill>
+                <a:latin typeface="+mn-lt"/>
+                <a:ea typeface="+mn-ea"/>
+                <a:cs typeface="+mn-cs"/>
+              </a:defRPr>
+            </a:lvl1pPr>
+            <a:lvl2pPr marL="457200" algn="l" defTabSz="914400" rtl="0" eaLnBrk="1" latinLnBrk="0" hangingPunct="1">
+              <a:defRPr sz="1800" kern="1200">
+                <a:solidFill>
+                  <a:schemeClr val="lt1"/>
+                </a:solidFill>
+                <a:latin typeface="+mn-lt"/>
+                <a:ea typeface="+mn-ea"/>
+                <a:cs typeface="+mn-cs"/>
+              </a:defRPr>
+            </a:lvl2pPr>
+            <a:lvl3pPr marL="914400" algn="l" defTabSz="914400" rtl="0" eaLnBrk="1" latinLnBrk="0" hangingPunct="1">
+              <a:defRPr sz="1800" kern="1200">
+                <a:solidFill>
+                  <a:schemeClr val="lt1"/>
+                </a:solidFill>
+                <a:latin typeface="+mn-lt"/>
+                <a:ea typeface="+mn-ea"/>
+                <a:cs typeface="+mn-cs"/>
+              </a:defRPr>
+            </a:lvl3pPr>
+            <a:lvl4pPr marL="1371600" algn="l" defTabSz="914400" rtl="0" eaLnBrk="1" latinLnBrk="0" hangingPunct="1">
+              <a:defRPr sz="1800" kern="1200">
+                <a:solidFill>
+                  <a:schemeClr val="lt1"/>
+                </a:solidFill>
+                <a:latin typeface="+mn-lt"/>
+                <a:ea typeface="+mn-ea"/>
+                <a:cs typeface="+mn-cs"/>
+              </a:defRPr>
+            </a:lvl4pPr>
+            <a:lvl5pPr marL="1828800" algn="l" defTabSz="914400" rtl="0" eaLnBrk="1" latinLnBrk="0" hangingPunct="1">
+              <a:defRPr sz="1800" kern="1200">
+                <a:solidFill>
+                  <a:schemeClr val="lt1"/>
+                </a:solidFill>
+                <a:latin typeface="+mn-lt"/>
+                <a:ea typeface="+mn-ea"/>
+                <a:cs typeface="+mn-cs"/>
+              </a:defRPr>
+            </a:lvl5pPr>
+            <a:lvl6pPr marL="2286000" algn="l" defTabSz="914400" rtl="0" eaLnBrk="1" latinLnBrk="0" hangingPunct="1">
+              <a:defRPr sz="1800" kern="1200">
+                <a:solidFill>
+                  <a:schemeClr val="lt1"/>
+                </a:solidFill>
+                <a:latin typeface="+mn-lt"/>
+                <a:ea typeface="+mn-ea"/>
+                <a:cs typeface="+mn-cs"/>
+              </a:defRPr>
+            </a:lvl6pPr>
+            <a:lvl7pPr marL="2743200" algn="l" defTabSz="914400" rtl="0" eaLnBrk="1" latinLnBrk="0" hangingPunct="1">
+              <a:defRPr sz="1800" kern="1200">
+                <a:solidFill>
+                  <a:schemeClr val="lt1"/>
+                </a:solidFill>
+                <a:latin typeface="+mn-lt"/>
+                <a:ea typeface="+mn-ea"/>
+                <a:cs typeface="+mn-cs"/>
+              </a:defRPr>
+            </a:lvl7pPr>
+            <a:lvl8pPr marL="3200400" algn="l" defTabSz="914400" rtl="0" eaLnBrk="1" latinLnBrk="0" hangingPunct="1">
+              <a:defRPr sz="1800" kern="1200">
+                <a:solidFill>
+                  <a:schemeClr val="lt1"/>
+                </a:solidFill>
+                <a:latin typeface="+mn-lt"/>
+                <a:ea typeface="+mn-ea"/>
+                <a:cs typeface="+mn-cs"/>
+              </a:defRPr>
+            </a:lvl8pPr>
+            <a:lvl9pPr marL="3657600" algn="l" defTabSz="914400" rtl="0" eaLnBrk="1" latinLnBrk="0" hangingPunct="1">
+              <a:defRPr sz="1800" kern="1200">
+                <a:solidFill>
+                  <a:schemeClr val="lt1"/>
+                </a:solidFill>
+                <a:latin typeface="+mn-lt"/>
+                <a:ea typeface="+mn-ea"/>
+                <a:cs typeface="+mn-cs"/>
+              </a:defRPr>
+            </a:lvl9pPr>
+          </a:lstStyle>
+          <a:p>
+            <a:pPr algn="ctr"/>
+            <a:endParaRPr lang="en-CA"/>
+          </a:p>
+        </p:txBody>
+      </p:sp>
+      <p:sp>
+        <p:nvSpPr>
+          <p:cNvPr id="5" name="TextBox 4">
+            <a:extLst>
+              <a:ext uri="{FF2B5EF4-FFF2-40B4-BE49-F238E27FC236}">
+                <a16:creationId xmlns:a16="http://schemas.microsoft.com/office/drawing/2014/main" id="{F7ECC1CE-8E06-7958-0EBF-A2A7B9442C93}"/>
+              </a:ext>
+            </a:extLst>
+          </p:cNvPr>
+          <p:cNvSpPr txBox="1"/>
+          <p:nvPr/>
+        </p:nvSpPr>
+        <p:spPr>
+          <a:xfrm>
+            <a:off x="527959" y="76731"/>
+            <a:ext cx="8710932" cy="492443"/>
+          </a:xfrm>
+          <a:prstGeom prst="rect">
+            <a:avLst/>
+          </a:prstGeom>
+          <a:noFill/>
+        </p:spPr>
+        <p:txBody>
+          <a:bodyPr wrap="square" rtlCol="0">
+            <a:spAutoFit/>
+          </a:bodyPr>
+          <a:lstStyle/>
+          <a:p>
+            <a:r>
+              <a:rPr lang="en-US" sz="2600" b="1" dirty="0">
+                <a:solidFill>
+                  <a:schemeClr val="bg1"/>
+                </a:solidFill>
+                <a:latin typeface="Georgia Pro" panose="02040502050405020303" pitchFamily="18" charset="0"/>
+              </a:rPr>
+              <a:t>Composite score: PyMOL RMSD term</a:t>
+            </a:r>
+            <a:endParaRPr lang="en-CA" sz="2600" b="1" dirty="0">
+              <a:solidFill>
+                <a:schemeClr val="bg1"/>
+              </a:solidFill>
+              <a:latin typeface="Georgia Pro" panose="02040502050405020303" pitchFamily="18" charset="0"/>
+            </a:endParaRPr>
+          </a:p>
+        </p:txBody>
+      </p:sp>
+      <p:sp>
+        <p:nvSpPr>
+          <p:cNvPr id="4" name="Left Brace 3">
+            <a:extLst>
+              <a:ext uri="{FF2B5EF4-FFF2-40B4-BE49-F238E27FC236}">
+                <a16:creationId xmlns:a16="http://schemas.microsoft.com/office/drawing/2014/main" id="{F9AEED0B-859E-9ADC-B75F-82FA477055CA}"/>
+              </a:ext>
+            </a:extLst>
+          </p:cNvPr>
+          <p:cNvSpPr/>
+          <p:nvPr/>
+        </p:nvSpPr>
+        <p:spPr>
+          <a:xfrm>
+            <a:off x="3769744" y="1535501"/>
+            <a:ext cx="491706" cy="4054415"/>
+          </a:xfrm>
+          <a:prstGeom prst="leftBrace">
+            <a:avLst>
+              <a:gd name="adj1" fmla="val 66406"/>
+              <a:gd name="adj2" fmla="val 50000"/>
+            </a:avLst>
+          </a:prstGeom>
+          <a:ln w="19050">
+            <a:solidFill>
+              <a:schemeClr val="tx1"/>
+            </a:solidFill>
+          </a:ln>
+        </p:spPr>
+        <p:style>
+          <a:lnRef idx="2">
+            <a:schemeClr val="accent1"/>
+          </a:lnRef>
+          <a:fillRef idx="0">
+            <a:schemeClr val="accent1"/>
+          </a:fillRef>
+          <a:effectRef idx="1">
+            <a:schemeClr val="accent1"/>
+          </a:effectRef>
+          <a:fontRef idx="minor">
+            <a:schemeClr val="tx1"/>
+          </a:fontRef>
+        </p:style>
+        <p:txBody>
+          <a:bodyPr rtlCol="0" anchor="ctr"/>
+          <a:lstStyle/>
+          <a:p>
+            <a:pPr algn="ctr"/>
+            <a:endParaRPr lang="en-CA"/>
+          </a:p>
+        </p:txBody>
+      </p:sp>
+      <p:sp>
+        <p:nvSpPr>
+          <p:cNvPr id="8" name="TextBox 7">
+            <a:extLst>
+              <a:ext uri="{FF2B5EF4-FFF2-40B4-BE49-F238E27FC236}">
+                <a16:creationId xmlns:a16="http://schemas.microsoft.com/office/drawing/2014/main" id="{8328DED4-DBC8-683D-0AD8-0D5A443D9BF4}"/>
+              </a:ext>
+            </a:extLst>
+          </p:cNvPr>
+          <p:cNvSpPr txBox="1"/>
+          <p:nvPr/>
+        </p:nvSpPr>
+        <p:spPr>
+          <a:xfrm>
+            <a:off x="1802921" y="3343712"/>
+            <a:ext cx="1751162" cy="646331"/>
+          </a:xfrm>
+          <a:prstGeom prst="rect">
+            <a:avLst/>
+          </a:prstGeom>
+          <a:noFill/>
+        </p:spPr>
+        <p:txBody>
+          <a:bodyPr wrap="square" rtlCol="0">
+            <a:spAutoFit/>
+          </a:bodyPr>
+          <a:lstStyle/>
+          <a:p>
+            <a:pPr algn="ctr"/>
+            <a:r>
+              <a:rPr lang="en-US" dirty="0">
+                <a:latin typeface="Verdana Pro" panose="020B0604030504040204" pitchFamily="34" charset="0"/>
+              </a:rPr>
+              <a:t>Composite score</a:t>
+            </a:r>
+            <a:endParaRPr lang="en-CA" dirty="0">
+              <a:latin typeface="Verdana Pro" panose="020B0604030504040204" pitchFamily="34" charset="0"/>
+            </a:endParaRPr>
+          </a:p>
+        </p:txBody>
+      </p:sp>
+      <p:sp>
+        <p:nvSpPr>
+          <p:cNvPr id="11" name="TextBox 10">
+            <a:extLst>
+              <a:ext uri="{FF2B5EF4-FFF2-40B4-BE49-F238E27FC236}">
+                <a16:creationId xmlns:a16="http://schemas.microsoft.com/office/drawing/2014/main" id="{2548A35C-C229-4D3B-B997-AAB149919B61}"/>
+              </a:ext>
+            </a:extLst>
+          </p:cNvPr>
+          <p:cNvSpPr txBox="1"/>
+          <p:nvPr/>
+        </p:nvSpPr>
+        <p:spPr>
+          <a:xfrm>
+            <a:off x="4477111" y="1750580"/>
+            <a:ext cx="853141" cy="400110"/>
+          </a:xfrm>
+          <a:prstGeom prst="rect">
+            <a:avLst/>
+          </a:prstGeom>
+          <a:noFill/>
+          <a:ln>
+            <a:solidFill>
+              <a:schemeClr val="tx1"/>
+            </a:solidFill>
+          </a:ln>
+        </p:spPr>
+        <p:txBody>
+          <a:bodyPr wrap="square" rtlCol="0">
+            <a:spAutoFit/>
+          </a:bodyPr>
+          <a:lstStyle/>
+          <a:p>
+            <a:pPr algn="ctr"/>
+            <a:r>
+              <a:rPr lang="en-US" sz="2000" dirty="0">
+                <a:latin typeface="Verdana Pro" panose="020B0604030504040204" pitchFamily="34" charset="0"/>
+              </a:rPr>
+              <a:t>0.40</a:t>
+            </a:r>
+            <a:endParaRPr lang="en-CA" sz="2000" dirty="0">
+              <a:latin typeface="Verdana Pro" panose="020B0604030504040204" pitchFamily="34" charset="0"/>
+            </a:endParaRPr>
+          </a:p>
+        </p:txBody>
+      </p:sp>
+      <p:sp>
+        <p:nvSpPr>
+          <p:cNvPr id="18" name="TextBox 17">
+            <a:extLst>
+              <a:ext uri="{FF2B5EF4-FFF2-40B4-BE49-F238E27FC236}">
+                <a16:creationId xmlns:a16="http://schemas.microsoft.com/office/drawing/2014/main" id="{E16B46B0-3007-BCB5-CC7B-BA07D110976D}"/>
+              </a:ext>
+            </a:extLst>
+          </p:cNvPr>
+          <p:cNvSpPr txBox="1"/>
+          <p:nvPr/>
+        </p:nvSpPr>
+        <p:spPr>
+          <a:xfrm>
+            <a:off x="4477111" y="2388323"/>
+            <a:ext cx="853141" cy="400110"/>
+          </a:xfrm>
+          <a:prstGeom prst="rect">
+            <a:avLst/>
+          </a:prstGeom>
+          <a:noFill/>
+          <a:ln>
+            <a:solidFill>
+              <a:schemeClr val="tx1"/>
+            </a:solidFill>
+          </a:ln>
+        </p:spPr>
+        <p:txBody>
+          <a:bodyPr wrap="square" rtlCol="0">
+            <a:spAutoFit/>
+          </a:bodyPr>
+          <a:lstStyle/>
+          <a:p>
+            <a:pPr algn="ctr"/>
+            <a:r>
+              <a:rPr lang="en-US" sz="2000" dirty="0">
+                <a:latin typeface="Verdana Pro" panose="020B0604030504040204" pitchFamily="34" charset="0"/>
+              </a:rPr>
+              <a:t>0.35</a:t>
+            </a:r>
+            <a:endParaRPr lang="en-CA" sz="2000" dirty="0">
+              <a:latin typeface="Verdana Pro" panose="020B0604030504040204" pitchFamily="34" charset="0"/>
+            </a:endParaRPr>
+          </a:p>
+        </p:txBody>
+      </p:sp>
+      <p:sp>
+        <p:nvSpPr>
+          <p:cNvPr id="28" name="TextBox 27">
+            <a:extLst>
+              <a:ext uri="{FF2B5EF4-FFF2-40B4-BE49-F238E27FC236}">
+                <a16:creationId xmlns:a16="http://schemas.microsoft.com/office/drawing/2014/main" id="{6B3C0383-BE71-D53A-E78A-8914873CE23D}"/>
+              </a:ext>
+            </a:extLst>
+          </p:cNvPr>
+          <p:cNvSpPr txBox="1"/>
+          <p:nvPr/>
+        </p:nvSpPr>
+        <p:spPr>
+          <a:xfrm>
+            <a:off x="4477111" y="3026066"/>
+            <a:ext cx="853141" cy="400110"/>
+          </a:xfrm>
+          <a:prstGeom prst="rect">
+            <a:avLst/>
+          </a:prstGeom>
+          <a:noFill/>
+          <a:ln>
+            <a:solidFill>
+              <a:schemeClr val="tx1"/>
+            </a:solidFill>
+          </a:ln>
+        </p:spPr>
+        <p:txBody>
+          <a:bodyPr wrap="square" rtlCol="0">
+            <a:spAutoFit/>
+          </a:bodyPr>
+          <a:lstStyle/>
+          <a:p>
+            <a:pPr algn="ctr"/>
+            <a:r>
+              <a:rPr lang="en-US" sz="2000" dirty="0">
+                <a:latin typeface="Verdana Pro" panose="020B0604030504040204" pitchFamily="34" charset="0"/>
+              </a:rPr>
+              <a:t>0.05</a:t>
+            </a:r>
+            <a:endParaRPr lang="en-CA" sz="2000" dirty="0">
+              <a:latin typeface="Verdana Pro" panose="020B0604030504040204" pitchFamily="34" charset="0"/>
+            </a:endParaRPr>
+          </a:p>
+        </p:txBody>
+      </p:sp>
+      <p:sp>
+        <p:nvSpPr>
+          <p:cNvPr id="30" name="TextBox 29">
+            <a:extLst>
+              <a:ext uri="{FF2B5EF4-FFF2-40B4-BE49-F238E27FC236}">
+                <a16:creationId xmlns:a16="http://schemas.microsoft.com/office/drawing/2014/main" id="{86CDBEE4-AF87-D882-E926-2C1B647F509A}"/>
+              </a:ext>
+            </a:extLst>
+          </p:cNvPr>
+          <p:cNvSpPr txBox="1"/>
+          <p:nvPr/>
+        </p:nvSpPr>
+        <p:spPr>
+          <a:xfrm>
+            <a:off x="4307522" y="4301552"/>
+            <a:ext cx="1192317" cy="400110"/>
+          </a:xfrm>
+          <a:prstGeom prst="rect">
+            <a:avLst/>
+          </a:prstGeom>
+          <a:noFill/>
+          <a:ln>
+            <a:solidFill>
+              <a:schemeClr val="tx1"/>
+            </a:solidFill>
+          </a:ln>
+        </p:spPr>
+        <p:txBody>
+          <a:bodyPr wrap="square" rtlCol="0">
+            <a:spAutoFit/>
+          </a:bodyPr>
+          <a:lstStyle/>
+          <a:p>
+            <a:pPr algn="ctr"/>
+            <a:r>
+              <a:rPr lang="en-US" sz="2000" dirty="0">
+                <a:latin typeface="Verdana Pro" panose="020B0604030504040204" pitchFamily="34" charset="0"/>
+              </a:rPr>
+              <a:t>0.075</a:t>
+            </a:r>
+            <a:endParaRPr lang="en-CA" sz="2000" dirty="0">
+              <a:latin typeface="Verdana Pro" panose="020B0604030504040204" pitchFamily="34" charset="0"/>
+            </a:endParaRPr>
+          </a:p>
+        </p:txBody>
+      </p:sp>
+      <p:sp>
+        <p:nvSpPr>
+          <p:cNvPr id="32" name="TextBox 31">
+            <a:extLst>
+              <a:ext uri="{FF2B5EF4-FFF2-40B4-BE49-F238E27FC236}">
+                <a16:creationId xmlns:a16="http://schemas.microsoft.com/office/drawing/2014/main" id="{81E05E2A-88A7-4FE5-B73D-087489CCC75A}"/>
+              </a:ext>
+            </a:extLst>
+          </p:cNvPr>
+          <p:cNvSpPr txBox="1"/>
+          <p:nvPr/>
+        </p:nvSpPr>
+        <p:spPr>
+          <a:xfrm>
+            <a:off x="4477111" y="3663809"/>
+            <a:ext cx="853141" cy="400110"/>
+          </a:xfrm>
+          <a:prstGeom prst="rect">
+            <a:avLst/>
+          </a:prstGeom>
+          <a:noFill/>
+          <a:ln>
+            <a:solidFill>
+              <a:schemeClr val="tx1"/>
+            </a:solidFill>
+          </a:ln>
+        </p:spPr>
+        <p:txBody>
+          <a:bodyPr wrap="square" rtlCol="0">
+            <a:spAutoFit/>
+          </a:bodyPr>
+          <a:lstStyle/>
+          <a:p>
+            <a:pPr algn="ctr"/>
+            <a:r>
+              <a:rPr lang="en-US" sz="2000" dirty="0">
+                <a:latin typeface="Verdana Pro" panose="020B0604030504040204" pitchFamily="34" charset="0"/>
+              </a:rPr>
+              <a:t>0.05</a:t>
+            </a:r>
+            <a:endParaRPr lang="en-CA" sz="2000" dirty="0">
+              <a:latin typeface="Verdana Pro" panose="020B0604030504040204" pitchFamily="34" charset="0"/>
+            </a:endParaRPr>
+          </a:p>
+        </p:txBody>
+      </p:sp>
+      <p:sp>
+        <p:nvSpPr>
+          <p:cNvPr id="34" name="TextBox 33">
+            <a:extLst>
+              <a:ext uri="{FF2B5EF4-FFF2-40B4-BE49-F238E27FC236}">
+                <a16:creationId xmlns:a16="http://schemas.microsoft.com/office/drawing/2014/main" id="{935FDD19-BE06-690C-1633-B2C65A4190ED}"/>
+              </a:ext>
+            </a:extLst>
+          </p:cNvPr>
+          <p:cNvSpPr txBox="1"/>
+          <p:nvPr/>
+        </p:nvSpPr>
+        <p:spPr>
+          <a:xfrm>
+            <a:off x="4307522" y="4939295"/>
+            <a:ext cx="1192317" cy="400110"/>
+          </a:xfrm>
+          <a:prstGeom prst="rect">
+            <a:avLst/>
+          </a:prstGeom>
+          <a:noFill/>
+          <a:ln>
+            <a:solidFill>
+              <a:schemeClr val="tx1"/>
+            </a:solidFill>
+          </a:ln>
+        </p:spPr>
+        <p:txBody>
+          <a:bodyPr wrap="square" rtlCol="0">
+            <a:spAutoFit/>
+          </a:bodyPr>
+          <a:lstStyle/>
+          <a:p>
+            <a:pPr algn="ctr"/>
+            <a:r>
+              <a:rPr lang="en-US" sz="2000" dirty="0">
+                <a:latin typeface="Verdana Pro" panose="020B0604030504040204" pitchFamily="34" charset="0"/>
+              </a:rPr>
+              <a:t>0.075</a:t>
+            </a:r>
+            <a:endParaRPr lang="en-CA" sz="2000" dirty="0">
+              <a:latin typeface="Verdana Pro" panose="020B0604030504040204" pitchFamily="34" charset="0"/>
+            </a:endParaRPr>
+          </a:p>
+        </p:txBody>
+      </p:sp>
+      <p:sp>
+        <p:nvSpPr>
+          <p:cNvPr id="35" name="TextBox 34">
+            <a:extLst>
+              <a:ext uri="{FF2B5EF4-FFF2-40B4-BE49-F238E27FC236}">
+                <a16:creationId xmlns:a16="http://schemas.microsoft.com/office/drawing/2014/main" id="{7723687C-5692-135C-A4FE-826450958AAA}"/>
+              </a:ext>
+            </a:extLst>
+          </p:cNvPr>
+          <p:cNvSpPr txBox="1"/>
+          <p:nvPr/>
+        </p:nvSpPr>
+        <p:spPr>
+          <a:xfrm>
+            <a:off x="5827142" y="1725962"/>
+            <a:ext cx="2851031" cy="369332"/>
+          </a:xfrm>
+          <a:prstGeom prst="rect">
+            <a:avLst/>
+          </a:prstGeom>
+          <a:noFill/>
+        </p:spPr>
+        <p:txBody>
+          <a:bodyPr wrap="square" rtlCol="0">
+            <a:spAutoFit/>
+          </a:bodyPr>
+          <a:lstStyle/>
+          <a:p>
+            <a:r>
+              <a:rPr lang="en-US" dirty="0">
+                <a:latin typeface="Verdana Pro" panose="020B0604030504040204" pitchFamily="34" charset="0"/>
+              </a:rPr>
+              <a:t>PyMOL score term</a:t>
+            </a:r>
+            <a:endParaRPr lang="en-CA" dirty="0">
+              <a:latin typeface="Verdana Pro" panose="020B0604030504040204" pitchFamily="34" charset="0"/>
+            </a:endParaRPr>
+          </a:p>
+        </p:txBody>
+      </p:sp>
+      <p:sp>
+        <p:nvSpPr>
+          <p:cNvPr id="37" name="TextBox 36">
+            <a:extLst>
+              <a:ext uri="{FF2B5EF4-FFF2-40B4-BE49-F238E27FC236}">
+                <a16:creationId xmlns:a16="http://schemas.microsoft.com/office/drawing/2014/main" id="{42CBEC20-DE87-68C0-E171-8639471C5A67}"/>
+              </a:ext>
+            </a:extLst>
+          </p:cNvPr>
+          <p:cNvSpPr txBox="1"/>
+          <p:nvPr/>
+        </p:nvSpPr>
+        <p:spPr>
+          <a:xfrm>
+            <a:off x="5827142" y="2363705"/>
+            <a:ext cx="2851031" cy="369332"/>
+          </a:xfrm>
+          <a:prstGeom prst="rect">
+            <a:avLst/>
+          </a:prstGeom>
+          <a:noFill/>
+        </p:spPr>
+        <p:txBody>
+          <a:bodyPr wrap="square" rtlCol="0">
+            <a:spAutoFit/>
+          </a:bodyPr>
+          <a:lstStyle/>
+          <a:p>
+            <a:r>
+              <a:rPr lang="en-US" dirty="0">
+                <a:latin typeface="Verdana Pro" panose="020B0604030504040204" pitchFamily="34" charset="0"/>
+              </a:rPr>
+              <a:t>E-value score term</a:t>
+            </a:r>
+            <a:endParaRPr lang="en-CA" dirty="0">
+              <a:latin typeface="Verdana Pro" panose="020B0604030504040204" pitchFamily="34" charset="0"/>
+            </a:endParaRPr>
+          </a:p>
+        </p:txBody>
+      </p:sp>
+      <p:sp>
+        <p:nvSpPr>
+          <p:cNvPr id="39" name="TextBox 38">
+            <a:extLst>
+              <a:ext uri="{FF2B5EF4-FFF2-40B4-BE49-F238E27FC236}">
+                <a16:creationId xmlns:a16="http://schemas.microsoft.com/office/drawing/2014/main" id="{5361785F-B575-62D9-1FD4-C08CE622EDA0}"/>
+              </a:ext>
+            </a:extLst>
+          </p:cNvPr>
+          <p:cNvSpPr txBox="1"/>
+          <p:nvPr/>
+        </p:nvSpPr>
+        <p:spPr>
+          <a:xfrm>
+            <a:off x="5827141" y="3041455"/>
+            <a:ext cx="3411750" cy="369332"/>
+          </a:xfrm>
+          <a:prstGeom prst="rect">
+            <a:avLst/>
+          </a:prstGeom>
+          <a:noFill/>
+        </p:spPr>
+        <p:txBody>
+          <a:bodyPr wrap="square" rtlCol="0">
+            <a:spAutoFit/>
+          </a:bodyPr>
+          <a:lstStyle/>
+          <a:p>
+            <a:r>
+              <a:rPr lang="en-US" dirty="0">
+                <a:latin typeface="Verdana Pro" panose="020B0604030504040204" pitchFamily="34" charset="0"/>
+              </a:rPr>
+              <a:t>TM score (human protein)</a:t>
+            </a:r>
+            <a:endParaRPr lang="en-CA" dirty="0">
+              <a:latin typeface="Verdana Pro" panose="020B0604030504040204" pitchFamily="34" charset="0"/>
+            </a:endParaRPr>
+          </a:p>
+        </p:txBody>
+      </p:sp>
+      <p:sp>
+        <p:nvSpPr>
+          <p:cNvPr id="41" name="TextBox 40">
+            <a:extLst>
+              <a:ext uri="{FF2B5EF4-FFF2-40B4-BE49-F238E27FC236}">
+                <a16:creationId xmlns:a16="http://schemas.microsoft.com/office/drawing/2014/main" id="{33183B46-826A-720E-6A3B-310E6F84CCCD}"/>
+              </a:ext>
+            </a:extLst>
+          </p:cNvPr>
+          <p:cNvSpPr txBox="1"/>
+          <p:nvPr/>
+        </p:nvSpPr>
+        <p:spPr>
+          <a:xfrm>
+            <a:off x="5827141" y="3620711"/>
+            <a:ext cx="3411750" cy="369332"/>
+          </a:xfrm>
+          <a:prstGeom prst="rect">
+            <a:avLst/>
+          </a:prstGeom>
+          <a:noFill/>
+        </p:spPr>
+        <p:txBody>
+          <a:bodyPr wrap="square" rtlCol="0">
+            <a:spAutoFit/>
+          </a:bodyPr>
+          <a:lstStyle/>
+          <a:p>
+            <a:r>
+              <a:rPr lang="en-US" dirty="0">
+                <a:latin typeface="Verdana Pro" panose="020B0604030504040204" pitchFamily="34" charset="0"/>
+              </a:rPr>
+              <a:t>TM score (bacterial protein)</a:t>
+            </a:r>
+            <a:endParaRPr lang="en-CA" dirty="0">
+              <a:latin typeface="Verdana Pro" panose="020B0604030504040204" pitchFamily="34" charset="0"/>
+            </a:endParaRPr>
+          </a:p>
+        </p:txBody>
+      </p:sp>
+      <p:sp>
+        <p:nvSpPr>
+          <p:cNvPr id="43" name="TextBox 42">
+            <a:extLst>
+              <a:ext uri="{FF2B5EF4-FFF2-40B4-BE49-F238E27FC236}">
+                <a16:creationId xmlns:a16="http://schemas.microsoft.com/office/drawing/2014/main" id="{036A0E3E-AC9A-F986-2B7B-5BB737BE6048}"/>
+              </a:ext>
+            </a:extLst>
+          </p:cNvPr>
+          <p:cNvSpPr txBox="1"/>
+          <p:nvPr/>
+        </p:nvSpPr>
+        <p:spPr>
+          <a:xfrm>
+            <a:off x="5827141" y="4301552"/>
+            <a:ext cx="3739052" cy="369332"/>
+          </a:xfrm>
+          <a:prstGeom prst="rect">
+            <a:avLst/>
+          </a:prstGeom>
+          <a:noFill/>
+        </p:spPr>
+        <p:txBody>
+          <a:bodyPr wrap="square" rtlCol="0">
+            <a:spAutoFit/>
+          </a:bodyPr>
+          <a:lstStyle/>
+          <a:p>
+            <a:r>
+              <a:rPr lang="en-US" dirty="0">
+                <a:latin typeface="Verdana Pro" panose="020B0604030504040204" pitchFamily="34" charset="0"/>
+              </a:rPr>
+              <a:t>pLDDT (human protein) / 100</a:t>
+            </a:r>
+            <a:endParaRPr lang="en-CA" dirty="0">
+              <a:latin typeface="Verdana Pro" panose="020B0604030504040204" pitchFamily="34" charset="0"/>
+            </a:endParaRPr>
+          </a:p>
+        </p:txBody>
+      </p:sp>
+      <p:sp>
+        <p:nvSpPr>
+          <p:cNvPr id="45" name="TextBox 44">
+            <a:extLst>
+              <a:ext uri="{FF2B5EF4-FFF2-40B4-BE49-F238E27FC236}">
+                <a16:creationId xmlns:a16="http://schemas.microsoft.com/office/drawing/2014/main" id="{13D79893-B955-E120-12A9-F39980A98AF7}"/>
+              </a:ext>
+            </a:extLst>
+          </p:cNvPr>
+          <p:cNvSpPr txBox="1"/>
+          <p:nvPr/>
+        </p:nvSpPr>
+        <p:spPr>
+          <a:xfrm>
+            <a:off x="5827141" y="4939295"/>
+            <a:ext cx="3929334" cy="369332"/>
+          </a:xfrm>
+          <a:prstGeom prst="rect">
+            <a:avLst/>
+          </a:prstGeom>
+          <a:noFill/>
+        </p:spPr>
+        <p:txBody>
+          <a:bodyPr wrap="square" rtlCol="0">
+            <a:spAutoFit/>
+          </a:bodyPr>
+          <a:lstStyle/>
+          <a:p>
+            <a:r>
+              <a:rPr lang="en-US" dirty="0">
+                <a:latin typeface="Verdana Pro" panose="020B0604030504040204" pitchFamily="34" charset="0"/>
+              </a:rPr>
+              <a:t>pLDDT (bacterial protein) / 100</a:t>
+            </a:r>
+            <a:endParaRPr lang="en-CA" dirty="0">
+              <a:latin typeface="Verdana Pro" panose="020B0604030504040204" pitchFamily="34" charset="0"/>
+            </a:endParaRPr>
+          </a:p>
+        </p:txBody>
+      </p:sp>
+      <mc:AlternateContent xmlns:mc="http://schemas.openxmlformats.org/markup-compatibility/2006">
+        <mc:Choice xmlns:a14="http://schemas.microsoft.com/office/drawing/2010/main" Requires="a14">
+          <p:sp>
+            <p:nvSpPr>
+              <p:cNvPr id="47" name="TextBox 46">
+                <a:extLst>
+                  <a:ext uri="{FF2B5EF4-FFF2-40B4-BE49-F238E27FC236}">
+                    <a16:creationId xmlns:a16="http://schemas.microsoft.com/office/drawing/2014/main" id="{FE1257FA-61B4-79E9-59D2-FDAA739A4643}"/>
+                  </a:ext>
+                </a:extLst>
+              </p:cNvPr>
+              <p:cNvSpPr txBox="1"/>
+              <p:nvPr/>
+            </p:nvSpPr>
+            <p:spPr>
+              <a:xfrm>
+                <a:off x="8517480" y="2230481"/>
+                <a:ext cx="2585772" cy="447110"/>
+              </a:xfrm>
+              <a:prstGeom prst="rect">
+                <a:avLst/>
+              </a:prstGeom>
+              <a:noFill/>
+            </p:spPr>
+            <p:txBody>
+              <a:bodyPr wrap="none" lIns="0" tIns="0" rIns="0" bIns="0" rtlCol="0">
+                <a:spAutoFit/>
+              </a:bodyPr>
+              <a:lstStyle/>
+              <a:p>
+                <a14:m>
+                  <m:oMath xmlns:m="http://schemas.openxmlformats.org/officeDocument/2006/math">
+                    <m:r>
+                      <a:rPr lang="en-US" b="0" i="1" smtClean="0">
+                        <a:latin typeface="Cambria Math" panose="02040503050406030204" pitchFamily="18" charset="0"/>
+                      </a:rPr>
+                      <m:t>=1−</m:t>
+                    </m:r>
+                    <m:sSup>
+                      <m:sSupPr>
+                        <m:ctrlPr>
+                          <a:rPr lang="en-US" b="0" i="1" smtClean="0">
+                            <a:latin typeface="Cambria Math" panose="02040503050406030204" pitchFamily="18" charset="0"/>
+                          </a:rPr>
+                        </m:ctrlPr>
+                      </m:sSupPr>
+                      <m:e>
+                        <m:r>
+                          <a:rPr lang="en-US" b="0" i="1" smtClean="0">
+                            <a:latin typeface="Cambria Math" panose="02040503050406030204" pitchFamily="18" charset="0"/>
+                          </a:rPr>
+                          <m:t>𝑒</m:t>
+                        </m:r>
+                      </m:e>
+                      <m:sup>
+                        <m:sSup>
+                          <m:sSupPr>
+                            <m:ctrlPr>
+                              <a:rPr lang="en-US" b="0" i="1" smtClean="0">
+                                <a:latin typeface="Cambria Math" panose="02040503050406030204" pitchFamily="18" charset="0"/>
+                              </a:rPr>
+                            </m:ctrlPr>
+                          </m:sSupPr>
+                          <m:e>
+                            <m:r>
+                              <a:rPr lang="en-US" b="0" i="1" smtClean="0">
+                                <a:latin typeface="Cambria Math" panose="02040503050406030204" pitchFamily="18" charset="0"/>
+                              </a:rPr>
+                              <m:t>−</m:t>
+                            </m:r>
+                            <m:d>
+                              <m:dPr>
+                                <m:ctrlPr>
+                                  <a:rPr lang="en-US" i="1">
+                                    <a:latin typeface="Cambria Math" panose="02040503050406030204" pitchFamily="18" charset="0"/>
+                                  </a:rPr>
+                                </m:ctrlPr>
+                              </m:dPr>
+                              <m:e>
+                                <m:f>
+                                  <m:fPr>
+                                    <m:ctrlPr>
+                                      <a:rPr lang="en-US" b="0" i="1" smtClean="0">
+                                        <a:latin typeface="Cambria Math" panose="02040503050406030204" pitchFamily="18" charset="0"/>
+                                      </a:rPr>
+                                    </m:ctrlPr>
+                                  </m:fPr>
+                                  <m:num>
+                                    <m:r>
+                                      <a:rPr lang="en-US" b="0" i="1" smtClean="0">
+                                        <a:latin typeface="Cambria Math" panose="02040503050406030204" pitchFamily="18" charset="0"/>
+                                      </a:rPr>
+                                      <m:t>−</m:t>
+                                    </m:r>
+                                    <m:sSub>
+                                      <m:sSubPr>
+                                        <m:ctrlPr>
+                                          <a:rPr lang="en-US" b="0" i="0" smtClean="0">
+                                            <a:latin typeface="Cambria Math" panose="02040503050406030204" pitchFamily="18" charset="0"/>
+                                          </a:rPr>
+                                        </m:ctrlPr>
+                                      </m:sSubPr>
+                                      <m:e>
+                                        <m:r>
+                                          <m:rPr>
+                                            <m:sty m:val="p"/>
+                                          </m:rPr>
+                                          <a:rPr lang="en-US" b="0" i="0" smtClean="0">
+                                            <a:latin typeface="Cambria Math" panose="02040503050406030204" pitchFamily="18" charset="0"/>
+                                          </a:rPr>
+                                          <m:t>log</m:t>
+                                        </m:r>
+                                      </m:e>
+                                      <m:sub>
+                                        <m:r>
+                                          <a:rPr lang="en-US" b="0" i="0" smtClean="0">
+                                            <a:latin typeface="Cambria Math" panose="02040503050406030204" pitchFamily="18" charset="0"/>
+                                          </a:rPr>
+                                          <m:t>10</m:t>
+                                        </m:r>
+                                      </m:sub>
+                                    </m:sSub>
+                                    <m:r>
+                                      <a:rPr lang="en-US" b="0" i="1" smtClean="0">
+                                        <a:latin typeface="Cambria Math" panose="02040503050406030204" pitchFamily="18" charset="0"/>
+                                      </a:rPr>
+                                      <m:t>⁡(</m:t>
+                                    </m:r>
+                                    <m:r>
+                                      <a:rPr lang="en-US" b="0" i="1" smtClean="0">
+                                        <a:latin typeface="Cambria Math" panose="02040503050406030204" pitchFamily="18" charset="0"/>
+                                      </a:rPr>
+                                      <m:t>𝑒</m:t>
+                                    </m:r>
+                                    <m:r>
+                                      <a:rPr lang="en-US" b="0" i="1" smtClean="0">
+                                        <a:latin typeface="Cambria Math" panose="02040503050406030204" pitchFamily="18" charset="0"/>
+                                      </a:rPr>
+                                      <m:t>_</m:t>
+                                    </m:r>
+                                    <m:r>
+                                      <a:rPr lang="en-US" b="0" i="1" smtClean="0">
+                                        <a:latin typeface="Cambria Math" panose="02040503050406030204" pitchFamily="18" charset="0"/>
+                                      </a:rPr>
+                                      <m:t>𝑣𝑎𝑙𝑢𝑒</m:t>
+                                    </m:r>
+                                    <m:r>
+                                      <a:rPr lang="en-US" b="0" i="1" smtClean="0">
+                                        <a:latin typeface="Cambria Math" panose="02040503050406030204" pitchFamily="18" charset="0"/>
+                                      </a:rPr>
+                                      <m:t>)</m:t>
+                                    </m:r>
+                                  </m:num>
+                                  <m:den>
+                                    <m:r>
+                                      <a:rPr lang="en-US" i="1">
+                                        <a:latin typeface="Cambria Math" panose="02040503050406030204" pitchFamily="18" charset="0"/>
+                                      </a:rPr>
+                                      <m:t>4.7</m:t>
+                                    </m:r>
+                                  </m:den>
+                                </m:f>
+                              </m:e>
+                            </m:d>
+                          </m:e>
+                          <m:sup>
+                            <m:r>
+                              <a:rPr lang="en-US" i="1">
+                                <a:latin typeface="Cambria Math" panose="02040503050406030204" pitchFamily="18" charset="0"/>
+                              </a:rPr>
+                              <m:t>1.03</m:t>
+                            </m:r>
+                          </m:sup>
+                        </m:sSup>
+                      </m:sup>
+                    </m:sSup>
+                  </m:oMath>
+                </a14:m>
+                <a:r>
+                  <a:rPr lang="en-CA" dirty="0"/>
+                  <a:t> </a:t>
+                </a:r>
+              </a:p>
+            </p:txBody>
+          </p:sp>
+        </mc:Choice>
+        <mc:Fallback>
+          <p:sp>
+            <p:nvSpPr>
+              <p:cNvPr id="47" name="TextBox 46">
+                <a:extLst>
+                  <a:ext uri="{FF2B5EF4-FFF2-40B4-BE49-F238E27FC236}">
+                    <a16:creationId xmlns:a16="http://schemas.microsoft.com/office/drawing/2014/main" id="{FE1257FA-61B4-79E9-59D2-FDAA739A4643}"/>
+                  </a:ext>
+                </a:extLst>
+              </p:cNvPr>
+              <p:cNvSpPr txBox="1">
+                <a:spLocks noRot="1" noChangeAspect="1" noMove="1" noResize="1" noEditPoints="1" noAdjustHandles="1" noChangeArrowheads="1" noChangeShapeType="1" noTextEdit="1"/>
+              </p:cNvSpPr>
+              <p:nvPr/>
+            </p:nvSpPr>
+            <p:spPr>
+              <a:xfrm>
+                <a:off x="8517480" y="2230481"/>
+                <a:ext cx="2585772" cy="447110"/>
+              </a:xfrm>
+              <a:prstGeom prst="rect">
+                <a:avLst/>
+              </a:prstGeom>
+              <a:blipFill>
+                <a:blip r:embed="rId3"/>
+                <a:stretch>
+                  <a:fillRect/>
+                </a:stretch>
+              </a:blipFill>
+            </p:spPr>
+            <p:txBody>
+              <a:bodyPr/>
+              <a:lstStyle/>
+              <a:p>
+                <a:r>
+                  <a:rPr lang="en-CA">
+                    <a:noFill/>
+                  </a:rPr>
+                  <a:t> </a:t>
+                </a:r>
+              </a:p>
+            </p:txBody>
+          </p:sp>
+        </mc:Fallback>
+      </mc:AlternateContent>
+      <mc:AlternateContent xmlns:mc="http://schemas.openxmlformats.org/markup-compatibility/2006">
+        <mc:Choice xmlns:a14="http://schemas.microsoft.com/office/drawing/2010/main" Requires="a14">
+          <p:sp>
+            <p:nvSpPr>
+              <p:cNvPr id="51" name="TextBox 50">
+                <a:extLst>
+                  <a:ext uri="{FF2B5EF4-FFF2-40B4-BE49-F238E27FC236}">
+                    <a16:creationId xmlns:a16="http://schemas.microsoft.com/office/drawing/2014/main" id="{ED07372F-CC59-F650-3BDF-BD7D83BD1D26}"/>
+                  </a:ext>
+                </a:extLst>
+              </p:cNvPr>
+              <p:cNvSpPr txBox="1"/>
+              <p:nvPr/>
+            </p:nvSpPr>
+            <p:spPr>
+              <a:xfrm>
+                <a:off x="8500228" y="1601768"/>
+                <a:ext cx="2951193" cy="529697"/>
+              </a:xfrm>
+              <a:prstGeom prst="rect">
+                <a:avLst/>
+              </a:prstGeom>
+              <a:noFill/>
+            </p:spPr>
+            <p:txBody>
+              <a:bodyPr wrap="none" lIns="0" tIns="0" rIns="0" bIns="0" rtlCol="0">
+                <a:spAutoFit/>
+              </a:bodyPr>
+              <a:lstStyle/>
+              <a:p>
+                <a:pPr/>
+                <a14:m>
+                  <m:oMathPara xmlns:m="http://schemas.openxmlformats.org/officeDocument/2006/math">
+                    <m:oMath>
+                      <m:r>
+                        <a:rPr lang="en-US" b="0" i="1" smtClean="0">
+                          <a:latin typeface="Cambria Math" panose="02040503050406030204" pitchFamily="18" charset="0"/>
+                        </a:rPr>
+                        <m:t>=</m:t>
+                      </m:r>
+                      <m:f>
+                        <m:fPr>
+                          <m:ctrlPr>
+                            <a:rPr lang="en-US" b="0" i="1" smtClean="0">
+                              <a:latin typeface="Cambria Math" panose="02040503050406030204" pitchFamily="18" charset="0"/>
+                            </a:rPr>
+                          </m:ctrlPr>
+                        </m:fPr>
+                        <m:num>
+                          <m:r>
+                            <a:rPr lang="en-US" b="0" i="1" smtClean="0">
+                              <a:latin typeface="Cambria Math" panose="02040503050406030204" pitchFamily="18" charset="0"/>
+                            </a:rPr>
+                            <m:t>1.06</m:t>
+                          </m:r>
+                        </m:num>
+                        <m:den>
+                          <m:r>
+                            <a:rPr lang="en-US" b="0" i="1" smtClean="0">
+                              <a:latin typeface="Cambria Math" panose="02040503050406030204" pitchFamily="18" charset="0"/>
+                            </a:rPr>
+                            <m:t>1+</m:t>
+                          </m:r>
+                          <m:sSup>
+                            <m:sSupPr>
+                              <m:ctrlPr>
+                                <a:rPr lang="en-US" b="0" i="1" smtClean="0">
+                                  <a:latin typeface="Cambria Math" panose="02040503050406030204" pitchFamily="18" charset="0"/>
+                                </a:rPr>
+                              </m:ctrlPr>
+                            </m:sSupPr>
+                            <m:e>
+                              <m:r>
+                                <a:rPr lang="en-US" b="0" i="1" smtClean="0">
+                                  <a:latin typeface="Cambria Math" panose="02040503050406030204" pitchFamily="18" charset="0"/>
+                                </a:rPr>
+                                <m:t>𝑒</m:t>
+                              </m:r>
+                            </m:e>
+                            <m:sup>
+                              <m:r>
+                                <a:rPr lang="en-US" b="0" i="1" smtClean="0">
+                                  <a:latin typeface="Cambria Math" panose="02040503050406030204" pitchFamily="18" charset="0"/>
+                                </a:rPr>
+                                <m:t>0.635(</m:t>
+                              </m:r>
+                              <m:r>
+                                <a:rPr lang="en-US" b="0" i="1" smtClean="0">
+                                  <a:latin typeface="Cambria Math" panose="02040503050406030204" pitchFamily="18" charset="0"/>
+                                </a:rPr>
+                                <m:t>𝑃𝑦𝑀𝑂𝐿</m:t>
+                              </m:r>
+                              <m:r>
+                                <a:rPr lang="en-US" b="0" i="1" smtClean="0">
+                                  <a:latin typeface="Cambria Math" panose="02040503050406030204" pitchFamily="18" charset="0"/>
+                                </a:rPr>
+                                <m:t>_</m:t>
+                              </m:r>
+                              <m:r>
+                                <a:rPr lang="en-US" b="0" i="1" smtClean="0">
+                                  <a:latin typeface="Cambria Math" panose="02040503050406030204" pitchFamily="18" charset="0"/>
+                                </a:rPr>
+                                <m:t>𝑅𝑀𝑆𝐷</m:t>
+                              </m:r>
+                              <m:r>
+                                <a:rPr lang="en-US" b="0" i="1" smtClean="0">
+                                  <a:latin typeface="Cambria Math" panose="02040503050406030204" pitchFamily="18" charset="0"/>
+                                </a:rPr>
+                                <m:t>−4.94)</m:t>
+                              </m:r>
+                            </m:sup>
+                          </m:sSup>
+                        </m:den>
+                      </m:f>
+                    </m:oMath>
+                  </m:oMathPara>
+                </a14:m>
+                <a:endParaRPr lang="en-CA" dirty="0"/>
+              </a:p>
+            </p:txBody>
+          </p:sp>
+        </mc:Choice>
+        <mc:Fallback>
+          <p:sp>
+            <p:nvSpPr>
+              <p:cNvPr id="51" name="TextBox 50">
+                <a:extLst>
+                  <a:ext uri="{FF2B5EF4-FFF2-40B4-BE49-F238E27FC236}">
+                    <a16:creationId xmlns:a16="http://schemas.microsoft.com/office/drawing/2014/main" id="{ED07372F-CC59-F650-3BDF-BD7D83BD1D26}"/>
+                  </a:ext>
+                </a:extLst>
+              </p:cNvPr>
+              <p:cNvSpPr txBox="1">
+                <a:spLocks noRot="1" noChangeAspect="1" noMove="1" noResize="1" noEditPoints="1" noAdjustHandles="1" noChangeArrowheads="1" noChangeShapeType="1" noTextEdit="1"/>
+              </p:cNvSpPr>
+              <p:nvPr/>
+            </p:nvSpPr>
+            <p:spPr>
+              <a:xfrm>
+                <a:off x="8500228" y="1601768"/>
+                <a:ext cx="2951193" cy="529697"/>
+              </a:xfrm>
+              <a:prstGeom prst="rect">
+                <a:avLst/>
+              </a:prstGeom>
+              <a:blipFill>
+                <a:blip r:embed="rId4"/>
+                <a:stretch>
+                  <a:fillRect/>
+                </a:stretch>
+              </a:blipFill>
+            </p:spPr>
+            <p:txBody>
+              <a:bodyPr/>
+              <a:lstStyle/>
+              <a:p>
+                <a:r>
+                  <a:rPr lang="en-CA">
+                    <a:noFill/>
+                  </a:rPr>
+                  <a:t> </a:t>
+                </a:r>
+              </a:p>
+            </p:txBody>
+          </p:sp>
+        </mc:Fallback>
+      </mc:AlternateContent>
+      <mc:AlternateContent xmlns:mc="http://schemas.openxmlformats.org/markup-compatibility/2006">
+        <mc:Choice xmlns:a14="http://schemas.microsoft.com/office/drawing/2010/main" Requires="a14">
+          <p:sp>
+            <p:nvSpPr>
+              <p:cNvPr id="52" name="TextBox 51">
+                <a:extLst>
+                  <a:ext uri="{FF2B5EF4-FFF2-40B4-BE49-F238E27FC236}">
+                    <a16:creationId xmlns:a16="http://schemas.microsoft.com/office/drawing/2014/main" id="{E61CC45D-F2BB-BE0C-F1B1-FDEC601F88E6}"/>
+                  </a:ext>
+                </a:extLst>
+              </p:cNvPr>
+              <p:cNvSpPr txBox="1"/>
+              <p:nvPr/>
+            </p:nvSpPr>
+            <p:spPr>
+              <a:xfrm>
+                <a:off x="5615545" y="1772128"/>
+                <a:ext cx="211596" cy="276999"/>
+              </a:xfrm>
+              <a:prstGeom prst="rect">
+                <a:avLst/>
+              </a:prstGeom>
+              <a:noFill/>
+            </p:spPr>
+            <p:txBody>
+              <a:bodyPr wrap="none" lIns="0" tIns="0" rIns="0" bIns="0" rtlCol="0">
+                <a:spAutoFit/>
+              </a:bodyPr>
+              <a:lstStyle/>
+              <a:p>
+                <a14:m>
+                  <m:oMathPara xmlns:m="http://schemas.openxmlformats.org/officeDocument/2006/math">
+                    <m:oMath>
+                      <m:r>
+                        <a:rPr lang="en-CA" i="1" smtClean="0">
+                          <a:latin typeface="Cambria Math" panose="02040503050406030204" pitchFamily="18" charset="0"/>
+                          <a:ea typeface="Cambria Math" panose="02040503050406030204" pitchFamily="18" charset="0"/>
+                        </a:rPr>
+                        <m:t>×</m:t>
+                      </m:r>
+                    </m:oMath>
+                  </m:oMathPara>
+                </a14:m>
+                <a:endParaRPr lang="en-CA" dirty="0"/>
+              </a:p>
+            </p:txBody>
+          </p:sp>
+        </mc:Choice>
+        <mc:Fallback>
+          <p:sp>
+            <p:nvSpPr>
+              <p:cNvPr id="52" name="TextBox 51">
+                <a:extLst>
+                  <a:ext uri="{FF2B5EF4-FFF2-40B4-BE49-F238E27FC236}">
+                    <a16:creationId xmlns:a16="http://schemas.microsoft.com/office/drawing/2014/main" id="{E61CC45D-F2BB-BE0C-F1B1-FDEC601F88E6}"/>
+                  </a:ext>
+                </a:extLst>
+              </p:cNvPr>
+              <p:cNvSpPr txBox="1">
+                <a:spLocks noRot="1" noChangeAspect="1" noMove="1" noResize="1" noEditPoints="1" noAdjustHandles="1" noChangeArrowheads="1" noChangeShapeType="1" noTextEdit="1"/>
+              </p:cNvSpPr>
+              <p:nvPr/>
+            </p:nvSpPr>
+            <p:spPr>
+              <a:xfrm>
+                <a:off x="5615545" y="1772128"/>
+                <a:ext cx="211596" cy="276999"/>
+              </a:xfrm>
+              <a:prstGeom prst="rect">
+                <a:avLst/>
+              </a:prstGeom>
+              <a:blipFill>
+                <a:blip r:embed="rId5"/>
+                <a:stretch>
+                  <a:fillRect l="-20000" r="-20000" b="-2222"/>
+                </a:stretch>
+              </a:blipFill>
+            </p:spPr>
+            <p:txBody>
+              <a:bodyPr/>
+              <a:lstStyle/>
+              <a:p>
+                <a:r>
+                  <a:rPr lang="en-CA">
+                    <a:noFill/>
+                  </a:rPr>
+                  <a:t> </a:t>
+                </a:r>
+              </a:p>
+            </p:txBody>
+          </p:sp>
+        </mc:Fallback>
+      </mc:AlternateContent>
+      <mc:AlternateContent xmlns:mc="http://schemas.openxmlformats.org/markup-compatibility/2006">
+        <mc:Choice xmlns:a14="http://schemas.microsoft.com/office/drawing/2010/main" Requires="a14">
+          <p:sp>
+            <p:nvSpPr>
+              <p:cNvPr id="54" name="TextBox 53">
+                <a:extLst>
+                  <a:ext uri="{FF2B5EF4-FFF2-40B4-BE49-F238E27FC236}">
+                    <a16:creationId xmlns:a16="http://schemas.microsoft.com/office/drawing/2014/main" id="{767DADA6-301A-D32D-1B6C-13F3A119DEB7}"/>
+                  </a:ext>
+                </a:extLst>
+              </p:cNvPr>
+              <p:cNvSpPr txBox="1"/>
+              <p:nvPr/>
+            </p:nvSpPr>
+            <p:spPr>
+              <a:xfrm>
+                <a:off x="5642302" y="2410584"/>
+                <a:ext cx="211596" cy="276999"/>
+              </a:xfrm>
+              <a:prstGeom prst="rect">
+                <a:avLst/>
+              </a:prstGeom>
+              <a:noFill/>
+            </p:spPr>
+            <p:txBody>
+              <a:bodyPr wrap="none" lIns="0" tIns="0" rIns="0" bIns="0" rtlCol="0">
+                <a:spAutoFit/>
+              </a:bodyPr>
+              <a:lstStyle/>
+              <a:p>
+                <a:pPr/>
+                <a14:m>
+                  <m:oMathPara xmlns:m="http://schemas.openxmlformats.org/officeDocument/2006/math">
+                    <m:oMath>
+                      <m:r>
+                        <a:rPr lang="en-CA" i="1" smtClean="0">
+                          <a:latin typeface="Cambria Math" panose="02040503050406030204" pitchFamily="18" charset="0"/>
+                          <a:ea typeface="Cambria Math" panose="02040503050406030204" pitchFamily="18" charset="0"/>
+                        </a:rPr>
+                        <m:t>×</m:t>
+                      </m:r>
+                    </m:oMath>
+                  </m:oMathPara>
+                </a14:m>
+                <a:endParaRPr lang="en-CA" dirty="0"/>
+              </a:p>
+            </p:txBody>
+          </p:sp>
+        </mc:Choice>
+        <mc:Fallback>
+          <p:sp>
+            <p:nvSpPr>
+              <p:cNvPr id="54" name="TextBox 53">
+                <a:extLst>
+                  <a:ext uri="{FF2B5EF4-FFF2-40B4-BE49-F238E27FC236}">
+                    <a16:creationId xmlns:a16="http://schemas.microsoft.com/office/drawing/2014/main" id="{767DADA6-301A-D32D-1B6C-13F3A119DEB7}"/>
+                  </a:ext>
+                </a:extLst>
+              </p:cNvPr>
+              <p:cNvSpPr txBox="1">
+                <a:spLocks noRot="1" noChangeAspect="1" noMove="1" noResize="1" noEditPoints="1" noAdjustHandles="1" noChangeArrowheads="1" noChangeShapeType="1" noTextEdit="1"/>
+              </p:cNvSpPr>
+              <p:nvPr/>
+            </p:nvSpPr>
+            <p:spPr>
+              <a:xfrm>
+                <a:off x="5642302" y="2410584"/>
+                <a:ext cx="211596" cy="276999"/>
+              </a:xfrm>
+              <a:prstGeom prst="rect">
+                <a:avLst/>
+              </a:prstGeom>
+              <a:blipFill>
+                <a:blip r:embed="rId6"/>
+                <a:stretch>
+                  <a:fillRect l="-20588" r="-23529"/>
+                </a:stretch>
+              </a:blipFill>
+            </p:spPr>
+            <p:txBody>
+              <a:bodyPr/>
+              <a:lstStyle/>
+              <a:p>
+                <a:r>
+                  <a:rPr lang="en-CA">
+                    <a:noFill/>
+                  </a:rPr>
+                  <a:t> </a:t>
+                </a:r>
+              </a:p>
+            </p:txBody>
+          </p:sp>
+        </mc:Fallback>
+      </mc:AlternateContent>
+      <mc:AlternateContent xmlns:mc="http://schemas.openxmlformats.org/markup-compatibility/2006">
+        <mc:Choice xmlns:a14="http://schemas.microsoft.com/office/drawing/2010/main" Requires="a14">
+          <p:sp>
+            <p:nvSpPr>
+              <p:cNvPr id="56" name="TextBox 55">
+                <a:extLst>
+                  <a:ext uri="{FF2B5EF4-FFF2-40B4-BE49-F238E27FC236}">
+                    <a16:creationId xmlns:a16="http://schemas.microsoft.com/office/drawing/2014/main" id="{45D25EA9-1605-948B-B576-2C65D459BDC0}"/>
+                  </a:ext>
+                </a:extLst>
+              </p:cNvPr>
+              <p:cNvSpPr txBox="1"/>
+              <p:nvPr/>
+            </p:nvSpPr>
+            <p:spPr>
+              <a:xfrm>
+                <a:off x="5642302" y="3087621"/>
+                <a:ext cx="211596" cy="276999"/>
+              </a:xfrm>
+              <a:prstGeom prst="rect">
+                <a:avLst/>
+              </a:prstGeom>
+              <a:noFill/>
+            </p:spPr>
+            <p:txBody>
+              <a:bodyPr wrap="none" lIns="0" tIns="0" rIns="0" bIns="0" rtlCol="0">
+                <a:spAutoFit/>
+              </a:bodyPr>
+              <a:lstStyle/>
+              <a:p>
+                <a:pPr/>
+                <a14:m>
+                  <m:oMathPara xmlns:m="http://schemas.openxmlformats.org/officeDocument/2006/math">
+                    <m:oMath>
+                      <m:r>
+                        <a:rPr lang="en-CA" i="1" smtClean="0">
+                          <a:latin typeface="Cambria Math" panose="02040503050406030204" pitchFamily="18" charset="0"/>
+                          <a:ea typeface="Cambria Math" panose="02040503050406030204" pitchFamily="18" charset="0"/>
+                        </a:rPr>
+                        <m:t>×</m:t>
+                      </m:r>
+                    </m:oMath>
+                  </m:oMathPara>
+                </a14:m>
+                <a:endParaRPr lang="en-CA" dirty="0"/>
+              </a:p>
+            </p:txBody>
+          </p:sp>
+        </mc:Choice>
+        <mc:Fallback>
+          <p:sp>
+            <p:nvSpPr>
+              <p:cNvPr id="56" name="TextBox 55">
+                <a:extLst>
+                  <a:ext uri="{FF2B5EF4-FFF2-40B4-BE49-F238E27FC236}">
+                    <a16:creationId xmlns:a16="http://schemas.microsoft.com/office/drawing/2014/main" id="{45D25EA9-1605-948B-B576-2C65D459BDC0}"/>
+                  </a:ext>
+                </a:extLst>
+              </p:cNvPr>
+              <p:cNvSpPr txBox="1">
+                <a:spLocks noRot="1" noChangeAspect="1" noMove="1" noResize="1" noEditPoints="1" noAdjustHandles="1" noChangeArrowheads="1" noChangeShapeType="1" noTextEdit="1"/>
+              </p:cNvSpPr>
+              <p:nvPr/>
+            </p:nvSpPr>
+            <p:spPr>
+              <a:xfrm>
+                <a:off x="5642302" y="3087621"/>
+                <a:ext cx="211596" cy="276999"/>
+              </a:xfrm>
+              <a:prstGeom prst="rect">
+                <a:avLst/>
+              </a:prstGeom>
+              <a:blipFill>
+                <a:blip r:embed="rId7"/>
+                <a:stretch>
+                  <a:fillRect l="-20588" r="-23529"/>
+                </a:stretch>
+              </a:blipFill>
+            </p:spPr>
+            <p:txBody>
+              <a:bodyPr/>
+              <a:lstStyle/>
+              <a:p>
+                <a:r>
+                  <a:rPr lang="en-CA">
+                    <a:noFill/>
+                  </a:rPr>
+                  <a:t> </a:t>
+                </a:r>
+              </a:p>
+            </p:txBody>
+          </p:sp>
+        </mc:Fallback>
+      </mc:AlternateContent>
+      <mc:AlternateContent xmlns:mc="http://schemas.openxmlformats.org/markup-compatibility/2006">
+        <mc:Choice xmlns:a14="http://schemas.microsoft.com/office/drawing/2010/main" Requires="a14">
+          <p:sp>
+            <p:nvSpPr>
+              <p:cNvPr id="58" name="TextBox 57">
+                <a:extLst>
+                  <a:ext uri="{FF2B5EF4-FFF2-40B4-BE49-F238E27FC236}">
+                    <a16:creationId xmlns:a16="http://schemas.microsoft.com/office/drawing/2014/main" id="{AFB992AB-489E-22E8-7737-74D1D4230F38}"/>
+                  </a:ext>
+                </a:extLst>
+              </p:cNvPr>
+              <p:cNvSpPr txBox="1"/>
+              <p:nvPr/>
+            </p:nvSpPr>
+            <p:spPr>
+              <a:xfrm>
+                <a:off x="5642302" y="3663809"/>
+                <a:ext cx="211596" cy="276999"/>
+              </a:xfrm>
+              <a:prstGeom prst="rect">
+                <a:avLst/>
+              </a:prstGeom>
+              <a:noFill/>
+            </p:spPr>
+            <p:txBody>
+              <a:bodyPr wrap="none" lIns="0" tIns="0" rIns="0" bIns="0" rtlCol="0">
+                <a:spAutoFit/>
+              </a:bodyPr>
+              <a:lstStyle/>
+              <a:p>
+                <a:pPr/>
+                <a14:m>
+                  <m:oMathPara xmlns:m="http://schemas.openxmlformats.org/officeDocument/2006/math">
+                    <m:oMath>
+                      <m:r>
+                        <a:rPr lang="en-CA" i="1" smtClean="0">
+                          <a:latin typeface="Cambria Math" panose="02040503050406030204" pitchFamily="18" charset="0"/>
+                          <a:ea typeface="Cambria Math" panose="02040503050406030204" pitchFamily="18" charset="0"/>
+                        </a:rPr>
+                        <m:t>×</m:t>
+                      </m:r>
+                    </m:oMath>
+                  </m:oMathPara>
+                </a14:m>
+                <a:endParaRPr lang="en-CA" dirty="0"/>
+              </a:p>
+            </p:txBody>
+          </p:sp>
+        </mc:Choice>
+        <mc:Fallback>
+          <p:sp>
+            <p:nvSpPr>
+              <p:cNvPr id="58" name="TextBox 57">
+                <a:extLst>
+                  <a:ext uri="{FF2B5EF4-FFF2-40B4-BE49-F238E27FC236}">
+                    <a16:creationId xmlns:a16="http://schemas.microsoft.com/office/drawing/2014/main" id="{AFB992AB-489E-22E8-7737-74D1D4230F38}"/>
+                  </a:ext>
+                </a:extLst>
+              </p:cNvPr>
+              <p:cNvSpPr txBox="1">
+                <a:spLocks noRot="1" noChangeAspect="1" noMove="1" noResize="1" noEditPoints="1" noAdjustHandles="1" noChangeArrowheads="1" noChangeShapeType="1" noTextEdit="1"/>
+              </p:cNvSpPr>
+              <p:nvPr/>
+            </p:nvSpPr>
+            <p:spPr>
+              <a:xfrm>
+                <a:off x="5642302" y="3663809"/>
+                <a:ext cx="211596" cy="276999"/>
+              </a:xfrm>
+              <a:prstGeom prst="rect">
+                <a:avLst/>
+              </a:prstGeom>
+              <a:blipFill>
+                <a:blip r:embed="rId8"/>
+                <a:stretch>
+                  <a:fillRect l="-20588" r="-23529" b="-2222"/>
+                </a:stretch>
+              </a:blipFill>
+            </p:spPr>
+            <p:txBody>
+              <a:bodyPr/>
+              <a:lstStyle/>
+              <a:p>
+                <a:r>
+                  <a:rPr lang="en-CA">
+                    <a:noFill/>
+                  </a:rPr>
+                  <a:t> </a:t>
+                </a:r>
+              </a:p>
+            </p:txBody>
+          </p:sp>
+        </mc:Fallback>
+      </mc:AlternateContent>
+      <mc:AlternateContent xmlns:mc="http://schemas.openxmlformats.org/markup-compatibility/2006">
+        <mc:Choice xmlns:a14="http://schemas.microsoft.com/office/drawing/2010/main" Requires="a14">
+          <p:sp>
+            <p:nvSpPr>
+              <p:cNvPr id="60" name="TextBox 59">
+                <a:extLst>
+                  <a:ext uri="{FF2B5EF4-FFF2-40B4-BE49-F238E27FC236}">
+                    <a16:creationId xmlns:a16="http://schemas.microsoft.com/office/drawing/2014/main" id="{6C54D887-6A46-65F6-E273-5532D8C79E5F}"/>
+                  </a:ext>
+                </a:extLst>
+              </p:cNvPr>
+              <p:cNvSpPr txBox="1"/>
+              <p:nvPr/>
+            </p:nvSpPr>
+            <p:spPr>
+              <a:xfrm>
+                <a:off x="5642302" y="4986527"/>
+                <a:ext cx="211596" cy="276999"/>
+              </a:xfrm>
+              <a:prstGeom prst="rect">
+                <a:avLst/>
+              </a:prstGeom>
+              <a:noFill/>
+            </p:spPr>
+            <p:txBody>
+              <a:bodyPr wrap="none" lIns="0" tIns="0" rIns="0" bIns="0" rtlCol="0">
+                <a:spAutoFit/>
+              </a:bodyPr>
+              <a:lstStyle/>
+              <a:p>
+                <a:pPr/>
+                <a14:m>
+                  <m:oMathPara xmlns:m="http://schemas.openxmlformats.org/officeDocument/2006/math">
+                    <m:oMath>
+                      <m:r>
+                        <a:rPr lang="en-CA" i="1" smtClean="0">
+                          <a:latin typeface="Cambria Math" panose="02040503050406030204" pitchFamily="18" charset="0"/>
+                          <a:ea typeface="Cambria Math" panose="02040503050406030204" pitchFamily="18" charset="0"/>
+                        </a:rPr>
+                        <m:t>×</m:t>
+                      </m:r>
+                    </m:oMath>
+                  </m:oMathPara>
+                </a14:m>
+                <a:endParaRPr lang="en-CA" dirty="0"/>
+              </a:p>
+            </p:txBody>
+          </p:sp>
+        </mc:Choice>
+        <mc:Fallback>
+          <p:sp>
+            <p:nvSpPr>
+              <p:cNvPr id="60" name="TextBox 59">
+                <a:extLst>
+                  <a:ext uri="{FF2B5EF4-FFF2-40B4-BE49-F238E27FC236}">
+                    <a16:creationId xmlns:a16="http://schemas.microsoft.com/office/drawing/2014/main" id="{6C54D887-6A46-65F6-E273-5532D8C79E5F}"/>
+                  </a:ext>
+                </a:extLst>
+              </p:cNvPr>
+              <p:cNvSpPr txBox="1">
+                <a:spLocks noRot="1" noChangeAspect="1" noMove="1" noResize="1" noEditPoints="1" noAdjustHandles="1" noChangeArrowheads="1" noChangeShapeType="1" noTextEdit="1"/>
+              </p:cNvSpPr>
+              <p:nvPr/>
+            </p:nvSpPr>
+            <p:spPr>
+              <a:xfrm>
+                <a:off x="5642302" y="4986527"/>
+                <a:ext cx="211596" cy="276999"/>
+              </a:xfrm>
+              <a:prstGeom prst="rect">
+                <a:avLst/>
+              </a:prstGeom>
+              <a:blipFill>
+                <a:blip r:embed="rId9"/>
+                <a:stretch>
+                  <a:fillRect l="-20588" r="-23529" b="-2222"/>
+                </a:stretch>
+              </a:blipFill>
+            </p:spPr>
+            <p:txBody>
+              <a:bodyPr/>
+              <a:lstStyle/>
+              <a:p>
+                <a:r>
+                  <a:rPr lang="en-CA">
+                    <a:noFill/>
+                  </a:rPr>
+                  <a:t> </a:t>
+                </a:r>
+              </a:p>
+            </p:txBody>
+          </p:sp>
+        </mc:Fallback>
+      </mc:AlternateContent>
+      <mc:AlternateContent xmlns:mc="http://schemas.openxmlformats.org/markup-compatibility/2006">
+        <mc:Choice xmlns:a14="http://schemas.microsoft.com/office/drawing/2010/main" Requires="a14">
+          <p:sp>
+            <p:nvSpPr>
+              <p:cNvPr id="62" name="TextBox 61">
+                <a:extLst>
+                  <a:ext uri="{FF2B5EF4-FFF2-40B4-BE49-F238E27FC236}">
+                    <a16:creationId xmlns:a16="http://schemas.microsoft.com/office/drawing/2014/main" id="{E7A4BF02-3753-B25E-F29F-8885B574B8FD}"/>
+                  </a:ext>
+                </a:extLst>
+              </p:cNvPr>
+              <p:cNvSpPr txBox="1"/>
+              <p:nvPr/>
+            </p:nvSpPr>
+            <p:spPr>
+              <a:xfrm>
+                <a:off x="5642302" y="4363107"/>
+                <a:ext cx="211596" cy="276999"/>
+              </a:xfrm>
+              <a:prstGeom prst="rect">
+                <a:avLst/>
+              </a:prstGeom>
+              <a:noFill/>
+            </p:spPr>
+            <p:txBody>
+              <a:bodyPr wrap="none" lIns="0" tIns="0" rIns="0" bIns="0" rtlCol="0">
+                <a:spAutoFit/>
+              </a:bodyPr>
+              <a:lstStyle/>
+              <a:p>
+                <a:pPr/>
+                <a14:m>
+                  <m:oMathPara xmlns:m="http://schemas.openxmlformats.org/officeDocument/2006/math">
+                    <m:oMath>
+                      <m:r>
+                        <a:rPr lang="en-CA" i="1" smtClean="0">
+                          <a:latin typeface="Cambria Math" panose="02040503050406030204" pitchFamily="18" charset="0"/>
+                          <a:ea typeface="Cambria Math" panose="02040503050406030204" pitchFamily="18" charset="0"/>
+                        </a:rPr>
+                        <m:t>×</m:t>
+                      </m:r>
+                    </m:oMath>
+                  </m:oMathPara>
+                </a14:m>
+                <a:endParaRPr lang="en-CA" dirty="0"/>
+              </a:p>
+            </p:txBody>
+          </p:sp>
+        </mc:Choice>
+        <mc:Fallback>
+          <p:sp>
+            <p:nvSpPr>
+              <p:cNvPr id="62" name="TextBox 61">
+                <a:extLst>
+                  <a:ext uri="{FF2B5EF4-FFF2-40B4-BE49-F238E27FC236}">
+                    <a16:creationId xmlns:a16="http://schemas.microsoft.com/office/drawing/2014/main" id="{E7A4BF02-3753-B25E-F29F-8885B574B8FD}"/>
+                  </a:ext>
+                </a:extLst>
+              </p:cNvPr>
+              <p:cNvSpPr txBox="1">
+                <a:spLocks noRot="1" noChangeAspect="1" noMove="1" noResize="1" noEditPoints="1" noAdjustHandles="1" noChangeArrowheads="1" noChangeShapeType="1" noTextEdit="1"/>
+              </p:cNvSpPr>
+              <p:nvPr/>
+            </p:nvSpPr>
+            <p:spPr>
+              <a:xfrm>
+                <a:off x="5642302" y="4363107"/>
+                <a:ext cx="211596" cy="276999"/>
+              </a:xfrm>
+              <a:prstGeom prst="rect">
+                <a:avLst/>
+              </a:prstGeom>
+              <a:blipFill>
+                <a:blip r:embed="rId10"/>
+                <a:stretch>
+                  <a:fillRect l="-20588" r="-23529" b="-2222"/>
+                </a:stretch>
+              </a:blipFill>
+            </p:spPr>
+            <p:txBody>
+              <a:bodyPr/>
+              <a:lstStyle/>
+              <a:p>
+                <a:r>
+                  <a:rPr lang="en-CA">
+                    <a:noFill/>
+                  </a:rPr>
+                  <a:t> </a:t>
+                </a:r>
+              </a:p>
+            </p:txBody>
+          </p:sp>
+        </mc:Fallback>
+      </mc:AlternateContent>
+      <p:sp>
+        <p:nvSpPr>
+          <p:cNvPr id="63" name="TextBox 62">
+            <a:extLst>
+              <a:ext uri="{FF2B5EF4-FFF2-40B4-BE49-F238E27FC236}">
+                <a16:creationId xmlns:a16="http://schemas.microsoft.com/office/drawing/2014/main" id="{ED0DAFEE-3EF3-38A9-44F0-1354DB6BFDE9}"/>
+              </a:ext>
+            </a:extLst>
+          </p:cNvPr>
+          <p:cNvSpPr txBox="1"/>
+          <p:nvPr/>
+        </p:nvSpPr>
+        <p:spPr>
+          <a:xfrm>
+            <a:off x="2119788" y="4116886"/>
+            <a:ext cx="1244514" cy="369332"/>
+          </a:xfrm>
+          <a:prstGeom prst="rect">
+            <a:avLst/>
+          </a:prstGeom>
+          <a:noFill/>
+        </p:spPr>
+        <p:txBody>
+          <a:bodyPr wrap="square" rtlCol="0">
+            <a:spAutoFit/>
+          </a:bodyPr>
+          <a:lstStyle/>
+          <a:p>
+            <a:r>
+              <a:rPr lang="en-US" dirty="0"/>
+              <a:t>0.0 </a:t>
+            </a:r>
+            <a:r>
+              <a:rPr lang="en-US" dirty="0">
+                <a:sym typeface="Wingdings" panose="05000000000000000000" pitchFamily="2" charset="2"/>
+              </a:rPr>
+              <a:t> 1.0</a:t>
+            </a:r>
+            <a:endParaRPr lang="en-CA" dirty="0"/>
+          </a:p>
+        </p:txBody>
+      </p:sp>
+    </p:spTree>
+    <p:extLst>
+      <p:ext uri="{BB962C8B-B14F-4D97-AF65-F5344CB8AC3E}">
+        <p14:creationId xmlns:p14="http://schemas.microsoft.com/office/powerpoint/2010/main" val="3531026977"/>
       </p:ext>
     </p:extLst>
   </p:cSld>

</xml_diff>

<commit_message>
Added slide summarising pipeline IO.
</commit_message>
<xml_diff>
--- a/reports/2026-08-28_projectUpdate_3/2026-08-28_projectUpdate_3_jmoran.pptx
+++ b/reports/2026-08-28_projectUpdate_3/2026-08-28_projectUpdate_3_jmoran.pptx
@@ -5,7 +5,7 @@
     <p:sldMasterId id="2147483648" r:id="rId1"/>
   </p:sldMasterIdLst>
   <p:notesMasterIdLst>
-    <p:notesMasterId r:id="rId13"/>
+    <p:notesMasterId r:id="rId14"/>
   </p:notesMasterIdLst>
   <p:sldIdLst>
     <p:sldId id="256" r:id="rId2"/>
@@ -17,8 +17,9 @@
     <p:sldId id="287" r:id="rId8"/>
     <p:sldId id="284" r:id="rId9"/>
     <p:sldId id="288" r:id="rId10"/>
-    <p:sldId id="289" r:id="rId11"/>
-    <p:sldId id="290" r:id="rId12"/>
+    <p:sldId id="292" r:id="rId11"/>
+    <p:sldId id="289" r:id="rId12"/>
+    <p:sldId id="290" r:id="rId13"/>
   </p:sldIdLst>
   <p:sldSz cx="12192000" cy="6858000"/>
   <p:notesSz cx="6858000" cy="9144000"/>
@@ -4947,6 +4948,3188 @@
 <file path=ppt/slides/slide10.xml><?xml version="1.0" encoding="utf-8"?>
 <p:sld xmlns:a="http://schemas.openxmlformats.org/drawingml/2006/main" xmlns:r="http://schemas.openxmlformats.org/officeDocument/2006/relationships" xmlns:p="http://schemas.openxmlformats.org/presentationml/2006/main">
   <p:cSld>
+    <p:spTree>
+      <p:nvGrpSpPr>
+        <p:cNvPr id="1" name=""/>
+        <p:cNvGrpSpPr/>
+        <p:nvPr/>
+      </p:nvGrpSpPr>
+      <p:grpSpPr>
+        <a:xfrm>
+          <a:off x="0" y="0"/>
+          <a:ext cx="0" cy="0"/>
+          <a:chOff x="0" y="0"/>
+          <a:chExt cx="0" cy="0"/>
+        </a:xfrm>
+      </p:grpSpPr>
+      <p:sp>
+        <p:nvSpPr>
+          <p:cNvPr id="5" name="Rectangle: Rounded Corners 4">
+            <a:extLst>
+              <a:ext uri="{FF2B5EF4-FFF2-40B4-BE49-F238E27FC236}">
+                <a16:creationId xmlns:a16="http://schemas.microsoft.com/office/drawing/2014/main" id="{3EE49C3D-4F55-2A4E-9E34-6CEE16631388}"/>
+              </a:ext>
+            </a:extLst>
+          </p:cNvPr>
+          <p:cNvSpPr/>
+          <p:nvPr/>
+        </p:nvSpPr>
+        <p:spPr>
+          <a:xfrm>
+            <a:off x="315257" y="8582"/>
+            <a:ext cx="9363581" cy="628742"/>
+          </a:xfrm>
+          <a:prstGeom prst="roundRect">
+            <a:avLst/>
+          </a:prstGeom>
+          <a:solidFill>
+            <a:srgbClr val="0162B3"/>
+          </a:solidFill>
+          <a:ln>
+            <a:solidFill>
+              <a:srgbClr val="0162B3"/>
+            </a:solidFill>
+          </a:ln>
+        </p:spPr>
+        <p:style>
+          <a:lnRef idx="2">
+            <a:schemeClr val="accent1">
+              <a:shade val="50000"/>
+            </a:schemeClr>
+          </a:lnRef>
+          <a:fillRef idx="1">
+            <a:schemeClr val="accent1"/>
+          </a:fillRef>
+          <a:effectRef idx="0">
+            <a:schemeClr val="accent1"/>
+          </a:effectRef>
+          <a:fontRef idx="minor">
+            <a:schemeClr val="lt1"/>
+          </a:fontRef>
+        </p:style>
+        <p:txBody>
+          <a:bodyPr rtlCol="0" anchor="ctr"/>
+          <a:lstStyle>
+            <a:defPPr>
+              <a:defRPr lang="en-US"/>
+            </a:defPPr>
+            <a:lvl1pPr marL="0" algn="l" defTabSz="914400" rtl="0" eaLnBrk="1" latinLnBrk="0" hangingPunct="1">
+              <a:defRPr sz="1800" kern="1200">
+                <a:solidFill>
+                  <a:schemeClr val="lt1"/>
+                </a:solidFill>
+                <a:latin typeface="+mn-lt"/>
+                <a:ea typeface="+mn-ea"/>
+                <a:cs typeface="+mn-cs"/>
+              </a:defRPr>
+            </a:lvl1pPr>
+            <a:lvl2pPr marL="457200" algn="l" defTabSz="914400" rtl="0" eaLnBrk="1" latinLnBrk="0" hangingPunct="1">
+              <a:defRPr sz="1800" kern="1200">
+                <a:solidFill>
+                  <a:schemeClr val="lt1"/>
+                </a:solidFill>
+                <a:latin typeface="+mn-lt"/>
+                <a:ea typeface="+mn-ea"/>
+                <a:cs typeface="+mn-cs"/>
+              </a:defRPr>
+            </a:lvl2pPr>
+            <a:lvl3pPr marL="914400" algn="l" defTabSz="914400" rtl="0" eaLnBrk="1" latinLnBrk="0" hangingPunct="1">
+              <a:defRPr sz="1800" kern="1200">
+                <a:solidFill>
+                  <a:schemeClr val="lt1"/>
+                </a:solidFill>
+                <a:latin typeface="+mn-lt"/>
+                <a:ea typeface="+mn-ea"/>
+                <a:cs typeface="+mn-cs"/>
+              </a:defRPr>
+            </a:lvl3pPr>
+            <a:lvl4pPr marL="1371600" algn="l" defTabSz="914400" rtl="0" eaLnBrk="1" latinLnBrk="0" hangingPunct="1">
+              <a:defRPr sz="1800" kern="1200">
+                <a:solidFill>
+                  <a:schemeClr val="lt1"/>
+                </a:solidFill>
+                <a:latin typeface="+mn-lt"/>
+                <a:ea typeface="+mn-ea"/>
+                <a:cs typeface="+mn-cs"/>
+              </a:defRPr>
+            </a:lvl4pPr>
+            <a:lvl5pPr marL="1828800" algn="l" defTabSz="914400" rtl="0" eaLnBrk="1" latinLnBrk="0" hangingPunct="1">
+              <a:defRPr sz="1800" kern="1200">
+                <a:solidFill>
+                  <a:schemeClr val="lt1"/>
+                </a:solidFill>
+                <a:latin typeface="+mn-lt"/>
+                <a:ea typeface="+mn-ea"/>
+                <a:cs typeface="+mn-cs"/>
+              </a:defRPr>
+            </a:lvl5pPr>
+            <a:lvl6pPr marL="2286000" algn="l" defTabSz="914400" rtl="0" eaLnBrk="1" latinLnBrk="0" hangingPunct="1">
+              <a:defRPr sz="1800" kern="1200">
+                <a:solidFill>
+                  <a:schemeClr val="lt1"/>
+                </a:solidFill>
+                <a:latin typeface="+mn-lt"/>
+                <a:ea typeface="+mn-ea"/>
+                <a:cs typeface="+mn-cs"/>
+              </a:defRPr>
+            </a:lvl6pPr>
+            <a:lvl7pPr marL="2743200" algn="l" defTabSz="914400" rtl="0" eaLnBrk="1" latinLnBrk="0" hangingPunct="1">
+              <a:defRPr sz="1800" kern="1200">
+                <a:solidFill>
+                  <a:schemeClr val="lt1"/>
+                </a:solidFill>
+                <a:latin typeface="+mn-lt"/>
+                <a:ea typeface="+mn-ea"/>
+                <a:cs typeface="+mn-cs"/>
+              </a:defRPr>
+            </a:lvl7pPr>
+            <a:lvl8pPr marL="3200400" algn="l" defTabSz="914400" rtl="0" eaLnBrk="1" latinLnBrk="0" hangingPunct="1">
+              <a:defRPr sz="1800" kern="1200">
+                <a:solidFill>
+                  <a:schemeClr val="lt1"/>
+                </a:solidFill>
+                <a:latin typeface="+mn-lt"/>
+                <a:ea typeface="+mn-ea"/>
+                <a:cs typeface="+mn-cs"/>
+              </a:defRPr>
+            </a:lvl8pPr>
+            <a:lvl9pPr marL="3657600" algn="l" defTabSz="914400" rtl="0" eaLnBrk="1" latinLnBrk="0" hangingPunct="1">
+              <a:defRPr sz="1800" kern="1200">
+                <a:solidFill>
+                  <a:schemeClr val="lt1"/>
+                </a:solidFill>
+                <a:latin typeface="+mn-lt"/>
+                <a:ea typeface="+mn-ea"/>
+                <a:cs typeface="+mn-cs"/>
+              </a:defRPr>
+            </a:lvl9pPr>
+          </a:lstStyle>
+          <a:p>
+            <a:pPr algn="ctr"/>
+            <a:endParaRPr lang="en-CA"/>
+          </a:p>
+        </p:txBody>
+      </p:sp>
+      <p:sp>
+        <p:nvSpPr>
+          <p:cNvPr id="7" name="TextBox 6">
+            <a:extLst>
+              <a:ext uri="{FF2B5EF4-FFF2-40B4-BE49-F238E27FC236}">
+                <a16:creationId xmlns:a16="http://schemas.microsoft.com/office/drawing/2014/main" id="{503A4886-B1AC-EA6D-01D4-77894B69E9FC}"/>
+              </a:ext>
+            </a:extLst>
+          </p:cNvPr>
+          <p:cNvSpPr txBox="1"/>
+          <p:nvPr/>
+        </p:nvSpPr>
+        <p:spPr>
+          <a:xfrm>
+            <a:off x="527959" y="76731"/>
+            <a:ext cx="8710932" cy="492443"/>
+          </a:xfrm>
+          <a:prstGeom prst="rect">
+            <a:avLst/>
+          </a:prstGeom>
+          <a:noFill/>
+        </p:spPr>
+        <p:txBody>
+          <a:bodyPr wrap="square" rtlCol="0">
+            <a:spAutoFit/>
+          </a:bodyPr>
+          <a:lstStyle/>
+          <a:p>
+            <a:r>
+              <a:rPr lang="en-US" sz="2600" b="1" dirty="0">
+                <a:solidFill>
+                  <a:schemeClr val="bg1"/>
+                </a:solidFill>
+                <a:latin typeface="Georgia Pro" panose="02040502050405020303" pitchFamily="18" charset="0"/>
+              </a:rPr>
+              <a:t>Pipeline schematic</a:t>
+            </a:r>
+            <a:endParaRPr lang="en-CA" sz="2600" b="1" dirty="0">
+              <a:solidFill>
+                <a:schemeClr val="bg1"/>
+              </a:solidFill>
+              <a:latin typeface="Georgia Pro" panose="02040502050405020303" pitchFamily="18" charset="0"/>
+            </a:endParaRPr>
+          </a:p>
+        </p:txBody>
+      </p:sp>
+      <p:sp>
+        <p:nvSpPr>
+          <p:cNvPr id="8" name="TextBox 7">
+            <a:extLst>
+              <a:ext uri="{FF2B5EF4-FFF2-40B4-BE49-F238E27FC236}">
+                <a16:creationId xmlns:a16="http://schemas.microsoft.com/office/drawing/2014/main" id="{807E2AB0-B71B-D41A-7A04-C71BDE321B1A}"/>
+              </a:ext>
+            </a:extLst>
+          </p:cNvPr>
+          <p:cNvSpPr txBox="1"/>
+          <p:nvPr/>
+        </p:nvSpPr>
+        <p:spPr>
+          <a:xfrm>
+            <a:off x="585619" y="1755871"/>
+            <a:ext cx="2652622" cy="307777"/>
+          </a:xfrm>
+          <a:prstGeom prst="rect">
+            <a:avLst/>
+          </a:prstGeom>
+          <a:noFill/>
+          <a:ln>
+            <a:solidFill>
+              <a:schemeClr val="tx1"/>
+            </a:solidFill>
+          </a:ln>
+        </p:spPr>
+        <p:txBody>
+          <a:bodyPr wrap="square" rtlCol="0">
+            <a:spAutoFit/>
+          </a:bodyPr>
+          <a:lstStyle/>
+          <a:p>
+            <a:r>
+              <a:rPr lang="en-US" sz="1400" dirty="0">
+                <a:latin typeface="Verdana Pro" panose="020B0604030504040204" pitchFamily="34" charset="0"/>
+              </a:rPr>
+              <a:t>DefenseFinder UniProt IDs</a:t>
+            </a:r>
+            <a:endParaRPr lang="en-CA" sz="1400" dirty="0">
+              <a:latin typeface="Verdana Pro" panose="020B0604030504040204" pitchFamily="34" charset="0"/>
+            </a:endParaRPr>
+          </a:p>
+        </p:txBody>
+      </p:sp>
+      <p:sp>
+        <p:nvSpPr>
+          <p:cNvPr id="10" name="TextBox 9">
+            <a:extLst>
+              <a:ext uri="{FF2B5EF4-FFF2-40B4-BE49-F238E27FC236}">
+                <a16:creationId xmlns:a16="http://schemas.microsoft.com/office/drawing/2014/main" id="{AC482159-6150-31DC-0C89-FFC0F811E6C8}"/>
+              </a:ext>
+            </a:extLst>
+          </p:cNvPr>
+          <p:cNvSpPr txBox="1"/>
+          <p:nvPr/>
+        </p:nvSpPr>
+        <p:spPr>
+          <a:xfrm>
+            <a:off x="527959" y="3392485"/>
+            <a:ext cx="2652622" cy="523220"/>
+          </a:xfrm>
+          <a:prstGeom prst="rect">
+            <a:avLst/>
+          </a:prstGeom>
+          <a:noFill/>
+          <a:ln>
+            <a:solidFill>
+              <a:schemeClr val="tx1"/>
+            </a:solidFill>
+          </a:ln>
+        </p:spPr>
+        <p:txBody>
+          <a:bodyPr wrap="square" rtlCol="0">
+            <a:spAutoFit/>
+          </a:bodyPr>
+          <a:lstStyle/>
+          <a:p>
+            <a:r>
+              <a:rPr lang="en-US" sz="1400" dirty="0">
+                <a:latin typeface="Verdana Pro" panose="020B0604030504040204" pitchFamily="34" charset="0"/>
+              </a:rPr>
+              <a:t>AFDB FoldSeek all-v-all</a:t>
+            </a:r>
+          </a:p>
+          <a:p>
+            <a:r>
+              <a:rPr lang="en-US" sz="1400" dirty="0">
+                <a:latin typeface="Verdana Pro" panose="020B0604030504040204" pitchFamily="34" charset="0"/>
+              </a:rPr>
+              <a:t>network</a:t>
+            </a:r>
+            <a:endParaRPr lang="en-CA" sz="1400" dirty="0">
+              <a:latin typeface="Verdana Pro" panose="020B0604030504040204" pitchFamily="34" charset="0"/>
+            </a:endParaRPr>
+          </a:p>
+        </p:txBody>
+      </p:sp>
+      <p:grpSp>
+        <p:nvGrpSpPr>
+          <p:cNvPr id="18" name="Group 17">
+            <a:extLst>
+              <a:ext uri="{FF2B5EF4-FFF2-40B4-BE49-F238E27FC236}">
+                <a16:creationId xmlns:a16="http://schemas.microsoft.com/office/drawing/2014/main" id="{49B3762C-08E2-50D0-C363-57E5057F2C1C}"/>
+              </a:ext>
+            </a:extLst>
+          </p:cNvPr>
+          <p:cNvGrpSpPr/>
+          <p:nvPr/>
+        </p:nvGrpSpPr>
+        <p:grpSpPr>
+          <a:xfrm>
+            <a:off x="585619" y="2153230"/>
+            <a:ext cx="1997014" cy="797920"/>
+            <a:chOff x="892835" y="1928027"/>
+            <a:chExt cx="1997014" cy="797920"/>
+          </a:xfrm>
+        </p:grpSpPr>
+        <p:sp>
+          <p:nvSpPr>
+            <p:cNvPr id="11" name="Rectangle 10">
+              <a:extLst>
+                <a:ext uri="{FF2B5EF4-FFF2-40B4-BE49-F238E27FC236}">
+                  <a16:creationId xmlns:a16="http://schemas.microsoft.com/office/drawing/2014/main" id="{3155809C-D238-02A1-32C4-9D0C3A8C9C78}"/>
+                </a:ext>
+              </a:extLst>
+            </p:cNvPr>
+            <p:cNvSpPr/>
+            <p:nvPr/>
+          </p:nvSpPr>
+          <p:spPr>
+            <a:xfrm>
+              <a:off x="892835" y="1932317"/>
+              <a:ext cx="1997014" cy="793630"/>
+            </a:xfrm>
+            <a:prstGeom prst="rect">
+              <a:avLst/>
+            </a:prstGeom>
+            <a:noFill/>
+            <a:ln w="19050">
+              <a:solidFill>
+                <a:schemeClr val="tx1"/>
+              </a:solidFill>
+            </a:ln>
+          </p:spPr>
+          <p:style>
+            <a:lnRef idx="2">
+              <a:schemeClr val="accent1">
+                <a:shade val="15000"/>
+              </a:schemeClr>
+            </a:lnRef>
+            <a:fillRef idx="1">
+              <a:schemeClr val="accent1"/>
+            </a:fillRef>
+            <a:effectRef idx="0">
+              <a:schemeClr val="accent1"/>
+            </a:effectRef>
+            <a:fontRef idx="minor">
+              <a:schemeClr val="lt1"/>
+            </a:fontRef>
+          </p:style>
+          <p:txBody>
+            <a:bodyPr rtlCol="0" anchor="ctr"/>
+            <a:lstStyle/>
+            <a:p>
+              <a:pPr algn="ctr"/>
+              <a:endParaRPr lang="en-CA"/>
+            </a:p>
+          </p:txBody>
+        </p:sp>
+        <p:sp>
+          <p:nvSpPr>
+            <p:cNvPr id="13" name="Rectangle 12">
+              <a:extLst>
+                <a:ext uri="{FF2B5EF4-FFF2-40B4-BE49-F238E27FC236}">
+                  <a16:creationId xmlns:a16="http://schemas.microsoft.com/office/drawing/2014/main" id="{31409073-8540-490B-2E26-F00F6726E36E}"/>
+                </a:ext>
+              </a:extLst>
+            </p:cNvPr>
+            <p:cNvSpPr/>
+            <p:nvPr/>
+          </p:nvSpPr>
+          <p:spPr>
+            <a:xfrm>
+              <a:off x="892835" y="2148248"/>
+              <a:ext cx="1997014" cy="187767"/>
+            </a:xfrm>
+            <a:prstGeom prst="rect">
+              <a:avLst/>
+            </a:prstGeom>
+            <a:noFill/>
+            <a:ln w="3175">
+              <a:solidFill>
+                <a:schemeClr val="tx1"/>
+              </a:solidFill>
+            </a:ln>
+          </p:spPr>
+          <p:style>
+            <a:lnRef idx="2">
+              <a:schemeClr val="accent1">
+                <a:shade val="15000"/>
+              </a:schemeClr>
+            </a:lnRef>
+            <a:fillRef idx="1">
+              <a:schemeClr val="accent1"/>
+            </a:fillRef>
+            <a:effectRef idx="0">
+              <a:schemeClr val="accent1"/>
+            </a:effectRef>
+            <a:fontRef idx="minor">
+              <a:schemeClr val="lt1"/>
+            </a:fontRef>
+          </p:style>
+          <p:txBody>
+            <a:bodyPr rtlCol="0" anchor="ctr"/>
+            <a:lstStyle/>
+            <a:p>
+              <a:pPr algn="ctr"/>
+              <a:endParaRPr lang="en-CA"/>
+            </a:p>
+          </p:txBody>
+        </p:sp>
+        <p:sp>
+          <p:nvSpPr>
+            <p:cNvPr id="15" name="Rectangle 14">
+              <a:extLst>
+                <a:ext uri="{FF2B5EF4-FFF2-40B4-BE49-F238E27FC236}">
+                  <a16:creationId xmlns:a16="http://schemas.microsoft.com/office/drawing/2014/main" id="{89908847-4851-CF9C-B87A-0CD52953B874}"/>
+                </a:ext>
+              </a:extLst>
+            </p:cNvPr>
+            <p:cNvSpPr/>
+            <p:nvPr/>
+          </p:nvSpPr>
+          <p:spPr>
+            <a:xfrm>
+              <a:off x="892835" y="2533890"/>
+              <a:ext cx="1997014" cy="187767"/>
+            </a:xfrm>
+            <a:prstGeom prst="rect">
+              <a:avLst/>
+            </a:prstGeom>
+            <a:noFill/>
+            <a:ln w="3175">
+              <a:solidFill>
+                <a:schemeClr val="tx1"/>
+              </a:solidFill>
+            </a:ln>
+          </p:spPr>
+          <p:style>
+            <a:lnRef idx="2">
+              <a:schemeClr val="accent1">
+                <a:shade val="15000"/>
+              </a:schemeClr>
+            </a:lnRef>
+            <a:fillRef idx="1">
+              <a:schemeClr val="accent1"/>
+            </a:fillRef>
+            <a:effectRef idx="0">
+              <a:schemeClr val="accent1"/>
+            </a:effectRef>
+            <a:fontRef idx="minor">
+              <a:schemeClr val="lt1"/>
+            </a:fontRef>
+          </p:style>
+          <p:txBody>
+            <a:bodyPr rtlCol="0" anchor="ctr"/>
+            <a:lstStyle/>
+            <a:p>
+              <a:pPr algn="ctr"/>
+              <a:endParaRPr lang="en-CA"/>
+            </a:p>
+          </p:txBody>
+        </p:sp>
+        <p:sp>
+          <p:nvSpPr>
+            <p:cNvPr id="17" name="Rectangle 16">
+              <a:extLst>
+                <a:ext uri="{FF2B5EF4-FFF2-40B4-BE49-F238E27FC236}">
+                  <a16:creationId xmlns:a16="http://schemas.microsoft.com/office/drawing/2014/main" id="{B500B8D5-2535-B8A5-10D9-18C4BFF406FE}"/>
+                </a:ext>
+              </a:extLst>
+            </p:cNvPr>
+            <p:cNvSpPr/>
+            <p:nvPr/>
+          </p:nvSpPr>
+          <p:spPr>
+            <a:xfrm>
+              <a:off x="892836" y="1928027"/>
+              <a:ext cx="327964" cy="793630"/>
+            </a:xfrm>
+            <a:prstGeom prst="rect">
+              <a:avLst/>
+            </a:prstGeom>
+            <a:noFill/>
+            <a:ln w="3175">
+              <a:solidFill>
+                <a:schemeClr val="tx1"/>
+              </a:solidFill>
+            </a:ln>
+          </p:spPr>
+          <p:style>
+            <a:lnRef idx="2">
+              <a:schemeClr val="accent1">
+                <a:shade val="15000"/>
+              </a:schemeClr>
+            </a:lnRef>
+            <a:fillRef idx="1">
+              <a:schemeClr val="accent1"/>
+            </a:fillRef>
+            <a:effectRef idx="0">
+              <a:schemeClr val="accent1"/>
+            </a:effectRef>
+            <a:fontRef idx="minor">
+              <a:schemeClr val="lt1"/>
+            </a:fontRef>
+          </p:style>
+          <p:txBody>
+            <a:bodyPr rtlCol="0" anchor="ctr"/>
+            <a:lstStyle/>
+            <a:p>
+              <a:pPr algn="ctr"/>
+              <a:endParaRPr lang="en-CA"/>
+            </a:p>
+          </p:txBody>
+        </p:sp>
+      </p:grpSp>
+      <p:grpSp>
+        <p:nvGrpSpPr>
+          <p:cNvPr id="115" name="Group 114">
+            <a:extLst>
+              <a:ext uri="{FF2B5EF4-FFF2-40B4-BE49-F238E27FC236}">
+                <a16:creationId xmlns:a16="http://schemas.microsoft.com/office/drawing/2014/main" id="{2A673C08-5E00-0296-8220-C14241A97C22}"/>
+              </a:ext>
+            </a:extLst>
+          </p:cNvPr>
+          <p:cNvGrpSpPr/>
+          <p:nvPr/>
+        </p:nvGrpSpPr>
+        <p:grpSpPr>
+          <a:xfrm>
+            <a:off x="563503" y="4112852"/>
+            <a:ext cx="1348427" cy="1405139"/>
+            <a:chOff x="4226224" y="1980968"/>
+            <a:chExt cx="934101" cy="973387"/>
+          </a:xfrm>
+        </p:grpSpPr>
+        <p:cxnSp>
+          <p:nvCxnSpPr>
+            <p:cNvPr id="103" name="Straight Connector 102">
+              <a:extLst>
+                <a:ext uri="{FF2B5EF4-FFF2-40B4-BE49-F238E27FC236}">
+                  <a16:creationId xmlns:a16="http://schemas.microsoft.com/office/drawing/2014/main" id="{48BC38BD-5485-7068-A1D0-2A277362407D}"/>
+                </a:ext>
+              </a:extLst>
+            </p:cNvPr>
+            <p:cNvCxnSpPr>
+              <a:cxnSpLocks/>
+            </p:cNvCxnSpPr>
+            <p:nvPr/>
+          </p:nvCxnSpPr>
+          <p:spPr>
+            <a:xfrm flipV="1">
+              <a:off x="4688126" y="2200930"/>
+              <a:ext cx="254669" cy="476119"/>
+            </a:xfrm>
+            <a:prstGeom prst="line">
+              <a:avLst/>
+            </a:prstGeom>
+            <a:ln>
+              <a:solidFill>
+                <a:schemeClr val="tx1"/>
+              </a:solidFill>
+            </a:ln>
+          </p:spPr>
+          <p:style>
+            <a:lnRef idx="2">
+              <a:schemeClr val="accent1"/>
+            </a:lnRef>
+            <a:fillRef idx="0">
+              <a:schemeClr val="accent1"/>
+            </a:fillRef>
+            <a:effectRef idx="1">
+              <a:schemeClr val="accent1"/>
+            </a:effectRef>
+            <a:fontRef idx="minor">
+              <a:schemeClr val="tx1"/>
+            </a:fontRef>
+          </p:style>
+        </p:cxnSp>
+        <p:cxnSp>
+          <p:nvCxnSpPr>
+            <p:cNvPr id="100" name="Straight Connector 99">
+              <a:extLst>
+                <a:ext uri="{FF2B5EF4-FFF2-40B4-BE49-F238E27FC236}">
+                  <a16:creationId xmlns:a16="http://schemas.microsoft.com/office/drawing/2014/main" id="{27A8ECE3-C0D5-1E89-80B4-6A56ADFEE76D}"/>
+                </a:ext>
+              </a:extLst>
+            </p:cNvPr>
+            <p:cNvCxnSpPr>
+              <a:cxnSpLocks/>
+            </p:cNvCxnSpPr>
+            <p:nvPr/>
+          </p:nvCxnSpPr>
+          <p:spPr>
+            <a:xfrm flipV="1">
+              <a:off x="4378624" y="2212835"/>
+              <a:ext cx="564171" cy="142789"/>
+            </a:xfrm>
+            <a:prstGeom prst="line">
+              <a:avLst/>
+            </a:prstGeom>
+            <a:ln>
+              <a:solidFill>
+                <a:schemeClr val="tx1"/>
+              </a:solidFill>
+            </a:ln>
+          </p:spPr>
+          <p:style>
+            <a:lnRef idx="2">
+              <a:schemeClr val="accent1"/>
+            </a:lnRef>
+            <a:fillRef idx="0">
+              <a:schemeClr val="accent1"/>
+            </a:fillRef>
+            <a:effectRef idx="1">
+              <a:schemeClr val="accent1"/>
+            </a:effectRef>
+            <a:fontRef idx="minor">
+              <a:schemeClr val="tx1"/>
+            </a:fontRef>
+          </p:style>
+        </p:cxnSp>
+        <p:cxnSp>
+          <p:nvCxnSpPr>
+            <p:cNvPr id="98" name="Straight Connector 97">
+              <a:extLst>
+                <a:ext uri="{FF2B5EF4-FFF2-40B4-BE49-F238E27FC236}">
+                  <a16:creationId xmlns:a16="http://schemas.microsoft.com/office/drawing/2014/main" id="{74774099-69B7-2D71-C928-6D72BBFBAB8C}"/>
+                </a:ext>
+              </a:extLst>
+            </p:cNvPr>
+            <p:cNvCxnSpPr>
+              <a:cxnSpLocks/>
+              <a:stCxn id="21" idx="1"/>
+              <a:endCxn id="69" idx="5"/>
+            </p:cNvCxnSpPr>
+            <p:nvPr/>
+          </p:nvCxnSpPr>
+          <p:spPr>
+            <a:xfrm>
+              <a:off x="4389395" y="2319709"/>
+              <a:ext cx="350739" cy="357340"/>
+            </a:xfrm>
+            <a:prstGeom prst="line">
+              <a:avLst/>
+            </a:prstGeom>
+            <a:ln>
+              <a:solidFill>
+                <a:schemeClr val="tx1"/>
+              </a:solidFill>
+            </a:ln>
+          </p:spPr>
+          <p:style>
+            <a:lnRef idx="2">
+              <a:schemeClr val="accent1"/>
+            </a:lnRef>
+            <a:fillRef idx="0">
+              <a:schemeClr val="accent1"/>
+            </a:fillRef>
+            <a:effectRef idx="1">
+              <a:schemeClr val="accent1"/>
+            </a:effectRef>
+            <a:fontRef idx="minor">
+              <a:schemeClr val="tx1"/>
+            </a:fontRef>
+          </p:style>
+        </p:cxnSp>
+        <p:cxnSp>
+          <p:nvCxnSpPr>
+            <p:cNvPr id="29" name="Straight Connector 28">
+              <a:extLst>
+                <a:ext uri="{FF2B5EF4-FFF2-40B4-BE49-F238E27FC236}">
+                  <a16:creationId xmlns:a16="http://schemas.microsoft.com/office/drawing/2014/main" id="{AD443148-F790-D8E3-F1EF-BA243415E26C}"/>
+                </a:ext>
+              </a:extLst>
+            </p:cNvPr>
+            <p:cNvCxnSpPr>
+              <a:cxnSpLocks/>
+              <a:stCxn id="19" idx="1"/>
+              <a:endCxn id="21" idx="5"/>
+            </p:cNvCxnSpPr>
+            <p:nvPr/>
+          </p:nvCxnSpPr>
+          <p:spPr>
+            <a:xfrm>
+              <a:off x="4236995" y="2167309"/>
+              <a:ext cx="204408" cy="200420"/>
+            </a:xfrm>
+            <a:prstGeom prst="line">
+              <a:avLst/>
+            </a:prstGeom>
+            <a:ln>
+              <a:solidFill>
+                <a:srgbClr val="4A27F9"/>
+              </a:solidFill>
+            </a:ln>
+          </p:spPr>
+          <p:style>
+            <a:lnRef idx="2">
+              <a:schemeClr val="accent1"/>
+            </a:lnRef>
+            <a:fillRef idx="0">
+              <a:schemeClr val="accent1"/>
+            </a:fillRef>
+            <a:effectRef idx="1">
+              <a:schemeClr val="accent1"/>
+            </a:effectRef>
+            <a:fontRef idx="minor">
+              <a:schemeClr val="tx1"/>
+            </a:fontRef>
+          </p:style>
+        </p:cxnSp>
+        <p:sp>
+          <p:nvSpPr>
+            <p:cNvPr id="19" name="Oval 18">
+              <a:extLst>
+                <a:ext uri="{FF2B5EF4-FFF2-40B4-BE49-F238E27FC236}">
+                  <a16:creationId xmlns:a16="http://schemas.microsoft.com/office/drawing/2014/main" id="{081EF6D6-EDBD-4979-E12D-6395D0B2FD67}"/>
+                </a:ext>
+              </a:extLst>
+            </p:cNvPr>
+            <p:cNvSpPr/>
+            <p:nvPr/>
+          </p:nvSpPr>
+          <p:spPr>
+            <a:xfrm>
+              <a:off x="4226224" y="2157364"/>
+              <a:ext cx="73550" cy="67910"/>
+            </a:xfrm>
+            <a:prstGeom prst="ellipse">
+              <a:avLst/>
+            </a:prstGeom>
+            <a:solidFill>
+              <a:srgbClr val="4A27F9"/>
+            </a:solidFill>
+            <a:ln>
+              <a:solidFill>
+                <a:srgbClr val="4A27F9"/>
+              </a:solidFill>
+            </a:ln>
+          </p:spPr>
+          <p:style>
+            <a:lnRef idx="2">
+              <a:schemeClr val="accent1">
+                <a:shade val="15000"/>
+              </a:schemeClr>
+            </a:lnRef>
+            <a:fillRef idx="1">
+              <a:schemeClr val="accent1"/>
+            </a:fillRef>
+            <a:effectRef idx="0">
+              <a:schemeClr val="accent1"/>
+            </a:effectRef>
+            <a:fontRef idx="minor">
+              <a:schemeClr val="lt1"/>
+            </a:fontRef>
+          </p:style>
+          <p:txBody>
+            <a:bodyPr rtlCol="0" anchor="ctr"/>
+            <a:lstStyle/>
+            <a:p>
+              <a:pPr algn="ctr"/>
+              <a:endParaRPr lang="en-CA"/>
+            </a:p>
+          </p:txBody>
+        </p:sp>
+        <p:sp>
+          <p:nvSpPr>
+            <p:cNvPr id="21" name="Oval 20">
+              <a:extLst>
+                <a:ext uri="{FF2B5EF4-FFF2-40B4-BE49-F238E27FC236}">
+                  <a16:creationId xmlns:a16="http://schemas.microsoft.com/office/drawing/2014/main" id="{6085ABB3-6CC5-194B-62B9-51F34BA705E1}"/>
+                </a:ext>
+              </a:extLst>
+            </p:cNvPr>
+            <p:cNvSpPr/>
+            <p:nvPr/>
+          </p:nvSpPr>
+          <p:spPr>
+            <a:xfrm>
+              <a:off x="4378624" y="2309764"/>
+              <a:ext cx="73550" cy="67910"/>
+            </a:xfrm>
+            <a:prstGeom prst="ellipse">
+              <a:avLst/>
+            </a:prstGeom>
+            <a:solidFill>
+              <a:srgbClr val="4A27F9"/>
+            </a:solidFill>
+            <a:ln>
+              <a:solidFill>
+                <a:srgbClr val="4A27F9"/>
+              </a:solidFill>
+            </a:ln>
+          </p:spPr>
+          <p:style>
+            <a:lnRef idx="2">
+              <a:schemeClr val="accent1">
+                <a:shade val="15000"/>
+              </a:schemeClr>
+            </a:lnRef>
+            <a:fillRef idx="1">
+              <a:schemeClr val="accent1"/>
+            </a:fillRef>
+            <a:effectRef idx="0">
+              <a:schemeClr val="accent1"/>
+            </a:effectRef>
+            <a:fontRef idx="minor">
+              <a:schemeClr val="lt1"/>
+            </a:fontRef>
+          </p:style>
+          <p:txBody>
+            <a:bodyPr rtlCol="0" anchor="ctr"/>
+            <a:lstStyle/>
+            <a:p>
+              <a:pPr algn="ctr"/>
+              <a:endParaRPr lang="en-CA"/>
+            </a:p>
+          </p:txBody>
+        </p:sp>
+        <p:sp>
+          <p:nvSpPr>
+            <p:cNvPr id="23" name="Oval 22">
+              <a:extLst>
+                <a:ext uri="{FF2B5EF4-FFF2-40B4-BE49-F238E27FC236}">
+                  <a16:creationId xmlns:a16="http://schemas.microsoft.com/office/drawing/2014/main" id="{C5D0699C-35D8-36F2-2907-B9370A5E6C88}"/>
+                </a:ext>
+              </a:extLst>
+            </p:cNvPr>
+            <p:cNvSpPr/>
+            <p:nvPr/>
+          </p:nvSpPr>
+          <p:spPr>
+            <a:xfrm>
+              <a:off x="4257742" y="2401008"/>
+              <a:ext cx="73550" cy="67910"/>
+            </a:xfrm>
+            <a:prstGeom prst="ellipse">
+              <a:avLst/>
+            </a:prstGeom>
+            <a:solidFill>
+              <a:srgbClr val="4A27F9"/>
+            </a:solidFill>
+            <a:ln>
+              <a:solidFill>
+                <a:srgbClr val="4A27F9"/>
+              </a:solidFill>
+            </a:ln>
+          </p:spPr>
+          <p:style>
+            <a:lnRef idx="2">
+              <a:schemeClr val="accent1">
+                <a:shade val="15000"/>
+              </a:schemeClr>
+            </a:lnRef>
+            <a:fillRef idx="1">
+              <a:schemeClr val="accent1"/>
+            </a:fillRef>
+            <a:effectRef idx="0">
+              <a:schemeClr val="accent1"/>
+            </a:effectRef>
+            <a:fontRef idx="minor">
+              <a:schemeClr val="lt1"/>
+            </a:fontRef>
+          </p:style>
+          <p:txBody>
+            <a:bodyPr rtlCol="0" anchor="ctr"/>
+            <a:lstStyle/>
+            <a:p>
+              <a:pPr algn="ctr"/>
+              <a:endParaRPr lang="en-CA"/>
+            </a:p>
+          </p:txBody>
+        </p:sp>
+        <p:sp>
+          <p:nvSpPr>
+            <p:cNvPr id="25" name="Oval 24">
+              <a:extLst>
+                <a:ext uri="{FF2B5EF4-FFF2-40B4-BE49-F238E27FC236}">
+                  <a16:creationId xmlns:a16="http://schemas.microsoft.com/office/drawing/2014/main" id="{1218D8C3-3685-D029-3978-476D864073A0}"/>
+                </a:ext>
+              </a:extLst>
+            </p:cNvPr>
+            <p:cNvSpPr/>
+            <p:nvPr/>
+          </p:nvSpPr>
+          <p:spPr>
+            <a:xfrm>
+              <a:off x="4548608" y="2161869"/>
+              <a:ext cx="73550" cy="67910"/>
+            </a:xfrm>
+            <a:prstGeom prst="ellipse">
+              <a:avLst/>
+            </a:prstGeom>
+            <a:solidFill>
+              <a:srgbClr val="4A27F9"/>
+            </a:solidFill>
+            <a:ln>
+              <a:solidFill>
+                <a:srgbClr val="4A27F9"/>
+              </a:solidFill>
+            </a:ln>
+          </p:spPr>
+          <p:style>
+            <a:lnRef idx="2">
+              <a:schemeClr val="accent1">
+                <a:shade val="15000"/>
+              </a:schemeClr>
+            </a:lnRef>
+            <a:fillRef idx="1">
+              <a:schemeClr val="accent1"/>
+            </a:fillRef>
+            <a:effectRef idx="0">
+              <a:schemeClr val="accent1"/>
+            </a:effectRef>
+            <a:fontRef idx="minor">
+              <a:schemeClr val="lt1"/>
+            </a:fontRef>
+          </p:style>
+          <p:txBody>
+            <a:bodyPr rtlCol="0" anchor="ctr"/>
+            <a:lstStyle/>
+            <a:p>
+              <a:pPr algn="ctr"/>
+              <a:endParaRPr lang="en-CA"/>
+            </a:p>
+          </p:txBody>
+        </p:sp>
+        <p:sp>
+          <p:nvSpPr>
+            <p:cNvPr id="27" name="Oval 26">
+              <a:extLst>
+                <a:ext uri="{FF2B5EF4-FFF2-40B4-BE49-F238E27FC236}">
+                  <a16:creationId xmlns:a16="http://schemas.microsoft.com/office/drawing/2014/main" id="{2697E2B0-D477-1861-C677-D88B02E87554}"/>
+                </a:ext>
+              </a:extLst>
+            </p:cNvPr>
+            <p:cNvSpPr/>
+            <p:nvPr/>
+          </p:nvSpPr>
+          <p:spPr>
+            <a:xfrm>
+              <a:off x="4384712" y="2566682"/>
+              <a:ext cx="73550" cy="67910"/>
+            </a:xfrm>
+            <a:prstGeom prst="ellipse">
+              <a:avLst/>
+            </a:prstGeom>
+            <a:solidFill>
+              <a:srgbClr val="4A27F9"/>
+            </a:solidFill>
+            <a:ln>
+              <a:solidFill>
+                <a:srgbClr val="4A27F9"/>
+              </a:solidFill>
+            </a:ln>
+          </p:spPr>
+          <p:style>
+            <a:lnRef idx="2">
+              <a:schemeClr val="accent1">
+                <a:shade val="15000"/>
+              </a:schemeClr>
+            </a:lnRef>
+            <a:fillRef idx="1">
+              <a:schemeClr val="accent1"/>
+            </a:fillRef>
+            <a:effectRef idx="0">
+              <a:schemeClr val="accent1"/>
+            </a:effectRef>
+            <a:fontRef idx="minor">
+              <a:schemeClr val="lt1"/>
+            </a:fontRef>
+          </p:style>
+          <p:txBody>
+            <a:bodyPr rtlCol="0" anchor="ctr"/>
+            <a:lstStyle/>
+            <a:p>
+              <a:pPr algn="ctr"/>
+              <a:endParaRPr lang="en-CA"/>
+            </a:p>
+          </p:txBody>
+        </p:sp>
+        <p:cxnSp>
+          <p:nvCxnSpPr>
+            <p:cNvPr id="32" name="Straight Connector 31">
+              <a:extLst>
+                <a:ext uri="{FF2B5EF4-FFF2-40B4-BE49-F238E27FC236}">
+                  <a16:creationId xmlns:a16="http://schemas.microsoft.com/office/drawing/2014/main" id="{D82FAA3D-718B-81F8-2749-683892BE6D2B}"/>
+                </a:ext>
+              </a:extLst>
+            </p:cNvPr>
+            <p:cNvCxnSpPr>
+              <a:cxnSpLocks/>
+              <a:stCxn id="21" idx="3"/>
+              <a:endCxn id="25" idx="7"/>
+            </p:cNvCxnSpPr>
+            <p:nvPr/>
+          </p:nvCxnSpPr>
+          <p:spPr>
+            <a:xfrm flipV="1">
+              <a:off x="4389395" y="2171814"/>
+              <a:ext cx="221992" cy="195915"/>
+            </a:xfrm>
+            <a:prstGeom prst="line">
+              <a:avLst/>
+            </a:prstGeom>
+            <a:ln>
+              <a:solidFill>
+                <a:srgbClr val="4A27F9"/>
+              </a:solidFill>
+            </a:ln>
+          </p:spPr>
+          <p:style>
+            <a:lnRef idx="2">
+              <a:schemeClr val="accent1"/>
+            </a:lnRef>
+            <a:fillRef idx="0">
+              <a:schemeClr val="accent1"/>
+            </a:fillRef>
+            <a:effectRef idx="1">
+              <a:schemeClr val="accent1"/>
+            </a:effectRef>
+            <a:fontRef idx="minor">
+              <a:schemeClr val="tx1"/>
+            </a:fontRef>
+          </p:style>
+        </p:cxnSp>
+        <p:cxnSp>
+          <p:nvCxnSpPr>
+            <p:cNvPr id="35" name="Straight Connector 34">
+              <a:extLst>
+                <a:ext uri="{FF2B5EF4-FFF2-40B4-BE49-F238E27FC236}">
+                  <a16:creationId xmlns:a16="http://schemas.microsoft.com/office/drawing/2014/main" id="{2E63D84E-38E7-1A84-38C9-81E17B38D67B}"/>
+                </a:ext>
+              </a:extLst>
+            </p:cNvPr>
+            <p:cNvCxnSpPr>
+              <a:cxnSpLocks/>
+              <a:stCxn id="21" idx="7"/>
+              <a:endCxn id="23" idx="3"/>
+            </p:cNvCxnSpPr>
+            <p:nvPr/>
+          </p:nvCxnSpPr>
+          <p:spPr>
+            <a:xfrm flipH="1">
+              <a:off x="4268513" y="2319709"/>
+              <a:ext cx="172890" cy="139264"/>
+            </a:xfrm>
+            <a:prstGeom prst="line">
+              <a:avLst/>
+            </a:prstGeom>
+            <a:ln>
+              <a:solidFill>
+                <a:srgbClr val="4A27F9"/>
+              </a:solidFill>
+            </a:ln>
+          </p:spPr>
+          <p:style>
+            <a:lnRef idx="2">
+              <a:schemeClr val="accent1"/>
+            </a:lnRef>
+            <a:fillRef idx="0">
+              <a:schemeClr val="accent1"/>
+            </a:fillRef>
+            <a:effectRef idx="1">
+              <a:schemeClr val="accent1"/>
+            </a:effectRef>
+            <a:fontRef idx="minor">
+              <a:schemeClr val="tx1"/>
+            </a:fontRef>
+          </p:style>
+        </p:cxnSp>
+        <p:cxnSp>
+          <p:nvCxnSpPr>
+            <p:cNvPr id="38" name="Straight Connector 37">
+              <a:extLst>
+                <a:ext uri="{FF2B5EF4-FFF2-40B4-BE49-F238E27FC236}">
+                  <a16:creationId xmlns:a16="http://schemas.microsoft.com/office/drawing/2014/main" id="{FC619806-5D1B-7BBF-B279-574D17F67F9B}"/>
+                </a:ext>
+              </a:extLst>
+            </p:cNvPr>
+            <p:cNvCxnSpPr>
+              <a:cxnSpLocks/>
+              <a:stCxn id="21" idx="0"/>
+              <a:endCxn id="27" idx="4"/>
+            </p:cNvCxnSpPr>
+            <p:nvPr/>
+          </p:nvCxnSpPr>
+          <p:spPr>
+            <a:xfrm>
+              <a:off x="4415399" y="2309764"/>
+              <a:ext cx="6088" cy="324828"/>
+            </a:xfrm>
+            <a:prstGeom prst="line">
+              <a:avLst/>
+            </a:prstGeom>
+            <a:ln>
+              <a:solidFill>
+                <a:srgbClr val="4A27F9"/>
+              </a:solidFill>
+            </a:ln>
+          </p:spPr>
+          <p:style>
+            <a:lnRef idx="2">
+              <a:schemeClr val="accent1"/>
+            </a:lnRef>
+            <a:fillRef idx="0">
+              <a:schemeClr val="accent1"/>
+            </a:fillRef>
+            <a:effectRef idx="1">
+              <a:schemeClr val="accent1"/>
+            </a:effectRef>
+            <a:fontRef idx="minor">
+              <a:schemeClr val="tx1"/>
+            </a:fontRef>
+          </p:style>
+        </p:cxnSp>
+        <p:cxnSp>
+          <p:nvCxnSpPr>
+            <p:cNvPr id="41" name="Straight Connector 40">
+              <a:extLst>
+                <a:ext uri="{FF2B5EF4-FFF2-40B4-BE49-F238E27FC236}">
+                  <a16:creationId xmlns:a16="http://schemas.microsoft.com/office/drawing/2014/main" id="{3C917FAC-9F98-7DC8-1F1E-936043AF9ADE}"/>
+                </a:ext>
+              </a:extLst>
+            </p:cNvPr>
+            <p:cNvCxnSpPr>
+              <a:cxnSpLocks/>
+            </p:cNvCxnSpPr>
+            <p:nvPr/>
+          </p:nvCxnSpPr>
+          <p:spPr>
+            <a:xfrm flipH="1" flipV="1">
+              <a:off x="4884778" y="2215416"/>
+              <a:ext cx="269538" cy="89146"/>
+            </a:xfrm>
+            <a:prstGeom prst="line">
+              <a:avLst/>
+            </a:prstGeom>
+            <a:ln>
+              <a:solidFill>
+                <a:srgbClr val="DC445D"/>
+              </a:solidFill>
+            </a:ln>
+          </p:spPr>
+          <p:style>
+            <a:lnRef idx="2">
+              <a:schemeClr val="accent1"/>
+            </a:lnRef>
+            <a:fillRef idx="0">
+              <a:schemeClr val="accent1"/>
+            </a:fillRef>
+            <a:effectRef idx="1">
+              <a:schemeClr val="accent1"/>
+            </a:effectRef>
+            <a:fontRef idx="minor">
+              <a:schemeClr val="tx1"/>
+            </a:fontRef>
+          </p:style>
+        </p:cxnSp>
+        <p:sp>
+          <p:nvSpPr>
+            <p:cNvPr id="42" name="Oval 41">
+              <a:extLst>
+                <a:ext uri="{FF2B5EF4-FFF2-40B4-BE49-F238E27FC236}">
+                  <a16:creationId xmlns:a16="http://schemas.microsoft.com/office/drawing/2014/main" id="{60662BCC-64DC-5F56-F1AF-841B1CA46AAB}"/>
+                </a:ext>
+              </a:extLst>
+            </p:cNvPr>
+            <p:cNvSpPr/>
+            <p:nvPr/>
+          </p:nvSpPr>
+          <p:spPr>
+            <a:xfrm>
+              <a:off x="5086775" y="2256121"/>
+              <a:ext cx="73550" cy="67910"/>
+            </a:xfrm>
+            <a:prstGeom prst="ellipse">
+              <a:avLst/>
+            </a:prstGeom>
+            <a:solidFill>
+              <a:srgbClr val="DC445D"/>
+            </a:solidFill>
+            <a:ln>
+              <a:solidFill>
+                <a:srgbClr val="DC445D"/>
+              </a:solidFill>
+            </a:ln>
+          </p:spPr>
+          <p:style>
+            <a:lnRef idx="2">
+              <a:schemeClr val="accent1">
+                <a:shade val="15000"/>
+              </a:schemeClr>
+            </a:lnRef>
+            <a:fillRef idx="1">
+              <a:schemeClr val="accent1"/>
+            </a:fillRef>
+            <a:effectRef idx="0">
+              <a:schemeClr val="accent1"/>
+            </a:effectRef>
+            <a:fontRef idx="minor">
+              <a:schemeClr val="lt1"/>
+            </a:fontRef>
+          </p:style>
+          <p:txBody>
+            <a:bodyPr rtlCol="0" anchor="ctr"/>
+            <a:lstStyle/>
+            <a:p>
+              <a:pPr algn="ctr"/>
+              <a:endParaRPr lang="en-CA"/>
+            </a:p>
+          </p:txBody>
+        </p:sp>
+        <p:sp>
+          <p:nvSpPr>
+            <p:cNvPr id="43" name="Oval 42">
+              <a:extLst>
+                <a:ext uri="{FF2B5EF4-FFF2-40B4-BE49-F238E27FC236}">
+                  <a16:creationId xmlns:a16="http://schemas.microsoft.com/office/drawing/2014/main" id="{A0329036-493A-582C-9911-DD8C2D251EF8}"/>
+                </a:ext>
+              </a:extLst>
+            </p:cNvPr>
+            <p:cNvSpPr/>
+            <p:nvPr/>
+          </p:nvSpPr>
+          <p:spPr>
+            <a:xfrm>
+              <a:off x="4880016" y="2190985"/>
+              <a:ext cx="73550" cy="67910"/>
+            </a:xfrm>
+            <a:prstGeom prst="ellipse">
+              <a:avLst/>
+            </a:prstGeom>
+            <a:solidFill>
+              <a:srgbClr val="DC445D"/>
+            </a:solidFill>
+            <a:ln>
+              <a:solidFill>
+                <a:srgbClr val="DC445D"/>
+              </a:solidFill>
+            </a:ln>
+          </p:spPr>
+          <p:style>
+            <a:lnRef idx="2">
+              <a:schemeClr val="accent1">
+                <a:shade val="15000"/>
+              </a:schemeClr>
+            </a:lnRef>
+            <a:fillRef idx="1">
+              <a:schemeClr val="accent1"/>
+            </a:fillRef>
+            <a:effectRef idx="0">
+              <a:schemeClr val="accent1"/>
+            </a:effectRef>
+            <a:fontRef idx="minor">
+              <a:schemeClr val="lt1"/>
+            </a:fontRef>
+          </p:style>
+          <p:txBody>
+            <a:bodyPr rtlCol="0" anchor="ctr"/>
+            <a:lstStyle/>
+            <a:p>
+              <a:pPr algn="ctr"/>
+              <a:endParaRPr lang="en-CA"/>
+            </a:p>
+          </p:txBody>
+        </p:sp>
+        <p:sp>
+          <p:nvSpPr>
+            <p:cNvPr id="44" name="Oval 43">
+              <a:extLst>
+                <a:ext uri="{FF2B5EF4-FFF2-40B4-BE49-F238E27FC236}">
+                  <a16:creationId xmlns:a16="http://schemas.microsoft.com/office/drawing/2014/main" id="{F742D6F0-A580-DF22-0B10-353947028973}"/>
+                </a:ext>
+              </a:extLst>
+            </p:cNvPr>
+            <p:cNvSpPr/>
+            <p:nvPr/>
+          </p:nvSpPr>
+          <p:spPr>
+            <a:xfrm>
+              <a:off x="4788079" y="2319444"/>
+              <a:ext cx="73550" cy="67910"/>
+            </a:xfrm>
+            <a:prstGeom prst="ellipse">
+              <a:avLst/>
+            </a:prstGeom>
+            <a:solidFill>
+              <a:srgbClr val="DC445D"/>
+            </a:solidFill>
+            <a:ln>
+              <a:solidFill>
+                <a:srgbClr val="DC445D"/>
+              </a:solidFill>
+            </a:ln>
+          </p:spPr>
+          <p:style>
+            <a:lnRef idx="2">
+              <a:schemeClr val="accent1">
+                <a:shade val="15000"/>
+              </a:schemeClr>
+            </a:lnRef>
+            <a:fillRef idx="1">
+              <a:schemeClr val="accent1"/>
+            </a:fillRef>
+            <a:effectRef idx="0">
+              <a:schemeClr val="accent1"/>
+            </a:effectRef>
+            <a:fontRef idx="minor">
+              <a:schemeClr val="lt1"/>
+            </a:fontRef>
+          </p:style>
+          <p:txBody>
+            <a:bodyPr rtlCol="0" anchor="ctr"/>
+            <a:lstStyle/>
+            <a:p>
+              <a:pPr algn="ctr"/>
+              <a:endParaRPr lang="en-CA"/>
+            </a:p>
+          </p:txBody>
+        </p:sp>
+        <p:sp>
+          <p:nvSpPr>
+            <p:cNvPr id="45" name="Oval 44">
+              <a:extLst>
+                <a:ext uri="{FF2B5EF4-FFF2-40B4-BE49-F238E27FC236}">
+                  <a16:creationId xmlns:a16="http://schemas.microsoft.com/office/drawing/2014/main" id="{E48ED028-E19D-2BF3-F6C6-10696F68015C}"/>
+                </a:ext>
+              </a:extLst>
+            </p:cNvPr>
+            <p:cNvSpPr/>
+            <p:nvPr/>
+          </p:nvSpPr>
+          <p:spPr>
+            <a:xfrm>
+              <a:off x="4729363" y="1980968"/>
+              <a:ext cx="73550" cy="67910"/>
+            </a:xfrm>
+            <a:prstGeom prst="ellipse">
+              <a:avLst/>
+            </a:prstGeom>
+            <a:solidFill>
+              <a:srgbClr val="DC445D"/>
+            </a:solidFill>
+            <a:ln>
+              <a:solidFill>
+                <a:srgbClr val="DC445D"/>
+              </a:solidFill>
+            </a:ln>
+          </p:spPr>
+          <p:style>
+            <a:lnRef idx="2">
+              <a:schemeClr val="accent1">
+                <a:shade val="15000"/>
+              </a:schemeClr>
+            </a:lnRef>
+            <a:fillRef idx="1">
+              <a:schemeClr val="accent1"/>
+            </a:fillRef>
+            <a:effectRef idx="0">
+              <a:schemeClr val="accent1"/>
+            </a:effectRef>
+            <a:fontRef idx="minor">
+              <a:schemeClr val="lt1"/>
+            </a:fontRef>
+          </p:style>
+          <p:txBody>
+            <a:bodyPr rtlCol="0" anchor="ctr"/>
+            <a:lstStyle/>
+            <a:p>
+              <a:pPr algn="ctr"/>
+              <a:endParaRPr lang="en-CA"/>
+            </a:p>
+          </p:txBody>
+        </p:sp>
+        <p:sp>
+          <p:nvSpPr>
+            <p:cNvPr id="46" name="Oval 45">
+              <a:extLst>
+                <a:ext uri="{FF2B5EF4-FFF2-40B4-BE49-F238E27FC236}">
+                  <a16:creationId xmlns:a16="http://schemas.microsoft.com/office/drawing/2014/main" id="{FE8405C9-BA06-1AE4-18D2-99978F4F0FE4}"/>
+                </a:ext>
+              </a:extLst>
+            </p:cNvPr>
+            <p:cNvSpPr/>
+            <p:nvPr/>
+          </p:nvSpPr>
+          <p:spPr>
+            <a:xfrm>
+              <a:off x="5013225" y="2110628"/>
+              <a:ext cx="73550" cy="67910"/>
+            </a:xfrm>
+            <a:prstGeom prst="ellipse">
+              <a:avLst/>
+            </a:prstGeom>
+            <a:solidFill>
+              <a:srgbClr val="DC445D"/>
+            </a:solidFill>
+            <a:ln>
+              <a:solidFill>
+                <a:srgbClr val="DC445D"/>
+              </a:solidFill>
+            </a:ln>
+          </p:spPr>
+          <p:style>
+            <a:lnRef idx="2">
+              <a:schemeClr val="accent1">
+                <a:shade val="15000"/>
+              </a:schemeClr>
+            </a:lnRef>
+            <a:fillRef idx="1">
+              <a:schemeClr val="accent1"/>
+            </a:fillRef>
+            <a:effectRef idx="0">
+              <a:schemeClr val="accent1"/>
+            </a:effectRef>
+            <a:fontRef idx="minor">
+              <a:schemeClr val="lt1"/>
+            </a:fontRef>
+          </p:style>
+          <p:txBody>
+            <a:bodyPr rtlCol="0" anchor="ctr"/>
+            <a:lstStyle/>
+            <a:p>
+              <a:pPr algn="ctr"/>
+              <a:endParaRPr lang="en-CA"/>
+            </a:p>
+          </p:txBody>
+        </p:sp>
+        <p:cxnSp>
+          <p:nvCxnSpPr>
+            <p:cNvPr id="47" name="Straight Connector 46">
+              <a:extLst>
+                <a:ext uri="{FF2B5EF4-FFF2-40B4-BE49-F238E27FC236}">
+                  <a16:creationId xmlns:a16="http://schemas.microsoft.com/office/drawing/2014/main" id="{DCB9F063-1A96-0791-C0AD-5469A951A4F0}"/>
+                </a:ext>
+              </a:extLst>
+            </p:cNvPr>
+            <p:cNvCxnSpPr>
+              <a:cxnSpLocks/>
+              <a:stCxn id="43" idx="7"/>
+              <a:endCxn id="44" idx="3"/>
+            </p:cNvCxnSpPr>
+            <p:nvPr/>
+          </p:nvCxnSpPr>
+          <p:spPr>
+            <a:xfrm flipH="1">
+              <a:off x="4798850" y="2200930"/>
+              <a:ext cx="143945" cy="176479"/>
+            </a:xfrm>
+            <a:prstGeom prst="line">
+              <a:avLst/>
+            </a:prstGeom>
+            <a:ln>
+              <a:solidFill>
+                <a:srgbClr val="DC445D"/>
+              </a:solidFill>
+            </a:ln>
+          </p:spPr>
+          <p:style>
+            <a:lnRef idx="2">
+              <a:schemeClr val="accent1"/>
+            </a:lnRef>
+            <a:fillRef idx="0">
+              <a:schemeClr val="accent1"/>
+            </a:fillRef>
+            <a:effectRef idx="1">
+              <a:schemeClr val="accent1"/>
+            </a:effectRef>
+            <a:fontRef idx="minor">
+              <a:schemeClr val="tx1"/>
+            </a:fontRef>
+          </p:style>
+        </p:cxnSp>
+        <p:cxnSp>
+          <p:nvCxnSpPr>
+            <p:cNvPr id="48" name="Straight Connector 47">
+              <a:extLst>
+                <a:ext uri="{FF2B5EF4-FFF2-40B4-BE49-F238E27FC236}">
+                  <a16:creationId xmlns:a16="http://schemas.microsoft.com/office/drawing/2014/main" id="{667B0733-C98D-4EED-C4B2-A68EC4AD2C47}"/>
+                </a:ext>
+              </a:extLst>
+            </p:cNvPr>
+            <p:cNvCxnSpPr>
+              <a:cxnSpLocks/>
+              <a:stCxn id="43" idx="3"/>
+              <a:endCxn id="46" idx="7"/>
+            </p:cNvCxnSpPr>
+            <p:nvPr/>
+          </p:nvCxnSpPr>
+          <p:spPr>
+            <a:xfrm flipV="1">
+              <a:off x="4890787" y="2120573"/>
+              <a:ext cx="185217" cy="128377"/>
+            </a:xfrm>
+            <a:prstGeom prst="line">
+              <a:avLst/>
+            </a:prstGeom>
+            <a:ln>
+              <a:solidFill>
+                <a:srgbClr val="DC445D"/>
+              </a:solidFill>
+            </a:ln>
+          </p:spPr>
+          <p:style>
+            <a:lnRef idx="2">
+              <a:schemeClr val="accent1"/>
+            </a:lnRef>
+            <a:fillRef idx="0">
+              <a:schemeClr val="accent1"/>
+            </a:fillRef>
+            <a:effectRef idx="1">
+              <a:schemeClr val="accent1"/>
+            </a:effectRef>
+            <a:fontRef idx="minor">
+              <a:schemeClr val="tx1"/>
+            </a:fontRef>
+          </p:style>
+        </p:cxnSp>
+        <p:cxnSp>
+          <p:nvCxnSpPr>
+            <p:cNvPr id="49" name="Straight Connector 48">
+              <a:extLst>
+                <a:ext uri="{FF2B5EF4-FFF2-40B4-BE49-F238E27FC236}">
+                  <a16:creationId xmlns:a16="http://schemas.microsoft.com/office/drawing/2014/main" id="{9C4C0168-501A-9F8A-30D2-CCB4F3D76A11}"/>
+                </a:ext>
+              </a:extLst>
+            </p:cNvPr>
+            <p:cNvCxnSpPr>
+              <a:cxnSpLocks/>
+            </p:cNvCxnSpPr>
+            <p:nvPr/>
+          </p:nvCxnSpPr>
+          <p:spPr>
+            <a:xfrm>
+              <a:off x="4905073" y="2196168"/>
+              <a:ext cx="99554" cy="220379"/>
+            </a:xfrm>
+            <a:prstGeom prst="line">
+              <a:avLst/>
+            </a:prstGeom>
+            <a:ln>
+              <a:solidFill>
+                <a:srgbClr val="DC445D"/>
+              </a:solidFill>
+            </a:ln>
+          </p:spPr>
+          <p:style>
+            <a:lnRef idx="2">
+              <a:schemeClr val="accent1"/>
+            </a:lnRef>
+            <a:fillRef idx="0">
+              <a:schemeClr val="accent1"/>
+            </a:fillRef>
+            <a:effectRef idx="1">
+              <a:schemeClr val="accent1"/>
+            </a:effectRef>
+            <a:fontRef idx="minor">
+              <a:schemeClr val="tx1"/>
+            </a:fontRef>
+          </p:style>
+        </p:cxnSp>
+        <p:sp>
+          <p:nvSpPr>
+            <p:cNvPr id="52" name="Oval 51">
+              <a:extLst>
+                <a:ext uri="{FF2B5EF4-FFF2-40B4-BE49-F238E27FC236}">
+                  <a16:creationId xmlns:a16="http://schemas.microsoft.com/office/drawing/2014/main" id="{D6FC40C0-DAD7-0368-B5C5-CFF8E959A039}"/>
+                </a:ext>
+              </a:extLst>
+            </p:cNvPr>
+            <p:cNvSpPr/>
+            <p:nvPr/>
+          </p:nvSpPr>
+          <p:spPr>
+            <a:xfrm>
+              <a:off x="4953566" y="2353399"/>
+              <a:ext cx="73550" cy="67910"/>
+            </a:xfrm>
+            <a:prstGeom prst="ellipse">
+              <a:avLst/>
+            </a:prstGeom>
+            <a:solidFill>
+              <a:srgbClr val="DC445D"/>
+            </a:solidFill>
+            <a:ln>
+              <a:solidFill>
+                <a:srgbClr val="DC445D"/>
+              </a:solidFill>
+            </a:ln>
+          </p:spPr>
+          <p:style>
+            <a:lnRef idx="2">
+              <a:schemeClr val="accent1">
+                <a:shade val="15000"/>
+              </a:schemeClr>
+            </a:lnRef>
+            <a:fillRef idx="1">
+              <a:schemeClr val="accent1"/>
+            </a:fillRef>
+            <a:effectRef idx="0">
+              <a:schemeClr val="accent1"/>
+            </a:effectRef>
+            <a:fontRef idx="minor">
+              <a:schemeClr val="lt1"/>
+            </a:fontRef>
+          </p:style>
+          <p:txBody>
+            <a:bodyPr rtlCol="0" anchor="ctr"/>
+            <a:lstStyle/>
+            <a:p>
+              <a:pPr algn="ctr"/>
+              <a:endParaRPr lang="en-CA"/>
+            </a:p>
+          </p:txBody>
+        </p:sp>
+        <p:cxnSp>
+          <p:nvCxnSpPr>
+            <p:cNvPr id="63" name="Straight Connector 62">
+              <a:extLst>
+                <a:ext uri="{FF2B5EF4-FFF2-40B4-BE49-F238E27FC236}">
+                  <a16:creationId xmlns:a16="http://schemas.microsoft.com/office/drawing/2014/main" id="{4D2FA517-B6BD-F3ED-0A83-1614D05C3061}"/>
+                </a:ext>
+              </a:extLst>
+            </p:cNvPr>
+            <p:cNvCxnSpPr>
+              <a:cxnSpLocks/>
+              <a:stCxn id="45" idx="1"/>
+              <a:endCxn id="43" idx="5"/>
+            </p:cNvCxnSpPr>
+            <p:nvPr/>
+          </p:nvCxnSpPr>
+          <p:spPr>
+            <a:xfrm>
+              <a:off x="4740134" y="1990913"/>
+              <a:ext cx="202661" cy="258037"/>
+            </a:xfrm>
+            <a:prstGeom prst="line">
+              <a:avLst/>
+            </a:prstGeom>
+            <a:ln>
+              <a:solidFill>
+                <a:srgbClr val="DC445D"/>
+              </a:solidFill>
+            </a:ln>
+          </p:spPr>
+          <p:style>
+            <a:lnRef idx="2">
+              <a:schemeClr val="accent1"/>
+            </a:lnRef>
+            <a:fillRef idx="0">
+              <a:schemeClr val="accent1"/>
+            </a:fillRef>
+            <a:effectRef idx="1">
+              <a:schemeClr val="accent1"/>
+            </a:effectRef>
+            <a:fontRef idx="minor">
+              <a:schemeClr val="tx1"/>
+            </a:fontRef>
+          </p:style>
+        </p:cxnSp>
+        <p:cxnSp>
+          <p:nvCxnSpPr>
+            <p:cNvPr id="67" name="Straight Connector 66">
+              <a:extLst>
+                <a:ext uri="{FF2B5EF4-FFF2-40B4-BE49-F238E27FC236}">
+                  <a16:creationId xmlns:a16="http://schemas.microsoft.com/office/drawing/2014/main" id="{566484AA-AA72-2B72-1265-C5022310C2C2}"/>
+                </a:ext>
+              </a:extLst>
+            </p:cNvPr>
+            <p:cNvCxnSpPr>
+              <a:cxnSpLocks/>
+              <a:stCxn id="76" idx="7"/>
+              <a:endCxn id="69" idx="3"/>
+            </p:cNvCxnSpPr>
+            <p:nvPr/>
+          </p:nvCxnSpPr>
+          <p:spPr>
+            <a:xfrm flipH="1">
+              <a:off x="4688126" y="2542672"/>
+              <a:ext cx="181119" cy="134377"/>
+            </a:xfrm>
+            <a:prstGeom prst="line">
+              <a:avLst/>
+            </a:prstGeom>
+            <a:ln>
+              <a:solidFill>
+                <a:srgbClr val="FFC000"/>
+              </a:solidFill>
+            </a:ln>
+          </p:spPr>
+          <p:style>
+            <a:lnRef idx="2">
+              <a:schemeClr val="accent1"/>
+            </a:lnRef>
+            <a:fillRef idx="0">
+              <a:schemeClr val="accent1"/>
+            </a:fillRef>
+            <a:effectRef idx="1">
+              <a:schemeClr val="accent1"/>
+            </a:effectRef>
+            <a:fontRef idx="minor">
+              <a:schemeClr val="tx1"/>
+            </a:fontRef>
+          </p:style>
+        </p:cxnSp>
+        <p:sp>
+          <p:nvSpPr>
+            <p:cNvPr id="68" name="Oval 67">
+              <a:extLst>
+                <a:ext uri="{FF2B5EF4-FFF2-40B4-BE49-F238E27FC236}">
+                  <a16:creationId xmlns:a16="http://schemas.microsoft.com/office/drawing/2014/main" id="{E180036A-A98F-D7B5-7CFC-79A819FC5D45}"/>
+                </a:ext>
+              </a:extLst>
+            </p:cNvPr>
+            <p:cNvSpPr/>
+            <p:nvPr/>
+          </p:nvSpPr>
+          <p:spPr>
+            <a:xfrm>
+              <a:off x="4884114" y="2684220"/>
+              <a:ext cx="73550" cy="67910"/>
+            </a:xfrm>
+            <a:prstGeom prst="ellipse">
+              <a:avLst/>
+            </a:prstGeom>
+            <a:solidFill>
+              <a:srgbClr val="FFC000"/>
+            </a:solidFill>
+            <a:ln>
+              <a:solidFill>
+                <a:srgbClr val="FFC000"/>
+              </a:solidFill>
+            </a:ln>
+          </p:spPr>
+          <p:style>
+            <a:lnRef idx="2">
+              <a:schemeClr val="accent1">
+                <a:shade val="15000"/>
+              </a:schemeClr>
+            </a:lnRef>
+            <a:fillRef idx="1">
+              <a:schemeClr val="accent1"/>
+            </a:fillRef>
+            <a:effectRef idx="0">
+              <a:schemeClr val="accent1"/>
+            </a:effectRef>
+            <a:fontRef idx="minor">
+              <a:schemeClr val="lt1"/>
+            </a:fontRef>
+          </p:style>
+          <p:txBody>
+            <a:bodyPr rtlCol="0" anchor="ctr"/>
+            <a:lstStyle/>
+            <a:p>
+              <a:pPr algn="ctr"/>
+              <a:endParaRPr lang="en-CA"/>
+            </a:p>
+          </p:txBody>
+        </p:sp>
+        <p:sp>
+          <p:nvSpPr>
+            <p:cNvPr id="69" name="Oval 68">
+              <a:extLst>
+                <a:ext uri="{FF2B5EF4-FFF2-40B4-BE49-F238E27FC236}">
+                  <a16:creationId xmlns:a16="http://schemas.microsoft.com/office/drawing/2014/main" id="{3A80BE4D-063C-2618-B8CA-78125421D875}"/>
+                </a:ext>
+              </a:extLst>
+            </p:cNvPr>
+            <p:cNvSpPr/>
+            <p:nvPr/>
+          </p:nvSpPr>
+          <p:spPr>
+            <a:xfrm>
+              <a:off x="4677355" y="2619084"/>
+              <a:ext cx="73550" cy="67910"/>
+            </a:xfrm>
+            <a:prstGeom prst="ellipse">
+              <a:avLst/>
+            </a:prstGeom>
+            <a:solidFill>
+              <a:srgbClr val="FFC000"/>
+            </a:solidFill>
+            <a:ln>
+              <a:solidFill>
+                <a:srgbClr val="FFC000"/>
+              </a:solidFill>
+            </a:ln>
+          </p:spPr>
+          <p:style>
+            <a:lnRef idx="2">
+              <a:schemeClr val="accent1">
+                <a:shade val="15000"/>
+              </a:schemeClr>
+            </a:lnRef>
+            <a:fillRef idx="1">
+              <a:schemeClr val="accent1"/>
+            </a:fillRef>
+            <a:effectRef idx="0">
+              <a:schemeClr val="accent1"/>
+            </a:effectRef>
+            <a:fontRef idx="minor">
+              <a:schemeClr val="lt1"/>
+            </a:fontRef>
+          </p:style>
+          <p:txBody>
+            <a:bodyPr rtlCol="0" anchor="ctr"/>
+            <a:lstStyle/>
+            <a:p>
+              <a:pPr algn="ctr"/>
+              <a:endParaRPr lang="en-CA"/>
+            </a:p>
+          </p:txBody>
+        </p:sp>
+        <p:sp>
+          <p:nvSpPr>
+            <p:cNvPr id="70" name="Oval 69">
+              <a:extLst>
+                <a:ext uri="{FF2B5EF4-FFF2-40B4-BE49-F238E27FC236}">
+                  <a16:creationId xmlns:a16="http://schemas.microsoft.com/office/drawing/2014/main" id="{45E38CA0-635B-ACE6-3B8A-80B0331844FF}"/>
+                </a:ext>
+              </a:extLst>
+            </p:cNvPr>
+            <p:cNvSpPr/>
+            <p:nvPr/>
+          </p:nvSpPr>
+          <p:spPr>
+            <a:xfrm>
+              <a:off x="4585418" y="2747543"/>
+              <a:ext cx="73550" cy="67910"/>
+            </a:xfrm>
+            <a:prstGeom prst="ellipse">
+              <a:avLst/>
+            </a:prstGeom>
+            <a:solidFill>
+              <a:srgbClr val="FFC000"/>
+            </a:solidFill>
+            <a:ln>
+              <a:solidFill>
+                <a:srgbClr val="FFC000"/>
+              </a:solidFill>
+            </a:ln>
+          </p:spPr>
+          <p:style>
+            <a:lnRef idx="2">
+              <a:schemeClr val="accent1">
+                <a:shade val="15000"/>
+              </a:schemeClr>
+            </a:lnRef>
+            <a:fillRef idx="1">
+              <a:schemeClr val="accent1"/>
+            </a:fillRef>
+            <a:effectRef idx="0">
+              <a:schemeClr val="accent1"/>
+            </a:effectRef>
+            <a:fontRef idx="minor">
+              <a:schemeClr val="lt1"/>
+            </a:fontRef>
+          </p:style>
+          <p:txBody>
+            <a:bodyPr rtlCol="0" anchor="ctr"/>
+            <a:lstStyle/>
+            <a:p>
+              <a:pPr algn="ctr"/>
+              <a:endParaRPr lang="en-CA"/>
+            </a:p>
+          </p:txBody>
+        </p:sp>
+        <p:sp>
+          <p:nvSpPr>
+            <p:cNvPr id="71" name="Oval 70">
+              <a:extLst>
+                <a:ext uri="{FF2B5EF4-FFF2-40B4-BE49-F238E27FC236}">
+                  <a16:creationId xmlns:a16="http://schemas.microsoft.com/office/drawing/2014/main" id="{E527DEAE-9EB9-D726-C435-798F6FCC1672}"/>
+                </a:ext>
+              </a:extLst>
+            </p:cNvPr>
+            <p:cNvSpPr/>
+            <p:nvPr/>
+          </p:nvSpPr>
+          <p:spPr>
+            <a:xfrm>
+              <a:off x="4628876" y="2454706"/>
+              <a:ext cx="73550" cy="67910"/>
+            </a:xfrm>
+            <a:prstGeom prst="ellipse">
+              <a:avLst/>
+            </a:prstGeom>
+            <a:solidFill>
+              <a:srgbClr val="FFC000"/>
+            </a:solidFill>
+            <a:ln>
+              <a:solidFill>
+                <a:srgbClr val="FFC000"/>
+              </a:solidFill>
+            </a:ln>
+          </p:spPr>
+          <p:style>
+            <a:lnRef idx="2">
+              <a:schemeClr val="accent1">
+                <a:shade val="15000"/>
+              </a:schemeClr>
+            </a:lnRef>
+            <a:fillRef idx="1">
+              <a:schemeClr val="accent1"/>
+            </a:fillRef>
+            <a:effectRef idx="0">
+              <a:schemeClr val="accent1"/>
+            </a:effectRef>
+            <a:fontRef idx="minor">
+              <a:schemeClr val="lt1"/>
+            </a:fontRef>
+          </p:style>
+          <p:txBody>
+            <a:bodyPr rtlCol="0" anchor="ctr"/>
+            <a:lstStyle/>
+            <a:p>
+              <a:pPr algn="ctr"/>
+              <a:endParaRPr lang="en-CA"/>
+            </a:p>
+          </p:txBody>
+        </p:sp>
+        <p:sp>
+          <p:nvSpPr>
+            <p:cNvPr id="72" name="Oval 71">
+              <a:extLst>
+                <a:ext uri="{FF2B5EF4-FFF2-40B4-BE49-F238E27FC236}">
+                  <a16:creationId xmlns:a16="http://schemas.microsoft.com/office/drawing/2014/main" id="{A75AEAE8-7EFE-4A6C-413A-411E9DE26E45}"/>
+                </a:ext>
+              </a:extLst>
+            </p:cNvPr>
+            <p:cNvSpPr/>
+            <p:nvPr/>
+          </p:nvSpPr>
+          <p:spPr>
+            <a:xfrm>
+              <a:off x="4507371" y="2656368"/>
+              <a:ext cx="73550" cy="67910"/>
+            </a:xfrm>
+            <a:prstGeom prst="ellipse">
+              <a:avLst/>
+            </a:prstGeom>
+            <a:solidFill>
+              <a:srgbClr val="FFC000"/>
+            </a:solidFill>
+            <a:ln>
+              <a:solidFill>
+                <a:srgbClr val="FFC000"/>
+              </a:solidFill>
+            </a:ln>
+          </p:spPr>
+          <p:style>
+            <a:lnRef idx="2">
+              <a:schemeClr val="accent1">
+                <a:shade val="15000"/>
+              </a:schemeClr>
+            </a:lnRef>
+            <a:fillRef idx="1">
+              <a:schemeClr val="accent1"/>
+            </a:fillRef>
+            <a:effectRef idx="0">
+              <a:schemeClr val="accent1"/>
+            </a:effectRef>
+            <a:fontRef idx="minor">
+              <a:schemeClr val="lt1"/>
+            </a:fontRef>
+          </p:style>
+          <p:txBody>
+            <a:bodyPr rtlCol="0" anchor="ctr"/>
+            <a:lstStyle/>
+            <a:p>
+              <a:pPr algn="ctr"/>
+              <a:endParaRPr lang="en-CA"/>
+            </a:p>
+          </p:txBody>
+        </p:sp>
+        <p:cxnSp>
+          <p:nvCxnSpPr>
+            <p:cNvPr id="73" name="Straight Connector 72">
+              <a:extLst>
+                <a:ext uri="{FF2B5EF4-FFF2-40B4-BE49-F238E27FC236}">
+                  <a16:creationId xmlns:a16="http://schemas.microsoft.com/office/drawing/2014/main" id="{8E837D91-AC0E-1B1E-A6BE-6C3DE76A1C28}"/>
+                </a:ext>
+              </a:extLst>
+            </p:cNvPr>
+            <p:cNvCxnSpPr>
+              <a:cxnSpLocks/>
+            </p:cNvCxnSpPr>
+            <p:nvPr/>
+          </p:nvCxnSpPr>
+          <p:spPr>
+            <a:xfrm flipH="1" flipV="1">
+              <a:off x="4680983" y="2638553"/>
+              <a:ext cx="269538" cy="89146"/>
+            </a:xfrm>
+            <a:prstGeom prst="line">
+              <a:avLst/>
+            </a:prstGeom>
+            <a:ln>
+              <a:solidFill>
+                <a:srgbClr val="FFC000"/>
+              </a:solidFill>
+            </a:ln>
+          </p:spPr>
+          <p:style>
+            <a:lnRef idx="2">
+              <a:schemeClr val="accent1"/>
+            </a:lnRef>
+            <a:fillRef idx="0">
+              <a:schemeClr val="accent1"/>
+            </a:fillRef>
+            <a:effectRef idx="1">
+              <a:schemeClr val="accent1"/>
+            </a:effectRef>
+            <a:fontRef idx="minor">
+              <a:schemeClr val="tx1"/>
+            </a:fontRef>
+          </p:style>
+        </p:cxnSp>
+        <p:cxnSp>
+          <p:nvCxnSpPr>
+            <p:cNvPr id="74" name="Straight Connector 73">
+              <a:extLst>
+                <a:ext uri="{FF2B5EF4-FFF2-40B4-BE49-F238E27FC236}">
+                  <a16:creationId xmlns:a16="http://schemas.microsoft.com/office/drawing/2014/main" id="{A6D419CA-3EEC-8A1E-E310-BA65C0E5EF68}"/>
+                </a:ext>
+              </a:extLst>
+            </p:cNvPr>
+            <p:cNvCxnSpPr>
+              <a:cxnSpLocks/>
+              <a:stCxn id="70" idx="3"/>
+              <a:endCxn id="69" idx="7"/>
+            </p:cNvCxnSpPr>
+            <p:nvPr/>
+          </p:nvCxnSpPr>
+          <p:spPr>
+            <a:xfrm flipV="1">
+              <a:off x="4596189" y="2629029"/>
+              <a:ext cx="143945" cy="176479"/>
+            </a:xfrm>
+            <a:prstGeom prst="line">
+              <a:avLst/>
+            </a:prstGeom>
+            <a:ln>
+              <a:solidFill>
+                <a:srgbClr val="FFC000"/>
+              </a:solidFill>
+            </a:ln>
+          </p:spPr>
+          <p:style>
+            <a:lnRef idx="2">
+              <a:schemeClr val="accent1"/>
+            </a:lnRef>
+            <a:fillRef idx="0">
+              <a:schemeClr val="accent1"/>
+            </a:fillRef>
+            <a:effectRef idx="1">
+              <a:schemeClr val="accent1"/>
+            </a:effectRef>
+            <a:fontRef idx="minor">
+              <a:schemeClr val="tx1"/>
+            </a:fontRef>
+          </p:style>
+        </p:cxnSp>
+        <p:cxnSp>
+          <p:nvCxnSpPr>
+            <p:cNvPr id="75" name="Straight Connector 74">
+              <a:extLst>
+                <a:ext uri="{FF2B5EF4-FFF2-40B4-BE49-F238E27FC236}">
+                  <a16:creationId xmlns:a16="http://schemas.microsoft.com/office/drawing/2014/main" id="{4A592A9B-213A-1744-F28D-311445D921C2}"/>
+                </a:ext>
+              </a:extLst>
+            </p:cNvPr>
+            <p:cNvCxnSpPr>
+              <a:cxnSpLocks/>
+            </p:cNvCxnSpPr>
+            <p:nvPr/>
+          </p:nvCxnSpPr>
+          <p:spPr>
+            <a:xfrm flipH="1" flipV="1">
+              <a:off x="4646603" y="2457087"/>
+              <a:ext cx="79245" cy="219962"/>
+            </a:xfrm>
+            <a:prstGeom prst="line">
+              <a:avLst/>
+            </a:prstGeom>
+            <a:ln>
+              <a:solidFill>
+                <a:srgbClr val="FFC000"/>
+              </a:solidFill>
+            </a:ln>
+          </p:spPr>
+          <p:style>
+            <a:lnRef idx="2">
+              <a:schemeClr val="accent1"/>
+            </a:lnRef>
+            <a:fillRef idx="0">
+              <a:schemeClr val="accent1"/>
+            </a:fillRef>
+            <a:effectRef idx="1">
+              <a:schemeClr val="accent1"/>
+            </a:effectRef>
+            <a:fontRef idx="minor">
+              <a:schemeClr val="tx1"/>
+            </a:fontRef>
+          </p:style>
+        </p:cxnSp>
+        <p:sp>
+          <p:nvSpPr>
+            <p:cNvPr id="76" name="Oval 75">
+              <a:extLst>
+                <a:ext uri="{FF2B5EF4-FFF2-40B4-BE49-F238E27FC236}">
+                  <a16:creationId xmlns:a16="http://schemas.microsoft.com/office/drawing/2014/main" id="{E3DA2B0B-F45E-F799-971A-C85A4B01616D}"/>
+                </a:ext>
+              </a:extLst>
+            </p:cNvPr>
+            <p:cNvSpPr/>
+            <p:nvPr/>
+          </p:nvSpPr>
+          <p:spPr>
+            <a:xfrm>
+              <a:off x="4806466" y="2532727"/>
+              <a:ext cx="73550" cy="67910"/>
+            </a:xfrm>
+            <a:prstGeom prst="ellipse">
+              <a:avLst/>
+            </a:prstGeom>
+            <a:solidFill>
+              <a:srgbClr val="FFC000"/>
+            </a:solidFill>
+            <a:ln>
+              <a:solidFill>
+                <a:srgbClr val="FFC000"/>
+              </a:solidFill>
+            </a:ln>
+          </p:spPr>
+          <p:style>
+            <a:lnRef idx="2">
+              <a:schemeClr val="accent1">
+                <a:shade val="15000"/>
+              </a:schemeClr>
+            </a:lnRef>
+            <a:fillRef idx="1">
+              <a:schemeClr val="accent1"/>
+            </a:fillRef>
+            <a:effectRef idx="0">
+              <a:schemeClr val="accent1"/>
+            </a:effectRef>
+            <a:fontRef idx="minor">
+              <a:schemeClr val="lt1"/>
+            </a:fontRef>
+          </p:style>
+          <p:txBody>
+            <a:bodyPr rtlCol="0" anchor="ctr"/>
+            <a:lstStyle/>
+            <a:p>
+              <a:pPr algn="ctr"/>
+              <a:endParaRPr lang="en-CA"/>
+            </a:p>
+          </p:txBody>
+        </p:sp>
+        <p:cxnSp>
+          <p:nvCxnSpPr>
+            <p:cNvPr id="77" name="Straight Connector 76">
+              <a:extLst>
+                <a:ext uri="{FF2B5EF4-FFF2-40B4-BE49-F238E27FC236}">
+                  <a16:creationId xmlns:a16="http://schemas.microsoft.com/office/drawing/2014/main" id="{266492D5-0741-746C-4FD9-ACF3722A9B02}"/>
+                </a:ext>
+              </a:extLst>
+            </p:cNvPr>
+            <p:cNvCxnSpPr>
+              <a:cxnSpLocks/>
+            </p:cNvCxnSpPr>
+            <p:nvPr/>
+          </p:nvCxnSpPr>
+          <p:spPr>
+            <a:xfrm flipV="1">
+              <a:off x="4509752" y="2640934"/>
+              <a:ext cx="232763" cy="61294"/>
+            </a:xfrm>
+            <a:prstGeom prst="line">
+              <a:avLst/>
+            </a:prstGeom>
+            <a:ln>
+              <a:solidFill>
+                <a:srgbClr val="FFC000"/>
+              </a:solidFill>
+            </a:ln>
+          </p:spPr>
+          <p:style>
+            <a:lnRef idx="2">
+              <a:schemeClr val="accent1"/>
+            </a:lnRef>
+            <a:fillRef idx="0">
+              <a:schemeClr val="accent1"/>
+            </a:fillRef>
+            <a:effectRef idx="1">
+              <a:schemeClr val="accent1"/>
+            </a:effectRef>
+            <a:fontRef idx="minor">
+              <a:schemeClr val="tx1"/>
+            </a:fontRef>
+          </p:style>
+        </p:cxnSp>
+        <p:sp>
+          <p:nvSpPr>
+            <p:cNvPr id="92" name="Oval 91">
+              <a:extLst>
+                <a:ext uri="{FF2B5EF4-FFF2-40B4-BE49-F238E27FC236}">
+                  <a16:creationId xmlns:a16="http://schemas.microsoft.com/office/drawing/2014/main" id="{2E9DDA3A-37C6-8F01-55D3-4E6A70B13770}"/>
+                </a:ext>
+              </a:extLst>
+            </p:cNvPr>
+            <p:cNvSpPr/>
+            <p:nvPr/>
+          </p:nvSpPr>
+          <p:spPr>
+            <a:xfrm>
+              <a:off x="4670333" y="2886445"/>
+              <a:ext cx="73550" cy="67910"/>
+            </a:xfrm>
+            <a:prstGeom prst="ellipse">
+              <a:avLst/>
+            </a:prstGeom>
+            <a:solidFill>
+              <a:srgbClr val="FFC000"/>
+            </a:solidFill>
+            <a:ln>
+              <a:solidFill>
+                <a:srgbClr val="FFC000"/>
+              </a:solidFill>
+            </a:ln>
+          </p:spPr>
+          <p:style>
+            <a:lnRef idx="2">
+              <a:schemeClr val="accent1">
+                <a:shade val="15000"/>
+              </a:schemeClr>
+            </a:lnRef>
+            <a:fillRef idx="1">
+              <a:schemeClr val="accent1"/>
+            </a:fillRef>
+            <a:effectRef idx="0">
+              <a:schemeClr val="accent1"/>
+            </a:effectRef>
+            <a:fontRef idx="minor">
+              <a:schemeClr val="lt1"/>
+            </a:fontRef>
+          </p:style>
+          <p:txBody>
+            <a:bodyPr rtlCol="0" anchor="ctr"/>
+            <a:lstStyle/>
+            <a:p>
+              <a:pPr algn="ctr"/>
+              <a:endParaRPr lang="en-CA"/>
+            </a:p>
+          </p:txBody>
+        </p:sp>
+        <p:cxnSp>
+          <p:nvCxnSpPr>
+            <p:cNvPr id="93" name="Straight Connector 92">
+              <a:extLst>
+                <a:ext uri="{FF2B5EF4-FFF2-40B4-BE49-F238E27FC236}">
+                  <a16:creationId xmlns:a16="http://schemas.microsoft.com/office/drawing/2014/main" id="{F88C601E-3155-2914-3E5F-E2219AADDC36}"/>
+                </a:ext>
+              </a:extLst>
+            </p:cNvPr>
+            <p:cNvCxnSpPr>
+              <a:cxnSpLocks/>
+              <a:stCxn id="69" idx="0"/>
+              <a:endCxn id="92" idx="4"/>
+            </p:cNvCxnSpPr>
+            <p:nvPr/>
+          </p:nvCxnSpPr>
+          <p:spPr>
+            <a:xfrm flipH="1">
+              <a:off x="4707108" y="2619084"/>
+              <a:ext cx="7022" cy="335271"/>
+            </a:xfrm>
+            <a:prstGeom prst="line">
+              <a:avLst/>
+            </a:prstGeom>
+            <a:ln>
+              <a:solidFill>
+                <a:srgbClr val="FFC000"/>
+              </a:solidFill>
+            </a:ln>
+          </p:spPr>
+          <p:style>
+            <a:lnRef idx="2">
+              <a:schemeClr val="accent1"/>
+            </a:lnRef>
+            <a:fillRef idx="0">
+              <a:schemeClr val="accent1"/>
+            </a:fillRef>
+            <a:effectRef idx="1">
+              <a:schemeClr val="accent1"/>
+            </a:effectRef>
+            <a:fontRef idx="minor">
+              <a:schemeClr val="tx1"/>
+            </a:fontRef>
+          </p:style>
+        </p:cxnSp>
+      </p:grpSp>
+      <p:sp>
+        <p:nvSpPr>
+          <p:cNvPr id="107" name="TextBox 106">
+            <a:extLst>
+              <a:ext uri="{FF2B5EF4-FFF2-40B4-BE49-F238E27FC236}">
+                <a16:creationId xmlns:a16="http://schemas.microsoft.com/office/drawing/2014/main" id="{A4D89389-CE9D-C96E-8378-71E08A093C8A}"/>
+              </a:ext>
+            </a:extLst>
+          </p:cNvPr>
+          <p:cNvSpPr txBox="1"/>
+          <p:nvPr/>
+        </p:nvSpPr>
+        <p:spPr>
+          <a:xfrm>
+            <a:off x="4227609" y="1755870"/>
+            <a:ext cx="2907821" cy="307777"/>
+          </a:xfrm>
+          <a:prstGeom prst="rect">
+            <a:avLst/>
+          </a:prstGeom>
+          <a:noFill/>
+          <a:ln>
+            <a:solidFill>
+              <a:schemeClr val="tx1"/>
+            </a:solidFill>
+          </a:ln>
+        </p:spPr>
+        <p:txBody>
+          <a:bodyPr wrap="square" rtlCol="0">
+            <a:spAutoFit/>
+          </a:bodyPr>
+          <a:lstStyle/>
+          <a:p>
+            <a:r>
+              <a:rPr lang="en-US" sz="1400" dirty="0">
+                <a:latin typeface="Verdana Pro" panose="020B0604030504040204" pitchFamily="34" charset="0"/>
+              </a:rPr>
+              <a:t>Human-bacteria protein pairs</a:t>
+            </a:r>
+            <a:endParaRPr lang="en-CA" sz="1400" dirty="0">
+              <a:latin typeface="Verdana Pro" panose="020B0604030504040204" pitchFamily="34" charset="0"/>
+            </a:endParaRPr>
+          </a:p>
+        </p:txBody>
+      </p:sp>
+      <p:cxnSp>
+        <p:nvCxnSpPr>
+          <p:cNvPr id="114" name="Connector: Elbow 113">
+            <a:extLst>
+              <a:ext uri="{FF2B5EF4-FFF2-40B4-BE49-F238E27FC236}">
+                <a16:creationId xmlns:a16="http://schemas.microsoft.com/office/drawing/2014/main" id="{FDA91FCA-C304-3406-3EEC-B14900AC32FA}"/>
+              </a:ext>
+            </a:extLst>
+          </p:cNvPr>
+          <p:cNvCxnSpPr>
+            <a:cxnSpLocks/>
+            <a:stCxn id="8" idx="3"/>
+            <a:endCxn id="107" idx="1"/>
+          </p:cNvCxnSpPr>
+          <p:nvPr/>
+        </p:nvCxnSpPr>
+        <p:spPr>
+          <a:xfrm flipV="1">
+            <a:off x="3238241" y="1909759"/>
+            <a:ext cx="989368" cy="1"/>
+          </a:xfrm>
+          <a:prstGeom prst="bentConnector3">
+            <a:avLst/>
+          </a:prstGeom>
+          <a:ln>
+            <a:solidFill>
+              <a:schemeClr val="tx1"/>
+            </a:solidFill>
+            <a:tailEnd type="triangle"/>
+          </a:ln>
+        </p:spPr>
+        <p:style>
+          <a:lnRef idx="2">
+            <a:schemeClr val="accent1"/>
+          </a:lnRef>
+          <a:fillRef idx="0">
+            <a:schemeClr val="accent1"/>
+          </a:fillRef>
+          <a:effectRef idx="1">
+            <a:schemeClr val="accent1"/>
+          </a:effectRef>
+          <a:fontRef idx="minor">
+            <a:schemeClr val="tx1"/>
+          </a:fontRef>
+        </p:style>
+      </p:cxnSp>
+      <p:cxnSp>
+        <p:nvCxnSpPr>
+          <p:cNvPr id="117" name="Connector: Elbow 116">
+            <a:extLst>
+              <a:ext uri="{FF2B5EF4-FFF2-40B4-BE49-F238E27FC236}">
+                <a16:creationId xmlns:a16="http://schemas.microsoft.com/office/drawing/2014/main" id="{757B1020-BD65-9003-1637-5C69A8B54BB9}"/>
+              </a:ext>
+            </a:extLst>
+          </p:cNvPr>
+          <p:cNvCxnSpPr>
+            <a:cxnSpLocks/>
+            <a:stCxn id="10" idx="3"/>
+            <a:endCxn id="107" idx="1"/>
+          </p:cNvCxnSpPr>
+          <p:nvPr/>
+        </p:nvCxnSpPr>
+        <p:spPr>
+          <a:xfrm flipV="1">
+            <a:off x="3180581" y="1909759"/>
+            <a:ext cx="1047028" cy="1744336"/>
+          </a:xfrm>
+          <a:prstGeom prst="bentConnector3">
+            <a:avLst>
+              <a:gd name="adj1" fmla="val 50000"/>
+            </a:avLst>
+          </a:prstGeom>
+          <a:ln>
+            <a:solidFill>
+              <a:schemeClr val="tx1"/>
+            </a:solidFill>
+            <a:tailEnd type="triangle"/>
+          </a:ln>
+        </p:spPr>
+        <p:style>
+          <a:lnRef idx="2">
+            <a:schemeClr val="accent1"/>
+          </a:lnRef>
+          <a:fillRef idx="0">
+            <a:schemeClr val="accent1"/>
+          </a:fillRef>
+          <a:effectRef idx="1">
+            <a:schemeClr val="accent1"/>
+          </a:effectRef>
+          <a:fontRef idx="minor">
+            <a:schemeClr val="tx1"/>
+          </a:fontRef>
+        </p:style>
+      </p:cxnSp>
+      <p:sp>
+        <p:nvSpPr>
+          <p:cNvPr id="127" name="TextBox 126">
+            <a:extLst>
+              <a:ext uri="{FF2B5EF4-FFF2-40B4-BE49-F238E27FC236}">
+                <a16:creationId xmlns:a16="http://schemas.microsoft.com/office/drawing/2014/main" id="{73EC1BDA-16B8-F15B-DEA1-0928C4E3020D}"/>
+              </a:ext>
+            </a:extLst>
+          </p:cNvPr>
+          <p:cNvSpPr txBox="1"/>
+          <p:nvPr/>
+        </p:nvSpPr>
+        <p:spPr>
+          <a:xfrm>
+            <a:off x="4227609" y="2217535"/>
+            <a:ext cx="3135704" cy="1107996"/>
+          </a:xfrm>
+          <a:prstGeom prst="rect">
+            <a:avLst/>
+          </a:prstGeom>
+          <a:noFill/>
+        </p:spPr>
+        <p:txBody>
+          <a:bodyPr wrap="square" rtlCol="0">
+            <a:spAutoFit/>
+          </a:bodyPr>
+          <a:lstStyle/>
+          <a:p>
+            <a:pPr>
+              <a:spcAft>
+                <a:spcPts val="600"/>
+              </a:spcAft>
+            </a:pPr>
+            <a:r>
+              <a:rPr lang="en-US" sz="1400" dirty="0">
+                <a:latin typeface="Verdana Pro" panose="020B0604030504040204" pitchFamily="34" charset="0"/>
+              </a:rPr>
+              <a:t>Proteins with ...</a:t>
+            </a:r>
+          </a:p>
+          <a:p>
+            <a:pPr>
+              <a:spcAft>
+                <a:spcPts val="600"/>
+              </a:spcAft>
+            </a:pPr>
+            <a:r>
+              <a:rPr lang="en-US" sz="1400" dirty="0">
+                <a:latin typeface="Verdana Pro" panose="020B0604030504040204" pitchFamily="34" charset="0"/>
+              </a:rPr>
+              <a:t>1. </a:t>
+            </a:r>
+            <a:r>
+              <a:rPr lang="en-US" sz="1400" i="1" dirty="0">
+                <a:latin typeface="Verdana Pro" panose="020B0604030504040204" pitchFamily="34" charset="0"/>
+              </a:rPr>
+              <a:t>H. sapiens</a:t>
+            </a:r>
+            <a:r>
+              <a:rPr lang="en-US" sz="1400" dirty="0">
+                <a:latin typeface="Verdana Pro" panose="020B0604030504040204" pitchFamily="34" charset="0"/>
+              </a:rPr>
+              <a:t> taxID in FoldSeek</a:t>
+            </a:r>
+          </a:p>
+          <a:p>
+            <a:r>
+              <a:rPr lang="en-CA" sz="1400" dirty="0">
+                <a:latin typeface="Verdana Pro" panose="020B0604030504040204" pitchFamily="34" charset="0"/>
+              </a:rPr>
+              <a:t>2. e-value with protein in DefenseFinder</a:t>
+            </a:r>
+          </a:p>
+        </p:txBody>
+      </p:sp>
+      <p:cxnSp>
+        <p:nvCxnSpPr>
+          <p:cNvPr id="131" name="Connector: Elbow 130">
+            <a:extLst>
+              <a:ext uri="{FF2B5EF4-FFF2-40B4-BE49-F238E27FC236}">
+                <a16:creationId xmlns:a16="http://schemas.microsoft.com/office/drawing/2014/main" id="{D8D45798-7DF9-C8FC-6DB2-C7230BA5880D}"/>
+              </a:ext>
+            </a:extLst>
+          </p:cNvPr>
+          <p:cNvCxnSpPr>
+            <a:cxnSpLocks/>
+          </p:cNvCxnSpPr>
+          <p:nvPr/>
+        </p:nvCxnSpPr>
+        <p:spPr>
+          <a:xfrm flipV="1">
+            <a:off x="7135430" y="1909758"/>
+            <a:ext cx="989368" cy="1"/>
+          </a:xfrm>
+          <a:prstGeom prst="bentConnector3">
+            <a:avLst/>
+          </a:prstGeom>
+          <a:ln>
+            <a:solidFill>
+              <a:schemeClr val="tx1"/>
+            </a:solidFill>
+            <a:tailEnd type="triangle"/>
+          </a:ln>
+        </p:spPr>
+        <p:style>
+          <a:lnRef idx="2">
+            <a:schemeClr val="accent1"/>
+          </a:lnRef>
+          <a:fillRef idx="0">
+            <a:schemeClr val="accent1"/>
+          </a:fillRef>
+          <a:effectRef idx="1">
+            <a:schemeClr val="accent1"/>
+          </a:effectRef>
+          <a:fontRef idx="minor">
+            <a:schemeClr val="tx1"/>
+          </a:fontRef>
+        </p:style>
+      </p:cxnSp>
+      <p:sp>
+        <p:nvSpPr>
+          <p:cNvPr id="133" name="TextBox 132">
+            <a:extLst>
+              <a:ext uri="{FF2B5EF4-FFF2-40B4-BE49-F238E27FC236}">
+                <a16:creationId xmlns:a16="http://schemas.microsoft.com/office/drawing/2014/main" id="{BF16BC33-2984-B617-CF5C-42D7CFA7F0A9}"/>
+              </a:ext>
+            </a:extLst>
+          </p:cNvPr>
+          <p:cNvSpPr txBox="1"/>
+          <p:nvPr/>
+        </p:nvSpPr>
+        <p:spPr>
+          <a:xfrm>
+            <a:off x="8128367" y="1756315"/>
+            <a:ext cx="2907821" cy="307777"/>
+          </a:xfrm>
+          <a:prstGeom prst="rect">
+            <a:avLst/>
+          </a:prstGeom>
+          <a:noFill/>
+          <a:ln>
+            <a:solidFill>
+              <a:schemeClr val="tx1"/>
+            </a:solidFill>
+          </a:ln>
+        </p:spPr>
+        <p:txBody>
+          <a:bodyPr wrap="square" rtlCol="0">
+            <a:spAutoFit/>
+          </a:bodyPr>
+          <a:lstStyle/>
+          <a:p>
+            <a:r>
+              <a:rPr lang="en-US" sz="1400" dirty="0">
+                <a:latin typeface="Verdana Pro" panose="020B0604030504040204" pitchFamily="34" charset="0"/>
+              </a:rPr>
+              <a:t>AlphaFold structures</a:t>
+            </a:r>
+            <a:endParaRPr lang="en-CA" sz="1400" dirty="0">
+              <a:latin typeface="Verdana Pro" panose="020B0604030504040204" pitchFamily="34" charset="0"/>
+            </a:endParaRPr>
+          </a:p>
+        </p:txBody>
+      </p:sp>
+      <p:cxnSp>
+        <p:nvCxnSpPr>
+          <p:cNvPr id="134" name="Connector: Elbow 133">
+            <a:extLst>
+              <a:ext uri="{FF2B5EF4-FFF2-40B4-BE49-F238E27FC236}">
+                <a16:creationId xmlns:a16="http://schemas.microsoft.com/office/drawing/2014/main" id="{5CDF36C5-0A33-7EBB-9651-44F21ED73DF0}"/>
+              </a:ext>
+            </a:extLst>
+          </p:cNvPr>
+          <p:cNvCxnSpPr>
+            <a:cxnSpLocks/>
+          </p:cNvCxnSpPr>
+          <p:nvPr/>
+        </p:nvCxnSpPr>
+        <p:spPr>
+          <a:xfrm rot="16200000" flipH="1">
+            <a:off x="7888177" y="2393484"/>
+            <a:ext cx="831456" cy="171781"/>
+          </a:xfrm>
+          <a:prstGeom prst="bentConnector3">
+            <a:avLst>
+              <a:gd name="adj1" fmla="val 99800"/>
+            </a:avLst>
+          </a:prstGeom>
+          <a:ln>
+            <a:solidFill>
+              <a:schemeClr val="tx1"/>
+            </a:solidFill>
+            <a:tailEnd type="triangle"/>
+          </a:ln>
+        </p:spPr>
+        <p:style>
+          <a:lnRef idx="2">
+            <a:schemeClr val="accent1"/>
+          </a:lnRef>
+          <a:fillRef idx="0">
+            <a:schemeClr val="accent1"/>
+          </a:fillRef>
+          <a:effectRef idx="1">
+            <a:schemeClr val="accent1"/>
+          </a:effectRef>
+          <a:fontRef idx="minor">
+            <a:schemeClr val="tx1"/>
+          </a:fontRef>
+        </p:style>
+      </p:cxnSp>
+      <p:sp>
+        <p:nvSpPr>
+          <p:cNvPr id="140" name="TextBox 139">
+            <a:extLst>
+              <a:ext uri="{FF2B5EF4-FFF2-40B4-BE49-F238E27FC236}">
+                <a16:creationId xmlns:a16="http://schemas.microsoft.com/office/drawing/2014/main" id="{D382093C-EB4F-E583-7FBB-0B33B71771BD}"/>
+              </a:ext>
+            </a:extLst>
+          </p:cNvPr>
+          <p:cNvSpPr txBox="1"/>
+          <p:nvPr/>
+        </p:nvSpPr>
+        <p:spPr>
+          <a:xfrm>
+            <a:off x="8410341" y="2741214"/>
+            <a:ext cx="2119553" cy="307777"/>
+          </a:xfrm>
+          <a:prstGeom prst="rect">
+            <a:avLst/>
+          </a:prstGeom>
+          <a:noFill/>
+          <a:ln>
+            <a:solidFill>
+              <a:schemeClr val="tx1"/>
+            </a:solidFill>
+          </a:ln>
+        </p:spPr>
+        <p:txBody>
+          <a:bodyPr wrap="square" rtlCol="0">
+            <a:spAutoFit/>
+          </a:bodyPr>
+          <a:lstStyle/>
+          <a:p>
+            <a:r>
+              <a:rPr lang="en-US" sz="1400" dirty="0">
+                <a:latin typeface="Verdana Pro" panose="020B0604030504040204" pitchFamily="34" charset="0"/>
+              </a:rPr>
+              <a:t>TM-align</a:t>
+            </a:r>
+            <a:endParaRPr lang="en-CA" sz="1400" dirty="0">
+              <a:latin typeface="Verdana Pro" panose="020B0604030504040204" pitchFamily="34" charset="0"/>
+            </a:endParaRPr>
+          </a:p>
+        </p:txBody>
+      </p:sp>
+      <p:sp>
+        <p:nvSpPr>
+          <p:cNvPr id="142" name="TextBox 141">
+            <a:extLst>
+              <a:ext uri="{FF2B5EF4-FFF2-40B4-BE49-F238E27FC236}">
+                <a16:creationId xmlns:a16="http://schemas.microsoft.com/office/drawing/2014/main" id="{3DC01794-2DD0-C54A-275F-3E2939A7898F}"/>
+              </a:ext>
+            </a:extLst>
+          </p:cNvPr>
+          <p:cNvSpPr txBox="1"/>
+          <p:nvPr/>
+        </p:nvSpPr>
+        <p:spPr>
+          <a:xfrm>
+            <a:off x="8410341" y="3608571"/>
+            <a:ext cx="2119553" cy="307777"/>
+          </a:xfrm>
+          <a:prstGeom prst="rect">
+            <a:avLst/>
+          </a:prstGeom>
+          <a:noFill/>
+          <a:ln>
+            <a:solidFill>
+              <a:schemeClr val="tx1"/>
+            </a:solidFill>
+          </a:ln>
+        </p:spPr>
+        <p:txBody>
+          <a:bodyPr wrap="square" rtlCol="0">
+            <a:spAutoFit/>
+          </a:bodyPr>
+          <a:lstStyle/>
+          <a:p>
+            <a:r>
+              <a:rPr lang="en-US" sz="1400" dirty="0">
+                <a:latin typeface="Verdana Pro" panose="020B0604030504040204" pitchFamily="34" charset="0"/>
+              </a:rPr>
+              <a:t>PyMOL-super</a:t>
+            </a:r>
+            <a:endParaRPr lang="en-CA" sz="1400" dirty="0">
+              <a:latin typeface="Verdana Pro" panose="020B0604030504040204" pitchFamily="34" charset="0"/>
+            </a:endParaRPr>
+          </a:p>
+        </p:txBody>
+      </p:sp>
+      <p:sp>
+        <p:nvSpPr>
+          <p:cNvPr id="144" name="TextBox 143">
+            <a:extLst>
+              <a:ext uri="{FF2B5EF4-FFF2-40B4-BE49-F238E27FC236}">
+                <a16:creationId xmlns:a16="http://schemas.microsoft.com/office/drawing/2014/main" id="{3D4C6186-6C1A-AF6C-FB54-15FC9B19DBEF}"/>
+              </a:ext>
+            </a:extLst>
+          </p:cNvPr>
+          <p:cNvSpPr txBox="1"/>
+          <p:nvPr/>
+        </p:nvSpPr>
+        <p:spPr>
+          <a:xfrm>
+            <a:off x="8389795" y="4403869"/>
+            <a:ext cx="2343875" cy="307777"/>
+          </a:xfrm>
+          <a:prstGeom prst="rect">
+            <a:avLst/>
+          </a:prstGeom>
+          <a:noFill/>
+          <a:ln>
+            <a:solidFill>
+              <a:schemeClr val="tx1"/>
+            </a:solidFill>
+          </a:ln>
+        </p:spPr>
+        <p:txBody>
+          <a:bodyPr wrap="square" rtlCol="0">
+            <a:spAutoFit/>
+          </a:bodyPr>
+          <a:lstStyle/>
+          <a:p>
+            <a:r>
+              <a:rPr lang="en-US" sz="1400" dirty="0">
+                <a:latin typeface="Verdana Pro" panose="020B0604030504040204" pitchFamily="34" charset="0"/>
+              </a:rPr>
+              <a:t>Domain annotation</a:t>
+            </a:r>
+            <a:endParaRPr lang="en-CA" sz="1400" dirty="0">
+              <a:latin typeface="Verdana Pro" panose="020B0604030504040204" pitchFamily="34" charset="0"/>
+            </a:endParaRPr>
+          </a:p>
+        </p:txBody>
+      </p:sp>
+      <p:cxnSp>
+        <p:nvCxnSpPr>
+          <p:cNvPr id="147" name="Connector: Elbow 146">
+            <a:extLst>
+              <a:ext uri="{FF2B5EF4-FFF2-40B4-BE49-F238E27FC236}">
+                <a16:creationId xmlns:a16="http://schemas.microsoft.com/office/drawing/2014/main" id="{66B4A858-B710-FA40-B1D2-91CE585502AA}"/>
+              </a:ext>
+            </a:extLst>
+          </p:cNvPr>
+          <p:cNvCxnSpPr>
+            <a:cxnSpLocks/>
+          </p:cNvCxnSpPr>
+          <p:nvPr/>
+        </p:nvCxnSpPr>
+        <p:spPr>
+          <a:xfrm rot="16200000" flipH="1">
+            <a:off x="7888176" y="3239885"/>
+            <a:ext cx="831456" cy="171781"/>
+          </a:xfrm>
+          <a:prstGeom prst="bentConnector3">
+            <a:avLst>
+              <a:gd name="adj1" fmla="val 99800"/>
+            </a:avLst>
+          </a:prstGeom>
+          <a:ln>
+            <a:solidFill>
+              <a:schemeClr val="tx1"/>
+            </a:solidFill>
+            <a:tailEnd type="triangle"/>
+          </a:ln>
+        </p:spPr>
+        <p:style>
+          <a:lnRef idx="2">
+            <a:schemeClr val="accent1"/>
+          </a:lnRef>
+          <a:fillRef idx="0">
+            <a:schemeClr val="accent1"/>
+          </a:fillRef>
+          <a:effectRef idx="1">
+            <a:schemeClr val="accent1"/>
+          </a:effectRef>
+          <a:fontRef idx="minor">
+            <a:schemeClr val="tx1"/>
+          </a:fontRef>
+        </p:style>
+      </p:cxnSp>
+      <p:cxnSp>
+        <p:nvCxnSpPr>
+          <p:cNvPr id="148" name="Connector: Elbow 147">
+            <a:extLst>
+              <a:ext uri="{FF2B5EF4-FFF2-40B4-BE49-F238E27FC236}">
+                <a16:creationId xmlns:a16="http://schemas.microsoft.com/office/drawing/2014/main" id="{953BB405-8981-7EC4-17EC-080344492422}"/>
+              </a:ext>
+            </a:extLst>
+          </p:cNvPr>
+          <p:cNvCxnSpPr>
+            <a:cxnSpLocks/>
+          </p:cNvCxnSpPr>
+          <p:nvPr/>
+        </p:nvCxnSpPr>
+        <p:spPr>
+          <a:xfrm rot="16200000" flipH="1">
+            <a:off x="7888176" y="4071693"/>
+            <a:ext cx="831456" cy="171781"/>
+          </a:xfrm>
+          <a:prstGeom prst="bentConnector3">
+            <a:avLst>
+              <a:gd name="adj1" fmla="val 99800"/>
+            </a:avLst>
+          </a:prstGeom>
+          <a:ln>
+            <a:solidFill>
+              <a:schemeClr val="tx1"/>
+            </a:solidFill>
+            <a:tailEnd type="triangle"/>
+          </a:ln>
+        </p:spPr>
+        <p:style>
+          <a:lnRef idx="2">
+            <a:schemeClr val="accent1"/>
+          </a:lnRef>
+          <a:fillRef idx="0">
+            <a:schemeClr val="accent1"/>
+          </a:fillRef>
+          <a:effectRef idx="1">
+            <a:schemeClr val="accent1"/>
+          </a:effectRef>
+          <a:fontRef idx="minor">
+            <a:schemeClr val="tx1"/>
+          </a:fontRef>
+        </p:style>
+      </p:cxnSp>
+      <p:sp>
+        <p:nvSpPr>
+          <p:cNvPr id="150" name="TextBox 149">
+            <a:extLst>
+              <a:ext uri="{FF2B5EF4-FFF2-40B4-BE49-F238E27FC236}">
+                <a16:creationId xmlns:a16="http://schemas.microsoft.com/office/drawing/2014/main" id="{03470975-3E7B-0F53-8AC3-113DA53804D9}"/>
+              </a:ext>
+            </a:extLst>
+          </p:cNvPr>
+          <p:cNvSpPr txBox="1"/>
+          <p:nvPr/>
+        </p:nvSpPr>
+        <p:spPr>
+          <a:xfrm>
+            <a:off x="8389794" y="5250270"/>
+            <a:ext cx="2343875" cy="523220"/>
+          </a:xfrm>
+          <a:prstGeom prst="rect">
+            <a:avLst/>
+          </a:prstGeom>
+          <a:noFill/>
+          <a:ln>
+            <a:solidFill>
+              <a:schemeClr val="tx1"/>
+            </a:solidFill>
+          </a:ln>
+        </p:spPr>
+        <p:txBody>
+          <a:bodyPr wrap="square" rtlCol="0">
+            <a:spAutoFit/>
+          </a:bodyPr>
+          <a:lstStyle/>
+          <a:p>
+            <a:r>
+              <a:rPr lang="en-US" sz="1400" dirty="0">
+                <a:latin typeface="Verdana Pro" panose="020B0604030504040204" pitchFamily="34" charset="0"/>
+              </a:rPr>
+              <a:t>Composite score annotation</a:t>
+            </a:r>
+            <a:endParaRPr lang="en-CA" sz="1400" dirty="0">
+              <a:latin typeface="Verdana Pro" panose="020B0604030504040204" pitchFamily="34" charset="0"/>
+            </a:endParaRPr>
+          </a:p>
+        </p:txBody>
+      </p:sp>
+      <p:cxnSp>
+        <p:nvCxnSpPr>
+          <p:cNvPr id="151" name="Connector: Elbow 150">
+            <a:extLst>
+              <a:ext uri="{FF2B5EF4-FFF2-40B4-BE49-F238E27FC236}">
+                <a16:creationId xmlns:a16="http://schemas.microsoft.com/office/drawing/2014/main" id="{BB1825B2-B940-87C2-5109-25F575E5C771}"/>
+              </a:ext>
+            </a:extLst>
+          </p:cNvPr>
+          <p:cNvCxnSpPr>
+            <a:cxnSpLocks/>
+          </p:cNvCxnSpPr>
+          <p:nvPr/>
+        </p:nvCxnSpPr>
+        <p:spPr>
+          <a:xfrm rot="16200000" flipH="1">
+            <a:off x="7888176" y="4921489"/>
+            <a:ext cx="831456" cy="171781"/>
+          </a:xfrm>
+          <a:prstGeom prst="bentConnector3">
+            <a:avLst>
+              <a:gd name="adj1" fmla="val 99800"/>
+            </a:avLst>
+          </a:prstGeom>
+          <a:ln>
+            <a:solidFill>
+              <a:schemeClr val="tx1"/>
+            </a:solidFill>
+            <a:tailEnd type="triangle"/>
+          </a:ln>
+        </p:spPr>
+        <p:style>
+          <a:lnRef idx="2">
+            <a:schemeClr val="accent1"/>
+          </a:lnRef>
+          <a:fillRef idx="0">
+            <a:schemeClr val="accent1"/>
+          </a:fillRef>
+          <a:effectRef idx="1">
+            <a:schemeClr val="accent1"/>
+          </a:effectRef>
+          <a:fontRef idx="minor">
+            <a:schemeClr val="tx1"/>
+          </a:fontRef>
+        </p:style>
+      </p:cxnSp>
+      <p:grpSp>
+        <p:nvGrpSpPr>
+          <p:cNvPr id="159" name="Group 158">
+            <a:extLst>
+              <a:ext uri="{FF2B5EF4-FFF2-40B4-BE49-F238E27FC236}">
+                <a16:creationId xmlns:a16="http://schemas.microsoft.com/office/drawing/2014/main" id="{C0D4A427-7132-F54C-A374-309D4E705073}"/>
+              </a:ext>
+            </a:extLst>
+          </p:cNvPr>
+          <p:cNvGrpSpPr/>
+          <p:nvPr/>
+        </p:nvGrpSpPr>
+        <p:grpSpPr>
+          <a:xfrm>
+            <a:off x="10790885" y="2741214"/>
+            <a:ext cx="1393447" cy="3092898"/>
+            <a:chOff x="10790885" y="2741214"/>
+            <a:chExt cx="1393447" cy="3092898"/>
+          </a:xfrm>
+        </p:grpSpPr>
+        <p:sp>
+          <p:nvSpPr>
+            <p:cNvPr id="158" name="Rectangle 157">
+              <a:extLst>
+                <a:ext uri="{FF2B5EF4-FFF2-40B4-BE49-F238E27FC236}">
+                  <a16:creationId xmlns:a16="http://schemas.microsoft.com/office/drawing/2014/main" id="{0349F890-E835-A504-B1F6-1DA6E0B9702C}"/>
+                </a:ext>
+              </a:extLst>
+            </p:cNvPr>
+            <p:cNvSpPr/>
+            <p:nvPr/>
+          </p:nvSpPr>
+          <p:spPr>
+            <a:xfrm>
+              <a:off x="10790885" y="4021098"/>
+              <a:ext cx="1393447" cy="771881"/>
+            </a:xfrm>
+            <a:prstGeom prst="rect">
+              <a:avLst/>
+            </a:prstGeom>
+            <a:solidFill>
+              <a:srgbClr val="F8F9FA"/>
+            </a:solidFill>
+            <a:ln>
+              <a:noFill/>
+            </a:ln>
+          </p:spPr>
+          <p:style>
+            <a:lnRef idx="2">
+              <a:schemeClr val="accent1">
+                <a:shade val="15000"/>
+              </a:schemeClr>
+            </a:lnRef>
+            <a:fillRef idx="1">
+              <a:schemeClr val="accent1"/>
+            </a:fillRef>
+            <a:effectRef idx="0">
+              <a:schemeClr val="accent1"/>
+            </a:effectRef>
+            <a:fontRef idx="minor">
+              <a:schemeClr val="lt1"/>
+            </a:fontRef>
+          </p:style>
+          <p:txBody>
+            <a:bodyPr rtlCol="0" anchor="ctr"/>
+            <a:lstStyle/>
+            <a:p>
+              <a:pPr algn="ctr"/>
+              <a:endParaRPr lang="en-CA"/>
+            </a:p>
+          </p:txBody>
+        </p:sp>
+        <p:pic>
+          <p:nvPicPr>
+            <p:cNvPr id="155" name="Picture 154">
+              <a:extLst>
+                <a:ext uri="{FF2B5EF4-FFF2-40B4-BE49-F238E27FC236}">
+                  <a16:creationId xmlns:a16="http://schemas.microsoft.com/office/drawing/2014/main" id="{75AF42F9-C387-1720-F708-36EA48A1E60C}"/>
+                </a:ext>
+              </a:extLst>
+            </p:cNvPr>
+            <p:cNvPicPr>
+              <a:picLocks noChangeAspect="1"/>
+            </p:cNvPicPr>
+            <p:nvPr/>
+          </p:nvPicPr>
+          <p:blipFill>
+            <a:blip r:embed="rId2"/>
+            <a:srcRect t="3049" r="16301"/>
+            <a:stretch>
+              <a:fillRect/>
+            </a:stretch>
+          </p:blipFill>
+          <p:spPr>
+            <a:xfrm>
+              <a:off x="10790885" y="4418800"/>
+              <a:ext cx="1375890" cy="1415312"/>
+            </a:xfrm>
+            <a:prstGeom prst="rect">
+              <a:avLst/>
+            </a:prstGeom>
+          </p:spPr>
+        </p:pic>
+        <p:pic>
+          <p:nvPicPr>
+            <p:cNvPr id="157" name="Picture 156">
+              <a:extLst>
+                <a:ext uri="{FF2B5EF4-FFF2-40B4-BE49-F238E27FC236}">
+                  <a16:creationId xmlns:a16="http://schemas.microsoft.com/office/drawing/2014/main" id="{07792FB4-7BCC-06BF-8439-CCB868A85289}"/>
+                </a:ext>
+              </a:extLst>
+            </p:cNvPr>
+            <p:cNvPicPr>
+              <a:picLocks noChangeAspect="1"/>
+            </p:cNvPicPr>
+            <p:nvPr/>
+          </p:nvPicPr>
+          <p:blipFill>
+            <a:blip r:embed="rId3"/>
+            <a:srcRect t="2384" r="16178"/>
+            <a:stretch>
+              <a:fillRect/>
+            </a:stretch>
+          </p:blipFill>
+          <p:spPr>
+            <a:xfrm>
+              <a:off x="10790885" y="2741214"/>
+              <a:ext cx="1375890" cy="1402636"/>
+            </a:xfrm>
+            <a:prstGeom prst="rect">
+              <a:avLst/>
+            </a:prstGeom>
+          </p:spPr>
+        </p:pic>
+      </p:grpSp>
+      <p:sp>
+        <p:nvSpPr>
+          <p:cNvPr id="160" name="TextBox 159">
+            <a:extLst>
+              <a:ext uri="{FF2B5EF4-FFF2-40B4-BE49-F238E27FC236}">
+                <a16:creationId xmlns:a16="http://schemas.microsoft.com/office/drawing/2014/main" id="{4587CE1A-B379-7828-EA4E-5BFC7C108186}"/>
+              </a:ext>
+            </a:extLst>
+          </p:cNvPr>
+          <p:cNvSpPr txBox="1"/>
+          <p:nvPr/>
+        </p:nvSpPr>
+        <p:spPr>
+          <a:xfrm>
+            <a:off x="11487608" y="5486940"/>
+            <a:ext cx="914400" cy="369332"/>
+          </a:xfrm>
+          <a:prstGeom prst="rect">
+            <a:avLst/>
+          </a:prstGeom>
+          <a:noFill/>
+        </p:spPr>
+        <p:txBody>
+          <a:bodyPr wrap="square" rtlCol="0">
+            <a:spAutoFit/>
+          </a:bodyPr>
+          <a:lstStyle/>
+          <a:p>
+            <a:r>
+              <a:rPr lang="en-US" dirty="0">
+                <a:latin typeface="Verdana Pro" panose="020B0604030504040204" pitchFamily="34" charset="0"/>
+              </a:rPr>
+              <a:t>0.92</a:t>
+            </a:r>
+            <a:endParaRPr lang="en-CA" dirty="0">
+              <a:latin typeface="Verdana Pro" panose="020B0604030504040204" pitchFamily="34" charset="0"/>
+            </a:endParaRPr>
+          </a:p>
+        </p:txBody>
+      </p:sp>
+    </p:spTree>
+    <p:extLst>
+      <p:ext uri="{BB962C8B-B14F-4D97-AF65-F5344CB8AC3E}">
+        <p14:creationId xmlns:p14="http://schemas.microsoft.com/office/powerpoint/2010/main" val="523328065"/>
+      </p:ext>
+    </p:extLst>
+  </p:cSld>
+  <p:clrMapOvr>
+    <a:masterClrMapping/>
+  </p:clrMapOvr>
+</p:sld>
+</file>
+
+<file path=ppt/slides/slide11.xml><?xml version="1.0" encoding="utf-8"?>
+<p:sld xmlns:a="http://schemas.openxmlformats.org/drawingml/2006/main" xmlns:r="http://schemas.openxmlformats.org/officeDocument/2006/relationships" xmlns:p="http://schemas.openxmlformats.org/presentationml/2006/main">
+  <p:cSld>
     <p:bg>
       <p:bgPr>
         <a:solidFill>
@@ -5029,7 +8212,7 @@
 </p:sld>
 </file>
 
-<file path=ppt/slides/slide11.xml><?xml version="1.0" encoding="utf-8"?>
+<file path=ppt/slides/slide12.xml><?xml version="1.0" encoding="utf-8"?>
 <p:sld xmlns:a="http://schemas.openxmlformats.org/drawingml/2006/main" xmlns:r="http://schemas.openxmlformats.org/officeDocument/2006/relationships" xmlns:p="http://schemas.openxmlformats.org/presentationml/2006/main">
   <p:cSld>
     <p:spTree>

</xml_diff>

<commit_message>
Added slide about top structural homology hits.
</commit_message>
<xml_diff>
--- a/reports/2026-08-28_projectUpdate_3/2026-08-28_projectUpdate_3_jmoran.pptx
+++ b/reports/2026-08-28_projectUpdate_3/2026-08-28_projectUpdate_3_jmoran.pptx
@@ -5,7 +5,7 @@
     <p:sldMasterId id="2147483648" r:id="rId1"/>
   </p:sldMasterIdLst>
   <p:notesMasterIdLst>
-    <p:notesMasterId r:id="rId14"/>
+    <p:notesMasterId r:id="rId18"/>
   </p:notesMasterIdLst>
   <p:sldIdLst>
     <p:sldId id="256" r:id="rId2"/>
@@ -20,6 +20,10 @@
     <p:sldId id="292" r:id="rId11"/>
     <p:sldId id="289" r:id="rId12"/>
     <p:sldId id="290" r:id="rId13"/>
+    <p:sldId id="293" r:id="rId14"/>
+    <p:sldId id="294" r:id="rId15"/>
+    <p:sldId id="295" r:id="rId16"/>
+    <p:sldId id="296" r:id="rId17"/>
   </p:sldIdLst>
   <p:sldSz cx="12192000" cy="6858000"/>
   <p:notesSz cx="6858000" cy="9144000"/>
@@ -7486,50 +7490,6 @@
           </a:p>
         </p:txBody>
       </p:sp>
-      <p:cxnSp>
-        <p:nvCxnSpPr>
-          <p:cNvPr id="131" name="Connector: Elbow 130">
-            <a:extLst>
-              <a:ext uri="{FF2B5EF4-FFF2-40B4-BE49-F238E27FC236}">
-                <a16:creationId xmlns:a16="http://schemas.microsoft.com/office/drawing/2014/main" id="{D8D45798-7DF9-C8FC-6DB2-C7230BA5880D}"/>
-              </a:ext>
-            </a:extLst>
-          </p:cNvPr>
-          <p:cNvCxnSpPr>
-            <a:cxnSpLocks/>
-          </p:cNvCxnSpPr>
-          <p:nvPr/>
-        </p:nvCxnSpPr>
-        <p:spPr>
-          <a:xfrm flipV="1">
-            <a:off x="7135430" y="1909758"/>
-            <a:ext cx="989368" cy="1"/>
-          </a:xfrm>
-          <a:prstGeom prst="bentConnector3">
-            <a:avLst/>
-          </a:prstGeom>
-          <a:ln>
-            <a:solidFill>
-              <a:schemeClr val="tx1"/>
-            </a:solidFill>
-            <a:tailEnd type="triangle"/>
-          </a:ln>
-        </p:spPr>
-        <p:style>
-          <a:lnRef idx="2">
-            <a:schemeClr val="accent1"/>
-          </a:lnRef>
-          <a:fillRef idx="0">
-            <a:schemeClr val="accent1"/>
-          </a:fillRef>
-          <a:effectRef idx="1">
-            <a:schemeClr val="accent1"/>
-          </a:effectRef>
-          <a:fontRef idx="minor">
-            <a:schemeClr val="tx1"/>
-          </a:fontRef>
-        </p:style>
-      </p:cxnSp>
       <p:sp>
         <p:nvSpPr>
           <p:cNvPr id="133" name="TextBox 132">
@@ -7544,7 +7504,7 @@
         </p:nvSpPr>
         <p:spPr>
           <a:xfrm>
-            <a:off x="8128367" y="1756315"/>
+            <a:off x="7446884" y="1756315"/>
             <a:ext cx="2907821" cy="307777"/>
           </a:xfrm>
           <a:prstGeom prst="rect">
@@ -7591,7 +7551,7 @@
         </p:nvCxnSpPr>
         <p:spPr>
           <a:xfrm rot="16200000" flipH="1">
-            <a:off x="7888177" y="2393484"/>
+            <a:off x="7206694" y="2393484"/>
             <a:ext cx="831456" cy="171781"/>
           </a:xfrm>
           <a:prstGeom prst="bentConnector3">
@@ -7635,7 +7595,7 @@
         </p:nvSpPr>
         <p:spPr>
           <a:xfrm>
-            <a:off x="8410341" y="2741214"/>
+            <a:off x="7728858" y="2741214"/>
             <a:ext cx="2119553" cy="307777"/>
           </a:xfrm>
           <a:prstGeom prst="rect">
@@ -7680,7 +7640,7 @@
         </p:nvSpPr>
         <p:spPr>
           <a:xfrm>
-            <a:off x="8410341" y="3608571"/>
+            <a:off x="7728858" y="3608571"/>
             <a:ext cx="2119553" cy="307777"/>
           </a:xfrm>
           <a:prstGeom prst="rect">
@@ -7725,7 +7685,7 @@
         </p:nvSpPr>
         <p:spPr>
           <a:xfrm>
-            <a:off x="8389795" y="4403869"/>
+            <a:off x="7708312" y="4403869"/>
             <a:ext cx="2343875" cy="307777"/>
           </a:xfrm>
           <a:prstGeom prst="rect">
@@ -7772,7 +7732,7 @@
         </p:nvCxnSpPr>
         <p:spPr>
           <a:xfrm rot="16200000" flipH="1">
-            <a:off x="7888176" y="3239885"/>
+            <a:off x="7206693" y="3239885"/>
             <a:ext cx="831456" cy="171781"/>
           </a:xfrm>
           <a:prstGeom prst="bentConnector3">
@@ -7818,7 +7778,7 @@
         </p:nvCxnSpPr>
         <p:spPr>
           <a:xfrm rot="16200000" flipH="1">
-            <a:off x="7888176" y="4071693"/>
+            <a:off x="7206693" y="4071693"/>
             <a:ext cx="831456" cy="171781"/>
           </a:xfrm>
           <a:prstGeom prst="bentConnector3">
@@ -7862,7 +7822,7 @@
         </p:nvSpPr>
         <p:spPr>
           <a:xfrm>
-            <a:off x="8389794" y="5250270"/>
+            <a:off x="7708311" y="5250270"/>
             <a:ext cx="2343875" cy="523220"/>
           </a:xfrm>
           <a:prstGeom prst="rect">
@@ -7909,7 +7869,7 @@
         </p:nvCxnSpPr>
         <p:spPr>
           <a:xfrm rot="16200000" flipH="1">
-            <a:off x="7888176" y="4921489"/>
+            <a:off x="7206693" y="4921489"/>
             <a:ext cx="831456" cy="171781"/>
           </a:xfrm>
           <a:prstGeom prst="bentConnector3">
@@ -7953,10 +7913,10 @@
         </p:nvGrpSpPr>
         <p:grpSpPr>
           <a:xfrm>
-            <a:off x="10790885" y="2741214"/>
-            <a:ext cx="1393447" cy="3092898"/>
+            <a:off x="10308296" y="2741214"/>
+            <a:ext cx="1375891" cy="3092898"/>
             <a:chOff x="10790885" y="2741214"/>
-            <a:chExt cx="1393447" cy="3092898"/>
+            <a:chExt cx="1375891" cy="3092898"/>
           </a:xfrm>
         </p:grpSpPr>
         <p:sp>
@@ -7973,8 +7933,8 @@
           </p:nvSpPr>
           <p:spPr>
             <a:xfrm>
-              <a:off x="10790885" y="4021098"/>
-              <a:ext cx="1393447" cy="771881"/>
+              <a:off x="10790886" y="4021098"/>
+              <a:ext cx="1375890" cy="771881"/>
             </a:xfrm>
             <a:prstGeom prst="rect">
               <a:avLst/>
@@ -8088,7 +8048,7 @@
         </p:nvSpPr>
         <p:spPr>
           <a:xfrm>
-            <a:off x="11487608" y="5486940"/>
+            <a:off x="11005019" y="5486940"/>
             <a:ext cx="914400" cy="369332"/>
           </a:xfrm>
           <a:prstGeom prst="rect">
@@ -8114,6 +8074,51 @@
           </a:p>
         </p:txBody>
       </p:sp>
+      <p:cxnSp>
+        <p:nvCxnSpPr>
+          <p:cNvPr id="164" name="Straight Arrow Connector 163">
+            <a:extLst>
+              <a:ext uri="{FF2B5EF4-FFF2-40B4-BE49-F238E27FC236}">
+                <a16:creationId xmlns:a16="http://schemas.microsoft.com/office/drawing/2014/main" id="{3CC0A439-DE2B-E5A3-6BDC-937CA42DCC63}"/>
+              </a:ext>
+            </a:extLst>
+          </p:cNvPr>
+          <p:cNvCxnSpPr>
+            <a:cxnSpLocks/>
+            <a:stCxn id="107" idx="3"/>
+          </p:cNvCxnSpPr>
+          <p:nvPr/>
+        </p:nvCxnSpPr>
+        <p:spPr>
+          <a:xfrm>
+            <a:off x="7135430" y="1909759"/>
+            <a:ext cx="313120" cy="0"/>
+          </a:xfrm>
+          <a:prstGeom prst="straightConnector1">
+            <a:avLst/>
+          </a:prstGeom>
+          <a:ln>
+            <a:solidFill>
+              <a:schemeClr val="tx1"/>
+            </a:solidFill>
+            <a:tailEnd type="triangle"/>
+          </a:ln>
+        </p:spPr>
+        <p:style>
+          <a:lnRef idx="2">
+            <a:schemeClr val="accent1"/>
+          </a:lnRef>
+          <a:fillRef idx="0">
+            <a:schemeClr val="accent1"/>
+          </a:fillRef>
+          <a:effectRef idx="1">
+            <a:schemeClr val="accent1"/>
+          </a:effectRef>
+          <a:fontRef idx="minor">
+            <a:schemeClr val="tx1"/>
+          </a:fontRef>
+        </p:style>
+      </p:cxnSp>
     </p:spTree>
     <p:extLst>
       <p:ext uri="{BB962C8B-B14F-4D97-AF65-F5344CB8AC3E}">
@@ -8215,6 +8220,14 @@
 <file path=ppt/slides/slide12.xml><?xml version="1.0" encoding="utf-8"?>
 <p:sld xmlns:a="http://schemas.openxmlformats.org/drawingml/2006/main" xmlns:r="http://schemas.openxmlformats.org/officeDocument/2006/relationships" xmlns:p="http://schemas.openxmlformats.org/presentationml/2006/main">
   <p:cSld>
+    <p:bg>
+      <p:bgPr>
+        <a:solidFill>
+          <a:srgbClr val="181A1B"/>
+        </a:solidFill>
+        <a:effectLst/>
+      </p:bgPr>
+    </p:bg>
     <p:spTree>
       <p:nvGrpSpPr>
         <p:cNvPr id="1" name=""/>
@@ -8229,10 +8242,1256 @@
           <a:chExt cx="0" cy="0"/>
         </a:xfrm>
       </p:grpSpPr>
+      <p:grpSp>
+        <p:nvGrpSpPr>
+          <p:cNvPr id="20" name="Group 19">
+            <a:extLst>
+              <a:ext uri="{FF2B5EF4-FFF2-40B4-BE49-F238E27FC236}">
+                <a16:creationId xmlns:a16="http://schemas.microsoft.com/office/drawing/2014/main" id="{EB91504B-73D4-8C2E-E7C0-99702B7967BB}"/>
+              </a:ext>
+            </a:extLst>
+          </p:cNvPr>
+          <p:cNvGrpSpPr/>
+          <p:nvPr/>
+        </p:nvGrpSpPr>
+        <p:grpSpPr>
+          <a:xfrm>
+            <a:off x="0" y="1138494"/>
+            <a:ext cx="12192000" cy="5363909"/>
+            <a:chOff x="0" y="856370"/>
+            <a:chExt cx="12192000" cy="5363909"/>
+          </a:xfrm>
+        </p:grpSpPr>
+        <p:pic>
+          <p:nvPicPr>
+            <p:cNvPr id="8" name="Picture 7">
+              <a:extLst>
+                <a:ext uri="{FF2B5EF4-FFF2-40B4-BE49-F238E27FC236}">
+                  <a16:creationId xmlns:a16="http://schemas.microsoft.com/office/drawing/2014/main" id="{0D369E40-9A3E-85BA-F618-50EEA50F28B7}"/>
+                </a:ext>
+              </a:extLst>
+            </p:cNvPr>
+            <p:cNvPicPr>
+              <a:picLocks noChangeAspect="1"/>
+            </p:cNvPicPr>
+            <p:nvPr/>
+          </p:nvPicPr>
+          <p:blipFill>
+            <a:blip r:embed="rId2">
+              <a:extLst>
+                <a:ext uri="{28A0092B-C50C-407E-A947-70E740481C1C}">
+                  <a14:useLocalDpi xmlns:a14="http://schemas.microsoft.com/office/drawing/2010/main" val="0"/>
+                </a:ext>
+              </a:extLst>
+            </a:blip>
+            <a:srcRect t="32058" b="6383"/>
+            <a:stretch>
+              <a:fillRect/>
+            </a:stretch>
+          </p:blipFill>
+          <p:spPr>
+            <a:xfrm>
+              <a:off x="0" y="2280870"/>
+              <a:ext cx="12192000" cy="3939409"/>
+            </a:xfrm>
+            <a:prstGeom prst="rect">
+              <a:avLst/>
+            </a:prstGeom>
+          </p:spPr>
+        </p:pic>
+        <p:sp>
+          <p:nvSpPr>
+            <p:cNvPr id="9" name="TextBox 8">
+              <a:extLst>
+                <a:ext uri="{FF2B5EF4-FFF2-40B4-BE49-F238E27FC236}">
+                  <a16:creationId xmlns:a16="http://schemas.microsoft.com/office/drawing/2014/main" id="{21568F1C-E6F7-1875-942D-B6D95C345E87}"/>
+                </a:ext>
+              </a:extLst>
+            </p:cNvPr>
+            <p:cNvSpPr txBox="1"/>
+            <p:nvPr/>
+          </p:nvSpPr>
+          <p:spPr>
+            <a:xfrm>
+              <a:off x="138107" y="856370"/>
+              <a:ext cx="3128968" cy="923330"/>
+            </a:xfrm>
+            <a:prstGeom prst="rect">
+              <a:avLst/>
+            </a:prstGeom>
+            <a:noFill/>
+          </p:spPr>
+          <p:txBody>
+            <a:bodyPr wrap="square" rtlCol="0">
+              <a:spAutoFit/>
+            </a:bodyPr>
+            <a:lstStyle/>
+            <a:p>
+              <a:r>
+                <a:rPr lang="en-US" dirty="0">
+                  <a:solidFill>
+                    <a:schemeClr val="bg1"/>
+                  </a:solidFill>
+                  <a:latin typeface="Verdana Pro" panose="020B0604030504040204" pitchFamily="34" charset="0"/>
+                </a:rPr>
+                <a:t>Q6ICS7</a:t>
+              </a:r>
+            </a:p>
+            <a:p>
+              <a:r>
+                <a:rPr lang="en-US" dirty="0">
+                  <a:solidFill>
+                    <a:schemeClr val="bg1"/>
+                  </a:solidFill>
+                  <a:latin typeface="Verdana Pro" panose="020B0604030504040204" pitchFamily="34" charset="0"/>
+                </a:rPr>
+                <a:t>DNMT2</a:t>
+              </a:r>
+            </a:p>
+            <a:p>
+              <a:r>
+                <a:rPr lang="en-US" dirty="0">
+                  <a:solidFill>
+                    <a:schemeClr val="bg1"/>
+                  </a:solidFill>
+                  <a:latin typeface="Verdana Pro" panose="020B0604030504040204" pitchFamily="34" charset="0"/>
+                </a:rPr>
+                <a:t>tRNA methyltransferase</a:t>
+              </a:r>
+              <a:endParaRPr lang="en-CA" dirty="0">
+                <a:solidFill>
+                  <a:schemeClr val="bg1"/>
+                </a:solidFill>
+                <a:latin typeface="Verdana Pro" panose="020B0604030504040204" pitchFamily="34" charset="0"/>
+              </a:endParaRPr>
+            </a:p>
+          </p:txBody>
+        </p:sp>
+        <p:sp>
+          <p:nvSpPr>
+            <p:cNvPr id="11" name="TextBox 10">
+              <a:extLst>
+                <a:ext uri="{FF2B5EF4-FFF2-40B4-BE49-F238E27FC236}">
+                  <a16:creationId xmlns:a16="http://schemas.microsoft.com/office/drawing/2014/main" id="{9124AEA8-3D9A-9ECB-645C-4CA60CF2C66D}"/>
+                </a:ext>
+              </a:extLst>
+            </p:cNvPr>
+            <p:cNvSpPr txBox="1"/>
+            <p:nvPr/>
+          </p:nvSpPr>
+          <p:spPr>
+            <a:xfrm>
+              <a:off x="8782054" y="856370"/>
+              <a:ext cx="2876551" cy="923330"/>
+            </a:xfrm>
+            <a:prstGeom prst="rect">
+              <a:avLst/>
+            </a:prstGeom>
+            <a:noFill/>
+          </p:spPr>
+          <p:txBody>
+            <a:bodyPr wrap="square" rtlCol="0">
+              <a:spAutoFit/>
+            </a:bodyPr>
+            <a:lstStyle/>
+            <a:p>
+              <a:r>
+                <a:rPr lang="en-US" dirty="0">
+                  <a:solidFill>
+                    <a:schemeClr val="bg1"/>
+                  </a:solidFill>
+                  <a:latin typeface="Verdana Pro" panose="020B0604030504040204" pitchFamily="34" charset="0"/>
+                </a:rPr>
+                <a:t>E4ZAF3</a:t>
+              </a:r>
+            </a:p>
+            <a:p>
+              <a:r>
+                <a:rPr lang="en-US" dirty="0">
+                  <a:solidFill>
+                    <a:schemeClr val="bg1"/>
+                  </a:solidFill>
+                  <a:latin typeface="Verdana Pro" panose="020B0604030504040204" pitchFamily="34" charset="0"/>
+                </a:rPr>
+                <a:t>RM Type II system</a:t>
+              </a:r>
+            </a:p>
+            <a:p>
+              <a:r>
+                <a:rPr lang="en-US" dirty="0">
+                  <a:solidFill>
+                    <a:schemeClr val="bg1"/>
+                  </a:solidFill>
+                  <a:latin typeface="Verdana Pro" panose="020B0604030504040204" pitchFamily="34" charset="0"/>
+                </a:rPr>
+                <a:t>C5 methyltransferase</a:t>
+              </a:r>
+              <a:endParaRPr lang="en-CA" dirty="0">
+                <a:solidFill>
+                  <a:schemeClr val="bg1"/>
+                </a:solidFill>
+                <a:latin typeface="Verdana Pro" panose="020B0604030504040204" pitchFamily="34" charset="0"/>
+              </a:endParaRPr>
+            </a:p>
+          </p:txBody>
+        </p:sp>
+        <p:sp>
+          <p:nvSpPr>
+            <p:cNvPr id="13" name="TextBox 12">
+              <a:extLst>
+                <a:ext uri="{FF2B5EF4-FFF2-40B4-BE49-F238E27FC236}">
+                  <a16:creationId xmlns:a16="http://schemas.microsoft.com/office/drawing/2014/main" id="{9A933D43-15CB-AE0A-C577-17D3FE9E46D1}"/>
+                </a:ext>
+              </a:extLst>
+            </p:cNvPr>
+            <p:cNvSpPr txBox="1"/>
+            <p:nvPr/>
+          </p:nvSpPr>
+          <p:spPr>
+            <a:xfrm>
+              <a:off x="3405181" y="905227"/>
+              <a:ext cx="4581526" cy="923330"/>
+            </a:xfrm>
+            <a:prstGeom prst="rect">
+              <a:avLst/>
+            </a:prstGeom>
+            <a:noFill/>
+          </p:spPr>
+          <p:txBody>
+            <a:bodyPr wrap="square" rtlCol="0">
+              <a:spAutoFit/>
+            </a:bodyPr>
+            <a:lstStyle/>
+            <a:p>
+              <a:r>
+                <a:rPr lang="en-US" dirty="0">
+                  <a:solidFill>
+                    <a:schemeClr val="bg1"/>
+                  </a:solidFill>
+                  <a:latin typeface="Verdana Pro" panose="020B0604030504040204" pitchFamily="34" charset="0"/>
+                </a:rPr>
+                <a:t>Composite score: 0.95</a:t>
+              </a:r>
+            </a:p>
+            <a:p>
+              <a:r>
+                <a:rPr lang="en-US" dirty="0">
+                  <a:solidFill>
+                    <a:schemeClr val="bg1"/>
+                  </a:solidFill>
+                  <a:latin typeface="Verdana Pro" panose="020B0604030504040204" pitchFamily="34" charset="0"/>
+                </a:rPr>
+                <a:t>FoldSeek e-value: 6.31e-25</a:t>
+              </a:r>
+            </a:p>
+            <a:p>
+              <a:r>
+                <a:rPr lang="en-US" dirty="0">
+                  <a:solidFill>
+                    <a:schemeClr val="bg1"/>
+                  </a:solidFill>
+                  <a:latin typeface="Verdana Pro" panose="020B0604030504040204" pitchFamily="34" charset="0"/>
+                </a:rPr>
+                <a:t>PyMOL RMSD: 1.23 Å</a:t>
+              </a:r>
+              <a:endParaRPr lang="en-CA" dirty="0">
+                <a:solidFill>
+                  <a:schemeClr val="bg1"/>
+                </a:solidFill>
+                <a:latin typeface="Verdana Pro" panose="020B0604030504040204" pitchFamily="34" charset="0"/>
+              </a:endParaRPr>
+            </a:p>
+          </p:txBody>
+        </p:sp>
+      </p:grpSp>
+      <p:sp>
+        <p:nvSpPr>
+          <p:cNvPr id="15" name="Rectangle: Rounded Corners 14">
+            <a:extLst>
+              <a:ext uri="{FF2B5EF4-FFF2-40B4-BE49-F238E27FC236}">
+                <a16:creationId xmlns:a16="http://schemas.microsoft.com/office/drawing/2014/main" id="{50C71EB9-CEA7-A481-F77A-1C4EBD1ACA3A}"/>
+              </a:ext>
+            </a:extLst>
+          </p:cNvPr>
+          <p:cNvSpPr/>
+          <p:nvPr/>
+        </p:nvSpPr>
+        <p:spPr>
+          <a:xfrm>
+            <a:off x="315257" y="8582"/>
+            <a:ext cx="9363581" cy="628742"/>
+          </a:xfrm>
+          <a:prstGeom prst="roundRect">
+            <a:avLst/>
+          </a:prstGeom>
+          <a:solidFill>
+            <a:srgbClr val="0162B3"/>
+          </a:solidFill>
+          <a:ln>
+            <a:solidFill>
+              <a:srgbClr val="0162B3"/>
+            </a:solidFill>
+          </a:ln>
+        </p:spPr>
+        <p:style>
+          <a:lnRef idx="2">
+            <a:schemeClr val="accent1">
+              <a:shade val="50000"/>
+            </a:schemeClr>
+          </a:lnRef>
+          <a:fillRef idx="1">
+            <a:schemeClr val="accent1"/>
+          </a:fillRef>
+          <a:effectRef idx="0">
+            <a:schemeClr val="accent1"/>
+          </a:effectRef>
+          <a:fontRef idx="minor">
+            <a:schemeClr val="lt1"/>
+          </a:fontRef>
+        </p:style>
+        <p:txBody>
+          <a:bodyPr rtlCol="0" anchor="ctr"/>
+          <a:lstStyle>
+            <a:defPPr>
+              <a:defRPr lang="en-US"/>
+            </a:defPPr>
+            <a:lvl1pPr marL="0" algn="l" defTabSz="914400" rtl="0" eaLnBrk="1" latinLnBrk="0" hangingPunct="1">
+              <a:defRPr sz="1800" kern="1200">
+                <a:solidFill>
+                  <a:schemeClr val="lt1"/>
+                </a:solidFill>
+                <a:latin typeface="+mn-lt"/>
+                <a:ea typeface="+mn-ea"/>
+                <a:cs typeface="+mn-cs"/>
+              </a:defRPr>
+            </a:lvl1pPr>
+            <a:lvl2pPr marL="457200" algn="l" defTabSz="914400" rtl="0" eaLnBrk="1" latinLnBrk="0" hangingPunct="1">
+              <a:defRPr sz="1800" kern="1200">
+                <a:solidFill>
+                  <a:schemeClr val="lt1"/>
+                </a:solidFill>
+                <a:latin typeface="+mn-lt"/>
+                <a:ea typeface="+mn-ea"/>
+                <a:cs typeface="+mn-cs"/>
+              </a:defRPr>
+            </a:lvl2pPr>
+            <a:lvl3pPr marL="914400" algn="l" defTabSz="914400" rtl="0" eaLnBrk="1" latinLnBrk="0" hangingPunct="1">
+              <a:defRPr sz="1800" kern="1200">
+                <a:solidFill>
+                  <a:schemeClr val="lt1"/>
+                </a:solidFill>
+                <a:latin typeface="+mn-lt"/>
+                <a:ea typeface="+mn-ea"/>
+                <a:cs typeface="+mn-cs"/>
+              </a:defRPr>
+            </a:lvl3pPr>
+            <a:lvl4pPr marL="1371600" algn="l" defTabSz="914400" rtl="0" eaLnBrk="1" latinLnBrk="0" hangingPunct="1">
+              <a:defRPr sz="1800" kern="1200">
+                <a:solidFill>
+                  <a:schemeClr val="lt1"/>
+                </a:solidFill>
+                <a:latin typeface="+mn-lt"/>
+                <a:ea typeface="+mn-ea"/>
+                <a:cs typeface="+mn-cs"/>
+              </a:defRPr>
+            </a:lvl4pPr>
+            <a:lvl5pPr marL="1828800" algn="l" defTabSz="914400" rtl="0" eaLnBrk="1" latinLnBrk="0" hangingPunct="1">
+              <a:defRPr sz="1800" kern="1200">
+                <a:solidFill>
+                  <a:schemeClr val="lt1"/>
+                </a:solidFill>
+                <a:latin typeface="+mn-lt"/>
+                <a:ea typeface="+mn-ea"/>
+                <a:cs typeface="+mn-cs"/>
+              </a:defRPr>
+            </a:lvl5pPr>
+            <a:lvl6pPr marL="2286000" algn="l" defTabSz="914400" rtl="0" eaLnBrk="1" latinLnBrk="0" hangingPunct="1">
+              <a:defRPr sz="1800" kern="1200">
+                <a:solidFill>
+                  <a:schemeClr val="lt1"/>
+                </a:solidFill>
+                <a:latin typeface="+mn-lt"/>
+                <a:ea typeface="+mn-ea"/>
+                <a:cs typeface="+mn-cs"/>
+              </a:defRPr>
+            </a:lvl6pPr>
+            <a:lvl7pPr marL="2743200" algn="l" defTabSz="914400" rtl="0" eaLnBrk="1" latinLnBrk="0" hangingPunct="1">
+              <a:defRPr sz="1800" kern="1200">
+                <a:solidFill>
+                  <a:schemeClr val="lt1"/>
+                </a:solidFill>
+                <a:latin typeface="+mn-lt"/>
+                <a:ea typeface="+mn-ea"/>
+                <a:cs typeface="+mn-cs"/>
+              </a:defRPr>
+            </a:lvl7pPr>
+            <a:lvl8pPr marL="3200400" algn="l" defTabSz="914400" rtl="0" eaLnBrk="1" latinLnBrk="0" hangingPunct="1">
+              <a:defRPr sz="1800" kern="1200">
+                <a:solidFill>
+                  <a:schemeClr val="lt1"/>
+                </a:solidFill>
+                <a:latin typeface="+mn-lt"/>
+                <a:ea typeface="+mn-ea"/>
+                <a:cs typeface="+mn-cs"/>
+              </a:defRPr>
+            </a:lvl8pPr>
+            <a:lvl9pPr marL="3657600" algn="l" defTabSz="914400" rtl="0" eaLnBrk="1" latinLnBrk="0" hangingPunct="1">
+              <a:defRPr sz="1800" kern="1200">
+                <a:solidFill>
+                  <a:schemeClr val="lt1"/>
+                </a:solidFill>
+                <a:latin typeface="+mn-lt"/>
+                <a:ea typeface="+mn-ea"/>
+                <a:cs typeface="+mn-cs"/>
+              </a:defRPr>
+            </a:lvl9pPr>
+          </a:lstStyle>
+          <a:p>
+            <a:pPr algn="ctr"/>
+            <a:endParaRPr lang="en-CA"/>
+          </a:p>
+        </p:txBody>
+      </p:sp>
+      <p:sp>
+        <p:nvSpPr>
+          <p:cNvPr id="19" name="TextBox 18">
+            <a:extLst>
+              <a:ext uri="{FF2B5EF4-FFF2-40B4-BE49-F238E27FC236}">
+                <a16:creationId xmlns:a16="http://schemas.microsoft.com/office/drawing/2014/main" id="{396D1CE8-7E69-8E0B-AF83-D4B4601709D3}"/>
+              </a:ext>
+            </a:extLst>
+          </p:cNvPr>
+          <p:cNvSpPr txBox="1"/>
+          <p:nvPr/>
+        </p:nvSpPr>
+        <p:spPr>
+          <a:xfrm>
+            <a:off x="527959" y="76731"/>
+            <a:ext cx="8710932" cy="492443"/>
+          </a:xfrm>
+          <a:prstGeom prst="rect">
+            <a:avLst/>
+          </a:prstGeom>
+          <a:noFill/>
+        </p:spPr>
+        <p:txBody>
+          <a:bodyPr wrap="square" rtlCol="0">
+            <a:spAutoFit/>
+          </a:bodyPr>
+          <a:lstStyle/>
+          <a:p>
+            <a:r>
+              <a:rPr lang="en-US" sz="2600" b="1" dirty="0">
+                <a:solidFill>
+                  <a:schemeClr val="bg1"/>
+                </a:solidFill>
+                <a:latin typeface="Georgia Pro" panose="02040502050405020303" pitchFamily="18" charset="0"/>
+              </a:rPr>
+              <a:t>Q6IC7-E4ZAF3</a:t>
+            </a:r>
+            <a:endParaRPr lang="en-CA" sz="2600" b="1" dirty="0">
+              <a:solidFill>
+                <a:schemeClr val="bg1"/>
+              </a:solidFill>
+              <a:latin typeface="Georgia Pro" panose="02040502050405020303" pitchFamily="18" charset="0"/>
+            </a:endParaRPr>
+          </a:p>
+        </p:txBody>
+      </p:sp>
+      <p:sp>
+        <p:nvSpPr>
+          <p:cNvPr id="21" name="TextBox 20">
+            <a:extLst>
+              <a:ext uri="{FF2B5EF4-FFF2-40B4-BE49-F238E27FC236}">
+                <a16:creationId xmlns:a16="http://schemas.microsoft.com/office/drawing/2014/main" id="{8F72B6BA-1CD0-834B-7DDC-0CD888A52F82}"/>
+              </a:ext>
+            </a:extLst>
+          </p:cNvPr>
+          <p:cNvSpPr txBox="1"/>
+          <p:nvPr/>
+        </p:nvSpPr>
+        <p:spPr>
+          <a:xfrm>
+            <a:off x="138107" y="2230633"/>
+            <a:ext cx="3267074" cy="1031051"/>
+          </a:xfrm>
+          <a:prstGeom prst="rect">
+            <a:avLst/>
+          </a:prstGeom>
+          <a:noFill/>
+        </p:spPr>
+        <p:txBody>
+          <a:bodyPr wrap="square" rtlCol="0">
+            <a:spAutoFit/>
+          </a:bodyPr>
+          <a:lstStyle/>
+          <a:p>
+            <a:pPr marL="285750" indent="-285750">
+              <a:spcAft>
+                <a:spcPts val="600"/>
+              </a:spcAft>
+              <a:buFont typeface="Arial" panose="020B0604020202020204" pitchFamily="34" charset="0"/>
+              <a:buChar char="•"/>
+            </a:pPr>
+            <a:r>
+              <a:rPr lang="en-US" sz="1400" dirty="0">
+                <a:solidFill>
+                  <a:schemeClr val="bg1"/>
+                </a:solidFill>
+                <a:latin typeface="Verdana Pro" panose="020B0604030504040204" pitchFamily="34" charset="0"/>
+              </a:rPr>
+              <a:t>C5 methyltransferase protecting tRNA from stress-induces cleavage</a:t>
+            </a:r>
+            <a:r>
+              <a:rPr lang="en-US" sz="1400" baseline="30000" dirty="0">
+                <a:solidFill>
+                  <a:schemeClr val="bg1"/>
+                </a:solidFill>
+                <a:latin typeface="Verdana Pro" panose="020B0604030504040204" pitchFamily="34" charset="0"/>
+              </a:rPr>
+              <a:t>1</a:t>
+            </a:r>
+          </a:p>
+          <a:p>
+            <a:pPr marL="285750" indent="-285750">
+              <a:buFont typeface="Arial" panose="020B0604020202020204" pitchFamily="34" charset="0"/>
+              <a:buChar char="•"/>
+            </a:pPr>
+            <a:r>
+              <a:rPr lang="en-US" sz="1400" dirty="0">
+                <a:solidFill>
+                  <a:schemeClr val="bg1"/>
+                </a:solidFill>
+                <a:latin typeface="Verdana Pro" panose="020B0604030504040204" pitchFamily="34" charset="0"/>
+              </a:rPr>
+              <a:t>Facilitates HIV RNA stability</a:t>
+            </a:r>
+            <a:r>
+              <a:rPr lang="en-US" sz="1400" baseline="30000" dirty="0">
+                <a:solidFill>
+                  <a:schemeClr val="bg1"/>
+                </a:solidFill>
+                <a:latin typeface="Verdana Pro" panose="020B0604030504040204" pitchFamily="34" charset="0"/>
+              </a:rPr>
+              <a:t>2</a:t>
+            </a:r>
+            <a:endParaRPr lang="en-CA" sz="1400" dirty="0">
+              <a:solidFill>
+                <a:schemeClr val="bg1"/>
+              </a:solidFill>
+              <a:latin typeface="Verdana Pro" panose="020B0604030504040204" pitchFamily="34" charset="0"/>
+            </a:endParaRPr>
+          </a:p>
+        </p:txBody>
+      </p:sp>
+      <p:sp>
+        <p:nvSpPr>
+          <p:cNvPr id="23" name="TextBox 22">
+            <a:extLst>
+              <a:ext uri="{FF2B5EF4-FFF2-40B4-BE49-F238E27FC236}">
+                <a16:creationId xmlns:a16="http://schemas.microsoft.com/office/drawing/2014/main" id="{98B87F0D-8DBC-5F80-5532-BBF7F3254C79}"/>
+              </a:ext>
+            </a:extLst>
+          </p:cNvPr>
+          <p:cNvSpPr txBox="1"/>
+          <p:nvPr/>
+        </p:nvSpPr>
+        <p:spPr>
+          <a:xfrm>
+            <a:off x="8782054" y="2176873"/>
+            <a:ext cx="3267074" cy="1677382"/>
+          </a:xfrm>
+          <a:prstGeom prst="rect">
+            <a:avLst/>
+          </a:prstGeom>
+          <a:noFill/>
+        </p:spPr>
+        <p:txBody>
+          <a:bodyPr wrap="square" rtlCol="0">
+            <a:spAutoFit/>
+          </a:bodyPr>
+          <a:lstStyle/>
+          <a:p>
+            <a:pPr marL="285750" indent="-285750">
+              <a:spcAft>
+                <a:spcPts val="600"/>
+              </a:spcAft>
+              <a:buFont typeface="Arial" panose="020B0604020202020204" pitchFamily="34" charset="0"/>
+              <a:buChar char="•"/>
+            </a:pPr>
+            <a:r>
+              <a:rPr lang="en-US" sz="1400" dirty="0">
+                <a:solidFill>
+                  <a:schemeClr val="bg1"/>
+                </a:solidFill>
+                <a:latin typeface="Verdana Pro" panose="020B0604030504040204" pitchFamily="34" charset="0"/>
+              </a:rPr>
+              <a:t>recognises short motifs on bacterial DNA and transfers methyl group to cytosine carbon 5 on the motif</a:t>
+            </a:r>
+            <a:r>
+              <a:rPr lang="en-US" sz="1400" baseline="30000" dirty="0">
+                <a:solidFill>
+                  <a:schemeClr val="bg1"/>
+                </a:solidFill>
+                <a:latin typeface="Verdana Pro" panose="020B0604030504040204" pitchFamily="34" charset="0"/>
+              </a:rPr>
+              <a:t>4</a:t>
+            </a:r>
+            <a:endParaRPr lang="en-US" sz="1400" dirty="0">
+              <a:solidFill>
+                <a:schemeClr val="bg1"/>
+              </a:solidFill>
+              <a:latin typeface="Verdana Pro" panose="020B0604030504040204" pitchFamily="34" charset="0"/>
+            </a:endParaRPr>
+          </a:p>
+          <a:p>
+            <a:pPr marL="285750" indent="-285750">
+              <a:spcAft>
+                <a:spcPts val="600"/>
+              </a:spcAft>
+              <a:buFont typeface="Arial" panose="020B0604020202020204" pitchFamily="34" charset="0"/>
+              <a:buChar char="•"/>
+            </a:pPr>
+            <a:r>
+              <a:rPr lang="en-US" sz="1400" dirty="0">
+                <a:solidFill>
+                  <a:schemeClr val="bg1"/>
+                </a:solidFill>
+                <a:latin typeface="Verdana Pro" panose="020B0604030504040204" pitchFamily="34" charset="0"/>
+              </a:rPr>
+              <a:t>viral DNA lacking methylation is targeted by restriction enzymes</a:t>
+            </a:r>
+            <a:r>
+              <a:rPr lang="en-US" sz="1400" baseline="30000" dirty="0">
+                <a:solidFill>
+                  <a:schemeClr val="bg1"/>
+                </a:solidFill>
+                <a:latin typeface="Verdana Pro" panose="020B0604030504040204" pitchFamily="34" charset="0"/>
+              </a:rPr>
+              <a:t>4</a:t>
+            </a:r>
+            <a:endParaRPr lang="en-CA" sz="1400" dirty="0">
+              <a:solidFill>
+                <a:schemeClr val="bg1"/>
+              </a:solidFill>
+              <a:latin typeface="Verdana Pro" panose="020B0604030504040204" pitchFamily="34" charset="0"/>
+            </a:endParaRPr>
+          </a:p>
+        </p:txBody>
+      </p:sp>
+      <p:sp>
+        <p:nvSpPr>
+          <p:cNvPr id="25" name="TextBox 24">
+            <a:extLst>
+              <a:ext uri="{FF2B5EF4-FFF2-40B4-BE49-F238E27FC236}">
+                <a16:creationId xmlns:a16="http://schemas.microsoft.com/office/drawing/2014/main" id="{7A00D8DE-55CD-D9AF-D600-99C3241FB647}"/>
+              </a:ext>
+            </a:extLst>
+          </p:cNvPr>
+          <p:cNvSpPr txBox="1"/>
+          <p:nvPr/>
+        </p:nvSpPr>
+        <p:spPr>
+          <a:xfrm>
+            <a:off x="3543288" y="2230633"/>
+            <a:ext cx="4976598" cy="738664"/>
+          </a:xfrm>
+          <a:prstGeom prst="rect">
+            <a:avLst/>
+          </a:prstGeom>
+          <a:noFill/>
+        </p:spPr>
+        <p:txBody>
+          <a:bodyPr wrap="square" rtlCol="0">
+            <a:spAutoFit/>
+          </a:bodyPr>
+          <a:lstStyle/>
+          <a:p>
+            <a:pPr marL="285750" indent="-285750">
+              <a:spcAft>
+                <a:spcPts val="600"/>
+              </a:spcAft>
+              <a:buFont typeface="Arial" panose="020B0604020202020204" pitchFamily="34" charset="0"/>
+              <a:buChar char="•"/>
+            </a:pPr>
+            <a:r>
+              <a:rPr lang="en-US" sz="1400" dirty="0">
+                <a:solidFill>
+                  <a:schemeClr val="bg1"/>
+                </a:solidFill>
+                <a:latin typeface="Verdana Pro" panose="020B0604030504040204" pitchFamily="34" charset="0"/>
+              </a:rPr>
+              <a:t>DNMT2 is reported in the literature as exhibiting sequence homology to bacterial RM Type II C5 methyltransferases</a:t>
+            </a:r>
+            <a:r>
+              <a:rPr lang="en-US" sz="1400" baseline="30000" dirty="0">
+                <a:solidFill>
+                  <a:schemeClr val="bg1"/>
+                </a:solidFill>
+                <a:latin typeface="Verdana Pro" panose="020B0604030504040204" pitchFamily="34" charset="0"/>
+              </a:rPr>
+              <a:t>3</a:t>
+            </a:r>
+            <a:endParaRPr lang="en-CA" sz="1400" dirty="0">
+              <a:solidFill>
+                <a:schemeClr val="bg1"/>
+              </a:solidFill>
+              <a:latin typeface="Verdana Pro" panose="020B0604030504040204" pitchFamily="34" charset="0"/>
+            </a:endParaRPr>
+          </a:p>
+        </p:txBody>
+      </p:sp>
     </p:spTree>
     <p:extLst>
       <p:ext uri="{BB962C8B-B14F-4D97-AF65-F5344CB8AC3E}">
         <p14:creationId xmlns:p14="http://schemas.microsoft.com/office/powerpoint/2010/main" val="485302257"/>
+      </p:ext>
+    </p:extLst>
+  </p:cSld>
+  <p:clrMapOvr>
+    <a:masterClrMapping/>
+  </p:clrMapOvr>
+</p:sld>
+</file>
+
+<file path=ppt/slides/slide13.xml><?xml version="1.0" encoding="utf-8"?>
+<p:sld xmlns:a="http://schemas.openxmlformats.org/drawingml/2006/main" xmlns:r="http://schemas.openxmlformats.org/officeDocument/2006/relationships" xmlns:p="http://schemas.openxmlformats.org/presentationml/2006/main">
+  <p:cSld>
+    <p:spTree>
+      <p:nvGrpSpPr>
+        <p:cNvPr id="1" name="">
+          <a:extLst>
+            <a:ext uri="{FF2B5EF4-FFF2-40B4-BE49-F238E27FC236}">
+              <a16:creationId xmlns:a16="http://schemas.microsoft.com/office/drawing/2014/main" id="{F58AED45-3F0C-244E-4A45-7F1E2BB51044}"/>
+            </a:ext>
+          </a:extLst>
+        </p:cNvPr>
+        <p:cNvGrpSpPr/>
+        <p:nvPr/>
+      </p:nvGrpSpPr>
+      <p:grpSpPr>
+        <a:xfrm>
+          <a:off x="0" y="0"/>
+          <a:ext cx="0" cy="0"/>
+          <a:chOff x="0" y="0"/>
+          <a:chExt cx="0" cy="0"/>
+        </a:xfrm>
+      </p:grpSpPr>
+      <p:sp>
+        <p:nvSpPr>
+          <p:cNvPr id="4" name="TextBox 3">
+            <a:extLst>
+              <a:ext uri="{FF2B5EF4-FFF2-40B4-BE49-F238E27FC236}">
+                <a16:creationId xmlns:a16="http://schemas.microsoft.com/office/drawing/2014/main" id="{E25B8F64-2811-4671-34C4-817BB60EB7E9}"/>
+              </a:ext>
+            </a:extLst>
+          </p:cNvPr>
+          <p:cNvSpPr txBox="1"/>
+          <p:nvPr/>
+        </p:nvSpPr>
+        <p:spPr>
+          <a:xfrm>
+            <a:off x="381000" y="215900"/>
+            <a:ext cx="7581900" cy="369332"/>
+          </a:xfrm>
+          <a:prstGeom prst="rect">
+            <a:avLst/>
+          </a:prstGeom>
+          <a:noFill/>
+        </p:spPr>
+        <p:txBody>
+          <a:bodyPr wrap="square" rtlCol="0">
+            <a:spAutoFit/>
+          </a:bodyPr>
+          <a:lstStyle/>
+          <a:p>
+            <a:r>
+              <a:rPr lang="en-US" dirty="0">
+                <a:latin typeface="Verdana Pro" panose="020B0604030504040204" pitchFamily="34" charset="0"/>
+              </a:rPr>
+              <a:t>Worked example: strong homology, low sequence homology</a:t>
+            </a:r>
+            <a:endParaRPr lang="en-CA" dirty="0">
+              <a:latin typeface="Verdana Pro" panose="020B0604030504040204" pitchFamily="34" charset="0"/>
+            </a:endParaRPr>
+          </a:p>
+        </p:txBody>
+      </p:sp>
+    </p:spTree>
+    <p:extLst>
+      <p:ext uri="{BB962C8B-B14F-4D97-AF65-F5344CB8AC3E}">
+        <p14:creationId xmlns:p14="http://schemas.microsoft.com/office/powerpoint/2010/main" val="2168839945"/>
+      </p:ext>
+    </p:extLst>
+  </p:cSld>
+  <p:clrMapOvr>
+    <a:masterClrMapping/>
+  </p:clrMapOvr>
+</p:sld>
+</file>
+
+<file path=ppt/slides/slide14.xml><?xml version="1.0" encoding="utf-8"?>
+<p:sld xmlns:a="http://schemas.openxmlformats.org/drawingml/2006/main" xmlns:r="http://schemas.openxmlformats.org/officeDocument/2006/relationships" xmlns:p="http://schemas.openxmlformats.org/presentationml/2006/main">
+  <p:cSld>
+    <p:spTree>
+      <p:nvGrpSpPr>
+        <p:cNvPr id="1" name="">
+          <a:extLst>
+            <a:ext uri="{FF2B5EF4-FFF2-40B4-BE49-F238E27FC236}">
+              <a16:creationId xmlns:a16="http://schemas.microsoft.com/office/drawing/2014/main" id="{ADF6FBCF-6996-7BE6-B15E-1A7B2134FC77}"/>
+            </a:ext>
+          </a:extLst>
+        </p:cNvPr>
+        <p:cNvGrpSpPr/>
+        <p:nvPr/>
+      </p:nvGrpSpPr>
+      <p:grpSpPr>
+        <a:xfrm>
+          <a:off x="0" y="0"/>
+          <a:ext cx="0" cy="0"/>
+          <a:chOff x="0" y="0"/>
+          <a:chExt cx="0" cy="0"/>
+        </a:xfrm>
+      </p:grpSpPr>
+      <p:sp>
+        <p:nvSpPr>
+          <p:cNvPr id="4" name="TextBox 3">
+            <a:extLst>
+              <a:ext uri="{FF2B5EF4-FFF2-40B4-BE49-F238E27FC236}">
+                <a16:creationId xmlns:a16="http://schemas.microsoft.com/office/drawing/2014/main" id="{A0BF4CD7-59D5-B2D2-FA64-845C5B11662A}"/>
+              </a:ext>
+            </a:extLst>
+          </p:cNvPr>
+          <p:cNvSpPr txBox="1"/>
+          <p:nvPr/>
+        </p:nvSpPr>
+        <p:spPr>
+          <a:xfrm>
+            <a:off x="381000" y="215900"/>
+            <a:ext cx="7581900" cy="369332"/>
+          </a:xfrm>
+          <a:prstGeom prst="rect">
+            <a:avLst/>
+          </a:prstGeom>
+          <a:noFill/>
+        </p:spPr>
+        <p:txBody>
+          <a:bodyPr wrap="square" rtlCol="0">
+            <a:spAutoFit/>
+          </a:bodyPr>
+          <a:lstStyle/>
+          <a:p>
+            <a:r>
+              <a:rPr lang="en-US" dirty="0">
+                <a:latin typeface="Verdana Pro" panose="020B0604030504040204" pitchFamily="34" charset="0"/>
+              </a:rPr>
+              <a:t>Worked example: domain-specific homology</a:t>
+            </a:r>
+            <a:endParaRPr lang="en-CA" dirty="0">
+              <a:latin typeface="Verdana Pro" panose="020B0604030504040204" pitchFamily="34" charset="0"/>
+            </a:endParaRPr>
+          </a:p>
+        </p:txBody>
+      </p:sp>
+    </p:spTree>
+    <p:extLst>
+      <p:ext uri="{BB962C8B-B14F-4D97-AF65-F5344CB8AC3E}">
+        <p14:creationId xmlns:p14="http://schemas.microsoft.com/office/powerpoint/2010/main" val="2238046284"/>
+      </p:ext>
+    </p:extLst>
+  </p:cSld>
+  <p:clrMapOvr>
+    <a:masterClrMapping/>
+  </p:clrMapOvr>
+</p:sld>
+</file>
+
+<file path=ppt/slides/slide15.xml><?xml version="1.0" encoding="utf-8"?>
+<p:sld xmlns:a="http://schemas.openxmlformats.org/drawingml/2006/main" xmlns:r="http://schemas.openxmlformats.org/officeDocument/2006/relationships" xmlns:p="http://schemas.openxmlformats.org/presentationml/2006/main">
+  <p:cSld>
+    <p:spTree>
+      <p:nvGrpSpPr>
+        <p:cNvPr id="1" name="">
+          <a:extLst>
+            <a:ext uri="{FF2B5EF4-FFF2-40B4-BE49-F238E27FC236}">
+              <a16:creationId xmlns:a16="http://schemas.microsoft.com/office/drawing/2014/main" id="{FE1AC05B-114B-43EA-7ED1-67E68CD514E8}"/>
+            </a:ext>
+          </a:extLst>
+        </p:cNvPr>
+        <p:cNvGrpSpPr/>
+        <p:nvPr/>
+      </p:nvGrpSpPr>
+      <p:grpSpPr>
+        <a:xfrm>
+          <a:off x="0" y="0"/>
+          <a:ext cx="0" cy="0"/>
+          <a:chOff x="0" y="0"/>
+          <a:chExt cx="0" cy="0"/>
+        </a:xfrm>
+      </p:grpSpPr>
+      <p:sp>
+        <p:nvSpPr>
+          <p:cNvPr id="4" name="TextBox 3">
+            <a:extLst>
+              <a:ext uri="{FF2B5EF4-FFF2-40B4-BE49-F238E27FC236}">
+                <a16:creationId xmlns:a16="http://schemas.microsoft.com/office/drawing/2014/main" id="{7B6E6A77-6B5A-DF34-8EC2-8F13A2024E0E}"/>
+              </a:ext>
+            </a:extLst>
+          </p:cNvPr>
+          <p:cNvSpPr txBox="1"/>
+          <p:nvPr/>
+        </p:nvSpPr>
+        <p:spPr>
+          <a:xfrm>
+            <a:off x="381000" y="215900"/>
+            <a:ext cx="7581900" cy="369332"/>
+          </a:xfrm>
+          <a:prstGeom prst="rect">
+            <a:avLst/>
+          </a:prstGeom>
+          <a:noFill/>
+        </p:spPr>
+        <p:txBody>
+          <a:bodyPr wrap="square" rtlCol="0">
+            <a:spAutoFit/>
+          </a:bodyPr>
+          <a:lstStyle/>
+          <a:p>
+            <a:r>
+              <a:rPr lang="en-US" dirty="0">
+                <a:latin typeface="Verdana Pro" panose="020B0604030504040204" pitchFamily="34" charset="0"/>
+              </a:rPr>
+              <a:t>IUIS-IEI genes have significantly higher score</a:t>
+            </a:r>
+            <a:endParaRPr lang="en-CA" dirty="0">
+              <a:latin typeface="Verdana Pro" panose="020B0604030504040204" pitchFamily="34" charset="0"/>
+            </a:endParaRPr>
+          </a:p>
+        </p:txBody>
+      </p:sp>
+    </p:spTree>
+    <p:extLst>
+      <p:ext uri="{BB962C8B-B14F-4D97-AF65-F5344CB8AC3E}">
+        <p14:creationId xmlns:p14="http://schemas.microsoft.com/office/powerpoint/2010/main" val="452590621"/>
+      </p:ext>
+    </p:extLst>
+  </p:cSld>
+  <p:clrMapOvr>
+    <a:masterClrMapping/>
+  </p:clrMapOvr>
+</p:sld>
+</file>
+
+<file path=ppt/slides/slide16.xml><?xml version="1.0" encoding="utf-8"?>
+<p:sld xmlns:a="http://schemas.openxmlformats.org/drawingml/2006/main" xmlns:r="http://schemas.openxmlformats.org/officeDocument/2006/relationships" xmlns:p="http://schemas.openxmlformats.org/presentationml/2006/main">
+  <p:cSld>
+    <p:spTree>
+      <p:nvGrpSpPr>
+        <p:cNvPr id="1" name="">
+          <a:extLst>
+            <a:ext uri="{FF2B5EF4-FFF2-40B4-BE49-F238E27FC236}">
+              <a16:creationId xmlns:a16="http://schemas.microsoft.com/office/drawing/2014/main" id="{5E96BC46-7673-C84B-18B4-63539AA9C004}"/>
+            </a:ext>
+          </a:extLst>
+        </p:cNvPr>
+        <p:cNvGrpSpPr/>
+        <p:nvPr/>
+      </p:nvGrpSpPr>
+      <p:grpSpPr>
+        <a:xfrm>
+          <a:off x="0" y="0"/>
+          <a:ext cx="0" cy="0"/>
+          <a:chOff x="0" y="0"/>
+          <a:chExt cx="0" cy="0"/>
+        </a:xfrm>
+      </p:grpSpPr>
+      <p:sp>
+        <p:nvSpPr>
+          <p:cNvPr id="15" name="Rectangle: Rounded Corners 14">
+            <a:extLst>
+              <a:ext uri="{FF2B5EF4-FFF2-40B4-BE49-F238E27FC236}">
+                <a16:creationId xmlns:a16="http://schemas.microsoft.com/office/drawing/2014/main" id="{7DA48913-4EF7-7226-450E-EB863B768EE5}"/>
+              </a:ext>
+            </a:extLst>
+          </p:cNvPr>
+          <p:cNvSpPr/>
+          <p:nvPr/>
+        </p:nvSpPr>
+        <p:spPr>
+          <a:xfrm>
+            <a:off x="315257" y="8582"/>
+            <a:ext cx="9363581" cy="628742"/>
+          </a:xfrm>
+          <a:prstGeom prst="roundRect">
+            <a:avLst/>
+          </a:prstGeom>
+          <a:solidFill>
+            <a:srgbClr val="0162B3"/>
+          </a:solidFill>
+          <a:ln>
+            <a:solidFill>
+              <a:srgbClr val="0162B3"/>
+            </a:solidFill>
+          </a:ln>
+        </p:spPr>
+        <p:style>
+          <a:lnRef idx="2">
+            <a:schemeClr val="accent1">
+              <a:shade val="50000"/>
+            </a:schemeClr>
+          </a:lnRef>
+          <a:fillRef idx="1">
+            <a:schemeClr val="accent1"/>
+          </a:fillRef>
+          <a:effectRef idx="0">
+            <a:schemeClr val="accent1"/>
+          </a:effectRef>
+          <a:fontRef idx="minor">
+            <a:schemeClr val="lt1"/>
+          </a:fontRef>
+        </p:style>
+        <p:txBody>
+          <a:bodyPr rtlCol="0" anchor="ctr"/>
+          <a:lstStyle>
+            <a:defPPr>
+              <a:defRPr lang="en-US"/>
+            </a:defPPr>
+            <a:lvl1pPr marL="0" algn="l" defTabSz="914400" rtl="0" eaLnBrk="1" latinLnBrk="0" hangingPunct="1">
+              <a:defRPr sz="1800" kern="1200">
+                <a:solidFill>
+                  <a:schemeClr val="lt1"/>
+                </a:solidFill>
+                <a:latin typeface="+mn-lt"/>
+                <a:ea typeface="+mn-ea"/>
+                <a:cs typeface="+mn-cs"/>
+              </a:defRPr>
+            </a:lvl1pPr>
+            <a:lvl2pPr marL="457200" algn="l" defTabSz="914400" rtl="0" eaLnBrk="1" latinLnBrk="0" hangingPunct="1">
+              <a:defRPr sz="1800" kern="1200">
+                <a:solidFill>
+                  <a:schemeClr val="lt1"/>
+                </a:solidFill>
+                <a:latin typeface="+mn-lt"/>
+                <a:ea typeface="+mn-ea"/>
+                <a:cs typeface="+mn-cs"/>
+              </a:defRPr>
+            </a:lvl2pPr>
+            <a:lvl3pPr marL="914400" algn="l" defTabSz="914400" rtl="0" eaLnBrk="1" latinLnBrk="0" hangingPunct="1">
+              <a:defRPr sz="1800" kern="1200">
+                <a:solidFill>
+                  <a:schemeClr val="lt1"/>
+                </a:solidFill>
+                <a:latin typeface="+mn-lt"/>
+                <a:ea typeface="+mn-ea"/>
+                <a:cs typeface="+mn-cs"/>
+              </a:defRPr>
+            </a:lvl3pPr>
+            <a:lvl4pPr marL="1371600" algn="l" defTabSz="914400" rtl="0" eaLnBrk="1" latinLnBrk="0" hangingPunct="1">
+              <a:defRPr sz="1800" kern="1200">
+                <a:solidFill>
+                  <a:schemeClr val="lt1"/>
+                </a:solidFill>
+                <a:latin typeface="+mn-lt"/>
+                <a:ea typeface="+mn-ea"/>
+                <a:cs typeface="+mn-cs"/>
+              </a:defRPr>
+            </a:lvl4pPr>
+            <a:lvl5pPr marL="1828800" algn="l" defTabSz="914400" rtl="0" eaLnBrk="1" latinLnBrk="0" hangingPunct="1">
+              <a:defRPr sz="1800" kern="1200">
+                <a:solidFill>
+                  <a:schemeClr val="lt1"/>
+                </a:solidFill>
+                <a:latin typeface="+mn-lt"/>
+                <a:ea typeface="+mn-ea"/>
+                <a:cs typeface="+mn-cs"/>
+              </a:defRPr>
+            </a:lvl5pPr>
+            <a:lvl6pPr marL="2286000" algn="l" defTabSz="914400" rtl="0" eaLnBrk="1" latinLnBrk="0" hangingPunct="1">
+              <a:defRPr sz="1800" kern="1200">
+                <a:solidFill>
+                  <a:schemeClr val="lt1"/>
+                </a:solidFill>
+                <a:latin typeface="+mn-lt"/>
+                <a:ea typeface="+mn-ea"/>
+                <a:cs typeface="+mn-cs"/>
+              </a:defRPr>
+            </a:lvl6pPr>
+            <a:lvl7pPr marL="2743200" algn="l" defTabSz="914400" rtl="0" eaLnBrk="1" latinLnBrk="0" hangingPunct="1">
+              <a:defRPr sz="1800" kern="1200">
+                <a:solidFill>
+                  <a:schemeClr val="lt1"/>
+                </a:solidFill>
+                <a:latin typeface="+mn-lt"/>
+                <a:ea typeface="+mn-ea"/>
+                <a:cs typeface="+mn-cs"/>
+              </a:defRPr>
+            </a:lvl7pPr>
+            <a:lvl8pPr marL="3200400" algn="l" defTabSz="914400" rtl="0" eaLnBrk="1" latinLnBrk="0" hangingPunct="1">
+              <a:defRPr sz="1800" kern="1200">
+                <a:solidFill>
+                  <a:schemeClr val="lt1"/>
+                </a:solidFill>
+                <a:latin typeface="+mn-lt"/>
+                <a:ea typeface="+mn-ea"/>
+                <a:cs typeface="+mn-cs"/>
+              </a:defRPr>
+            </a:lvl8pPr>
+            <a:lvl9pPr marL="3657600" algn="l" defTabSz="914400" rtl="0" eaLnBrk="1" latinLnBrk="0" hangingPunct="1">
+              <a:defRPr sz="1800" kern="1200">
+                <a:solidFill>
+                  <a:schemeClr val="lt1"/>
+                </a:solidFill>
+                <a:latin typeface="+mn-lt"/>
+                <a:ea typeface="+mn-ea"/>
+                <a:cs typeface="+mn-cs"/>
+              </a:defRPr>
+            </a:lvl9pPr>
+          </a:lstStyle>
+          <a:p>
+            <a:pPr algn="ctr"/>
+            <a:endParaRPr lang="en-CA"/>
+          </a:p>
+        </p:txBody>
+      </p:sp>
+      <p:sp>
+        <p:nvSpPr>
+          <p:cNvPr id="19" name="TextBox 18">
+            <a:extLst>
+              <a:ext uri="{FF2B5EF4-FFF2-40B4-BE49-F238E27FC236}">
+                <a16:creationId xmlns:a16="http://schemas.microsoft.com/office/drawing/2014/main" id="{C3A09E84-A853-2CE4-2353-6F32C167F0F1}"/>
+              </a:ext>
+            </a:extLst>
+          </p:cNvPr>
+          <p:cNvSpPr txBox="1"/>
+          <p:nvPr/>
+        </p:nvSpPr>
+        <p:spPr>
+          <a:xfrm>
+            <a:off x="527959" y="76731"/>
+            <a:ext cx="8710932" cy="492443"/>
+          </a:xfrm>
+          <a:prstGeom prst="rect">
+            <a:avLst/>
+          </a:prstGeom>
+          <a:noFill/>
+        </p:spPr>
+        <p:txBody>
+          <a:bodyPr wrap="square" rtlCol="0">
+            <a:spAutoFit/>
+          </a:bodyPr>
+          <a:lstStyle/>
+          <a:p>
+            <a:r>
+              <a:rPr lang="en-US" sz="2600" b="1" dirty="0">
+                <a:solidFill>
+                  <a:schemeClr val="bg1"/>
+                </a:solidFill>
+                <a:latin typeface="Georgia Pro" panose="02040502050405020303" pitchFamily="18" charset="0"/>
+              </a:rPr>
+              <a:t>References</a:t>
+            </a:r>
+            <a:endParaRPr lang="en-CA" sz="2600" b="1" dirty="0">
+              <a:solidFill>
+                <a:schemeClr val="bg1"/>
+              </a:solidFill>
+              <a:latin typeface="Georgia Pro" panose="02040502050405020303" pitchFamily="18" charset="0"/>
+            </a:endParaRPr>
+          </a:p>
+        </p:txBody>
+      </p:sp>
+      <p:sp>
+        <p:nvSpPr>
+          <p:cNvPr id="2" name="TextBox 1">
+            <a:extLst>
+              <a:ext uri="{FF2B5EF4-FFF2-40B4-BE49-F238E27FC236}">
+                <a16:creationId xmlns:a16="http://schemas.microsoft.com/office/drawing/2014/main" id="{D555B33F-2E1A-FAA4-32B8-ADE7D02D78D0}"/>
+              </a:ext>
+            </a:extLst>
+          </p:cNvPr>
+          <p:cNvSpPr txBox="1"/>
+          <p:nvPr/>
+        </p:nvSpPr>
+        <p:spPr>
+          <a:xfrm>
+            <a:off x="527958" y="1146628"/>
+            <a:ext cx="9363581" cy="2046714"/>
+          </a:xfrm>
+          <a:prstGeom prst="rect">
+            <a:avLst/>
+          </a:prstGeom>
+          <a:noFill/>
+        </p:spPr>
+        <p:txBody>
+          <a:bodyPr wrap="square" rtlCol="0">
+            <a:spAutoFit/>
+          </a:bodyPr>
+          <a:lstStyle/>
+          <a:p>
+            <a:pPr marL="342900" indent="-342900">
+              <a:spcAft>
+                <a:spcPts val="600"/>
+              </a:spcAft>
+              <a:buFont typeface="+mj-lt"/>
+              <a:buAutoNum type="arabicPeriod"/>
+            </a:pPr>
+            <a:r>
+              <a:rPr lang="en-CA" sz="1400" dirty="0">
+                <a:latin typeface="Verdana Pro" panose="020B0604030504040204" pitchFamily="34" charset="0"/>
+              </a:rPr>
+              <a:t>Schaefer M, et al. RNA methylation by Dnmt2 protects transfer RNAs against stress-induced cleavage. Genes Dev. 2010;24:1590–1595. DOI: 10.1101/gad.586710.</a:t>
+            </a:r>
+          </a:p>
+          <a:p>
+            <a:pPr marL="342900" indent="-342900">
+              <a:spcAft>
+                <a:spcPts val="600"/>
+              </a:spcAft>
+              <a:buFont typeface="+mj-lt"/>
+              <a:buAutoNum type="arabicPeriod"/>
+            </a:pPr>
+            <a:r>
+              <a:rPr lang="en-CA" sz="1400" dirty="0">
+                <a:latin typeface="Verdana Pro" panose="020B0604030504040204" pitchFamily="34" charset="0"/>
+              </a:rPr>
+              <a:t>Dev RR, et al. Cytosine methylation by DNMT2 facilitates stability and survival of HIV-1 RNA in the host cell during infection. Biochem J. 2017;474:2009–2026. DOI: 10.1042/BCJ20170258.</a:t>
+            </a:r>
+          </a:p>
+          <a:p>
+            <a:pPr marL="342900" indent="-342900">
+              <a:spcAft>
+                <a:spcPts val="600"/>
+              </a:spcAft>
+              <a:buFont typeface="+mj-lt"/>
+              <a:buAutoNum type="arabicPeriod"/>
+            </a:pPr>
+            <a:r>
+              <a:rPr lang="en-CA" sz="1400" dirty="0">
+                <a:latin typeface="Verdana Pro" panose="020B0604030504040204" pitchFamily="34" charset="0"/>
+              </a:rPr>
+              <a:t>Dong A, et al. Structure of human DNMT2, an enigmatic DNA methyltransferase homolog that displays denaturant-resistant binding to DNA. Nucleic Acids Res. 2001;29:439–448.</a:t>
+            </a:r>
+          </a:p>
+          <a:p>
+            <a:pPr marL="342900" indent="-342900">
+              <a:spcAft>
+                <a:spcPts val="600"/>
+              </a:spcAft>
+              <a:buFont typeface="+mj-lt"/>
+              <a:buAutoNum type="arabicPeriod"/>
+            </a:pPr>
+            <a:r>
+              <a:rPr lang="en-CA" sz="1400" dirty="0">
+                <a:latin typeface="Verdana Pro" panose="020B0604030504040204" pitchFamily="34" charset="0"/>
+              </a:rPr>
+              <a:t>Flodman K, et al. In vitro Type II Restriction of Bacteriophage DNA With Modified Pyrimidines. Front Microbiol. 2020;11:604618. DOI: 10.3389/fmicb.2020.604618</a:t>
+            </a:r>
+          </a:p>
+        </p:txBody>
+      </p:sp>
+    </p:spTree>
+    <p:extLst>
+      <p:ext uri="{BB962C8B-B14F-4D97-AF65-F5344CB8AC3E}">
+        <p14:creationId xmlns:p14="http://schemas.microsoft.com/office/powerpoint/2010/main" val="3064083664"/>
       </p:ext>
     </p:extLst>
   </p:cSld>
@@ -8395,7 +9654,7 @@
         <p:spPr>
           <a:xfrm>
             <a:off x="838200" y="1033157"/>
-            <a:ext cx="9272016" cy="2477601"/>
+            <a:ext cx="9272016" cy="2631490"/>
           </a:xfrm>
           <a:prstGeom prst="rect">
             <a:avLst/>
@@ -8441,8 +9700,8 @@
               <a:buChar char="•"/>
             </a:pPr>
             <a:r>
-              <a:rPr lang="en-US" sz="1200" dirty="0">
-                <a:latin typeface="Lucida Console" panose="020B0609040504020204" pitchFamily="49" charset="0"/>
+              <a:rPr lang="en-US" sz="1400" dirty="0">
+                <a:latin typeface="Verdana Pro" panose="020B0604030504040204" pitchFamily="34" charset="0"/>
                 <a:cs typeface="Courier New" panose="02070309020205020404" pitchFamily="49" charset="0"/>
               </a:rPr>
               <a:t>incurs prioritization problem</a:t>
@@ -8457,8 +9716,8 @@
               <a:buChar char="•"/>
             </a:pPr>
             <a:r>
-              <a:rPr lang="en-US" sz="1200" dirty="0">
-                <a:latin typeface="Lucida Console" panose="020B0609040504020204" pitchFamily="49" charset="0"/>
+              <a:rPr lang="en-US" sz="1400" dirty="0">
+                <a:latin typeface="Verdana Pro" panose="020B0604030504040204" pitchFamily="34" charset="0"/>
                 <a:cs typeface="Courier New" panose="02070309020205020404" pitchFamily="49" charset="0"/>
               </a:rPr>
               <a:t>therefore design composite score for protein pair prioritization</a:t>
@@ -8499,8 +9758,8 @@
               <a:buChar char="•"/>
             </a:pPr>
             <a:r>
-              <a:rPr lang="en-US" sz="1200" dirty="0">
-                <a:latin typeface="Lucida Console" panose="020B0609040504020204" pitchFamily="49" charset="0"/>
+              <a:rPr lang="en-US" sz="1400" dirty="0">
+                <a:latin typeface="Verdana Pro" panose="020B0604030504040204" pitchFamily="34" charset="0"/>
                 <a:cs typeface="Courier New" panose="02070309020205020404" pitchFamily="49" charset="0"/>
               </a:rPr>
               <a:t>target users: C Marshall clinical research group</a:t>
@@ -8515,14 +9774,14 @@
               <a:buChar char="•"/>
             </a:pPr>
             <a:r>
-              <a:rPr lang="en-US" sz="1200" dirty="0">
-                <a:latin typeface="Lucida Console" panose="020B0609040504020204" pitchFamily="49" charset="0"/>
+              <a:rPr lang="en-US" sz="1400" dirty="0">
+                <a:latin typeface="Verdana Pro" panose="020B0604030504040204" pitchFamily="34" charset="0"/>
                 <a:cs typeface="Courier New" panose="02070309020205020404" pitchFamily="49" charset="0"/>
               </a:rPr>
               <a:t>purpose: improve diagnostic yield for rare single-variant immune disease from genome sequencing</a:t>
             </a:r>
-            <a:endParaRPr lang="en-US" dirty="0">
-              <a:latin typeface="Georgia Pro" panose="02040502050405020303" pitchFamily="18" charset="0"/>
+            <a:endParaRPr lang="en-US" sz="1400" dirty="0">
+              <a:latin typeface="Verdana Pro" panose="020B0604030504040204" pitchFamily="34" charset="0"/>
             </a:endParaRPr>
           </a:p>
         </p:txBody>
@@ -12635,10 +13894,10 @@
         </p:nvGrpSpPr>
         <p:grpSpPr>
           <a:xfrm>
-            <a:off x="527959" y="3301586"/>
-            <a:ext cx="3337558" cy="3001835"/>
-            <a:chOff x="343293" y="3300621"/>
-            <a:chExt cx="3337558" cy="3001835"/>
+            <a:off x="558736" y="3479386"/>
+            <a:ext cx="3306781" cy="2824035"/>
+            <a:chOff x="374070" y="3478421"/>
+            <a:chExt cx="3306781" cy="2824035"/>
           </a:xfrm>
         </p:grpSpPr>
         <p:sp>
@@ -12693,8 +13952,8 @@
           </p:nvSpPr>
           <p:spPr>
             <a:xfrm rot="16200000">
-              <a:off x="-675426" y="4319340"/>
-              <a:ext cx="2406770" cy="369332"/>
+              <a:off x="-675426" y="4527917"/>
+              <a:ext cx="2406770" cy="307777"/>
             </a:xfrm>
             <a:prstGeom prst="rect">
               <a:avLst/>
@@ -12709,12 +13968,12 @@
             <a:p>
               <a:pPr algn="ctr"/>
               <a:r>
-                <a:rPr lang="en-US" dirty="0">
+                <a:rPr lang="en-US" sz="1400" dirty="0">
                   <a:latin typeface="Verdana Pro" panose="020B0604030504040204" pitchFamily="34" charset="0"/>
                 </a:rPr>
                 <a:t>PyMOL score term</a:t>
               </a:r>
-              <a:endParaRPr lang="en-CA" dirty="0">
+              <a:endParaRPr lang="en-CA" sz="1400" dirty="0">
                 <a:latin typeface="Verdana Pro" panose="020B0604030504040204" pitchFamily="34" charset="0"/>
               </a:endParaRPr>
             </a:p>

</xml_diff>

<commit_message>
Added slide about domain-specific alignment.
</commit_message>
<xml_diff>
--- a/reports/2026-08-28_projectUpdate_3/2026-08-28_projectUpdate_3_jmoran.pptx
+++ b/reports/2026-08-28_projectUpdate_3/2026-08-28_projectUpdate_3_jmoran.pptx
@@ -212,7 +212,7 @@
           <a:p>
             <a:fld id="{1479C651-C459-48E3-86F1-CED449A3498B}" type="datetimeFigureOut">
               <a:rPr lang="en-CA" smtClean="0"/>
-              <a:t>2026-08-25</a:t>
+              <a:t>2026-08-27</a:t>
             </a:fld>
             <a:endParaRPr lang="en-CA"/>
           </a:p>
@@ -1121,7 +1121,7 @@
           <a:p>
             <a:fld id="{643EFF56-2492-48E5-B1E7-E04EEB44BBAA}" type="datetimeFigureOut">
               <a:rPr lang="en-CA" smtClean="0"/>
-              <a:t>2026-08-25</a:t>
+              <a:t>2026-08-27</a:t>
             </a:fld>
             <a:endParaRPr lang="en-CA"/>
           </a:p>
@@ -1321,7 +1321,7 @@
           <a:p>
             <a:fld id="{643EFF56-2492-48E5-B1E7-E04EEB44BBAA}" type="datetimeFigureOut">
               <a:rPr lang="en-CA" smtClean="0"/>
-              <a:t>2026-08-25</a:t>
+              <a:t>2026-08-27</a:t>
             </a:fld>
             <a:endParaRPr lang="en-CA"/>
           </a:p>
@@ -1531,7 +1531,7 @@
           <a:p>
             <a:fld id="{643EFF56-2492-48E5-B1E7-E04EEB44BBAA}" type="datetimeFigureOut">
               <a:rPr lang="en-CA" smtClean="0"/>
-              <a:t>2026-08-25</a:t>
+              <a:t>2026-08-27</a:t>
             </a:fld>
             <a:endParaRPr lang="en-CA"/>
           </a:p>
@@ -1731,7 +1731,7 @@
           <a:p>
             <a:fld id="{643EFF56-2492-48E5-B1E7-E04EEB44BBAA}" type="datetimeFigureOut">
               <a:rPr lang="en-CA" smtClean="0"/>
-              <a:t>2026-08-25</a:t>
+              <a:t>2026-08-27</a:t>
             </a:fld>
             <a:endParaRPr lang="en-CA"/>
           </a:p>
@@ -2007,7 +2007,7 @@
           <a:p>
             <a:fld id="{643EFF56-2492-48E5-B1E7-E04EEB44BBAA}" type="datetimeFigureOut">
               <a:rPr lang="en-CA" smtClean="0"/>
-              <a:t>2026-08-25</a:t>
+              <a:t>2026-08-27</a:t>
             </a:fld>
             <a:endParaRPr lang="en-CA"/>
           </a:p>
@@ -2275,7 +2275,7 @@
           <a:p>
             <a:fld id="{643EFF56-2492-48E5-B1E7-E04EEB44BBAA}" type="datetimeFigureOut">
               <a:rPr lang="en-CA" smtClean="0"/>
-              <a:t>2026-08-25</a:t>
+              <a:t>2026-08-27</a:t>
             </a:fld>
             <a:endParaRPr lang="en-CA"/>
           </a:p>
@@ -2690,7 +2690,7 @@
           <a:p>
             <a:fld id="{643EFF56-2492-48E5-B1E7-E04EEB44BBAA}" type="datetimeFigureOut">
               <a:rPr lang="en-CA" smtClean="0"/>
-              <a:t>2026-08-25</a:t>
+              <a:t>2026-08-27</a:t>
             </a:fld>
             <a:endParaRPr lang="en-CA"/>
           </a:p>
@@ -2832,7 +2832,7 @@
           <a:p>
             <a:fld id="{643EFF56-2492-48E5-B1E7-E04EEB44BBAA}" type="datetimeFigureOut">
               <a:rPr lang="en-CA" smtClean="0"/>
-              <a:t>2026-08-25</a:t>
+              <a:t>2026-08-27</a:t>
             </a:fld>
             <a:endParaRPr lang="en-CA"/>
           </a:p>
@@ -2945,7 +2945,7 @@
           <a:p>
             <a:fld id="{643EFF56-2492-48E5-B1E7-E04EEB44BBAA}" type="datetimeFigureOut">
               <a:rPr lang="en-CA" smtClean="0"/>
-              <a:t>2026-08-25</a:t>
+              <a:t>2026-08-27</a:t>
             </a:fld>
             <a:endParaRPr lang="en-CA"/>
           </a:p>
@@ -3258,7 +3258,7 @@
           <a:p>
             <a:fld id="{643EFF56-2492-48E5-B1E7-E04EEB44BBAA}" type="datetimeFigureOut">
               <a:rPr lang="en-CA" smtClean="0"/>
-              <a:t>2026-08-25</a:t>
+              <a:t>2026-08-27</a:t>
             </a:fld>
             <a:endParaRPr lang="en-CA"/>
           </a:p>
@@ -3547,7 +3547,7 @@
           <a:p>
             <a:fld id="{643EFF56-2492-48E5-B1E7-E04EEB44BBAA}" type="datetimeFigureOut">
               <a:rPr lang="en-CA" smtClean="0"/>
-              <a:t>2026-08-25</a:t>
+              <a:t>2026-08-27</a:t>
             </a:fld>
             <a:endParaRPr lang="en-CA"/>
           </a:p>
@@ -3790,7 +3790,7 @@
           <a:p>
             <a:fld id="{643EFF56-2492-48E5-B1E7-E04EEB44BBAA}" type="datetimeFigureOut">
               <a:rPr lang="en-CA" smtClean="0"/>
-              <a:t>2026-08-25</a:t>
+              <a:t>2026-08-27</a:t>
             </a:fld>
             <a:endParaRPr lang="en-CA"/>
           </a:p>
@@ -8256,10 +8256,10 @@
         </p:nvGrpSpPr>
         <p:grpSpPr>
           <a:xfrm>
-            <a:off x="0" y="1138494"/>
-            <a:ext cx="12192000" cy="5363909"/>
-            <a:chOff x="0" y="856370"/>
-            <a:chExt cx="12192000" cy="5363909"/>
+            <a:off x="0" y="1182845"/>
+            <a:ext cx="12192000" cy="5319558"/>
+            <a:chOff x="0" y="900721"/>
+            <a:chExt cx="12192000" cy="5319558"/>
           </a:xfrm>
         </p:grpSpPr>
         <p:pic>
@@ -8313,7 +8313,7 @@
           </p:nvSpPr>
           <p:spPr>
             <a:xfrm>
-              <a:off x="138107" y="856370"/>
+              <a:off x="138107" y="900721"/>
               <a:ext cx="3128968" cy="923330"/>
             </a:xfrm>
             <a:prstGeom prst="rect">
@@ -8381,7 +8381,7 @@
           </p:nvSpPr>
           <p:spPr>
             <a:xfrm>
-              <a:off x="8782054" y="856370"/>
+              <a:off x="8782054" y="900721"/>
               <a:ext cx="2876551" cy="923330"/>
             </a:xfrm>
             <a:prstGeom prst="rect">
@@ -8957,6 +8957,14 @@
 <file path=ppt/slides/slide13.xml><?xml version="1.0" encoding="utf-8"?>
 <p:sld xmlns:a="http://schemas.openxmlformats.org/drawingml/2006/main" xmlns:r="http://schemas.openxmlformats.org/officeDocument/2006/relationships" xmlns:p="http://schemas.openxmlformats.org/presentationml/2006/main">
   <p:cSld>
+    <p:bg>
+      <p:bgPr>
+        <a:solidFill>
+          <a:srgbClr val="181A1B"/>
+        </a:solidFill>
+        <a:effectLst/>
+      </p:bgPr>
+    </p:bg>
     <p:spTree>
       <p:nvGrpSpPr>
         <p:cNvPr id="1" name="">
@@ -8979,10 +8987,158 @@
       </p:grpSpPr>
       <p:sp>
         <p:nvSpPr>
-          <p:cNvPr id="4" name="TextBox 3">
-            <a:extLst>
-              <a:ext uri="{FF2B5EF4-FFF2-40B4-BE49-F238E27FC236}">
-                <a16:creationId xmlns:a16="http://schemas.microsoft.com/office/drawing/2014/main" id="{E25B8F64-2811-4671-34C4-817BB60EB7E9}"/>
+          <p:cNvPr id="3" name="Rectangle: Rounded Corners 2">
+            <a:extLst>
+              <a:ext uri="{FF2B5EF4-FFF2-40B4-BE49-F238E27FC236}">
+                <a16:creationId xmlns:a16="http://schemas.microsoft.com/office/drawing/2014/main" id="{8E94D014-05EB-4912-E4AC-F47F045C91D7}"/>
+              </a:ext>
+            </a:extLst>
+          </p:cNvPr>
+          <p:cNvSpPr/>
+          <p:nvPr/>
+        </p:nvSpPr>
+        <p:spPr>
+          <a:xfrm>
+            <a:off x="315257" y="-5932"/>
+            <a:ext cx="9363581" cy="628742"/>
+          </a:xfrm>
+          <a:prstGeom prst="roundRect">
+            <a:avLst/>
+          </a:prstGeom>
+          <a:solidFill>
+            <a:srgbClr val="0162B3"/>
+          </a:solidFill>
+          <a:ln>
+            <a:solidFill>
+              <a:srgbClr val="0162B3"/>
+            </a:solidFill>
+          </a:ln>
+        </p:spPr>
+        <p:style>
+          <a:lnRef idx="2">
+            <a:schemeClr val="accent1">
+              <a:shade val="50000"/>
+            </a:schemeClr>
+          </a:lnRef>
+          <a:fillRef idx="1">
+            <a:schemeClr val="accent1"/>
+          </a:fillRef>
+          <a:effectRef idx="0">
+            <a:schemeClr val="accent1"/>
+          </a:effectRef>
+          <a:fontRef idx="minor">
+            <a:schemeClr val="lt1"/>
+          </a:fontRef>
+        </p:style>
+        <p:txBody>
+          <a:bodyPr rtlCol="0" anchor="ctr"/>
+          <a:lstStyle>
+            <a:defPPr>
+              <a:defRPr lang="en-US"/>
+            </a:defPPr>
+            <a:lvl1pPr marL="0" algn="l" defTabSz="914400" rtl="0" eaLnBrk="1" latinLnBrk="0" hangingPunct="1">
+              <a:defRPr sz="1800" kern="1200">
+                <a:solidFill>
+                  <a:schemeClr val="lt1"/>
+                </a:solidFill>
+                <a:latin typeface="+mn-lt"/>
+                <a:ea typeface="+mn-ea"/>
+                <a:cs typeface="+mn-cs"/>
+              </a:defRPr>
+            </a:lvl1pPr>
+            <a:lvl2pPr marL="457200" algn="l" defTabSz="914400" rtl="0" eaLnBrk="1" latinLnBrk="0" hangingPunct="1">
+              <a:defRPr sz="1800" kern="1200">
+                <a:solidFill>
+                  <a:schemeClr val="lt1"/>
+                </a:solidFill>
+                <a:latin typeface="+mn-lt"/>
+                <a:ea typeface="+mn-ea"/>
+                <a:cs typeface="+mn-cs"/>
+              </a:defRPr>
+            </a:lvl2pPr>
+            <a:lvl3pPr marL="914400" algn="l" defTabSz="914400" rtl="0" eaLnBrk="1" latinLnBrk="0" hangingPunct="1">
+              <a:defRPr sz="1800" kern="1200">
+                <a:solidFill>
+                  <a:schemeClr val="lt1"/>
+                </a:solidFill>
+                <a:latin typeface="+mn-lt"/>
+                <a:ea typeface="+mn-ea"/>
+                <a:cs typeface="+mn-cs"/>
+              </a:defRPr>
+            </a:lvl3pPr>
+            <a:lvl4pPr marL="1371600" algn="l" defTabSz="914400" rtl="0" eaLnBrk="1" latinLnBrk="0" hangingPunct="1">
+              <a:defRPr sz="1800" kern="1200">
+                <a:solidFill>
+                  <a:schemeClr val="lt1"/>
+                </a:solidFill>
+                <a:latin typeface="+mn-lt"/>
+                <a:ea typeface="+mn-ea"/>
+                <a:cs typeface="+mn-cs"/>
+              </a:defRPr>
+            </a:lvl4pPr>
+            <a:lvl5pPr marL="1828800" algn="l" defTabSz="914400" rtl="0" eaLnBrk="1" latinLnBrk="0" hangingPunct="1">
+              <a:defRPr sz="1800" kern="1200">
+                <a:solidFill>
+                  <a:schemeClr val="lt1"/>
+                </a:solidFill>
+                <a:latin typeface="+mn-lt"/>
+                <a:ea typeface="+mn-ea"/>
+                <a:cs typeface="+mn-cs"/>
+              </a:defRPr>
+            </a:lvl5pPr>
+            <a:lvl6pPr marL="2286000" algn="l" defTabSz="914400" rtl="0" eaLnBrk="1" latinLnBrk="0" hangingPunct="1">
+              <a:defRPr sz="1800" kern="1200">
+                <a:solidFill>
+                  <a:schemeClr val="lt1"/>
+                </a:solidFill>
+                <a:latin typeface="+mn-lt"/>
+                <a:ea typeface="+mn-ea"/>
+                <a:cs typeface="+mn-cs"/>
+              </a:defRPr>
+            </a:lvl6pPr>
+            <a:lvl7pPr marL="2743200" algn="l" defTabSz="914400" rtl="0" eaLnBrk="1" latinLnBrk="0" hangingPunct="1">
+              <a:defRPr sz="1800" kern="1200">
+                <a:solidFill>
+                  <a:schemeClr val="lt1"/>
+                </a:solidFill>
+                <a:latin typeface="+mn-lt"/>
+                <a:ea typeface="+mn-ea"/>
+                <a:cs typeface="+mn-cs"/>
+              </a:defRPr>
+            </a:lvl7pPr>
+            <a:lvl8pPr marL="3200400" algn="l" defTabSz="914400" rtl="0" eaLnBrk="1" latinLnBrk="0" hangingPunct="1">
+              <a:defRPr sz="1800" kern="1200">
+                <a:solidFill>
+                  <a:schemeClr val="lt1"/>
+                </a:solidFill>
+                <a:latin typeface="+mn-lt"/>
+                <a:ea typeface="+mn-ea"/>
+                <a:cs typeface="+mn-cs"/>
+              </a:defRPr>
+            </a:lvl8pPr>
+            <a:lvl9pPr marL="3657600" algn="l" defTabSz="914400" rtl="0" eaLnBrk="1" latinLnBrk="0" hangingPunct="1">
+              <a:defRPr sz="1800" kern="1200">
+                <a:solidFill>
+                  <a:schemeClr val="lt1"/>
+                </a:solidFill>
+                <a:latin typeface="+mn-lt"/>
+                <a:ea typeface="+mn-ea"/>
+                <a:cs typeface="+mn-cs"/>
+              </a:defRPr>
+            </a:lvl9pPr>
+          </a:lstStyle>
+          <a:p>
+            <a:pPr algn="ctr"/>
+            <a:endParaRPr lang="en-CA"/>
+          </a:p>
+        </p:txBody>
+      </p:sp>
+      <p:sp>
+        <p:nvSpPr>
+          <p:cNvPr id="6" name="TextBox 5">
+            <a:extLst>
+              <a:ext uri="{FF2B5EF4-FFF2-40B4-BE49-F238E27FC236}">
+                <a16:creationId xmlns:a16="http://schemas.microsoft.com/office/drawing/2014/main" id="{242325C7-E0C4-083A-3A93-556D9339CE5A}"/>
               </a:ext>
             </a:extLst>
           </p:cNvPr>
@@ -8991,8 +9147,8 @@
         </p:nvSpPr>
         <p:spPr>
           <a:xfrm>
-            <a:off x="381000" y="215900"/>
-            <a:ext cx="7581900" cy="369332"/>
+            <a:off x="527959" y="62217"/>
+            <a:ext cx="8710932" cy="492443"/>
           </a:xfrm>
           <a:prstGeom prst="rect">
             <a:avLst/>
@@ -9006,12 +9162,511 @@
           <a:lstStyle/>
           <a:p>
             <a:r>
+              <a:rPr lang="en-US" sz="2600" b="1" dirty="0">
+                <a:solidFill>
+                  <a:schemeClr val="bg1"/>
+                </a:solidFill>
+                <a:latin typeface="Georgia Pro" panose="02040502050405020303" pitchFamily="18" charset="0"/>
+              </a:rPr>
+              <a:t>A0A7P0TB94-A0A509EDC2</a:t>
+            </a:r>
+            <a:endParaRPr lang="en-CA" sz="2600" b="1" dirty="0">
+              <a:solidFill>
+                <a:schemeClr val="bg1"/>
+              </a:solidFill>
+              <a:latin typeface="Georgia Pro" panose="02040502050405020303" pitchFamily="18" charset="0"/>
+            </a:endParaRPr>
+          </a:p>
+        </p:txBody>
+      </p:sp>
+      <p:pic>
+        <p:nvPicPr>
+          <p:cNvPr id="8" name="Picture 7">
+            <a:extLst>
+              <a:ext uri="{FF2B5EF4-FFF2-40B4-BE49-F238E27FC236}">
+                <a16:creationId xmlns:a16="http://schemas.microsoft.com/office/drawing/2014/main" id="{E54A5418-024A-5D58-722B-4F7E96F9E535}"/>
+              </a:ext>
+            </a:extLst>
+          </p:cNvPr>
+          <p:cNvPicPr>
+            <a:picLocks noChangeAspect="1"/>
+          </p:cNvPicPr>
+          <p:nvPr/>
+        </p:nvPicPr>
+        <p:blipFill>
+          <a:blip r:embed="rId2">
+            <a:extLst>
+              <a:ext uri="{28A0092B-C50C-407E-A947-70E740481C1C}">
+                <a14:useLocalDpi xmlns:a14="http://schemas.microsoft.com/office/drawing/2010/main" val="0"/>
+              </a:ext>
+            </a:extLst>
+          </a:blip>
+          <a:srcRect t="34618"/>
+          <a:stretch>
+            <a:fillRect/>
+          </a:stretch>
+        </p:blipFill>
+        <p:spPr>
+          <a:xfrm>
+            <a:off x="0" y="3871608"/>
+            <a:ext cx="12192000" cy="2924175"/>
+          </a:xfrm>
+          <a:prstGeom prst="rect">
+            <a:avLst/>
+          </a:prstGeom>
+        </p:spPr>
+      </p:pic>
+      <p:sp>
+        <p:nvSpPr>
+          <p:cNvPr id="10" name="TextBox 9">
+            <a:extLst>
+              <a:ext uri="{FF2B5EF4-FFF2-40B4-BE49-F238E27FC236}">
+                <a16:creationId xmlns:a16="http://schemas.microsoft.com/office/drawing/2014/main" id="{0686B55F-AEA1-0C90-1799-8ABB02320248}"/>
+              </a:ext>
+            </a:extLst>
+          </p:cNvPr>
+          <p:cNvSpPr txBox="1"/>
+          <p:nvPr/>
+        </p:nvSpPr>
+        <p:spPr>
+          <a:xfrm>
+            <a:off x="128582" y="1187351"/>
+            <a:ext cx="3128968" cy="923330"/>
+          </a:xfrm>
+          <a:prstGeom prst="rect">
+            <a:avLst/>
+          </a:prstGeom>
+          <a:noFill/>
+        </p:spPr>
+        <p:txBody>
+          <a:bodyPr wrap="square" rtlCol="0">
+            <a:spAutoFit/>
+          </a:bodyPr>
+          <a:lstStyle/>
+          <a:p>
+            <a:r>
               <a:rPr lang="en-US" dirty="0">
+                <a:solidFill>
+                  <a:schemeClr val="bg1"/>
+                </a:solidFill>
                 <a:latin typeface="Verdana Pro" panose="020B0604030504040204" pitchFamily="34" charset="0"/>
               </a:rPr>
-              <a:t>Worked example: strong homology, low sequence homology</a:t>
+              <a:t>A0A7P0TB94</a:t>
+            </a:r>
+          </a:p>
+          <a:p>
+            <a:r>
+              <a:rPr lang="en-US" dirty="0">
+                <a:solidFill>
+                  <a:schemeClr val="bg1"/>
+                </a:solidFill>
+                <a:latin typeface="Verdana Pro" panose="020B0604030504040204" pitchFamily="34" charset="0"/>
+              </a:rPr>
+              <a:t>DDX20</a:t>
+            </a:r>
+          </a:p>
+          <a:p>
+            <a:r>
+              <a:rPr lang="en-US" dirty="0">
+                <a:solidFill>
+                  <a:schemeClr val="bg1"/>
+                </a:solidFill>
+                <a:latin typeface="Verdana Pro" panose="020B0604030504040204" pitchFamily="34" charset="0"/>
+              </a:rPr>
+              <a:t>RNA helicase</a:t>
             </a:r>
             <a:endParaRPr lang="en-CA" dirty="0">
+              <a:solidFill>
+                <a:schemeClr val="bg1"/>
+              </a:solidFill>
+              <a:latin typeface="Verdana Pro" panose="020B0604030504040204" pitchFamily="34" charset="0"/>
+            </a:endParaRPr>
+          </a:p>
+        </p:txBody>
+      </p:sp>
+      <p:sp>
+        <p:nvSpPr>
+          <p:cNvPr id="12" name="TextBox 11">
+            <a:extLst>
+              <a:ext uri="{FF2B5EF4-FFF2-40B4-BE49-F238E27FC236}">
+                <a16:creationId xmlns:a16="http://schemas.microsoft.com/office/drawing/2014/main" id="{70C6F725-7D36-EC74-8CBF-702E302E6210}"/>
+              </a:ext>
+            </a:extLst>
+          </p:cNvPr>
+          <p:cNvSpPr txBox="1"/>
+          <p:nvPr/>
+        </p:nvSpPr>
+        <p:spPr>
+          <a:xfrm>
+            <a:off x="8782054" y="1138494"/>
+            <a:ext cx="2876551" cy="923330"/>
+          </a:xfrm>
+          <a:prstGeom prst="rect">
+            <a:avLst/>
+          </a:prstGeom>
+          <a:noFill/>
+        </p:spPr>
+        <p:txBody>
+          <a:bodyPr wrap="square" rtlCol="0">
+            <a:spAutoFit/>
+          </a:bodyPr>
+          <a:lstStyle/>
+          <a:p>
+            <a:r>
+              <a:rPr lang="en-US" dirty="0">
+                <a:solidFill>
+                  <a:schemeClr val="bg1"/>
+                </a:solidFill>
+                <a:latin typeface="Verdana Pro" panose="020B0604030504040204" pitchFamily="34" charset="0"/>
+              </a:rPr>
+              <a:t>A0A509EDC2</a:t>
+            </a:r>
+          </a:p>
+          <a:p>
+            <a:r>
+              <a:rPr lang="en-US" dirty="0">
+                <a:solidFill>
+                  <a:schemeClr val="bg1"/>
+                </a:solidFill>
+                <a:latin typeface="Verdana Pro" panose="020B0604030504040204" pitchFamily="34" charset="0"/>
+              </a:rPr>
+              <a:t>Shango system</a:t>
+            </a:r>
+          </a:p>
+          <a:p>
+            <a:r>
+              <a:rPr lang="en-US" dirty="0">
+                <a:solidFill>
+                  <a:schemeClr val="bg1"/>
+                </a:solidFill>
+                <a:latin typeface="Verdana Pro" panose="020B0604030504040204" pitchFamily="34" charset="0"/>
+              </a:rPr>
+              <a:t>Helicase HelY, SngC</a:t>
+            </a:r>
+            <a:endParaRPr lang="en-CA" dirty="0">
+              <a:solidFill>
+                <a:schemeClr val="bg1"/>
+              </a:solidFill>
+              <a:latin typeface="Verdana Pro" panose="020B0604030504040204" pitchFamily="34" charset="0"/>
+            </a:endParaRPr>
+          </a:p>
+        </p:txBody>
+      </p:sp>
+      <p:sp>
+        <p:nvSpPr>
+          <p:cNvPr id="14" name="TextBox 13">
+            <a:extLst>
+              <a:ext uri="{FF2B5EF4-FFF2-40B4-BE49-F238E27FC236}">
+                <a16:creationId xmlns:a16="http://schemas.microsoft.com/office/drawing/2014/main" id="{6D99D806-1557-7763-4650-1BCADEB87BD0}"/>
+              </a:ext>
+            </a:extLst>
+          </p:cNvPr>
+          <p:cNvSpPr txBox="1"/>
+          <p:nvPr/>
+        </p:nvSpPr>
+        <p:spPr>
+          <a:xfrm>
+            <a:off x="3405181" y="1187351"/>
+            <a:ext cx="4581526" cy="923330"/>
+          </a:xfrm>
+          <a:prstGeom prst="rect">
+            <a:avLst/>
+          </a:prstGeom>
+          <a:noFill/>
+        </p:spPr>
+        <p:txBody>
+          <a:bodyPr wrap="square" rtlCol="0">
+            <a:spAutoFit/>
+          </a:bodyPr>
+          <a:lstStyle/>
+          <a:p>
+            <a:r>
+              <a:rPr lang="en-US" dirty="0">
+                <a:solidFill>
+                  <a:schemeClr val="bg1"/>
+                </a:solidFill>
+                <a:latin typeface="Verdana Pro" panose="020B0604030504040204" pitchFamily="34" charset="0"/>
+              </a:rPr>
+              <a:t>Composite score: 0.87</a:t>
+            </a:r>
+          </a:p>
+          <a:p>
+            <a:r>
+              <a:rPr lang="en-US" dirty="0">
+                <a:solidFill>
+                  <a:schemeClr val="bg1"/>
+                </a:solidFill>
+                <a:latin typeface="Verdana Pro" panose="020B0604030504040204" pitchFamily="34" charset="0"/>
+              </a:rPr>
+              <a:t>FoldSeek e-value: 1.10e-17</a:t>
+            </a:r>
+          </a:p>
+          <a:p>
+            <a:r>
+              <a:rPr lang="en-US" dirty="0">
+                <a:solidFill>
+                  <a:schemeClr val="bg1"/>
+                </a:solidFill>
+                <a:latin typeface="Verdana Pro" panose="020B0604030504040204" pitchFamily="34" charset="0"/>
+              </a:rPr>
+              <a:t>PyMOL RMSD: 2.81 Å</a:t>
+            </a:r>
+            <a:endParaRPr lang="en-CA" dirty="0">
+              <a:solidFill>
+                <a:schemeClr val="bg1"/>
+              </a:solidFill>
+              <a:latin typeface="Verdana Pro" panose="020B0604030504040204" pitchFamily="34" charset="0"/>
+            </a:endParaRPr>
+          </a:p>
+        </p:txBody>
+      </p:sp>
+      <p:sp>
+        <p:nvSpPr>
+          <p:cNvPr id="16" name="TextBox 15">
+            <a:extLst>
+              <a:ext uri="{FF2B5EF4-FFF2-40B4-BE49-F238E27FC236}">
+                <a16:creationId xmlns:a16="http://schemas.microsoft.com/office/drawing/2014/main" id="{375A44BE-0F4F-FD1C-BF53-1C3E64EAC09F}"/>
+              </a:ext>
+            </a:extLst>
+          </p:cNvPr>
+          <p:cNvSpPr txBox="1"/>
+          <p:nvPr/>
+        </p:nvSpPr>
+        <p:spPr>
+          <a:xfrm>
+            <a:off x="3407783" y="2164700"/>
+            <a:ext cx="4976598" cy="1323439"/>
+          </a:xfrm>
+          <a:prstGeom prst="rect">
+            <a:avLst/>
+          </a:prstGeom>
+          <a:noFill/>
+        </p:spPr>
+        <p:txBody>
+          <a:bodyPr wrap="square" rtlCol="0">
+            <a:spAutoFit/>
+          </a:bodyPr>
+          <a:lstStyle/>
+          <a:p>
+            <a:pPr marL="285750" indent="-285750">
+              <a:spcAft>
+                <a:spcPts val="600"/>
+              </a:spcAft>
+              <a:buFont typeface="Arial" panose="020B0604020202020204" pitchFamily="34" charset="0"/>
+              <a:buChar char="•"/>
+            </a:pPr>
+            <a:r>
+              <a:rPr lang="en-US" sz="1400" dirty="0">
+                <a:solidFill>
+                  <a:schemeClr val="bg1"/>
+                </a:solidFill>
+                <a:latin typeface="Verdana Pro" panose="020B0604030504040204" pitchFamily="34" charset="0"/>
+              </a:rPr>
+              <a:t>Align at helicase and ATP hydrolase domains</a:t>
+            </a:r>
+          </a:p>
+          <a:p>
+            <a:pPr marL="285750" indent="-285750">
+              <a:spcAft>
+                <a:spcPts val="600"/>
+              </a:spcAft>
+              <a:buFont typeface="Arial" panose="020B0604020202020204" pitchFamily="34" charset="0"/>
+              <a:buChar char="•"/>
+            </a:pPr>
+            <a:r>
+              <a:rPr lang="en-US" sz="1400" dirty="0">
+                <a:solidFill>
+                  <a:schemeClr val="bg1"/>
+                </a:solidFill>
+                <a:latin typeface="Verdana Pro" panose="020B0604030504040204" pitchFamily="34" charset="0"/>
+              </a:rPr>
+              <a:t>HelY A0A509EDC2 has additional non-aligned domains that do not bear InterPro annotations</a:t>
+            </a:r>
+          </a:p>
+          <a:p>
+            <a:pPr marL="285750" indent="-285750">
+              <a:spcAft>
+                <a:spcPts val="600"/>
+              </a:spcAft>
+              <a:buFont typeface="Arial" panose="020B0604020202020204" pitchFamily="34" charset="0"/>
+              <a:buChar char="•"/>
+            </a:pPr>
+            <a:r>
+              <a:rPr lang="en-US" sz="1400" dirty="0">
+                <a:solidFill>
+                  <a:schemeClr val="bg1"/>
+                </a:solidFill>
+                <a:latin typeface="Verdana Pro" panose="020B0604030504040204" pitchFamily="34" charset="0"/>
+              </a:rPr>
+              <a:t>Orange region does not bear a CATH superfamily annotation</a:t>
+            </a:r>
+            <a:endParaRPr lang="en-CA" sz="1400" dirty="0">
+              <a:solidFill>
+                <a:schemeClr val="bg1"/>
+              </a:solidFill>
+              <a:latin typeface="Verdana Pro" panose="020B0604030504040204" pitchFamily="34" charset="0"/>
+            </a:endParaRPr>
+          </a:p>
+        </p:txBody>
+      </p:sp>
+      <p:sp>
+        <p:nvSpPr>
+          <p:cNvPr id="18" name="TextBox 17">
+            <a:extLst>
+              <a:ext uri="{FF2B5EF4-FFF2-40B4-BE49-F238E27FC236}">
+                <a16:creationId xmlns:a16="http://schemas.microsoft.com/office/drawing/2014/main" id="{339C67CA-DD8E-FA87-1F15-2AE4A8EF40BD}"/>
+              </a:ext>
+            </a:extLst>
+          </p:cNvPr>
+          <p:cNvSpPr txBox="1"/>
+          <p:nvPr/>
+        </p:nvSpPr>
+        <p:spPr>
+          <a:xfrm>
+            <a:off x="8782054" y="2155595"/>
+            <a:ext cx="2876551" cy="1677382"/>
+          </a:xfrm>
+          <a:prstGeom prst="rect">
+            <a:avLst/>
+          </a:prstGeom>
+          <a:noFill/>
+        </p:spPr>
+        <p:txBody>
+          <a:bodyPr wrap="square" rtlCol="0">
+            <a:spAutoFit/>
+          </a:bodyPr>
+          <a:lstStyle/>
+          <a:p>
+            <a:pPr marL="285750" indent="-285750">
+              <a:spcAft>
+                <a:spcPts val="600"/>
+              </a:spcAft>
+              <a:buFont typeface="Arial" panose="020B0604020202020204" pitchFamily="34" charset="0"/>
+              <a:buChar char="•"/>
+            </a:pPr>
+            <a:r>
+              <a:rPr lang="en-US" sz="1400" dirty="0">
+                <a:solidFill>
+                  <a:schemeClr val="bg1"/>
+                </a:solidFill>
+                <a:latin typeface="Verdana Pro" panose="020B0604030504040204" pitchFamily="34" charset="0"/>
+              </a:rPr>
+              <a:t>ATP-dependent helicase (sometimes called SngC) required for SngA, SngB activity</a:t>
+            </a:r>
+          </a:p>
+          <a:p>
+            <a:pPr marL="285750" indent="-285750">
+              <a:spcAft>
+                <a:spcPts val="600"/>
+              </a:spcAft>
+              <a:buFont typeface="Arial" panose="020B0604020202020204" pitchFamily="34" charset="0"/>
+              <a:buChar char="•"/>
+            </a:pPr>
+            <a:r>
+              <a:rPr lang="en-US" sz="1400" dirty="0">
+                <a:solidFill>
+                  <a:schemeClr val="bg1"/>
+                </a:solidFill>
+                <a:latin typeface="Verdana Pro" panose="020B0604030504040204" pitchFamily="34" charset="0"/>
+              </a:rPr>
+              <a:t>Proposed that SngA acts as a sensor, SngC effects antiviral response</a:t>
+            </a:r>
+          </a:p>
+        </p:txBody>
+      </p:sp>
+      <p:sp>
+        <p:nvSpPr>
+          <p:cNvPr id="20" name="TextBox 19">
+            <a:extLst>
+              <a:ext uri="{FF2B5EF4-FFF2-40B4-BE49-F238E27FC236}">
+                <a16:creationId xmlns:a16="http://schemas.microsoft.com/office/drawing/2014/main" id="{DDD941F2-CB94-DFE2-8DFA-E8A593E0BD24}"/>
+              </a:ext>
+            </a:extLst>
+          </p:cNvPr>
+          <p:cNvSpPr txBox="1"/>
+          <p:nvPr/>
+        </p:nvSpPr>
+        <p:spPr>
+          <a:xfrm>
+            <a:off x="130957" y="2110681"/>
+            <a:ext cx="2876551" cy="2185214"/>
+          </a:xfrm>
+          <a:prstGeom prst="rect">
+            <a:avLst/>
+          </a:prstGeom>
+          <a:noFill/>
+        </p:spPr>
+        <p:txBody>
+          <a:bodyPr wrap="square" rtlCol="0">
+            <a:spAutoFit/>
+          </a:bodyPr>
+          <a:lstStyle/>
+          <a:p>
+            <a:pPr marL="285750" indent="-285750">
+              <a:spcAft>
+                <a:spcPts val="600"/>
+              </a:spcAft>
+              <a:buFont typeface="Arial" panose="020B0604020202020204" pitchFamily="34" charset="0"/>
+              <a:buChar char="•"/>
+            </a:pPr>
+            <a:r>
+              <a:rPr lang="en-US" sz="1400" dirty="0">
+                <a:solidFill>
+                  <a:schemeClr val="bg1"/>
+                </a:solidFill>
+                <a:latin typeface="Verdana Pro" panose="020B0604030504040204" pitchFamily="34" charset="0"/>
+              </a:rPr>
+              <a:t>ATP-dependent DEAD-box helicase</a:t>
+            </a:r>
+          </a:p>
+          <a:p>
+            <a:pPr marL="285750" indent="-285750">
+              <a:spcAft>
+                <a:spcPts val="600"/>
+              </a:spcAft>
+              <a:buFont typeface="Arial" panose="020B0604020202020204" pitchFamily="34" charset="0"/>
+              <a:buChar char="•"/>
+            </a:pPr>
+            <a:r>
+              <a:rPr lang="en-US" sz="1400" dirty="0">
+                <a:solidFill>
+                  <a:schemeClr val="bg1"/>
+                </a:solidFill>
+                <a:latin typeface="Verdana Pro" panose="020B0604030504040204" pitchFamily="34" charset="0"/>
+              </a:rPr>
+              <a:t>Participates in snRNP assembly for spliceosome-mediated pre-mRNA splicing</a:t>
+            </a:r>
+          </a:p>
+          <a:p>
+            <a:pPr marL="285750" indent="-285750">
+              <a:spcAft>
+                <a:spcPts val="600"/>
+              </a:spcAft>
+              <a:buFont typeface="Arial" panose="020B0604020202020204" pitchFamily="34" charset="0"/>
+              <a:buChar char="•"/>
+            </a:pPr>
+            <a:r>
+              <a:rPr lang="en-US" sz="1400" dirty="0">
+                <a:solidFill>
+                  <a:schemeClr val="bg1"/>
+                </a:solidFill>
+                <a:latin typeface="Verdana Pro" panose="020B0604030504040204" pitchFamily="34" charset="0"/>
+              </a:rPr>
+              <a:t>Exerts antiviral activity via transcriptional regulation in Vero E6 cells</a:t>
+            </a:r>
+            <a:r>
+              <a:rPr lang="en-US" sz="1400" baseline="30000" dirty="0">
+                <a:solidFill>
+                  <a:schemeClr val="bg1"/>
+                </a:solidFill>
+                <a:latin typeface="Verdana Pro" panose="020B0604030504040204" pitchFamily="34" charset="0"/>
+              </a:rPr>
+              <a:t>5</a:t>
+            </a:r>
+            <a:endParaRPr lang="en-US" sz="1400" dirty="0">
+              <a:solidFill>
+                <a:schemeClr val="bg1"/>
+              </a:solidFill>
               <a:latin typeface="Verdana Pro" panose="020B0604030504040204" pitchFamily="34" charset="0"/>
             </a:endParaRPr>
           </a:p>
@@ -9414,7 +10069,7 @@
         <p:spPr>
           <a:xfrm>
             <a:off x="527958" y="1146628"/>
-            <a:ext cx="9363581" cy="2046714"/>
+            <a:ext cx="9363581" cy="2554545"/>
           </a:xfrm>
           <a:prstGeom prst="rect">
             <a:avLst/>
@@ -9484,6 +10139,21 @@
                 <a:latin typeface="Verdana Pro" panose="020B0604030504040204" pitchFamily="34" charset="0"/>
               </a:rPr>
               <a:t>Flodman K, et al. In vitro Type II Restriction of Bacteriophage DNA With Modified Pyrimidines. Front Microbiol. 2020;11:604618. DOI: 10.3389/fmicb.2020.604618</a:t>
+            </a:r>
+          </a:p>
+          <a:p>
+            <a:pPr marL="342900" indent="-342900">
+              <a:spcAft>
+                <a:spcPts val="600"/>
+              </a:spcAft>
+              <a:buFont typeface="+mj-lt"/>
+              <a:buAutoNum type="arabicPeriod"/>
+            </a:pPr>
+            <a:r>
+              <a:rPr lang="en-CA" sz="1400" dirty="0">
+                <a:latin typeface="Verdana Pro" panose="020B0604030504040204" pitchFamily="34" charset="0"/>
+              </a:rPr>
+              <a:t>Chen Z, et al. DDX20 positively regulates the interferon pathway to inhibit viral infection. Antiviral Res. 2024;225:105875. DOI: 10.1016/j.antiviral.2024.105875</a:t>
             </a:r>
           </a:p>
         </p:txBody>
@@ -10388,8 +11058,8 @@
           </a:p>
         </p:txBody>
       </p:sp>
-      <mc:AlternateContent xmlns:mc="http://schemas.openxmlformats.org/markup-compatibility/2006">
-        <mc:Choice xmlns:a14="http://schemas.microsoft.com/office/drawing/2010/main" Requires="a14">
+      <mc:AlternateContent xmlns:mc="http://schemas.openxmlformats.org/markup-compatibility/2006" xmlns:a14="http://schemas.microsoft.com/office/drawing/2010/main">
+        <mc:Choice Requires="a14">
           <p:sp>
             <p:nvSpPr>
               <p:cNvPr id="13" name="TextBox 12">
@@ -10483,7 +11153,7 @@
             </p:txBody>
           </p:sp>
         </mc:Choice>
-        <mc:Fallback>
+        <mc:Fallback xmlns="">
           <p:sp>
             <p:nvSpPr>
               <p:cNvPr id="13" name="TextBox 12">
@@ -11846,8 +12516,8 @@
           </a:p>
         </p:txBody>
       </p:sp>
-      <mc:AlternateContent xmlns:mc="http://schemas.openxmlformats.org/markup-compatibility/2006">
-        <mc:Choice xmlns:a14="http://schemas.microsoft.com/office/drawing/2010/main" Requires="a14">
+      <mc:AlternateContent xmlns:mc="http://schemas.openxmlformats.org/markup-compatibility/2006" xmlns:a14="http://schemas.microsoft.com/office/drawing/2010/main">
+        <mc:Choice Requires="a14">
           <p:graphicFrame>
             <p:nvGraphicFramePr>
               <p:cNvPr id="6" name="Table 5">
@@ -12235,7 +12905,7 @@
             </a:graphic>
           </p:graphicFrame>
         </mc:Choice>
-        <mc:Fallback>
+        <mc:Fallback xmlns="">
           <p:graphicFrame>
             <p:nvGraphicFramePr>
               <p:cNvPr id="6" name="Table 5">
@@ -12603,8 +13273,8 @@
             </a:prstGeom>
           </p:spPr>
         </p:pic>
-        <mc:AlternateContent xmlns:mc="http://schemas.openxmlformats.org/markup-compatibility/2006">
-          <mc:Choice xmlns:a14="http://schemas.microsoft.com/office/drawing/2010/main" Requires="a14">
+        <mc:AlternateContent xmlns:mc="http://schemas.openxmlformats.org/markup-compatibility/2006" xmlns:a14="http://schemas.microsoft.com/office/drawing/2010/main">
+          <mc:Choice Requires="a14">
             <p:sp>
               <p:nvSpPr>
                 <p:cNvPr id="10" name="TextBox 9">
@@ -12633,6 +13303,7 @@
                 </a:bodyPr>
                 <a:lstStyle/>
                 <a:p>
+                  <a:pPr/>
                   <a14:m>
                     <m:oMathPara xmlns:m="http://schemas.openxmlformats.org/officeDocument/2006/math">
                       <m:oMath>
@@ -12722,7 +13393,7 @@
               </p:txBody>
             </p:sp>
           </mc:Choice>
-          <mc:Fallback>
+          <mc:Fallback xmlns="">
             <p:sp>
               <p:nvSpPr>
                 <p:cNvPr id="10" name="TextBox 9">
@@ -12887,8 +13558,8 @@
           </a:p>
         </p:txBody>
       </p:sp>
-      <mc:AlternateContent xmlns:mc="http://schemas.openxmlformats.org/markup-compatibility/2006">
-        <mc:Choice xmlns:a14="http://schemas.microsoft.com/office/drawing/2010/main" Requires="a14">
+      <mc:AlternateContent xmlns:mc="http://schemas.openxmlformats.org/markup-compatibility/2006" xmlns:a14="http://schemas.microsoft.com/office/drawing/2010/main">
+        <mc:Choice Requires="a14">
           <p:sp>
             <p:nvSpPr>
               <p:cNvPr id="19" name="TextBox 18">
@@ -13007,7 +13678,7 @@
             </p:txBody>
           </p:sp>
         </mc:Choice>
-        <mc:Fallback>
+        <mc:Fallback xmlns="">
           <p:sp>
             <p:nvSpPr>
               <p:cNvPr id="19" name="TextBox 18">
@@ -13052,8 +13723,8 @@
           </p:sp>
         </mc:Fallback>
       </mc:AlternateContent>
-      <mc:AlternateContent xmlns:mc="http://schemas.openxmlformats.org/markup-compatibility/2006">
-        <mc:Choice xmlns:a14="http://schemas.microsoft.com/office/drawing/2010/main" Requires="a14">
+      <mc:AlternateContent xmlns:mc="http://schemas.openxmlformats.org/markup-compatibility/2006" xmlns:a14="http://schemas.microsoft.com/office/drawing/2010/main">
+        <mc:Choice Requires="a14">
           <p:sp>
             <p:nvSpPr>
               <p:cNvPr id="2" name="TextBox 1">
@@ -13186,7 +13857,7 @@
             </p:txBody>
           </p:sp>
         </mc:Choice>
-        <mc:Fallback>
+        <mc:Fallback xmlns="">
           <p:sp>
             <p:nvSpPr>
               <p:cNvPr id="2" name="TextBox 1">
@@ -14021,8 +14692,8 @@
           </a:p>
         </p:txBody>
       </p:sp>
-      <mc:AlternateContent xmlns:mc="http://schemas.openxmlformats.org/markup-compatibility/2006">
-        <mc:Choice xmlns:a14="http://schemas.microsoft.com/office/drawing/2010/main" Requires="a14">
+      <mc:AlternateContent xmlns:mc="http://schemas.openxmlformats.org/markup-compatibility/2006" xmlns:a14="http://schemas.microsoft.com/office/drawing/2010/main">
+        <mc:Choice Requires="a14">
           <p:sp>
             <p:nvSpPr>
               <p:cNvPr id="19" name="TextBox 18">
@@ -14059,7 +14730,7 @@
                         <m:rPr>
                           <m:nor/>
                         </m:rPr>
-                        <a:rPr lang="en-US" dirty="0">
+                        <a:rPr lang="en-US" i="0" dirty="0">
                           <a:latin typeface="Verdana Pro" panose="020B0604030504040204" pitchFamily="34" charset="0"/>
                         </a:rPr>
                         <m:t>PyMOL RMSD (Å)</m:t>
@@ -14074,7 +14745,7 @@
             </p:txBody>
           </p:sp>
         </mc:Choice>
-        <mc:Fallback>
+        <mc:Fallback xmlns="">
           <p:sp>
             <p:nvSpPr>
               <p:cNvPr id="19" name="TextBox 18">
@@ -14156,8 +14827,8 @@
           </a:prstGeom>
         </p:spPr>
       </p:pic>
-      <mc:AlternateContent xmlns:mc="http://schemas.openxmlformats.org/markup-compatibility/2006">
-        <mc:Choice xmlns:a14="http://schemas.microsoft.com/office/drawing/2010/main" Requires="a14">
+      <mc:AlternateContent xmlns:mc="http://schemas.openxmlformats.org/markup-compatibility/2006" xmlns:a14="http://schemas.microsoft.com/office/drawing/2010/main">
+        <mc:Choice Requires="a14">
           <p:sp>
             <p:nvSpPr>
               <p:cNvPr id="27" name="TextBox 26">
@@ -14186,6 +14857,7 @@
               </a:bodyPr>
               <a:lstStyle/>
               <a:p>
+                <a:pPr/>
                 <a14:m>
                   <m:oMathPara xmlns:m="http://schemas.openxmlformats.org/officeDocument/2006/math">
                     <m:oMath>
@@ -14271,7 +14943,7 @@
             </p:txBody>
           </p:sp>
         </mc:Choice>
-        <mc:Fallback>
+        <mc:Fallback xmlns="">
           <p:sp>
             <p:nvSpPr>
               <p:cNvPr id="27" name="TextBox 26">
@@ -15185,8 +15857,8 @@
           </a:p>
         </p:txBody>
       </p:sp>
-      <mc:AlternateContent xmlns:mc="http://schemas.openxmlformats.org/markup-compatibility/2006">
-        <mc:Choice xmlns:a14="http://schemas.microsoft.com/office/drawing/2010/main" Requires="a14">
+      <mc:AlternateContent xmlns:mc="http://schemas.openxmlformats.org/markup-compatibility/2006" xmlns:a14="http://schemas.microsoft.com/office/drawing/2010/main">
+        <mc:Choice Requires="a14">
           <p:sp>
             <p:nvSpPr>
               <p:cNvPr id="47" name="TextBox 46">
@@ -15258,7 +15930,7 @@
                             <m:d>
                               <m:dPr>
                                 <m:ctrlPr>
-                                  <a:rPr lang="en-US" i="1">
+                                  <a:rPr lang="en-US" b="0" i="1" smtClean="0">
                                     <a:latin typeface="Cambria Math" panose="02040503050406030204" pitchFamily="18" charset="0"/>
                                   </a:rPr>
                                 </m:ctrlPr>
@@ -15371,7 +16043,7 @@
             </p:txBody>
           </p:sp>
         </mc:Choice>
-        <mc:Fallback>
+        <mc:Fallback xmlns="">
           <p:sp>
             <p:nvSpPr>
               <p:cNvPr id="47" name="TextBox 46">
@@ -15416,8 +16088,8 @@
           </p:sp>
         </mc:Fallback>
       </mc:AlternateContent>
-      <mc:AlternateContent xmlns:mc="http://schemas.openxmlformats.org/markup-compatibility/2006">
-        <mc:Choice xmlns:a14="http://schemas.microsoft.com/office/drawing/2010/main" Requires="a14">
+      <mc:AlternateContent xmlns:mc="http://schemas.openxmlformats.org/markup-compatibility/2006" xmlns:a14="http://schemas.microsoft.com/office/drawing/2010/main">
+        <mc:Choice Requires="a14">
           <p:sp>
             <p:nvSpPr>
               <p:cNvPr id="51" name="TextBox 50">
@@ -15538,7 +16210,7 @@
             </p:txBody>
           </p:sp>
         </mc:Choice>
-        <mc:Fallback>
+        <mc:Fallback xmlns="">
           <p:sp>
             <p:nvSpPr>
               <p:cNvPr id="51" name="TextBox 50">
@@ -15583,8 +16255,8 @@
           </p:sp>
         </mc:Fallback>
       </mc:AlternateContent>
-      <mc:AlternateContent xmlns:mc="http://schemas.openxmlformats.org/markup-compatibility/2006">
-        <mc:Choice xmlns:a14="http://schemas.microsoft.com/office/drawing/2010/main" Requires="a14">
+      <mc:AlternateContent xmlns:mc="http://schemas.openxmlformats.org/markup-compatibility/2006" xmlns:a14="http://schemas.microsoft.com/office/drawing/2010/main">
+        <mc:Choice Requires="a14">
           <p:sp>
             <p:nvSpPr>
               <p:cNvPr id="52" name="TextBox 51">
@@ -15613,6 +16285,7 @@
               </a:bodyPr>
               <a:lstStyle/>
               <a:p>
+                <a:pPr/>
                 <a14:m>
                   <m:oMathPara xmlns:m="http://schemas.openxmlformats.org/officeDocument/2006/math">
                     <m:oMath>
@@ -15631,7 +16304,7 @@
             </p:txBody>
           </p:sp>
         </mc:Choice>
-        <mc:Fallback>
+        <mc:Fallback xmlns="">
           <p:sp>
             <p:nvSpPr>
               <p:cNvPr id="52" name="TextBox 51">
@@ -15676,8 +16349,8 @@
           </p:sp>
         </mc:Fallback>
       </mc:AlternateContent>
-      <mc:AlternateContent xmlns:mc="http://schemas.openxmlformats.org/markup-compatibility/2006">
-        <mc:Choice xmlns:a14="http://schemas.microsoft.com/office/drawing/2010/main" Requires="a14">
+      <mc:AlternateContent xmlns:mc="http://schemas.openxmlformats.org/markup-compatibility/2006" xmlns:a14="http://schemas.microsoft.com/office/drawing/2010/main">
+        <mc:Choice Requires="a14">
           <p:sp>
             <p:nvSpPr>
               <p:cNvPr id="54" name="TextBox 53">
@@ -15725,7 +16398,7 @@
             </p:txBody>
           </p:sp>
         </mc:Choice>
-        <mc:Fallback>
+        <mc:Fallback xmlns="">
           <p:sp>
             <p:nvSpPr>
               <p:cNvPr id="54" name="TextBox 53">
@@ -15770,8 +16443,8 @@
           </p:sp>
         </mc:Fallback>
       </mc:AlternateContent>
-      <mc:AlternateContent xmlns:mc="http://schemas.openxmlformats.org/markup-compatibility/2006">
-        <mc:Choice xmlns:a14="http://schemas.microsoft.com/office/drawing/2010/main" Requires="a14">
+      <mc:AlternateContent xmlns:mc="http://schemas.openxmlformats.org/markup-compatibility/2006" xmlns:a14="http://schemas.microsoft.com/office/drawing/2010/main">
+        <mc:Choice Requires="a14">
           <p:sp>
             <p:nvSpPr>
               <p:cNvPr id="56" name="TextBox 55">
@@ -15819,7 +16492,7 @@
             </p:txBody>
           </p:sp>
         </mc:Choice>
-        <mc:Fallback>
+        <mc:Fallback xmlns="">
           <p:sp>
             <p:nvSpPr>
               <p:cNvPr id="56" name="TextBox 55">
@@ -15864,8 +16537,8 @@
           </p:sp>
         </mc:Fallback>
       </mc:AlternateContent>
-      <mc:AlternateContent xmlns:mc="http://schemas.openxmlformats.org/markup-compatibility/2006">
-        <mc:Choice xmlns:a14="http://schemas.microsoft.com/office/drawing/2010/main" Requires="a14">
+      <mc:AlternateContent xmlns:mc="http://schemas.openxmlformats.org/markup-compatibility/2006" xmlns:a14="http://schemas.microsoft.com/office/drawing/2010/main">
+        <mc:Choice Requires="a14">
           <p:sp>
             <p:nvSpPr>
               <p:cNvPr id="58" name="TextBox 57">
@@ -15913,7 +16586,7 @@
             </p:txBody>
           </p:sp>
         </mc:Choice>
-        <mc:Fallback>
+        <mc:Fallback xmlns="">
           <p:sp>
             <p:nvSpPr>
               <p:cNvPr id="58" name="TextBox 57">
@@ -15958,8 +16631,8 @@
           </p:sp>
         </mc:Fallback>
       </mc:AlternateContent>
-      <mc:AlternateContent xmlns:mc="http://schemas.openxmlformats.org/markup-compatibility/2006">
-        <mc:Choice xmlns:a14="http://schemas.microsoft.com/office/drawing/2010/main" Requires="a14">
+      <mc:AlternateContent xmlns:mc="http://schemas.openxmlformats.org/markup-compatibility/2006" xmlns:a14="http://schemas.microsoft.com/office/drawing/2010/main">
+        <mc:Choice Requires="a14">
           <p:sp>
             <p:nvSpPr>
               <p:cNvPr id="60" name="TextBox 59">
@@ -16007,7 +16680,7 @@
             </p:txBody>
           </p:sp>
         </mc:Choice>
-        <mc:Fallback>
+        <mc:Fallback xmlns="">
           <p:sp>
             <p:nvSpPr>
               <p:cNvPr id="60" name="TextBox 59">
@@ -16052,8 +16725,8 @@
           </p:sp>
         </mc:Fallback>
       </mc:AlternateContent>
-      <mc:AlternateContent xmlns:mc="http://schemas.openxmlformats.org/markup-compatibility/2006">
-        <mc:Choice xmlns:a14="http://schemas.microsoft.com/office/drawing/2010/main" Requires="a14">
+      <mc:AlternateContent xmlns:mc="http://schemas.openxmlformats.org/markup-compatibility/2006" xmlns:a14="http://schemas.microsoft.com/office/drawing/2010/main">
+        <mc:Choice Requires="a14">
           <p:sp>
             <p:nvSpPr>
               <p:cNvPr id="62" name="TextBox 61">
@@ -16101,7 +16774,7 @@
             </p:txBody>
           </p:sp>
         </mc:Choice>
-        <mc:Fallback>
+        <mc:Fallback xmlns="">
           <p:sp>
             <p:nvSpPr>
               <p:cNvPr id="62" name="TextBox 61">

</xml_diff>

<commit_message>
Assembled sequence homology findings for DDX20 / HelY (Shango).
</commit_message>
<xml_diff>
--- a/reports/2026-08-28_projectUpdate_3/2026-08-28_projectUpdate_3_jmoran.pptx
+++ b/reports/2026-08-28_projectUpdate_3/2026-08-28_projectUpdate_3_jmoran.pptx
@@ -5,7 +5,7 @@
     <p:sldMasterId id="2147483648" r:id="rId1"/>
   </p:sldMasterIdLst>
   <p:notesMasterIdLst>
-    <p:notesMasterId r:id="rId18"/>
+    <p:notesMasterId r:id="rId17"/>
   </p:notesMasterIdLst>
   <p:sldIdLst>
     <p:sldId id="256" r:id="rId2"/>
@@ -21,9 +21,8 @@
     <p:sldId id="289" r:id="rId12"/>
     <p:sldId id="290" r:id="rId13"/>
     <p:sldId id="293" r:id="rId14"/>
-    <p:sldId id="294" r:id="rId15"/>
-    <p:sldId id="295" r:id="rId16"/>
-    <p:sldId id="296" r:id="rId17"/>
+    <p:sldId id="297" r:id="rId15"/>
+    <p:sldId id="296" r:id="rId16"/>
   </p:sldIdLst>
   <p:sldSz cx="12192000" cy="6858000"/>
   <p:notesSz cx="6858000" cy="9144000"/>
@@ -963,6 +962,323 @@
     <p:extLst>
       <p:ext uri="{BB962C8B-B14F-4D97-AF65-F5344CB8AC3E}">
         <p14:creationId xmlns:p14="http://schemas.microsoft.com/office/powerpoint/2010/main" val="905556161"/>
+      </p:ext>
+    </p:extLst>
+  </p:cSld>
+  <p:clrMapOvr>
+    <a:masterClrMapping/>
+  </p:clrMapOvr>
+</p:notes>
+</file>
+
+<file path=ppt/notesSlides/notesSlide5.xml><?xml version="1.0" encoding="utf-8"?>
+<p:notes xmlns:a="http://schemas.openxmlformats.org/drawingml/2006/main" xmlns:r="http://schemas.openxmlformats.org/officeDocument/2006/relationships" xmlns:p="http://schemas.openxmlformats.org/presentationml/2006/main">
+  <p:cSld>
+    <p:spTree>
+      <p:nvGrpSpPr>
+        <p:cNvPr id="1" name=""/>
+        <p:cNvGrpSpPr/>
+        <p:nvPr/>
+      </p:nvGrpSpPr>
+      <p:grpSpPr>
+        <a:xfrm>
+          <a:off x="0" y="0"/>
+          <a:ext cx="0" cy="0"/>
+          <a:chOff x="0" y="0"/>
+          <a:chExt cx="0" cy="0"/>
+        </a:xfrm>
+      </p:grpSpPr>
+      <p:sp>
+        <p:nvSpPr>
+          <p:cNvPr id="2" name="Slide Image Placeholder 1"/>
+          <p:cNvSpPr>
+            <a:spLocks noGrp="1" noRot="1" noChangeAspect="1"/>
+          </p:cNvSpPr>
+          <p:nvPr>
+            <p:ph type="sldImg"/>
+          </p:nvPr>
+        </p:nvSpPr>
+        <p:spPr/>
+      </p:sp>
+      <p:sp>
+        <p:nvSpPr>
+          <p:cNvPr id="3" name="Notes Placeholder 2"/>
+          <p:cNvSpPr>
+            <a:spLocks noGrp="1"/>
+          </p:cNvSpPr>
+          <p:nvPr>
+            <p:ph type="body" idx="1"/>
+          </p:nvPr>
+        </p:nvSpPr>
+        <p:spPr/>
+        <p:txBody>
+          <a:bodyPr/>
+          <a:lstStyle/>
+          <a:p>
+            <a:r>
+              <a:rPr lang="en-US" dirty="0">
+                <a:solidFill>
+                  <a:schemeClr val="bg1"/>
+                </a:solidFill>
+                <a:latin typeface="Verdana Pro" panose="020B0604030504040204" pitchFamily="34" charset="0"/>
+              </a:rPr>
+              <a:t>E4ZAF3 species</a:t>
+            </a:r>
+            <a:r>
+              <a:rPr lang="en-US" dirty="0"/>
+              <a:t>:  N. </a:t>
+            </a:r>
+            <a:r>
+              <a:rPr lang="en-US" dirty="0" err="1"/>
+              <a:t>lactamica</a:t>
+            </a:r>
+            <a:endParaRPr lang="en-CA" dirty="0"/>
+          </a:p>
+        </p:txBody>
+      </p:sp>
+      <p:sp>
+        <p:nvSpPr>
+          <p:cNvPr id="4" name="Slide Number Placeholder 3"/>
+          <p:cNvSpPr>
+            <a:spLocks noGrp="1"/>
+          </p:cNvSpPr>
+          <p:nvPr>
+            <p:ph type="sldNum" sz="quarter" idx="5"/>
+          </p:nvPr>
+        </p:nvSpPr>
+        <p:spPr/>
+        <p:txBody>
+          <a:bodyPr/>
+          <a:lstStyle/>
+          <a:p>
+            <a:fld id="{2E88BC55-598C-4AA3-BC46-22AAD297F918}" type="slidenum">
+              <a:rPr lang="en-CA" smtClean="0"/>
+              <a:t>12</a:t>
+            </a:fld>
+            <a:endParaRPr lang="en-CA"/>
+          </a:p>
+        </p:txBody>
+      </p:sp>
+    </p:spTree>
+    <p:extLst>
+      <p:ext uri="{BB962C8B-B14F-4D97-AF65-F5344CB8AC3E}">
+        <p14:creationId xmlns:p14="http://schemas.microsoft.com/office/powerpoint/2010/main" val="1135616694"/>
+      </p:ext>
+    </p:extLst>
+  </p:cSld>
+  <p:clrMapOvr>
+    <a:masterClrMapping/>
+  </p:clrMapOvr>
+</p:notes>
+</file>
+
+<file path=ppt/notesSlides/notesSlide6.xml><?xml version="1.0" encoding="utf-8"?>
+<p:notes xmlns:a="http://schemas.openxmlformats.org/drawingml/2006/main" xmlns:r="http://schemas.openxmlformats.org/officeDocument/2006/relationships" xmlns:p="http://schemas.openxmlformats.org/presentationml/2006/main">
+  <p:cSld>
+    <p:spTree>
+      <p:nvGrpSpPr>
+        <p:cNvPr id="1" name=""/>
+        <p:cNvGrpSpPr/>
+        <p:nvPr/>
+      </p:nvGrpSpPr>
+      <p:grpSpPr>
+        <a:xfrm>
+          <a:off x="0" y="0"/>
+          <a:ext cx="0" cy="0"/>
+          <a:chOff x="0" y="0"/>
+          <a:chExt cx="0" cy="0"/>
+        </a:xfrm>
+      </p:grpSpPr>
+      <p:sp>
+        <p:nvSpPr>
+          <p:cNvPr id="2" name="Slide Image Placeholder 1"/>
+          <p:cNvSpPr>
+            <a:spLocks noGrp="1" noRot="1" noChangeAspect="1"/>
+          </p:cNvSpPr>
+          <p:nvPr>
+            <p:ph type="sldImg"/>
+          </p:nvPr>
+        </p:nvSpPr>
+        <p:spPr/>
+      </p:sp>
+      <p:sp>
+        <p:nvSpPr>
+          <p:cNvPr id="3" name="Notes Placeholder 2"/>
+          <p:cNvSpPr>
+            <a:spLocks noGrp="1"/>
+          </p:cNvSpPr>
+          <p:nvPr>
+            <p:ph type="body" idx="1"/>
+          </p:nvPr>
+        </p:nvSpPr>
+        <p:spPr/>
+        <p:txBody>
+          <a:bodyPr/>
+          <a:lstStyle/>
+          <a:p>
+            <a:r>
+              <a:rPr lang="en-US" dirty="0"/>
+              <a:t>HelY species: </a:t>
+            </a:r>
+            <a:r>
+              <a:rPr lang="en-US" dirty="0" err="1"/>
+              <a:t>Methylobacterium</a:t>
+            </a:r>
+            <a:r>
+              <a:rPr lang="en-US" dirty="0"/>
+              <a:t> </a:t>
+            </a:r>
+            <a:r>
+              <a:rPr lang="en-US" dirty="0" err="1"/>
+              <a:t>symbioticum</a:t>
+            </a:r>
+            <a:endParaRPr lang="en-CA" dirty="0"/>
+          </a:p>
+        </p:txBody>
+      </p:sp>
+      <p:sp>
+        <p:nvSpPr>
+          <p:cNvPr id="4" name="Slide Number Placeholder 3"/>
+          <p:cNvSpPr>
+            <a:spLocks noGrp="1"/>
+          </p:cNvSpPr>
+          <p:nvPr>
+            <p:ph type="sldNum" sz="quarter" idx="5"/>
+          </p:nvPr>
+        </p:nvSpPr>
+        <p:spPr/>
+        <p:txBody>
+          <a:bodyPr/>
+          <a:lstStyle/>
+          <a:p>
+            <a:fld id="{2E88BC55-598C-4AA3-BC46-22AAD297F918}" type="slidenum">
+              <a:rPr lang="en-CA" smtClean="0"/>
+              <a:t>13</a:t>
+            </a:fld>
+            <a:endParaRPr lang="en-CA"/>
+          </a:p>
+        </p:txBody>
+      </p:sp>
+    </p:spTree>
+    <p:extLst>
+      <p:ext uri="{BB962C8B-B14F-4D97-AF65-F5344CB8AC3E}">
+        <p14:creationId xmlns:p14="http://schemas.microsoft.com/office/powerpoint/2010/main" val="840864145"/>
+      </p:ext>
+    </p:extLst>
+  </p:cSld>
+  <p:clrMapOvr>
+    <a:masterClrMapping/>
+  </p:clrMapOvr>
+</p:notes>
+</file>
+
+<file path=ppt/notesSlides/notesSlide7.xml><?xml version="1.0" encoding="utf-8"?>
+<p:notes xmlns:a="http://schemas.openxmlformats.org/drawingml/2006/main" xmlns:r="http://schemas.openxmlformats.org/officeDocument/2006/relationships" xmlns:p="http://schemas.openxmlformats.org/presentationml/2006/main">
+  <p:cSld>
+    <p:spTree>
+      <p:nvGrpSpPr>
+        <p:cNvPr id="1" name=""/>
+        <p:cNvGrpSpPr/>
+        <p:nvPr/>
+      </p:nvGrpSpPr>
+      <p:grpSpPr>
+        <a:xfrm>
+          <a:off x="0" y="0"/>
+          <a:ext cx="0" cy="0"/>
+          <a:chOff x="0" y="0"/>
+          <a:chExt cx="0" cy="0"/>
+        </a:xfrm>
+      </p:grpSpPr>
+      <p:sp>
+        <p:nvSpPr>
+          <p:cNvPr id="2" name="Slide Image Placeholder 1"/>
+          <p:cNvSpPr>
+            <a:spLocks noGrp="1" noRot="1" noChangeAspect="1"/>
+          </p:cNvSpPr>
+          <p:nvPr>
+            <p:ph type="sldImg"/>
+          </p:nvPr>
+        </p:nvSpPr>
+        <p:spPr/>
+      </p:sp>
+      <p:sp>
+        <p:nvSpPr>
+          <p:cNvPr id="3" name="Notes Placeholder 2"/>
+          <p:cNvSpPr>
+            <a:spLocks noGrp="1"/>
+          </p:cNvSpPr>
+          <p:nvPr>
+            <p:ph type="body" idx="1"/>
+          </p:nvPr>
+        </p:nvSpPr>
+        <p:spPr/>
+        <p:txBody>
+          <a:bodyPr/>
+          <a:lstStyle/>
+          <a:p>
+            <a:r>
+              <a:rPr lang="en-US" dirty="0"/>
+              <a:t>If I run </a:t>
+            </a:r>
+            <a:r>
+              <a:rPr lang="en-US" dirty="0" err="1"/>
+              <a:t>BLASTp</a:t>
+            </a:r>
+            <a:r>
+              <a:rPr lang="en-US" dirty="0"/>
+              <a:t> of the HelY sequence, DDX20 is not a hit.</a:t>
+            </a:r>
+          </a:p>
+          <a:p>
+            <a:r>
+              <a:rPr lang="en-US" dirty="0"/>
+              <a:t>If I run </a:t>
+            </a:r>
+            <a:r>
+              <a:rPr lang="en-US" dirty="0" err="1"/>
+              <a:t>psiBLAST</a:t>
+            </a:r>
+            <a:r>
+              <a:rPr lang="en-US" dirty="0"/>
+              <a:t> of the HelY sequence,  DDX20 is not a hit.</a:t>
+            </a:r>
+          </a:p>
+          <a:p>
+            <a:r>
+              <a:rPr lang="en-US" dirty="0"/>
+              <a:t>There is no literature evidence that I could find indicating that DDX20 and the HelY have either sequence of structural homology.</a:t>
+            </a:r>
+            <a:endParaRPr lang="en-CA" dirty="0"/>
+          </a:p>
+        </p:txBody>
+      </p:sp>
+      <p:sp>
+        <p:nvSpPr>
+          <p:cNvPr id="4" name="Slide Number Placeholder 3"/>
+          <p:cNvSpPr>
+            <a:spLocks noGrp="1"/>
+          </p:cNvSpPr>
+          <p:nvPr>
+            <p:ph type="sldNum" sz="quarter" idx="5"/>
+          </p:nvPr>
+        </p:nvSpPr>
+        <p:spPr/>
+        <p:txBody>
+          <a:bodyPr/>
+          <a:lstStyle/>
+          <a:p>
+            <a:fld id="{2E88BC55-598C-4AA3-BC46-22AAD297F918}" type="slidenum">
+              <a:rPr lang="en-CA" smtClean="0"/>
+              <a:t>14</a:t>
+            </a:fld>
+            <a:endParaRPr lang="en-CA"/>
+          </a:p>
+        </p:txBody>
+      </p:sp>
+    </p:spTree>
+    <p:extLst>
+      <p:ext uri="{BB962C8B-B14F-4D97-AF65-F5344CB8AC3E}">
+        <p14:creationId xmlns:p14="http://schemas.microsoft.com/office/powerpoint/2010/main" val="1404124294"/>
       </p:ext>
     </p:extLst>
   </p:cSld>
@@ -8277,7 +8593,7 @@
             <p:nvPr/>
           </p:nvPicPr>
           <p:blipFill>
-            <a:blip r:embed="rId2">
+            <a:blip r:embed="rId3">
               <a:extLst>
                 <a:ext uri="{28A0092B-C50C-407E-A947-70E740481C1C}">
                   <a14:useLocalDpi xmlns:a14="http://schemas.microsoft.com/office/drawing/2010/main" val="0"/>
@@ -9194,7 +9510,7 @@
           <p:nvPr/>
         </p:nvPicPr>
         <p:blipFill>
-          <a:blip r:embed="rId2">
+          <a:blip r:embed="rId3">
             <a:extLst>
               <a:ext uri="{28A0092B-C50C-407E-A947-70E740481C1C}">
                 <a14:useLocalDpi xmlns:a14="http://schemas.microsoft.com/office/drawing/2010/main" val="0"/>
@@ -9341,7 +9657,7 @@
                 </a:solidFill>
                 <a:latin typeface="Verdana Pro" panose="020B0604030504040204" pitchFamily="34" charset="0"/>
               </a:rPr>
-              <a:t>Helicase HelY, SngC</a:t>
+              <a:t>Helicase HelY (SngC?)</a:t>
             </a:r>
             <a:endParaRPr lang="en-CA" dirty="0">
               <a:solidFill>
@@ -9524,7 +9840,7 @@
         <p:spPr>
           <a:xfrm>
             <a:off x="8782054" y="2155595"/>
-            <a:ext cx="2876551" cy="1677382"/>
+            <a:ext cx="2876551" cy="1246495"/>
           </a:xfrm>
           <a:prstGeom prst="rect">
             <a:avLst/>
@@ -9551,7 +9867,7 @@
                 </a:solidFill>
                 <a:latin typeface="Verdana Pro" panose="020B0604030504040204" pitchFamily="34" charset="0"/>
               </a:rPr>
-              <a:t>ATP-dependent helicase (sometimes called SngC) required for SngA, SngB activity</a:t>
+              <a:t>ATP-dependent helicase</a:t>
             </a:r>
           </a:p>
           <a:p>
@@ -9569,7 +9885,7 @@
                 </a:solidFill>
                 <a:latin typeface="Verdana Pro" panose="020B0604030504040204" pitchFamily="34" charset="0"/>
               </a:rPr>
-              <a:t>Proposed that SngA acts as a sensor, SngC effects antiviral response</a:t>
+              <a:t>Proposed that SngA acts as a sensor, Shango helicase activates antiviral response</a:t>
             </a:r>
           </a:p>
         </p:txBody>
@@ -9688,12 +10004,20 @@
 <file path=ppt/slides/slide14.xml><?xml version="1.0" encoding="utf-8"?>
 <p:sld xmlns:a="http://schemas.openxmlformats.org/drawingml/2006/main" xmlns:r="http://schemas.openxmlformats.org/officeDocument/2006/relationships" xmlns:p="http://schemas.openxmlformats.org/presentationml/2006/main">
   <p:cSld>
+    <p:bg>
+      <p:bgPr>
+        <a:solidFill>
+          <a:srgbClr val="181A1B"/>
+        </a:solidFill>
+        <a:effectLst/>
+      </p:bgPr>
+    </p:bg>
     <p:spTree>
       <p:nvGrpSpPr>
         <p:cNvPr id="1" name="">
           <a:extLst>
             <a:ext uri="{FF2B5EF4-FFF2-40B4-BE49-F238E27FC236}">
-              <a16:creationId xmlns:a16="http://schemas.microsoft.com/office/drawing/2014/main" id="{ADF6FBCF-6996-7BE6-B15E-1A7B2134FC77}"/>
+              <a16:creationId xmlns:a16="http://schemas.microsoft.com/office/drawing/2014/main" id="{0D78CCD6-A90A-63F9-3A82-A75084EA2DBD}"/>
             </a:ext>
           </a:extLst>
         </p:cNvPr>
@@ -9708,12 +10032,228 @@
           <a:chExt cx="0" cy="0"/>
         </a:xfrm>
       </p:grpSpPr>
+      <p:pic>
+        <p:nvPicPr>
+          <p:cNvPr id="4" name="Picture 3">
+            <a:extLst>
+              <a:ext uri="{FF2B5EF4-FFF2-40B4-BE49-F238E27FC236}">
+                <a16:creationId xmlns:a16="http://schemas.microsoft.com/office/drawing/2014/main" id="{B0E69BB3-3796-09BD-E00C-B2AE5BA4F03F}"/>
+              </a:ext>
+            </a:extLst>
+          </p:cNvPr>
+          <p:cNvPicPr>
+            <a:picLocks noChangeAspect="1"/>
+          </p:cNvPicPr>
+          <p:nvPr/>
+        </p:nvPicPr>
+        <p:blipFill>
+          <a:blip r:embed="rId3"/>
+          <a:srcRect t="24647" b="-1"/>
+          <a:stretch>
+            <a:fillRect/>
+          </a:stretch>
+        </p:blipFill>
+        <p:spPr>
+          <a:xfrm>
+            <a:off x="0" y="3701600"/>
+            <a:ext cx="12192000" cy="3142673"/>
+          </a:xfrm>
+          <a:prstGeom prst="rect">
+            <a:avLst/>
+          </a:prstGeom>
+        </p:spPr>
+      </p:pic>
+      <p:pic>
+        <p:nvPicPr>
+          <p:cNvPr id="8" name="Picture 7">
+            <a:extLst>
+              <a:ext uri="{FF2B5EF4-FFF2-40B4-BE49-F238E27FC236}">
+                <a16:creationId xmlns:a16="http://schemas.microsoft.com/office/drawing/2014/main" id="{7D34E845-2754-4E53-933A-BDCBDC395309}"/>
+              </a:ext>
+            </a:extLst>
+          </p:cNvPr>
+          <p:cNvPicPr>
+            <a:picLocks noChangeAspect="1"/>
+          </p:cNvPicPr>
+          <p:nvPr/>
+        </p:nvPicPr>
+        <p:blipFill>
+          <a:blip r:embed="rId4">
+            <a:extLst>
+              <a:ext uri="{28A0092B-C50C-407E-A947-70E740481C1C}">
+                <a14:useLocalDpi xmlns:a14="http://schemas.microsoft.com/office/drawing/2010/main" val="0"/>
+              </a:ext>
+            </a:extLst>
+          </a:blip>
+          <a:srcRect t="34618"/>
+          <a:stretch>
+            <a:fillRect/>
+          </a:stretch>
+        </p:blipFill>
+        <p:spPr>
+          <a:xfrm>
+            <a:off x="0" y="777426"/>
+            <a:ext cx="12192000" cy="2924175"/>
+          </a:xfrm>
+          <a:prstGeom prst="rect">
+            <a:avLst/>
+          </a:prstGeom>
+        </p:spPr>
+      </p:pic>
       <p:sp>
         <p:nvSpPr>
-          <p:cNvPr id="4" name="TextBox 3">
-            <a:extLst>
-              <a:ext uri="{FF2B5EF4-FFF2-40B4-BE49-F238E27FC236}">
-                <a16:creationId xmlns:a16="http://schemas.microsoft.com/office/drawing/2014/main" id="{A0BF4CD7-59D5-B2D2-FA64-845C5B11662A}"/>
+          <p:cNvPr id="3" name="Rectangle: Rounded Corners 2">
+            <a:extLst>
+              <a:ext uri="{FF2B5EF4-FFF2-40B4-BE49-F238E27FC236}">
+                <a16:creationId xmlns:a16="http://schemas.microsoft.com/office/drawing/2014/main" id="{150698A4-C1AD-54BB-6545-50BC20230B0D}"/>
+              </a:ext>
+            </a:extLst>
+          </p:cNvPr>
+          <p:cNvSpPr/>
+          <p:nvPr/>
+        </p:nvSpPr>
+        <p:spPr>
+          <a:xfrm>
+            <a:off x="315257" y="-5932"/>
+            <a:ext cx="9363581" cy="628742"/>
+          </a:xfrm>
+          <a:prstGeom prst="roundRect">
+            <a:avLst/>
+          </a:prstGeom>
+          <a:solidFill>
+            <a:srgbClr val="0162B3"/>
+          </a:solidFill>
+          <a:ln>
+            <a:solidFill>
+              <a:srgbClr val="0162B3"/>
+            </a:solidFill>
+          </a:ln>
+        </p:spPr>
+        <p:style>
+          <a:lnRef idx="2">
+            <a:schemeClr val="accent1">
+              <a:shade val="50000"/>
+            </a:schemeClr>
+          </a:lnRef>
+          <a:fillRef idx="1">
+            <a:schemeClr val="accent1"/>
+          </a:fillRef>
+          <a:effectRef idx="0">
+            <a:schemeClr val="accent1"/>
+          </a:effectRef>
+          <a:fontRef idx="minor">
+            <a:schemeClr val="lt1"/>
+          </a:fontRef>
+        </p:style>
+        <p:txBody>
+          <a:bodyPr rtlCol="0" anchor="ctr"/>
+          <a:lstStyle>
+            <a:defPPr>
+              <a:defRPr lang="en-US"/>
+            </a:defPPr>
+            <a:lvl1pPr marL="0" algn="l" defTabSz="914400" rtl="0" eaLnBrk="1" latinLnBrk="0" hangingPunct="1">
+              <a:defRPr sz="1800" kern="1200">
+                <a:solidFill>
+                  <a:schemeClr val="lt1"/>
+                </a:solidFill>
+                <a:latin typeface="+mn-lt"/>
+                <a:ea typeface="+mn-ea"/>
+                <a:cs typeface="+mn-cs"/>
+              </a:defRPr>
+            </a:lvl1pPr>
+            <a:lvl2pPr marL="457200" algn="l" defTabSz="914400" rtl="0" eaLnBrk="1" latinLnBrk="0" hangingPunct="1">
+              <a:defRPr sz="1800" kern="1200">
+                <a:solidFill>
+                  <a:schemeClr val="lt1"/>
+                </a:solidFill>
+                <a:latin typeface="+mn-lt"/>
+                <a:ea typeface="+mn-ea"/>
+                <a:cs typeface="+mn-cs"/>
+              </a:defRPr>
+            </a:lvl2pPr>
+            <a:lvl3pPr marL="914400" algn="l" defTabSz="914400" rtl="0" eaLnBrk="1" latinLnBrk="0" hangingPunct="1">
+              <a:defRPr sz="1800" kern="1200">
+                <a:solidFill>
+                  <a:schemeClr val="lt1"/>
+                </a:solidFill>
+                <a:latin typeface="+mn-lt"/>
+                <a:ea typeface="+mn-ea"/>
+                <a:cs typeface="+mn-cs"/>
+              </a:defRPr>
+            </a:lvl3pPr>
+            <a:lvl4pPr marL="1371600" algn="l" defTabSz="914400" rtl="0" eaLnBrk="1" latinLnBrk="0" hangingPunct="1">
+              <a:defRPr sz="1800" kern="1200">
+                <a:solidFill>
+                  <a:schemeClr val="lt1"/>
+                </a:solidFill>
+                <a:latin typeface="+mn-lt"/>
+                <a:ea typeface="+mn-ea"/>
+                <a:cs typeface="+mn-cs"/>
+              </a:defRPr>
+            </a:lvl4pPr>
+            <a:lvl5pPr marL="1828800" algn="l" defTabSz="914400" rtl="0" eaLnBrk="1" latinLnBrk="0" hangingPunct="1">
+              <a:defRPr sz="1800" kern="1200">
+                <a:solidFill>
+                  <a:schemeClr val="lt1"/>
+                </a:solidFill>
+                <a:latin typeface="+mn-lt"/>
+                <a:ea typeface="+mn-ea"/>
+                <a:cs typeface="+mn-cs"/>
+              </a:defRPr>
+            </a:lvl5pPr>
+            <a:lvl6pPr marL="2286000" algn="l" defTabSz="914400" rtl="0" eaLnBrk="1" latinLnBrk="0" hangingPunct="1">
+              <a:defRPr sz="1800" kern="1200">
+                <a:solidFill>
+                  <a:schemeClr val="lt1"/>
+                </a:solidFill>
+                <a:latin typeface="+mn-lt"/>
+                <a:ea typeface="+mn-ea"/>
+                <a:cs typeface="+mn-cs"/>
+              </a:defRPr>
+            </a:lvl6pPr>
+            <a:lvl7pPr marL="2743200" algn="l" defTabSz="914400" rtl="0" eaLnBrk="1" latinLnBrk="0" hangingPunct="1">
+              <a:defRPr sz="1800" kern="1200">
+                <a:solidFill>
+                  <a:schemeClr val="lt1"/>
+                </a:solidFill>
+                <a:latin typeface="+mn-lt"/>
+                <a:ea typeface="+mn-ea"/>
+                <a:cs typeface="+mn-cs"/>
+              </a:defRPr>
+            </a:lvl7pPr>
+            <a:lvl8pPr marL="3200400" algn="l" defTabSz="914400" rtl="0" eaLnBrk="1" latinLnBrk="0" hangingPunct="1">
+              <a:defRPr sz="1800" kern="1200">
+                <a:solidFill>
+                  <a:schemeClr val="lt1"/>
+                </a:solidFill>
+                <a:latin typeface="+mn-lt"/>
+                <a:ea typeface="+mn-ea"/>
+                <a:cs typeface="+mn-cs"/>
+              </a:defRPr>
+            </a:lvl8pPr>
+            <a:lvl9pPr marL="3657600" algn="l" defTabSz="914400" rtl="0" eaLnBrk="1" latinLnBrk="0" hangingPunct="1">
+              <a:defRPr sz="1800" kern="1200">
+                <a:solidFill>
+                  <a:schemeClr val="lt1"/>
+                </a:solidFill>
+                <a:latin typeface="+mn-lt"/>
+                <a:ea typeface="+mn-ea"/>
+                <a:cs typeface="+mn-cs"/>
+              </a:defRPr>
+            </a:lvl9pPr>
+          </a:lstStyle>
+          <a:p>
+            <a:pPr algn="ctr"/>
+            <a:endParaRPr lang="en-CA"/>
+          </a:p>
+        </p:txBody>
+      </p:sp>
+      <p:sp>
+        <p:nvSpPr>
+          <p:cNvPr id="6" name="TextBox 5">
+            <a:extLst>
+              <a:ext uri="{FF2B5EF4-FFF2-40B4-BE49-F238E27FC236}">
+                <a16:creationId xmlns:a16="http://schemas.microsoft.com/office/drawing/2014/main" id="{F7E8C51B-8CAE-C2EF-317E-D4F3B4608B94}"/>
               </a:ext>
             </a:extLst>
           </p:cNvPr>
@@ -9722,8 +10262,8 @@
         </p:nvSpPr>
         <p:spPr>
           <a:xfrm>
-            <a:off x="381000" y="215900"/>
-            <a:ext cx="7581900" cy="369332"/>
+            <a:off x="527959" y="62217"/>
+            <a:ext cx="8710932" cy="492443"/>
           </a:xfrm>
           <a:prstGeom prst="rect">
             <a:avLst/>
@@ -9737,59 +10277,29 @@
           <a:lstStyle/>
           <a:p>
             <a:r>
-              <a:rPr lang="en-US" dirty="0">
-                <a:latin typeface="Verdana Pro" panose="020B0604030504040204" pitchFamily="34" charset="0"/>
+              <a:rPr lang="en-US" sz="2600" b="1" dirty="0">
+                <a:solidFill>
+                  <a:schemeClr val="bg1"/>
+                </a:solidFill>
+                <a:latin typeface="Georgia Pro" panose="02040502050405020303" pitchFamily="18" charset="0"/>
               </a:rPr>
-              <a:t>Worked example: domain-specific homology</a:t>
-            </a:r>
-            <a:endParaRPr lang="en-CA" dirty="0">
-              <a:latin typeface="Verdana Pro" panose="020B0604030504040204" pitchFamily="34" charset="0"/>
+              <a:t>A0A7P0TB94(DDX20)-A0A509EDC2(HelY)</a:t>
+            </a:r>
+            <a:endParaRPr lang="en-CA" sz="2600" b="1" dirty="0">
+              <a:solidFill>
+                <a:schemeClr val="bg1"/>
+              </a:solidFill>
+              <a:latin typeface="Georgia Pro" panose="02040502050405020303" pitchFamily="18" charset="0"/>
             </a:endParaRPr>
           </a:p>
         </p:txBody>
       </p:sp>
-    </p:spTree>
-    <p:extLst>
-      <p:ext uri="{BB962C8B-B14F-4D97-AF65-F5344CB8AC3E}">
-        <p14:creationId xmlns:p14="http://schemas.microsoft.com/office/powerpoint/2010/main" val="2238046284"/>
-      </p:ext>
-    </p:extLst>
-  </p:cSld>
-  <p:clrMapOvr>
-    <a:masterClrMapping/>
-  </p:clrMapOvr>
-</p:sld>
-</file>
-
-<file path=ppt/slides/slide15.xml><?xml version="1.0" encoding="utf-8"?>
-<p:sld xmlns:a="http://schemas.openxmlformats.org/drawingml/2006/main" xmlns:r="http://schemas.openxmlformats.org/officeDocument/2006/relationships" xmlns:p="http://schemas.openxmlformats.org/presentationml/2006/main">
-  <p:cSld>
-    <p:spTree>
-      <p:nvGrpSpPr>
-        <p:cNvPr id="1" name="">
-          <a:extLst>
-            <a:ext uri="{FF2B5EF4-FFF2-40B4-BE49-F238E27FC236}">
-              <a16:creationId xmlns:a16="http://schemas.microsoft.com/office/drawing/2014/main" id="{FE1AC05B-114B-43EA-7ED1-67E68CD514E8}"/>
-            </a:ext>
-          </a:extLst>
-        </p:cNvPr>
-        <p:cNvGrpSpPr/>
-        <p:nvPr/>
-      </p:nvGrpSpPr>
-      <p:grpSpPr>
-        <a:xfrm>
-          <a:off x="0" y="0"/>
-          <a:ext cx="0" cy="0"/>
-          <a:chOff x="0" y="0"/>
-          <a:chExt cx="0" cy="0"/>
-        </a:xfrm>
-      </p:grpSpPr>
       <p:sp>
         <p:nvSpPr>
-          <p:cNvPr id="4" name="TextBox 3">
-            <a:extLst>
-              <a:ext uri="{FF2B5EF4-FFF2-40B4-BE49-F238E27FC236}">
-                <a16:creationId xmlns:a16="http://schemas.microsoft.com/office/drawing/2014/main" id="{7B6E6A77-6B5A-DF34-8EC2-8F13A2024E0E}"/>
+          <p:cNvPr id="5" name="TextBox 4">
+            <a:extLst>
+              <a:ext uri="{FF2B5EF4-FFF2-40B4-BE49-F238E27FC236}">
+                <a16:creationId xmlns:a16="http://schemas.microsoft.com/office/drawing/2014/main" id="{1A989AF6-E05D-96E1-196D-AD16F28D1BF2}"/>
               </a:ext>
             </a:extLst>
           </p:cNvPr>
@@ -9798,8 +10308,8 @@
         </p:nvSpPr>
         <p:spPr>
           <a:xfrm>
-            <a:off x="381000" y="215900"/>
-            <a:ext cx="7581900" cy="369332"/>
+            <a:off x="2735970" y="5775836"/>
+            <a:ext cx="8440030" cy="923330"/>
           </a:xfrm>
           <a:prstGeom prst="rect">
             <a:avLst/>
@@ -9814,11 +10324,152 @@
           <a:p>
             <a:r>
               <a:rPr lang="en-US" dirty="0">
+                <a:solidFill>
+                  <a:schemeClr val="bg1"/>
+                </a:solidFill>
                 <a:latin typeface="Verdana Pro" panose="020B0604030504040204" pitchFamily="34" charset="0"/>
               </a:rPr>
-              <a:t>IUIS-IEI genes have significantly higher score</a:t>
+              <a:t>Sequence identity: 24.3%			</a:t>
+            </a:r>
+            <a:r>
+              <a:rPr lang="en-US" dirty="0" err="1">
+                <a:solidFill>
+                  <a:schemeClr val="bg1"/>
+                </a:solidFill>
+                <a:latin typeface="Verdana Pro" panose="020B0604030504040204" pitchFamily="34" charset="0"/>
+              </a:rPr>
+              <a:t>BLASTp</a:t>
+            </a:r>
+            <a:r>
+              <a:rPr lang="en-US" dirty="0">
+                <a:solidFill>
+                  <a:schemeClr val="bg1"/>
+                </a:solidFill>
+                <a:latin typeface="Verdana Pro" panose="020B0604030504040204" pitchFamily="34" charset="0"/>
+              </a:rPr>
+              <a:t> score: 29.6</a:t>
+            </a:r>
+          </a:p>
+          <a:p>
+            <a:r>
+              <a:rPr lang="en-US" dirty="0">
+                <a:solidFill>
+                  <a:schemeClr val="bg1"/>
+                </a:solidFill>
+                <a:latin typeface="Verdana Pro" panose="020B0604030504040204" pitchFamily="34" charset="0"/>
+              </a:rPr>
+              <a:t>Sequence alignment coverage: 24%</a:t>
+            </a:r>
+          </a:p>
+          <a:p>
+            <a:r>
+              <a:rPr lang="en-CA" dirty="0" err="1">
+                <a:solidFill>
+                  <a:schemeClr val="bg1"/>
+                </a:solidFill>
+                <a:latin typeface="Verdana Pro" panose="020B0604030504040204" pitchFamily="34" charset="0"/>
+              </a:rPr>
+              <a:t>BLASTp</a:t>
+            </a:r>
+            <a:r>
+              <a:rPr lang="en-CA" dirty="0">
+                <a:solidFill>
+                  <a:schemeClr val="bg1"/>
+                </a:solidFill>
+                <a:latin typeface="Verdana Pro" panose="020B0604030504040204" pitchFamily="34" charset="0"/>
+              </a:rPr>
+              <a:t> e-value: 2e-4</a:t>
+            </a:r>
+          </a:p>
+        </p:txBody>
+      </p:sp>
+      <p:sp>
+        <p:nvSpPr>
+          <p:cNvPr id="9" name="TextBox 8">
+            <a:extLst>
+              <a:ext uri="{FF2B5EF4-FFF2-40B4-BE49-F238E27FC236}">
+                <a16:creationId xmlns:a16="http://schemas.microsoft.com/office/drawing/2014/main" id="{AAE6E66E-9D79-38CB-AC25-F25BE4A5579E}"/>
+              </a:ext>
+            </a:extLst>
+          </p:cNvPr>
+          <p:cNvSpPr txBox="1"/>
+          <p:nvPr/>
+        </p:nvSpPr>
+        <p:spPr>
+          <a:xfrm>
+            <a:off x="2232358" y="1037779"/>
+            <a:ext cx="1007224" cy="369332"/>
+          </a:xfrm>
+          <a:prstGeom prst="rect">
+            <a:avLst/>
+          </a:prstGeom>
+          <a:noFill/>
+        </p:spPr>
+        <p:txBody>
+          <a:bodyPr wrap="square" rtlCol="0">
+            <a:spAutoFit/>
+          </a:bodyPr>
+          <a:lstStyle/>
+          <a:p>
+            <a:r>
+              <a:rPr lang="en-US" dirty="0">
+                <a:solidFill>
+                  <a:schemeClr val="bg1"/>
+                </a:solidFill>
+                <a:latin typeface="Verdana Pro" panose="020B0604030504040204" pitchFamily="34" charset="0"/>
+              </a:rPr>
+              <a:t>DDX20</a:t>
             </a:r>
             <a:endParaRPr lang="en-CA" dirty="0">
+              <a:solidFill>
+                <a:schemeClr val="bg1"/>
+              </a:solidFill>
+              <a:latin typeface="Verdana Pro" panose="020B0604030504040204" pitchFamily="34" charset="0"/>
+            </a:endParaRPr>
+          </a:p>
+        </p:txBody>
+      </p:sp>
+      <p:sp>
+        <p:nvSpPr>
+          <p:cNvPr id="13" name="TextBox 12">
+            <a:extLst>
+              <a:ext uri="{FF2B5EF4-FFF2-40B4-BE49-F238E27FC236}">
+                <a16:creationId xmlns:a16="http://schemas.microsoft.com/office/drawing/2014/main" id="{F0B27A09-8966-EDAF-D4B5-C06CA8653D37}"/>
+              </a:ext>
+            </a:extLst>
+          </p:cNvPr>
+          <p:cNvSpPr txBox="1"/>
+          <p:nvPr/>
+        </p:nvSpPr>
+        <p:spPr>
+          <a:xfrm>
+            <a:off x="8952418" y="1037779"/>
+            <a:ext cx="1007224" cy="369332"/>
+          </a:xfrm>
+          <a:prstGeom prst="rect">
+            <a:avLst/>
+          </a:prstGeom>
+          <a:noFill/>
+        </p:spPr>
+        <p:txBody>
+          <a:bodyPr wrap="square" rtlCol="0">
+            <a:spAutoFit/>
+          </a:bodyPr>
+          <a:lstStyle/>
+          <a:p>
+            <a:r>
+              <a:rPr lang="en-US" dirty="0">
+                <a:solidFill>
+                  <a:schemeClr val="bg1"/>
+                </a:solidFill>
+                <a:latin typeface="Verdana Pro" panose="020B0604030504040204" pitchFamily="34" charset="0"/>
+              </a:rPr>
+              <a:t>HelY</a:t>
+            </a:r>
+            <a:endParaRPr lang="en-CA" dirty="0">
+              <a:solidFill>
+                <a:schemeClr val="bg1"/>
+              </a:solidFill>
               <a:latin typeface="Verdana Pro" panose="020B0604030504040204" pitchFamily="34" charset="0"/>
             </a:endParaRPr>
           </a:p>
@@ -9827,7 +10478,7 @@
     </p:spTree>
     <p:extLst>
       <p:ext uri="{BB962C8B-B14F-4D97-AF65-F5344CB8AC3E}">
-        <p14:creationId xmlns:p14="http://schemas.microsoft.com/office/powerpoint/2010/main" val="452590621"/>
+        <p14:creationId xmlns:p14="http://schemas.microsoft.com/office/powerpoint/2010/main" val="2473295309"/>
       </p:ext>
     </p:extLst>
   </p:cSld>
@@ -9837,7 +10488,7 @@
 </p:sld>
 </file>
 
-<file path=ppt/slides/slide16.xml><?xml version="1.0" encoding="utf-8"?>
+<file path=ppt/slides/slide15.xml><?xml version="1.0" encoding="utf-8"?>
 <p:sld xmlns:a="http://schemas.openxmlformats.org/drawingml/2006/main" xmlns:r="http://schemas.openxmlformats.org/officeDocument/2006/relationships" xmlns:p="http://schemas.openxmlformats.org/presentationml/2006/main">
   <p:cSld>
     <p:spTree>
@@ -11058,146 +11709,56 @@
           </a:p>
         </p:txBody>
       </p:sp>
-      <mc:AlternateContent xmlns:mc="http://schemas.openxmlformats.org/markup-compatibility/2006" xmlns:a14="http://schemas.microsoft.com/office/drawing/2010/main">
-        <mc:Choice Requires="a14">
-          <p:sp>
-            <p:nvSpPr>
-              <p:cNvPr id="13" name="TextBox 12">
-                <a:extLst>
-                  <a:ext uri="{FF2B5EF4-FFF2-40B4-BE49-F238E27FC236}">
-                    <a16:creationId xmlns:a16="http://schemas.microsoft.com/office/drawing/2014/main" id="{1996BCAD-5AA8-ED57-A337-0FC563367AAA}"/>
-                  </a:ext>
-                </a:extLst>
-              </p:cNvPr>
-              <p:cNvSpPr txBox="1"/>
-              <p:nvPr/>
-            </p:nvSpPr>
-            <p:spPr>
-              <a:xfrm>
-                <a:off x="6644626" y="1992440"/>
-                <a:ext cx="4406900" cy="2585323"/>
-              </a:xfrm>
-              <a:prstGeom prst="rect">
-                <a:avLst/>
-              </a:prstGeom>
-              <a:noFill/>
-            </p:spPr>
-            <p:txBody>
-              <a:bodyPr wrap="square" rtlCol="0">
-                <a:spAutoFit/>
-              </a:bodyPr>
-              <a:lstStyle/>
-              <a:p>
-                <a:r>
-                  <a:rPr lang="en-US" dirty="0">
-                    <a:latin typeface="Georgia Pro" panose="02040502050405020303" pitchFamily="18" charset="0"/>
-                  </a:rPr>
-                  <a:t>PyMol super can achieve good alignment when TM-align cannot </a:t>
-                </a:r>
-              </a:p>
-              <a:p>
-                <a:r>
-                  <a:rPr lang="en-US" dirty="0">
-                    <a:latin typeface="Georgia Pro" panose="02040502050405020303" pitchFamily="18" charset="0"/>
-                  </a:rPr>
-                  <a:t>(see top-left quadrant vs. bottom-right).</a:t>
-                </a:r>
-              </a:p>
-              <a:p>
-                <a:endParaRPr lang="en-US" dirty="0">
-                  <a:latin typeface="Georgia Pro" panose="02040502050405020303" pitchFamily="18" charset="0"/>
-                </a:endParaRPr>
-              </a:p>
-              <a:p>
-                <a:r>
-                  <a:rPr lang="en-US" dirty="0">
-                    <a:latin typeface="Georgia Pro" panose="02040502050405020303" pitchFamily="18" charset="0"/>
-                  </a:rPr>
-                  <a:t>However, this should always be checked against a threshold of </a:t>
-                </a:r>
-                <a14:m>
-                  <m:oMath xmlns:m="http://schemas.openxmlformats.org/officeDocument/2006/math">
-                    <m:r>
-                      <a:rPr lang="en-US" b="0" i="1" smtClean="0">
-                        <a:latin typeface="Cambria Math" panose="02040503050406030204" pitchFamily="18" charset="0"/>
-                      </a:rPr>
-                      <m:t>𝑒</m:t>
-                    </m:r>
-                    <m:r>
-                      <a:rPr lang="en-US" b="0" i="1" smtClean="0">
-                        <a:latin typeface="Cambria Math" panose="02040503050406030204" pitchFamily="18" charset="0"/>
-                      </a:rPr>
-                      <m:t>_</m:t>
-                    </m:r>
-                    <m:r>
-                      <a:rPr lang="en-US" b="0" i="1" smtClean="0">
-                        <a:latin typeface="Cambria Math" panose="02040503050406030204" pitchFamily="18" charset="0"/>
-                      </a:rPr>
-                      <m:t>𝑣𝑎𝑙𝑢𝑒</m:t>
-                    </m:r>
-                    <m:r>
-                      <a:rPr lang="en-US" b="0" i="1" smtClean="0">
-                        <a:latin typeface="Cambria Math" panose="02040503050406030204" pitchFamily="18" charset="0"/>
-                      </a:rPr>
-                      <m:t>&lt;0.05</m:t>
-                    </m:r>
-                  </m:oMath>
-                </a14:m>
-                <a:r>
-                  <a:rPr lang="en-CA" dirty="0">
-                    <a:latin typeface="Georgia Pro" panose="02040502050405020303" pitchFamily="18" charset="0"/>
-                  </a:rPr>
-                  <a:t> (after multiple hypothesis correction) to confirm that the alignment is not due to random chance.</a:t>
-                </a:r>
-              </a:p>
-            </p:txBody>
-          </p:sp>
-        </mc:Choice>
-        <mc:Fallback xmlns="">
-          <p:sp>
-            <p:nvSpPr>
-              <p:cNvPr id="13" name="TextBox 12">
-                <a:extLst>
-                  <a:ext uri="{FF2B5EF4-FFF2-40B4-BE49-F238E27FC236}">
-                    <a16:creationId xmlns:a16="http://schemas.microsoft.com/office/drawing/2014/main" id="{1996BCAD-5AA8-ED57-A337-0FC563367AAA}"/>
-                  </a:ext>
-                </a:extLst>
-              </p:cNvPr>
-              <p:cNvSpPr txBox="1">
-                <a:spLocks noRot="1" noChangeAspect="1" noMove="1" noResize="1" noEditPoints="1" noAdjustHandles="1" noChangeArrowheads="1" noChangeShapeType="1" noTextEdit="1"/>
-              </p:cNvSpPr>
-              <p:nvPr/>
-            </p:nvSpPr>
-            <p:spPr>
-              <a:xfrm>
-                <a:off x="6644626" y="1992440"/>
-                <a:ext cx="4406900" cy="2585323"/>
-              </a:xfrm>
-              <a:prstGeom prst="rect">
-                <a:avLst/>
-              </a:prstGeom>
-              <a:blipFill>
-                <a:blip r:embed="rId3"/>
-                <a:stretch>
-                  <a:fillRect l="-1245" t="-1415" r="-138" b="-2830"/>
-                </a:stretch>
-              </a:blipFill>
-            </p:spPr>
-            <p:txBody>
-              <a:bodyPr/>
-              <a:lstStyle/>
-              <a:p>
-                <a:r>
-                  <a:rPr lang="en-CA">
-                    <a:noFill/>
-                  </a:rPr>
-                  <a:t> </a:t>
-                </a:r>
-              </a:p>
-            </p:txBody>
-          </p:sp>
-        </mc:Fallback>
-      </mc:AlternateContent>
+      <p:sp>
+        <p:nvSpPr>
+          <p:cNvPr id="13" name="TextBox 12">
+            <a:extLst>
+              <a:ext uri="{FF2B5EF4-FFF2-40B4-BE49-F238E27FC236}">
+                <a16:creationId xmlns:a16="http://schemas.microsoft.com/office/drawing/2014/main" id="{1996BCAD-5AA8-ED57-A337-0FC563367AAA}"/>
+              </a:ext>
+            </a:extLst>
+          </p:cNvPr>
+          <p:cNvSpPr txBox="1"/>
+          <p:nvPr/>
+        </p:nvSpPr>
+        <p:spPr>
+          <a:xfrm>
+            <a:off x="6644626" y="2527277"/>
+            <a:ext cx="4406900" cy="1200329"/>
+          </a:xfrm>
+          <a:prstGeom prst="rect">
+            <a:avLst/>
+          </a:prstGeom>
+          <a:noFill/>
+        </p:spPr>
+        <p:txBody>
+          <a:bodyPr wrap="square" rtlCol="0">
+            <a:spAutoFit/>
+          </a:bodyPr>
+          <a:lstStyle/>
+          <a:p>
+            <a:r>
+              <a:rPr lang="en-US" dirty="0">
+                <a:latin typeface="Georgia Pro" panose="02040502050405020303" pitchFamily="18" charset="0"/>
+              </a:rPr>
+              <a:t>PyMol super can achieve good alignment when TM-align cannot </a:t>
+            </a:r>
+          </a:p>
+          <a:p>
+            <a:r>
+              <a:rPr lang="en-US" dirty="0">
+                <a:latin typeface="Georgia Pro" panose="02040502050405020303" pitchFamily="18" charset="0"/>
+              </a:rPr>
+              <a:t>(see top-left quadrant vs. bottom-right).</a:t>
+            </a:r>
+          </a:p>
+          <a:p>
+            <a:endParaRPr lang="en-US" dirty="0">
+              <a:latin typeface="Georgia Pro" panose="02040502050405020303" pitchFamily="18" charset="0"/>
+            </a:endParaRPr>
+          </a:p>
+        </p:txBody>
+      </p:sp>
     </p:spTree>
     <p:extLst>
       <p:ext uri="{BB962C8B-B14F-4D97-AF65-F5344CB8AC3E}">

</xml_diff>

<commit_message>
Copy editing of slides.
</commit_message>
<xml_diff>
--- a/reports/2026-08-28_projectUpdate_3/2026-08-28_projectUpdate_3_jmoran.pptx
+++ b/reports/2026-08-28_projectUpdate_3/2026-08-28_projectUpdate_3_jmoran.pptx
@@ -534,20 +534,6 @@
           <a:bodyPr/>
           <a:lstStyle/>
           <a:p>
-            <a:r>
-              <a:rPr lang="en-US" dirty="0"/>
-              <a:t>Gene list is for C Marshall</a:t>
-            </a:r>
-          </a:p>
-          <a:p>
-            <a:r>
-              <a:rPr lang="en-US" dirty="0"/>
-              <a:t>Used for improving diagnostic yield</a:t>
-            </a:r>
-            <a:r>
-              <a:rPr lang="en-CA" dirty="0"/>
-              <a:t> for pre-existing gene lists</a:t>
-            </a:r>
             <a:endParaRPr lang="en-US" dirty="0"/>
           </a:p>
         </p:txBody>
@@ -854,6 +840,13 @@
           </p:nvPr>
         </p:nvSpPr>
         <p:spPr/>
+        <p:txBody>
+          <a:bodyPr/>
+          <a:lstStyle/>
+          <a:p>
+            <a:endParaRPr lang="en-CA"/>
+          </a:p>
+        </p:txBody>
       </p:sp>
       <p:sp>
         <p:nvSpPr>
@@ -938,6 +931,13 @@
           </p:nvPr>
         </p:nvSpPr>
         <p:spPr/>
+        <p:txBody>
+          <a:bodyPr/>
+          <a:lstStyle/>
+          <a:p>
+            <a:endParaRPr lang="en-CA"/>
+          </a:p>
+        </p:txBody>
       </p:sp>
       <p:sp>
         <p:nvSpPr>
@@ -1022,6 +1022,13 @@
           </p:nvPr>
         </p:nvSpPr>
         <p:spPr/>
+        <p:txBody>
+          <a:bodyPr/>
+          <a:lstStyle/>
+          <a:p>
+            <a:endParaRPr lang="en-CA"/>
+          </a:p>
+        </p:txBody>
       </p:sp>
       <p:sp>
         <p:nvSpPr>
@@ -8166,7 +8173,7 @@
               <a:rPr lang="en-CA" sz="1400" dirty="0">
                 <a:latin typeface="Verdana Pro" panose="020B0604030504040204" pitchFamily="34" charset="0"/>
               </a:rPr>
-              <a:t>2. e-value with protein in DefenseFinder</a:t>
+              <a:t>2. e-value with DefenseFinder protein</a:t>
             </a:r>
           </a:p>
         </p:txBody>
@@ -10337,7 +10344,7 @@
                 </a:solidFill>
                 <a:latin typeface="Verdana Pro" panose="020B0604030504040204" pitchFamily="34" charset="0"/>
               </a:rPr>
-              <a:t>Proposed that SngA acts as a sensor, Shango helicase activates antiviral response</a:t>
+              <a:t>Proposed that SngA acts as a sensor, Shango helicase effects antiviral response</a:t>
             </a:r>
           </a:p>
         </p:txBody>
@@ -10810,25 +10817,7 @@
                 </a:solidFill>
                 <a:latin typeface="Verdana Pro" panose="020B0604030504040204" pitchFamily="34" charset="0"/>
               </a:rPr>
-              <a:t>Sequence identity: 24.3%			</a:t>
-            </a:r>
-            <a:r>
-              <a:rPr lang="en-US" dirty="0" err="1">
-                <a:solidFill>
-                  <a:schemeClr val="bg1"/>
-                </a:solidFill>
-                <a:latin typeface="Verdana Pro" panose="020B0604030504040204" pitchFamily="34" charset="0"/>
-              </a:rPr>
-              <a:t>BLASTp</a:t>
-            </a:r>
-            <a:r>
-              <a:rPr lang="en-US" dirty="0">
-                <a:solidFill>
-                  <a:schemeClr val="bg1"/>
-                </a:solidFill>
-                <a:latin typeface="Verdana Pro" panose="020B0604030504040204" pitchFamily="34" charset="0"/>
-              </a:rPr>
-              <a:t> score: 29.6</a:t>
+              <a:t>Sequence identity: 24.3%			BLASTp score: 29.6</a:t>
             </a:r>
           </a:p>
           <a:p>
@@ -11250,7 +11239,7 @@
         <p:spPr>
           <a:xfrm>
             <a:off x="415225" y="2018963"/>
-            <a:ext cx="5028550" cy="3647152"/>
+            <a:ext cx="5028550" cy="3724096"/>
           </a:xfrm>
           <a:prstGeom prst="rect">
             <a:avLst/>
@@ -11280,9 +11269,6 @@
               </a:rPr>
               <a:t>6</a:t>
             </a:r>
-            <a:endParaRPr lang="en-US" dirty="0">
-              <a:latin typeface="Verdana Pro" panose="020B0604030504040204" pitchFamily="34" charset="0"/>
-            </a:endParaRPr>
           </a:p>
           <a:p>
             <a:pPr marL="342900" indent="-342900">
@@ -11296,7 +11282,7 @@
               <a:rPr lang="en-US" dirty="0">
                 <a:latin typeface="Verdana Pro" panose="020B0604030504040204" pitchFamily="34" charset="0"/>
               </a:rPr>
-              <a:t>The candidate genotype is monogenic and is not found in individuals without the clinical phenotype.</a:t>
+              <a:t>Has a monogenic genotype reported in IEI cases</a:t>
             </a:r>
           </a:p>
           <a:p>
@@ -11311,7 +11297,7 @@
               <a:rPr lang="en-US" dirty="0">
                 <a:latin typeface="Verdana Pro" panose="020B0604030504040204" pitchFamily="34" charset="0"/>
               </a:rPr>
-              <a:t>Experimental studies show variant impairs, destroys, or alters expression or function of gene product.</a:t>
+              <a:t>Not found in individuals without IEI</a:t>
             </a:r>
           </a:p>
           <a:p>
@@ -11326,7 +11312,22 @@
               <a:rPr lang="en-US" dirty="0">
                 <a:latin typeface="Verdana Pro" panose="020B0604030504040204" pitchFamily="34" charset="0"/>
               </a:rPr>
-              <a:t>The causal relationship between the candidate genotype and the clinical phenotype is confirmed via a relevant cellular phenotype, including where possible rescue of a functional defect.</a:t>
+              <a:t>Experimental studies show variant impairs, destroys, or alters expression or function of gene product.</a:t>
+            </a:r>
+          </a:p>
+          <a:p>
+            <a:pPr marL="342900" indent="-342900">
+              <a:spcAft>
+                <a:spcPts val="600"/>
+              </a:spcAft>
+              <a:buFont typeface="+mj-lt"/>
+              <a:buAutoNum type="arabicPeriod"/>
+            </a:pPr>
+            <a:r>
+              <a:rPr lang="en-US" dirty="0">
+                <a:latin typeface="Verdana Pro" panose="020B0604030504040204" pitchFamily="34" charset="0"/>
+              </a:rPr>
+              <a:t>The causal relationship between the candidate genotype and IEI is confirmed via a relevant cellular phenotype, including where possible rescue of a functional defect.</a:t>
             </a:r>
             <a:endParaRPr lang="en-CA" dirty="0">
               <a:latin typeface="Verdana Pro" panose="020B0604030504040204" pitchFamily="34" charset="0"/>
@@ -12230,7 +12231,7 @@
         <p:spPr>
           <a:xfrm>
             <a:off x="527958" y="1146628"/>
-            <a:ext cx="9363581" cy="2492990"/>
+            <a:ext cx="9363581" cy="2846933"/>
           </a:xfrm>
           <a:prstGeom prst="rect">
             <a:avLst/>
@@ -12291,7 +12292,7 @@
               <a:rPr lang="en-US" dirty="0">
                 <a:latin typeface="Georgia Pro" panose="02040502050405020303" pitchFamily="18" charset="0"/>
               </a:rPr>
-              <a:t>Dr. Chantel Trost</a:t>
+              <a:t>Matthew Uchmanowicz</a:t>
             </a:r>
           </a:p>
           <a:p>
@@ -12304,7 +12305,7 @@
               <a:rPr lang="en-US" dirty="0">
                 <a:latin typeface="Georgia Pro" panose="02040502050405020303" pitchFamily="18" charset="0"/>
               </a:rPr>
-              <a:t>Dr. Christian Marshall</a:t>
+              <a:t>Dr. Chantel Trost</a:t>
             </a:r>
           </a:p>
           <a:p>
@@ -12317,7 +12318,20 @@
               <a:rPr lang="en-US" dirty="0">
                 <a:latin typeface="Georgia Pro" panose="02040502050405020303" pitchFamily="18" charset="0"/>
               </a:rPr>
-              <a:t>Dr. Steven Scherer</a:t>
+              <a:t>Dr. Christian Marshall</a:t>
+            </a:r>
+          </a:p>
+          <a:p>
+            <a:pPr>
+              <a:spcAft>
+                <a:spcPts val="600"/>
+              </a:spcAft>
+            </a:pPr>
+            <a:r>
+              <a:rPr lang="en-US" dirty="0">
+                <a:latin typeface="Georgia Pro" panose="02040502050405020303" pitchFamily="18" charset="0"/>
+              </a:rPr>
+              <a:t>Dr. Stephen Scherer</a:t>
             </a:r>
           </a:p>
           <a:p>
@@ -18287,8 +18301,8 @@
         </p:nvSpPr>
         <p:spPr>
           <a:xfrm>
-            <a:off x="5827142" y="2363705"/>
-            <a:ext cx="2851031" cy="369332"/>
+            <a:off x="5827142" y="2217063"/>
+            <a:ext cx="2851031" cy="646331"/>
           </a:xfrm>
           <a:prstGeom prst="rect">
             <a:avLst/>
@@ -18305,7 +18319,7 @@
               <a:rPr lang="en-US" dirty="0">
                 <a:latin typeface="Verdana Pro" panose="020B0604030504040204" pitchFamily="34" charset="0"/>
               </a:rPr>
-              <a:t>E-value score term</a:t>
+              <a:t>FoldSeek e-value score term</a:t>
             </a:r>
             <a:endParaRPr lang="en-CA" dirty="0">
               <a:latin typeface="Verdana Pro" panose="020B0604030504040204" pitchFamily="34" charset="0"/>
@@ -18473,8 +18487,8 @@
           </a:p>
         </p:txBody>
       </p:sp>
-      <mc:AlternateContent xmlns:mc="http://schemas.openxmlformats.org/markup-compatibility/2006" xmlns:a14="http://schemas.microsoft.com/office/drawing/2010/main">
-        <mc:Choice Requires="a14">
+      <mc:AlternateContent xmlns:mc="http://schemas.openxmlformats.org/markup-compatibility/2006">
+        <mc:Choice xmlns:a14="http://schemas.microsoft.com/office/drawing/2010/main" Requires="a14">
           <p:sp>
             <p:nvSpPr>
               <p:cNvPr id="47" name="TextBox 46">
@@ -18489,7 +18503,7 @@
             </p:nvSpPr>
             <p:spPr>
               <a:xfrm>
-                <a:off x="8517480" y="2230481"/>
+                <a:off x="8767642" y="2230481"/>
                 <a:ext cx="2585772" cy="447110"/>
               </a:xfrm>
               <a:prstGeom prst="rect">
@@ -18659,7 +18673,7 @@
             </p:txBody>
           </p:sp>
         </mc:Choice>
-        <mc:Fallback xmlns="">
+        <mc:Fallback>
           <p:sp>
             <p:nvSpPr>
               <p:cNvPr id="47" name="TextBox 46">
@@ -18676,7 +18690,7 @@
             </p:nvSpPr>
             <p:spPr>
               <a:xfrm>
-                <a:off x="8517480" y="2230481"/>
+                <a:off x="8767642" y="2230481"/>
                 <a:ext cx="2585772" cy="447110"/>
               </a:xfrm>
               <a:prstGeom prst="rect">
@@ -18704,8 +18718,8 @@
           </p:sp>
         </mc:Fallback>
       </mc:AlternateContent>
-      <mc:AlternateContent xmlns:mc="http://schemas.openxmlformats.org/markup-compatibility/2006" xmlns:a14="http://schemas.microsoft.com/office/drawing/2010/main">
-        <mc:Choice Requires="a14">
+      <mc:AlternateContent xmlns:mc="http://schemas.openxmlformats.org/markup-compatibility/2006">
+        <mc:Choice xmlns:a14="http://schemas.microsoft.com/office/drawing/2010/main" Requires="a14">
           <p:sp>
             <p:nvSpPr>
               <p:cNvPr id="51" name="TextBox 50">
@@ -18720,7 +18734,7 @@
             </p:nvSpPr>
             <p:spPr>
               <a:xfrm>
-                <a:off x="8500228" y="1601768"/>
+                <a:off x="8750390" y="1601768"/>
                 <a:ext cx="2951193" cy="529697"/>
               </a:xfrm>
               <a:prstGeom prst="rect">
@@ -18826,7 +18840,7 @@
             </p:txBody>
           </p:sp>
         </mc:Choice>
-        <mc:Fallback xmlns="">
+        <mc:Fallback>
           <p:sp>
             <p:nvSpPr>
               <p:cNvPr id="51" name="TextBox 50">
@@ -18843,7 +18857,7 @@
             </p:nvSpPr>
             <p:spPr>
               <a:xfrm>
-                <a:off x="8500228" y="1601768"/>
+                <a:off x="8750390" y="1601768"/>
                 <a:ext cx="2951193" cy="529697"/>
               </a:xfrm>
               <a:prstGeom prst="rect">

</xml_diff>

<commit_message>
Added ImmPort annotation pie plot. Changed protein pair headlines from gene names to protein IDs.
</commit_message>
<xml_diff>
--- a/reports/2026-08-28_projectUpdate_3/2026-08-28_projectUpdate_3_jmoran.pptx
+++ b/reports/2026-08-28_projectUpdate_3/2026-08-28_projectUpdate_3_jmoran.pptx
@@ -5,7 +5,7 @@
     <p:sldMasterId id="2147483648" r:id="rId1"/>
   </p:sldMasterIdLst>
   <p:notesMasterIdLst>
-    <p:notesMasterId r:id="rId21"/>
+    <p:notesMasterId r:id="rId22"/>
   </p:notesMasterIdLst>
   <p:sldIdLst>
     <p:sldId id="256" r:id="rId2"/>
@@ -24,9 +24,10 @@
     <p:sldId id="297" r:id="rId15"/>
     <p:sldId id="298" r:id="rId16"/>
     <p:sldId id="299" r:id="rId17"/>
-    <p:sldId id="300" r:id="rId18"/>
-    <p:sldId id="301" r:id="rId19"/>
-    <p:sldId id="296" r:id="rId20"/>
+    <p:sldId id="302" r:id="rId18"/>
+    <p:sldId id="300" r:id="rId19"/>
+    <p:sldId id="301" r:id="rId20"/>
+    <p:sldId id="296" r:id="rId21"/>
   </p:sldIdLst>
   <p:sldSz cx="12192000" cy="6858000"/>
   <p:notesSz cx="6858000" cy="9144000"/>
@@ -215,7 +216,7 @@
           <a:p>
             <a:fld id="{1479C651-C459-48E3-86F1-CED449A3498B}" type="datetimeFigureOut">
               <a:rPr lang="en-CA" smtClean="0"/>
-              <a:t>2026-08-27</a:t>
+              <a:t>2026-09-03</a:t>
             </a:fld>
             <a:endParaRPr lang="en-CA"/>
           </a:p>
@@ -1808,7 +1809,7 @@
           <a:p>
             <a:fld id="{58AF871A-C88D-4E10-8D99-FEC85A8B5E41}" type="datetime1">
               <a:rPr lang="en-CA" smtClean="0"/>
-              <a:t>2026-08-27</a:t>
+              <a:t>2026-09-03</a:t>
             </a:fld>
             <a:endParaRPr lang="en-CA"/>
           </a:p>
@@ -2008,7 +2009,7 @@
           <a:p>
             <a:fld id="{212C229A-4736-4449-92BD-4CADA47166CF}" type="datetime1">
               <a:rPr lang="en-CA" smtClean="0"/>
-              <a:t>2026-08-27</a:t>
+              <a:t>2026-09-03</a:t>
             </a:fld>
             <a:endParaRPr lang="en-CA"/>
           </a:p>
@@ -2218,7 +2219,7 @@
           <a:p>
             <a:fld id="{949905B2-E522-4BB5-808B-BCB1B07386AB}" type="datetime1">
               <a:rPr lang="en-CA" smtClean="0"/>
-              <a:t>2026-08-27</a:t>
+              <a:t>2026-09-03</a:t>
             </a:fld>
             <a:endParaRPr lang="en-CA"/>
           </a:p>
@@ -2418,7 +2419,7 @@
           <a:p>
             <a:fld id="{61F15EDE-C0F7-48C8-B8A5-4485BFFB8F68}" type="datetime1">
               <a:rPr lang="en-CA" smtClean="0"/>
-              <a:t>2026-08-27</a:t>
+              <a:t>2026-09-03</a:t>
             </a:fld>
             <a:endParaRPr lang="en-CA"/>
           </a:p>
@@ -2694,7 +2695,7 @@
           <a:p>
             <a:fld id="{30585E81-C11B-4BFC-8E0F-A46B659CA5CC}" type="datetime1">
               <a:rPr lang="en-CA" smtClean="0"/>
-              <a:t>2026-08-27</a:t>
+              <a:t>2026-09-03</a:t>
             </a:fld>
             <a:endParaRPr lang="en-CA"/>
           </a:p>
@@ -2962,7 +2963,7 @@
           <a:p>
             <a:fld id="{D1A352C1-CE60-48F2-83B2-89F8AAE1ABE4}" type="datetime1">
               <a:rPr lang="en-CA" smtClean="0"/>
-              <a:t>2026-08-27</a:t>
+              <a:t>2026-09-03</a:t>
             </a:fld>
             <a:endParaRPr lang="en-CA"/>
           </a:p>
@@ -3377,7 +3378,7 @@
           <a:p>
             <a:fld id="{50F4EB51-E2E5-4C12-94EF-09C758EA7AE2}" type="datetime1">
               <a:rPr lang="en-CA" smtClean="0"/>
-              <a:t>2026-08-27</a:t>
+              <a:t>2026-09-03</a:t>
             </a:fld>
             <a:endParaRPr lang="en-CA"/>
           </a:p>
@@ -3519,7 +3520,7 @@
           <a:p>
             <a:fld id="{0BEA2A0C-E38A-4D25-A5E7-41DB973BEC7B}" type="datetime1">
               <a:rPr lang="en-CA" smtClean="0"/>
-              <a:t>2026-08-27</a:t>
+              <a:t>2026-09-03</a:t>
             </a:fld>
             <a:endParaRPr lang="en-CA"/>
           </a:p>
@@ -3632,7 +3633,7 @@
           <a:p>
             <a:fld id="{36CA473A-0C70-42D7-BA3C-E2CE5C69DDC6}" type="datetime1">
               <a:rPr lang="en-CA" smtClean="0"/>
-              <a:t>2026-08-27</a:t>
+              <a:t>2026-09-03</a:t>
             </a:fld>
             <a:endParaRPr lang="en-CA"/>
           </a:p>
@@ -3945,7 +3946,7 @@
           <a:p>
             <a:fld id="{AE318C3E-A425-4BB7-888B-C63327DEEC39}" type="datetime1">
               <a:rPr lang="en-CA" smtClean="0"/>
-              <a:t>2026-08-27</a:t>
+              <a:t>2026-09-03</a:t>
             </a:fld>
             <a:endParaRPr lang="en-CA"/>
           </a:p>
@@ -4234,7 +4235,7 @@
           <a:p>
             <a:fld id="{15C68DE8-A919-4E28-A5E0-4E676A751803}" type="datetime1">
               <a:rPr lang="en-CA" smtClean="0"/>
-              <a:t>2026-08-27</a:t>
+              <a:t>2026-09-03</a:t>
             </a:fld>
             <a:endParaRPr lang="en-CA"/>
           </a:p>
@@ -4477,7 +4478,7 @@
           <a:p>
             <a:fld id="{7926DE4D-47A6-4C4B-B9C5-A49E0BFD7885}" type="datetime1">
               <a:rPr lang="en-CA" smtClean="0"/>
-              <a:t>2026-08-27</a:t>
+              <a:t>2026-09-03</a:t>
             </a:fld>
             <a:endParaRPr lang="en-CA"/>
           </a:p>
@@ -9060,7 +9061,7 @@
           <p:spPr>
             <a:xfrm>
               <a:off x="138107" y="900721"/>
-              <a:ext cx="3128968" cy="923330"/>
+              <a:ext cx="3128968" cy="646331"/>
             </a:xfrm>
             <a:prstGeom prst="rect">
               <a:avLst/>
@@ -9080,18 +9081,16 @@
                   </a:solidFill>
                   <a:latin typeface="Verdana Pro" panose="020B0604030504040204" pitchFamily="34" charset="0"/>
                 </a:rPr>
-                <a:t>Q6ICS7</a:t>
+                <a:t>DNMT2 </a:t>
               </a:r>
-            </a:p>
-            <a:p>
               <a:r>
-                <a:rPr lang="en-US" dirty="0">
+                <a:rPr lang="en-US" sz="1200" dirty="0">
                   <a:solidFill>
                     <a:schemeClr val="bg1"/>
                   </a:solidFill>
                   <a:latin typeface="Verdana Pro" panose="020B0604030504040204" pitchFamily="34" charset="0"/>
                 </a:rPr>
-                <a:t>DNMT2</a:t>
+                <a:t>(Q6ICS7)</a:t>
               </a:r>
             </a:p>
             <a:p>
@@ -9128,7 +9127,7 @@
           <p:spPr>
             <a:xfrm>
               <a:off x="8782054" y="900721"/>
-              <a:ext cx="2876551" cy="923330"/>
+              <a:ext cx="2876551" cy="830997"/>
             </a:xfrm>
             <a:prstGeom prst="rect">
               <a:avLst/>
@@ -9148,7 +9147,24 @@
                   </a:solidFill>
                   <a:latin typeface="Verdana Pro" panose="020B0604030504040204" pitchFamily="34" charset="0"/>
                 </a:rPr>
-                <a:t>E4ZAF3</a:t>
+                <a:t>C5 methyltransferase</a:t>
+              </a:r>
+              <a:endParaRPr lang="en-CA" dirty="0">
+                <a:solidFill>
+                  <a:schemeClr val="bg1"/>
+                </a:solidFill>
+                <a:latin typeface="Verdana Pro" panose="020B0604030504040204" pitchFamily="34" charset="0"/>
+              </a:endParaRPr>
+            </a:p>
+            <a:p>
+              <a:r>
+                <a:rPr lang="en-US" sz="1200" dirty="0">
+                  <a:solidFill>
+                    <a:schemeClr val="bg1"/>
+                  </a:solidFill>
+                  <a:latin typeface="Verdana Pro" panose="020B0604030504040204" pitchFamily="34" charset="0"/>
+                </a:rPr>
+                <a:t>(E4ZAF3)</a:t>
               </a:r>
             </a:p>
             <a:p>
@@ -9161,23 +9177,6 @@
                 </a:rPr>
                 <a:t>RM Type II system</a:t>
               </a:r>
-            </a:p>
-            <a:p>
-              <a:r>
-                <a:rPr lang="en-US" dirty="0">
-                  <a:solidFill>
-                    <a:schemeClr val="bg1"/>
-                  </a:solidFill>
-                  <a:latin typeface="Verdana Pro" panose="020B0604030504040204" pitchFamily="34" charset="0"/>
-                </a:rPr>
-                <a:t>C5 methyltransferase</a:t>
-              </a:r>
-              <a:endParaRPr lang="en-CA" dirty="0">
-                <a:solidFill>
-                  <a:schemeClr val="bg1"/>
-                </a:solidFill>
-                <a:latin typeface="Verdana Pro" panose="020B0604030504040204" pitchFamily="34" charset="0"/>
-              </a:endParaRPr>
             </a:p>
           </p:txBody>
         </p:sp>
@@ -9433,14 +9432,8 @@
                 </a:solidFill>
                 <a:latin typeface="Georgia Pro" panose="02040502050405020303" pitchFamily="18" charset="0"/>
               </a:rPr>
-              <a:t>Q6IC7-E4ZAF3</a:t>
-            </a:r>
-            <a:endParaRPr lang="en-CA" sz="2600" b="1" dirty="0">
-              <a:solidFill>
-                <a:schemeClr val="bg1"/>
-              </a:solidFill>
-              <a:latin typeface="Georgia Pro" panose="02040502050405020303" pitchFamily="18" charset="0"/>
-            </a:endParaRPr>
+              <a:t>DNMT2: C5 methyltransferase</a:t>
+            </a:r>
           </a:p>
         </p:txBody>
       </p:sp>
@@ -9937,20 +9930,14 @@
           <a:lstStyle/>
           <a:p>
             <a:r>
-              <a:rPr lang="en-US" sz="2600" b="1" dirty="0">
+              <a:rPr lang="en-CA" sz="2600" b="1" dirty="0">
                 <a:solidFill>
                   <a:schemeClr val="bg1"/>
                 </a:solidFill>
                 <a:latin typeface="Georgia Pro" panose="02040502050405020303" pitchFamily="18" charset="0"/>
               </a:rPr>
-              <a:t>A0A7P0TB94-A0A509EDC2</a:t>
-            </a:r>
-            <a:endParaRPr lang="en-CA" sz="2600" b="1" dirty="0">
-              <a:solidFill>
-                <a:schemeClr val="bg1"/>
-              </a:solidFill>
-              <a:latin typeface="Georgia Pro" panose="02040502050405020303" pitchFamily="18" charset="0"/>
-            </a:endParaRPr>
+              <a:t>DDX20: HelY</a:t>
+            </a:r>
           </a:p>
         </p:txBody>
       </p:sp>
@@ -10006,7 +9993,7 @@
         <p:spPr>
           <a:xfrm>
             <a:off x="128582" y="1187351"/>
-            <a:ext cx="3128968" cy="923330"/>
+            <a:ext cx="3128968" cy="646331"/>
           </a:xfrm>
           <a:prstGeom prst="rect">
             <a:avLst/>
@@ -10026,18 +10013,16 @@
                 </a:solidFill>
                 <a:latin typeface="Verdana Pro" panose="020B0604030504040204" pitchFamily="34" charset="0"/>
               </a:rPr>
-              <a:t>A0A7P0TB94</a:t>
-            </a:r>
-          </a:p>
-          <a:p>
-            <a:r>
-              <a:rPr lang="en-US" dirty="0">
+              <a:t>DDX20 </a:t>
+            </a:r>
+            <a:r>
+              <a:rPr lang="en-US" sz="1200" dirty="0">
                 <a:solidFill>
                   <a:schemeClr val="bg1"/>
                 </a:solidFill>
                 <a:latin typeface="Verdana Pro" panose="020B0604030504040204" pitchFamily="34" charset="0"/>
               </a:rPr>
-              <a:t>DDX20</a:t>
+              <a:t>(A0A7P0TB94)</a:t>
             </a:r>
           </a:p>
           <a:p>
@@ -10094,18 +10079,16 @@
                 </a:solidFill>
                 <a:latin typeface="Verdana Pro" panose="020B0604030504040204" pitchFamily="34" charset="0"/>
               </a:rPr>
-              <a:t>A0A509EDC2</a:t>
-            </a:r>
-          </a:p>
-          <a:p>
-            <a:r>
-              <a:rPr lang="en-US" dirty="0">
+              <a:t>HelY </a:t>
+            </a:r>
+            <a:r>
+              <a:rPr lang="en-US" sz="1200" dirty="0">
                 <a:solidFill>
                   <a:schemeClr val="bg1"/>
                 </a:solidFill>
                 <a:latin typeface="Verdana Pro" panose="020B0604030504040204" pitchFamily="34" charset="0"/>
               </a:rPr>
-              <a:t>Shango system</a:t>
+              <a:t>(A0A509EDC2)</a:t>
             </a:r>
           </a:p>
           <a:p>
@@ -10116,7 +10099,7 @@
                 </a:solidFill>
                 <a:latin typeface="Verdana Pro" panose="020B0604030504040204" pitchFamily="34" charset="0"/>
               </a:rPr>
-              <a:t>Helicase HelY (SngC?)</a:t>
+              <a:t>(SngC?)</a:t>
             </a:r>
             <a:endParaRPr lang="en-CA" dirty="0">
               <a:solidFill>
@@ -10124,6 +10107,17 @@
               </a:solidFill>
               <a:latin typeface="Verdana Pro" panose="020B0604030504040204" pitchFamily="34" charset="0"/>
             </a:endParaRPr>
+          </a:p>
+          <a:p>
+            <a:r>
+              <a:rPr lang="en-US" dirty="0">
+                <a:solidFill>
+                  <a:schemeClr val="bg1"/>
+                </a:solidFill>
+                <a:latin typeface="Verdana Pro" panose="020B0604030504040204" pitchFamily="34" charset="0"/>
+              </a:rPr>
+              <a:t>Shango system</a:t>
+            </a:r>
           </a:p>
         </p:txBody>
       </p:sp>
@@ -11411,6 +11405,48 @@
           </a:prstGeom>
         </p:spPr>
       </p:pic>
+      <p:cxnSp>
+        <p:nvCxnSpPr>
+          <p:cNvPr id="5" name="Straight Arrow Connector 4">
+            <a:extLst>
+              <a:ext uri="{FF2B5EF4-FFF2-40B4-BE49-F238E27FC236}">
+                <a16:creationId xmlns:a16="http://schemas.microsoft.com/office/drawing/2014/main" id="{2B93C869-0E57-0AC7-8720-7FFFD8985D51}"/>
+              </a:ext>
+            </a:extLst>
+          </p:cNvPr>
+          <p:cNvCxnSpPr/>
+          <p:nvPr/>
+        </p:nvCxnSpPr>
+        <p:spPr>
+          <a:xfrm>
+            <a:off x="10662247" y="3597215"/>
+            <a:ext cx="0" cy="388189"/>
+          </a:xfrm>
+          <a:prstGeom prst="straightConnector1">
+            <a:avLst/>
+          </a:prstGeom>
+          <a:ln>
+            <a:solidFill>
+              <a:schemeClr val="tx1"/>
+            </a:solidFill>
+            <a:tailEnd type="triangle"/>
+          </a:ln>
+        </p:spPr>
+        <p:style>
+          <a:lnRef idx="2">
+            <a:schemeClr val="accent1"/>
+          </a:lnRef>
+          <a:fillRef idx="0">
+            <a:schemeClr val="accent1"/>
+          </a:fillRef>
+          <a:effectRef idx="1">
+            <a:schemeClr val="accent1"/>
+          </a:effectRef>
+          <a:fontRef idx="minor">
+            <a:schemeClr val="tx1"/>
+          </a:fontRef>
+        </p:style>
+      </p:cxnSp>
     </p:spTree>
     <p:extLst>
       <p:ext uri="{BB962C8B-B14F-4D97-AF65-F5344CB8AC3E}">
@@ -11606,7 +11642,7 @@
         <p:spPr>
           <a:xfrm>
             <a:off x="527958" y="62217"/>
-            <a:ext cx="9016875" cy="892552"/>
+            <a:ext cx="9016875" cy="492443"/>
           </a:xfrm>
           <a:prstGeom prst="rect">
             <a:avLst/>
@@ -11624,7 +11660,7 @@
                 <a:solidFill>
                   <a:schemeClr val="bg1"/>
                 </a:solidFill>
-                <a:latin typeface="Verdana Pro" panose="020B0604030504040204" pitchFamily="34" charset="0"/>
+                <a:latin typeface="Georgia Pro" panose="02040502050405020303" pitchFamily="18" charset="0"/>
               </a:rPr>
               <a:t>IUIS-IEI have significantly greater composite score</a:t>
             </a:r>
@@ -11632,7 +11668,7 @@
               <a:solidFill>
                 <a:schemeClr val="bg1"/>
               </a:solidFill>
-              <a:latin typeface="Verdana Pro" panose="020B0604030504040204" pitchFamily="34" charset="0"/>
+              <a:latin typeface="Georgia Pro" panose="02040502050405020303" pitchFamily="18" charset="0"/>
             </a:endParaRPr>
           </a:p>
         </p:txBody>
@@ -11729,6 +11765,528 @@
 </file>
 
 <file path=ppt/slides/slide17.xml><?xml version="1.0" encoding="utf-8"?>
+<p:sld xmlns:a="http://schemas.openxmlformats.org/drawingml/2006/main" xmlns:r="http://schemas.openxmlformats.org/officeDocument/2006/relationships" xmlns:p="http://schemas.openxmlformats.org/presentationml/2006/main">
+  <p:cSld>
+    <p:spTree>
+      <p:nvGrpSpPr>
+        <p:cNvPr id="1" name="">
+          <a:extLst>
+            <a:ext uri="{FF2B5EF4-FFF2-40B4-BE49-F238E27FC236}">
+              <a16:creationId xmlns:a16="http://schemas.microsoft.com/office/drawing/2014/main" id="{528B5EDC-0665-E7E2-9086-31BE15473DD0}"/>
+            </a:ext>
+          </a:extLst>
+        </p:cNvPr>
+        <p:cNvGrpSpPr/>
+        <p:nvPr/>
+      </p:nvGrpSpPr>
+      <p:grpSpPr>
+        <a:xfrm>
+          <a:off x="0" y="0"/>
+          <a:ext cx="0" cy="0"/>
+          <a:chOff x="0" y="0"/>
+          <a:chExt cx="0" cy="0"/>
+        </a:xfrm>
+      </p:grpSpPr>
+      <p:sp>
+        <p:nvSpPr>
+          <p:cNvPr id="6" name="Rectangle: Rounded Corners 5">
+            <a:extLst>
+              <a:ext uri="{FF2B5EF4-FFF2-40B4-BE49-F238E27FC236}">
+                <a16:creationId xmlns:a16="http://schemas.microsoft.com/office/drawing/2014/main" id="{4BEE7EB9-6111-B105-D72F-68CD72883E4D}"/>
+              </a:ext>
+            </a:extLst>
+          </p:cNvPr>
+          <p:cNvSpPr/>
+          <p:nvPr/>
+        </p:nvSpPr>
+        <p:spPr>
+          <a:xfrm>
+            <a:off x="315257" y="-5932"/>
+            <a:ext cx="9363581" cy="628742"/>
+          </a:xfrm>
+          <a:prstGeom prst="roundRect">
+            <a:avLst/>
+          </a:prstGeom>
+          <a:solidFill>
+            <a:srgbClr val="0162B3"/>
+          </a:solidFill>
+          <a:ln>
+            <a:solidFill>
+              <a:srgbClr val="0162B3"/>
+            </a:solidFill>
+          </a:ln>
+        </p:spPr>
+        <p:style>
+          <a:lnRef idx="2">
+            <a:schemeClr val="accent1">
+              <a:shade val="50000"/>
+            </a:schemeClr>
+          </a:lnRef>
+          <a:fillRef idx="1">
+            <a:schemeClr val="accent1"/>
+          </a:fillRef>
+          <a:effectRef idx="0">
+            <a:schemeClr val="accent1"/>
+          </a:effectRef>
+          <a:fontRef idx="minor">
+            <a:schemeClr val="lt1"/>
+          </a:fontRef>
+        </p:style>
+        <p:txBody>
+          <a:bodyPr rtlCol="0" anchor="ctr"/>
+          <a:lstStyle>
+            <a:defPPr>
+              <a:defRPr lang="en-US"/>
+            </a:defPPr>
+            <a:lvl1pPr marL="0" algn="l" defTabSz="914400" rtl="0" eaLnBrk="1" latinLnBrk="0" hangingPunct="1">
+              <a:defRPr sz="1800" kern="1200">
+                <a:solidFill>
+                  <a:schemeClr val="lt1"/>
+                </a:solidFill>
+                <a:latin typeface="+mn-lt"/>
+                <a:ea typeface="+mn-ea"/>
+                <a:cs typeface="+mn-cs"/>
+              </a:defRPr>
+            </a:lvl1pPr>
+            <a:lvl2pPr marL="457200" algn="l" defTabSz="914400" rtl="0" eaLnBrk="1" latinLnBrk="0" hangingPunct="1">
+              <a:defRPr sz="1800" kern="1200">
+                <a:solidFill>
+                  <a:schemeClr val="lt1"/>
+                </a:solidFill>
+                <a:latin typeface="+mn-lt"/>
+                <a:ea typeface="+mn-ea"/>
+                <a:cs typeface="+mn-cs"/>
+              </a:defRPr>
+            </a:lvl2pPr>
+            <a:lvl3pPr marL="914400" algn="l" defTabSz="914400" rtl="0" eaLnBrk="1" latinLnBrk="0" hangingPunct="1">
+              <a:defRPr sz="1800" kern="1200">
+                <a:solidFill>
+                  <a:schemeClr val="lt1"/>
+                </a:solidFill>
+                <a:latin typeface="+mn-lt"/>
+                <a:ea typeface="+mn-ea"/>
+                <a:cs typeface="+mn-cs"/>
+              </a:defRPr>
+            </a:lvl3pPr>
+            <a:lvl4pPr marL="1371600" algn="l" defTabSz="914400" rtl="0" eaLnBrk="1" latinLnBrk="0" hangingPunct="1">
+              <a:defRPr sz="1800" kern="1200">
+                <a:solidFill>
+                  <a:schemeClr val="lt1"/>
+                </a:solidFill>
+                <a:latin typeface="+mn-lt"/>
+                <a:ea typeface="+mn-ea"/>
+                <a:cs typeface="+mn-cs"/>
+              </a:defRPr>
+            </a:lvl4pPr>
+            <a:lvl5pPr marL="1828800" algn="l" defTabSz="914400" rtl="0" eaLnBrk="1" latinLnBrk="0" hangingPunct="1">
+              <a:defRPr sz="1800" kern="1200">
+                <a:solidFill>
+                  <a:schemeClr val="lt1"/>
+                </a:solidFill>
+                <a:latin typeface="+mn-lt"/>
+                <a:ea typeface="+mn-ea"/>
+                <a:cs typeface="+mn-cs"/>
+              </a:defRPr>
+            </a:lvl5pPr>
+            <a:lvl6pPr marL="2286000" algn="l" defTabSz="914400" rtl="0" eaLnBrk="1" latinLnBrk="0" hangingPunct="1">
+              <a:defRPr sz="1800" kern="1200">
+                <a:solidFill>
+                  <a:schemeClr val="lt1"/>
+                </a:solidFill>
+                <a:latin typeface="+mn-lt"/>
+                <a:ea typeface="+mn-ea"/>
+                <a:cs typeface="+mn-cs"/>
+              </a:defRPr>
+            </a:lvl6pPr>
+            <a:lvl7pPr marL="2743200" algn="l" defTabSz="914400" rtl="0" eaLnBrk="1" latinLnBrk="0" hangingPunct="1">
+              <a:defRPr sz="1800" kern="1200">
+                <a:solidFill>
+                  <a:schemeClr val="lt1"/>
+                </a:solidFill>
+                <a:latin typeface="+mn-lt"/>
+                <a:ea typeface="+mn-ea"/>
+                <a:cs typeface="+mn-cs"/>
+              </a:defRPr>
+            </a:lvl7pPr>
+            <a:lvl8pPr marL="3200400" algn="l" defTabSz="914400" rtl="0" eaLnBrk="1" latinLnBrk="0" hangingPunct="1">
+              <a:defRPr sz="1800" kern="1200">
+                <a:solidFill>
+                  <a:schemeClr val="lt1"/>
+                </a:solidFill>
+                <a:latin typeface="+mn-lt"/>
+                <a:ea typeface="+mn-ea"/>
+                <a:cs typeface="+mn-cs"/>
+              </a:defRPr>
+            </a:lvl8pPr>
+            <a:lvl9pPr marL="3657600" algn="l" defTabSz="914400" rtl="0" eaLnBrk="1" latinLnBrk="0" hangingPunct="1">
+              <a:defRPr sz="1800" kern="1200">
+                <a:solidFill>
+                  <a:schemeClr val="lt1"/>
+                </a:solidFill>
+                <a:latin typeface="+mn-lt"/>
+                <a:ea typeface="+mn-ea"/>
+                <a:cs typeface="+mn-cs"/>
+              </a:defRPr>
+            </a:lvl9pPr>
+          </a:lstStyle>
+          <a:p>
+            <a:pPr algn="ctr"/>
+            <a:endParaRPr lang="en-CA">
+              <a:latin typeface="Verdana Pro" panose="020B0604030504040204" pitchFamily="34" charset="0"/>
+            </a:endParaRPr>
+          </a:p>
+        </p:txBody>
+      </p:sp>
+      <p:sp>
+        <p:nvSpPr>
+          <p:cNvPr id="8" name="TextBox 7">
+            <a:extLst>
+              <a:ext uri="{FF2B5EF4-FFF2-40B4-BE49-F238E27FC236}">
+                <a16:creationId xmlns:a16="http://schemas.microsoft.com/office/drawing/2014/main" id="{C3EEB74C-4BCE-7110-7209-CA9BD1E82135}"/>
+              </a:ext>
+            </a:extLst>
+          </p:cNvPr>
+          <p:cNvSpPr txBox="1"/>
+          <p:nvPr/>
+        </p:nvSpPr>
+        <p:spPr>
+          <a:xfrm>
+            <a:off x="527958" y="62217"/>
+            <a:ext cx="9016875" cy="492443"/>
+          </a:xfrm>
+          <a:prstGeom prst="rect">
+            <a:avLst/>
+          </a:prstGeom>
+          <a:noFill/>
+        </p:spPr>
+        <p:txBody>
+          <a:bodyPr wrap="square" rtlCol="0">
+            <a:spAutoFit/>
+          </a:bodyPr>
+          <a:lstStyle/>
+          <a:p>
+            <a:r>
+              <a:rPr lang="en-US" sz="2600" b="1" dirty="0">
+                <a:solidFill>
+                  <a:schemeClr val="bg1"/>
+                </a:solidFill>
+                <a:latin typeface="Georgia Pro" panose="02040502050405020303" pitchFamily="18" charset="0"/>
+              </a:rPr>
+              <a:t>ImmPort annotations on &gt;= 0.825 set</a:t>
+            </a:r>
+            <a:endParaRPr lang="en-CA" sz="2600" b="1" dirty="0">
+              <a:solidFill>
+                <a:schemeClr val="bg1"/>
+              </a:solidFill>
+              <a:latin typeface="Georgia Pro" panose="02040502050405020303" pitchFamily="18" charset="0"/>
+            </a:endParaRPr>
+          </a:p>
+        </p:txBody>
+      </p:sp>
+      <p:grpSp>
+        <p:nvGrpSpPr>
+          <p:cNvPr id="18" name="Group 17">
+            <a:extLst>
+              <a:ext uri="{FF2B5EF4-FFF2-40B4-BE49-F238E27FC236}">
+                <a16:creationId xmlns:a16="http://schemas.microsoft.com/office/drawing/2014/main" id="{44D1C052-910F-B676-F3E1-28310C7A9E0B}"/>
+              </a:ext>
+            </a:extLst>
+          </p:cNvPr>
+          <p:cNvGrpSpPr/>
+          <p:nvPr/>
+        </p:nvGrpSpPr>
+        <p:grpSpPr>
+          <a:xfrm>
+            <a:off x="621102" y="1509623"/>
+            <a:ext cx="4071668" cy="4037163"/>
+            <a:chOff x="457200" y="1570008"/>
+            <a:chExt cx="4071668" cy="4037163"/>
+          </a:xfrm>
+        </p:grpSpPr>
+        <p:pic>
+          <p:nvPicPr>
+            <p:cNvPr id="3" name="Graphic 2">
+              <a:extLst>
+                <a:ext uri="{FF2B5EF4-FFF2-40B4-BE49-F238E27FC236}">
+                  <a16:creationId xmlns:a16="http://schemas.microsoft.com/office/drawing/2014/main" id="{A3F1735D-EB76-444F-1A6C-8C6CFB6F2D3D}"/>
+                </a:ext>
+              </a:extLst>
+            </p:cNvPr>
+            <p:cNvPicPr>
+              <a:picLocks noChangeAspect="1"/>
+            </p:cNvPicPr>
+            <p:nvPr/>
+          </p:nvPicPr>
+          <p:blipFill>
+            <a:blip>
+              <a:extLst>
+                <a:ext uri="{96DAC541-7B7A-43D3-8B79-37D633B846F1}">
+                  <asvg:svgBlip xmlns:asvg="http://schemas.microsoft.com/office/drawing/2016/SVG/main" r:embed="rId2"/>
+                </a:ext>
+              </a:extLst>
+            </a:blip>
+            <a:srcRect l="2371" t="5391" r="52868" b="4428"/>
+            <a:stretch>
+              <a:fillRect/>
+            </a:stretch>
+          </p:blipFill>
+          <p:spPr>
+            <a:xfrm>
+              <a:off x="457200" y="1570008"/>
+              <a:ext cx="4071668" cy="4037163"/>
+            </a:xfrm>
+            <a:prstGeom prst="rect">
+              <a:avLst/>
+            </a:prstGeom>
+          </p:spPr>
+        </p:pic>
+        <p:sp>
+          <p:nvSpPr>
+            <p:cNvPr id="4" name="TextBox 3">
+              <a:extLst>
+                <a:ext uri="{FF2B5EF4-FFF2-40B4-BE49-F238E27FC236}">
+                  <a16:creationId xmlns:a16="http://schemas.microsoft.com/office/drawing/2014/main" id="{A14F3DEA-1231-4BEF-A74A-E08B8A03D02E}"/>
+                </a:ext>
+              </a:extLst>
+            </p:cNvPr>
+            <p:cNvSpPr txBox="1"/>
+            <p:nvPr/>
+          </p:nvSpPr>
+          <p:spPr>
+            <a:xfrm>
+              <a:off x="901460" y="3670539"/>
+              <a:ext cx="914400" cy="276999"/>
+            </a:xfrm>
+            <a:prstGeom prst="rect">
+              <a:avLst/>
+            </a:prstGeom>
+            <a:solidFill>
+              <a:srgbClr val="333336"/>
+            </a:solidFill>
+          </p:spPr>
+          <p:txBody>
+            <a:bodyPr wrap="square" rtlCol="0">
+              <a:spAutoFit/>
+            </a:bodyPr>
+            <a:lstStyle/>
+            <a:p>
+              <a:pPr algn="ctr"/>
+              <a:r>
+                <a:rPr lang="en-US" sz="1200" dirty="0">
+                  <a:solidFill>
+                    <a:schemeClr val="bg1"/>
+                  </a:solidFill>
+                  <a:latin typeface="Verdana Pro" panose="020B0604030504040204" pitchFamily="34" charset="0"/>
+                </a:rPr>
+                <a:t>57.3%</a:t>
+              </a:r>
+              <a:endParaRPr lang="en-CA" sz="1200" dirty="0">
+                <a:solidFill>
+                  <a:schemeClr val="bg1"/>
+                </a:solidFill>
+                <a:latin typeface="Verdana Pro" panose="020B0604030504040204" pitchFamily="34" charset="0"/>
+              </a:endParaRPr>
+            </a:p>
+          </p:txBody>
+        </p:sp>
+      </p:grpSp>
+      <p:grpSp>
+        <p:nvGrpSpPr>
+          <p:cNvPr id="17" name="Group 16">
+            <a:extLst>
+              <a:ext uri="{FF2B5EF4-FFF2-40B4-BE49-F238E27FC236}">
+                <a16:creationId xmlns:a16="http://schemas.microsoft.com/office/drawing/2014/main" id="{3F4CD489-DBBD-AEFE-9EFE-F3F5783E5F04}"/>
+              </a:ext>
+            </a:extLst>
+          </p:cNvPr>
+          <p:cNvGrpSpPr/>
+          <p:nvPr/>
+        </p:nvGrpSpPr>
+        <p:grpSpPr>
+          <a:xfrm>
+            <a:off x="5350627" y="2911412"/>
+            <a:ext cx="4728532" cy="2855343"/>
+            <a:chOff x="6668219" y="1992702"/>
+            <a:chExt cx="4728532" cy="2855343"/>
+          </a:xfrm>
+        </p:grpSpPr>
+        <p:pic>
+          <p:nvPicPr>
+            <p:cNvPr id="15" name="Graphic 14">
+              <a:extLst>
+                <a:ext uri="{FF2B5EF4-FFF2-40B4-BE49-F238E27FC236}">
+                  <a16:creationId xmlns:a16="http://schemas.microsoft.com/office/drawing/2014/main" id="{A6461EC0-AD35-7CE5-29EB-92C6A716520F}"/>
+                </a:ext>
+              </a:extLst>
+            </p:cNvPr>
+            <p:cNvPicPr>
+              <a:picLocks noChangeAspect="1"/>
+            </p:cNvPicPr>
+            <p:nvPr/>
+          </p:nvPicPr>
+          <p:blipFill>
+            <a:blip>
+              <a:extLst>
+                <a:ext uri="{96DAC541-7B7A-43D3-8B79-37D633B846F1}">
+                  <asvg:svgBlip xmlns:asvg="http://schemas.microsoft.com/office/drawing/2016/SVG/main" r:embed="rId2"/>
+                </a:ext>
+              </a:extLst>
+            </a:blip>
+            <a:srcRect l="48017" t="18399" b="17819"/>
+            <a:stretch>
+              <a:fillRect/>
+            </a:stretch>
+          </p:blipFill>
+          <p:spPr>
+            <a:xfrm>
+              <a:off x="6668219" y="1992702"/>
+              <a:ext cx="4728532" cy="2855343"/>
+            </a:xfrm>
+            <a:prstGeom prst="rect">
+              <a:avLst/>
+            </a:prstGeom>
+          </p:spPr>
+        </p:pic>
+        <p:sp>
+          <p:nvSpPr>
+            <p:cNvPr id="16" name="TextBox 15">
+              <a:extLst>
+                <a:ext uri="{FF2B5EF4-FFF2-40B4-BE49-F238E27FC236}">
+                  <a16:creationId xmlns:a16="http://schemas.microsoft.com/office/drawing/2014/main" id="{4EBB48B9-4792-792E-773D-2B6C192A2174}"/>
+                </a:ext>
+              </a:extLst>
+            </p:cNvPr>
+            <p:cNvSpPr txBox="1"/>
+            <p:nvPr/>
+          </p:nvSpPr>
+          <p:spPr>
+            <a:xfrm>
+              <a:off x="7571116" y="2152289"/>
+              <a:ext cx="2898476" cy="276999"/>
+            </a:xfrm>
+            <a:prstGeom prst="rect">
+              <a:avLst/>
+            </a:prstGeom>
+            <a:solidFill>
+              <a:schemeClr val="bg1"/>
+            </a:solidFill>
+          </p:spPr>
+          <p:txBody>
+            <a:bodyPr wrap="square" rtlCol="0">
+              <a:spAutoFit/>
+            </a:bodyPr>
+            <a:lstStyle/>
+            <a:p>
+              <a:pPr algn="ctr"/>
+              <a:r>
+                <a:rPr lang="en-US" sz="1200" dirty="0">
+                  <a:latin typeface="Verdana Pro" panose="020B0604030504040204" pitchFamily="34" charset="0"/>
+                </a:rPr>
+                <a:t>ImmPort pathway annotation</a:t>
+              </a:r>
+              <a:endParaRPr lang="en-CA" sz="1200" dirty="0">
+                <a:latin typeface="Verdana Pro" panose="020B0604030504040204" pitchFamily="34" charset="0"/>
+              </a:endParaRPr>
+            </a:p>
+          </p:txBody>
+        </p:sp>
+      </p:grpSp>
+      <p:sp>
+        <p:nvSpPr>
+          <p:cNvPr id="19" name="TextBox 18">
+            <a:extLst>
+              <a:ext uri="{FF2B5EF4-FFF2-40B4-BE49-F238E27FC236}">
+                <a16:creationId xmlns:a16="http://schemas.microsoft.com/office/drawing/2014/main" id="{E75E80F6-ADE0-6E16-C2F9-C2702EEBCB69}"/>
+              </a:ext>
+            </a:extLst>
+          </p:cNvPr>
+          <p:cNvSpPr txBox="1"/>
+          <p:nvPr/>
+        </p:nvSpPr>
+        <p:spPr>
+          <a:xfrm>
+            <a:off x="5414512" y="1324957"/>
+            <a:ext cx="5515155" cy="1677382"/>
+          </a:xfrm>
+          <a:prstGeom prst="rect">
+            <a:avLst/>
+          </a:prstGeom>
+          <a:noFill/>
+        </p:spPr>
+        <p:txBody>
+          <a:bodyPr wrap="square" rtlCol="0">
+            <a:spAutoFit/>
+          </a:bodyPr>
+          <a:lstStyle/>
+          <a:p>
+            <a:pPr>
+              <a:spcAft>
+                <a:spcPts val="600"/>
+              </a:spcAft>
+            </a:pPr>
+            <a:r>
+              <a:rPr lang="en-US" dirty="0">
+                <a:latin typeface="Verdana Pro" panose="020B0604030504040204" pitchFamily="34" charset="0"/>
+              </a:rPr>
+              <a:t>ImmPort annotation set</a:t>
+            </a:r>
+          </a:p>
+          <a:p>
+            <a:pPr marL="285750" indent="-285750">
+              <a:spcAft>
+                <a:spcPts val="600"/>
+              </a:spcAft>
+              <a:buFont typeface="Arial" panose="020B0604020202020204" pitchFamily="34" charset="0"/>
+              <a:buChar char="•"/>
+            </a:pPr>
+            <a:r>
+              <a:rPr lang="en-US" sz="1400" dirty="0">
+                <a:latin typeface="Verdana Pro" panose="020B0604030504040204" pitchFamily="34" charset="0"/>
+              </a:rPr>
+              <a:t>curated from "Immune System" event in Reactome and "Immune System Process" term in GO</a:t>
+            </a:r>
+          </a:p>
+          <a:p>
+            <a:pPr marL="285750" indent="-285750">
+              <a:spcAft>
+                <a:spcPts val="600"/>
+              </a:spcAft>
+              <a:buFont typeface="Arial" panose="020B0604020202020204" pitchFamily="34" charset="0"/>
+              <a:buChar char="•"/>
+            </a:pPr>
+            <a:r>
+              <a:rPr lang="en-US" sz="1400" dirty="0">
+                <a:latin typeface="Verdana Pro" panose="020B0604030504040204" pitchFamily="34" charset="0"/>
+              </a:rPr>
+              <a:t>further separated these broad term events until each gene list contains a maximum of 200 genes</a:t>
+            </a:r>
+          </a:p>
+          <a:p>
+            <a:pPr>
+              <a:spcAft>
+                <a:spcPts val="600"/>
+              </a:spcAft>
+            </a:pPr>
+            <a:endParaRPr lang="en-CA" sz="1400" dirty="0">
+              <a:latin typeface="Verdana Pro" panose="020B0604030504040204" pitchFamily="34" charset="0"/>
+            </a:endParaRPr>
+          </a:p>
+        </p:txBody>
+      </p:sp>
+    </p:spTree>
+    <p:extLst>
+      <p:ext uri="{BB962C8B-B14F-4D97-AF65-F5344CB8AC3E}">
+        <p14:creationId xmlns:p14="http://schemas.microsoft.com/office/powerpoint/2010/main" val="2856482574"/>
+      </p:ext>
+    </p:extLst>
+  </p:cSld>
+  <p:clrMapOvr>
+    <a:masterClrMapping/>
+  </p:clrMapOvr>
+</p:sld>
+</file>
+
+<file path=ppt/slides/slide18.xml><?xml version="1.0" encoding="utf-8"?>
 <p:sld xmlns:a="http://schemas.openxmlformats.org/drawingml/2006/main" xmlns:r="http://schemas.openxmlformats.org/officeDocument/2006/relationships" xmlns:p="http://schemas.openxmlformats.org/presentationml/2006/main">
   <p:cSld>
     <p:bg>
@@ -11822,7 +12380,7 @@
           <a:p>
             <a:fld id="{D20FA860-28F0-477C-BD76-C96AC22CF614}" type="slidenum">
               <a:rPr lang="en-CA" smtClean="0"/>
-              <a:t>17</a:t>
+              <a:t>18</a:t>
             </a:fld>
             <a:endParaRPr lang="en-CA"/>
           </a:p>
@@ -11999,7 +12557,7 @@
 </p:sld>
 </file>
 
-<file path=ppt/slides/slide18.xml><?xml version="1.0" encoding="utf-8"?>
+<file path=ppt/slides/slide19.xml><?xml version="1.0" encoding="utf-8"?>
 <p:sld xmlns:a="http://schemas.openxmlformats.org/drawingml/2006/main" xmlns:r="http://schemas.openxmlformats.org/officeDocument/2006/relationships" xmlns:p="http://schemas.openxmlformats.org/presentationml/2006/main">
   <p:cSld>
     <p:spTree>
@@ -12375,7 +12933,7 @@
           <a:p>
             <a:fld id="{D20FA860-28F0-477C-BD76-C96AC22CF614}" type="slidenum">
               <a:rPr lang="en-CA" smtClean="0"/>
-              <a:t>18</a:t>
+              <a:t>19</a:t>
             </a:fld>
             <a:endParaRPr lang="en-CA"/>
           </a:p>
@@ -12385,387 +12943,6 @@
     <p:extLst>
       <p:ext uri="{BB962C8B-B14F-4D97-AF65-F5344CB8AC3E}">
         <p14:creationId xmlns:p14="http://schemas.microsoft.com/office/powerpoint/2010/main" val="659556371"/>
-      </p:ext>
-    </p:extLst>
-  </p:cSld>
-  <p:clrMapOvr>
-    <a:masterClrMapping/>
-  </p:clrMapOvr>
-</p:sld>
-</file>
-
-<file path=ppt/slides/slide19.xml><?xml version="1.0" encoding="utf-8"?>
-<p:sld xmlns:a="http://schemas.openxmlformats.org/drawingml/2006/main" xmlns:r="http://schemas.openxmlformats.org/officeDocument/2006/relationships" xmlns:p="http://schemas.openxmlformats.org/presentationml/2006/main">
-  <p:cSld>
-    <p:spTree>
-      <p:nvGrpSpPr>
-        <p:cNvPr id="1" name="">
-          <a:extLst>
-            <a:ext uri="{FF2B5EF4-FFF2-40B4-BE49-F238E27FC236}">
-              <a16:creationId xmlns:a16="http://schemas.microsoft.com/office/drawing/2014/main" id="{5E96BC46-7673-C84B-18B4-63539AA9C004}"/>
-            </a:ext>
-          </a:extLst>
-        </p:cNvPr>
-        <p:cNvGrpSpPr/>
-        <p:nvPr/>
-      </p:nvGrpSpPr>
-      <p:grpSpPr>
-        <a:xfrm>
-          <a:off x="0" y="0"/>
-          <a:ext cx="0" cy="0"/>
-          <a:chOff x="0" y="0"/>
-          <a:chExt cx="0" cy="0"/>
-        </a:xfrm>
-      </p:grpSpPr>
-      <p:sp>
-        <p:nvSpPr>
-          <p:cNvPr id="15" name="Rectangle: Rounded Corners 14">
-            <a:extLst>
-              <a:ext uri="{FF2B5EF4-FFF2-40B4-BE49-F238E27FC236}">
-                <a16:creationId xmlns:a16="http://schemas.microsoft.com/office/drawing/2014/main" id="{7DA48913-4EF7-7226-450E-EB863B768EE5}"/>
-              </a:ext>
-            </a:extLst>
-          </p:cNvPr>
-          <p:cNvSpPr/>
-          <p:nvPr/>
-        </p:nvSpPr>
-        <p:spPr>
-          <a:xfrm>
-            <a:off x="315257" y="8582"/>
-            <a:ext cx="9363581" cy="628742"/>
-          </a:xfrm>
-          <a:prstGeom prst="roundRect">
-            <a:avLst/>
-          </a:prstGeom>
-          <a:solidFill>
-            <a:srgbClr val="0162B3"/>
-          </a:solidFill>
-          <a:ln>
-            <a:solidFill>
-              <a:srgbClr val="0162B3"/>
-            </a:solidFill>
-          </a:ln>
-        </p:spPr>
-        <p:style>
-          <a:lnRef idx="2">
-            <a:schemeClr val="accent1">
-              <a:shade val="50000"/>
-            </a:schemeClr>
-          </a:lnRef>
-          <a:fillRef idx="1">
-            <a:schemeClr val="accent1"/>
-          </a:fillRef>
-          <a:effectRef idx="0">
-            <a:schemeClr val="accent1"/>
-          </a:effectRef>
-          <a:fontRef idx="minor">
-            <a:schemeClr val="lt1"/>
-          </a:fontRef>
-        </p:style>
-        <p:txBody>
-          <a:bodyPr rtlCol="0" anchor="ctr"/>
-          <a:lstStyle>
-            <a:defPPr>
-              <a:defRPr lang="en-US"/>
-            </a:defPPr>
-            <a:lvl1pPr marL="0" algn="l" defTabSz="914400" rtl="0" eaLnBrk="1" latinLnBrk="0" hangingPunct="1">
-              <a:defRPr sz="1800" kern="1200">
-                <a:solidFill>
-                  <a:schemeClr val="lt1"/>
-                </a:solidFill>
-                <a:latin typeface="+mn-lt"/>
-                <a:ea typeface="+mn-ea"/>
-                <a:cs typeface="+mn-cs"/>
-              </a:defRPr>
-            </a:lvl1pPr>
-            <a:lvl2pPr marL="457200" algn="l" defTabSz="914400" rtl="0" eaLnBrk="1" latinLnBrk="0" hangingPunct="1">
-              <a:defRPr sz="1800" kern="1200">
-                <a:solidFill>
-                  <a:schemeClr val="lt1"/>
-                </a:solidFill>
-                <a:latin typeface="+mn-lt"/>
-                <a:ea typeface="+mn-ea"/>
-                <a:cs typeface="+mn-cs"/>
-              </a:defRPr>
-            </a:lvl2pPr>
-            <a:lvl3pPr marL="914400" algn="l" defTabSz="914400" rtl="0" eaLnBrk="1" latinLnBrk="0" hangingPunct="1">
-              <a:defRPr sz="1800" kern="1200">
-                <a:solidFill>
-                  <a:schemeClr val="lt1"/>
-                </a:solidFill>
-                <a:latin typeface="+mn-lt"/>
-                <a:ea typeface="+mn-ea"/>
-                <a:cs typeface="+mn-cs"/>
-              </a:defRPr>
-            </a:lvl3pPr>
-            <a:lvl4pPr marL="1371600" algn="l" defTabSz="914400" rtl="0" eaLnBrk="1" latinLnBrk="0" hangingPunct="1">
-              <a:defRPr sz="1800" kern="1200">
-                <a:solidFill>
-                  <a:schemeClr val="lt1"/>
-                </a:solidFill>
-                <a:latin typeface="+mn-lt"/>
-                <a:ea typeface="+mn-ea"/>
-                <a:cs typeface="+mn-cs"/>
-              </a:defRPr>
-            </a:lvl4pPr>
-            <a:lvl5pPr marL="1828800" algn="l" defTabSz="914400" rtl="0" eaLnBrk="1" latinLnBrk="0" hangingPunct="1">
-              <a:defRPr sz="1800" kern="1200">
-                <a:solidFill>
-                  <a:schemeClr val="lt1"/>
-                </a:solidFill>
-                <a:latin typeface="+mn-lt"/>
-                <a:ea typeface="+mn-ea"/>
-                <a:cs typeface="+mn-cs"/>
-              </a:defRPr>
-            </a:lvl5pPr>
-            <a:lvl6pPr marL="2286000" algn="l" defTabSz="914400" rtl="0" eaLnBrk="1" latinLnBrk="0" hangingPunct="1">
-              <a:defRPr sz="1800" kern="1200">
-                <a:solidFill>
-                  <a:schemeClr val="lt1"/>
-                </a:solidFill>
-                <a:latin typeface="+mn-lt"/>
-                <a:ea typeface="+mn-ea"/>
-                <a:cs typeface="+mn-cs"/>
-              </a:defRPr>
-            </a:lvl6pPr>
-            <a:lvl7pPr marL="2743200" algn="l" defTabSz="914400" rtl="0" eaLnBrk="1" latinLnBrk="0" hangingPunct="1">
-              <a:defRPr sz="1800" kern="1200">
-                <a:solidFill>
-                  <a:schemeClr val="lt1"/>
-                </a:solidFill>
-                <a:latin typeface="+mn-lt"/>
-                <a:ea typeface="+mn-ea"/>
-                <a:cs typeface="+mn-cs"/>
-              </a:defRPr>
-            </a:lvl7pPr>
-            <a:lvl8pPr marL="3200400" algn="l" defTabSz="914400" rtl="0" eaLnBrk="1" latinLnBrk="0" hangingPunct="1">
-              <a:defRPr sz="1800" kern="1200">
-                <a:solidFill>
-                  <a:schemeClr val="lt1"/>
-                </a:solidFill>
-                <a:latin typeface="+mn-lt"/>
-                <a:ea typeface="+mn-ea"/>
-                <a:cs typeface="+mn-cs"/>
-              </a:defRPr>
-            </a:lvl8pPr>
-            <a:lvl9pPr marL="3657600" algn="l" defTabSz="914400" rtl="0" eaLnBrk="1" latinLnBrk="0" hangingPunct="1">
-              <a:defRPr sz="1800" kern="1200">
-                <a:solidFill>
-                  <a:schemeClr val="lt1"/>
-                </a:solidFill>
-                <a:latin typeface="+mn-lt"/>
-                <a:ea typeface="+mn-ea"/>
-                <a:cs typeface="+mn-cs"/>
-              </a:defRPr>
-            </a:lvl9pPr>
-          </a:lstStyle>
-          <a:p>
-            <a:pPr algn="ctr"/>
-            <a:endParaRPr lang="en-CA"/>
-          </a:p>
-        </p:txBody>
-      </p:sp>
-      <p:sp>
-        <p:nvSpPr>
-          <p:cNvPr id="19" name="TextBox 18">
-            <a:extLst>
-              <a:ext uri="{FF2B5EF4-FFF2-40B4-BE49-F238E27FC236}">
-                <a16:creationId xmlns:a16="http://schemas.microsoft.com/office/drawing/2014/main" id="{C3A09E84-A853-2CE4-2353-6F32C167F0F1}"/>
-              </a:ext>
-            </a:extLst>
-          </p:cNvPr>
-          <p:cNvSpPr txBox="1"/>
-          <p:nvPr/>
-        </p:nvSpPr>
-        <p:spPr>
-          <a:xfrm>
-            <a:off x="527959" y="76731"/>
-            <a:ext cx="8710932" cy="492443"/>
-          </a:xfrm>
-          <a:prstGeom prst="rect">
-            <a:avLst/>
-          </a:prstGeom>
-          <a:noFill/>
-        </p:spPr>
-        <p:txBody>
-          <a:bodyPr wrap="square" rtlCol="0">
-            <a:spAutoFit/>
-          </a:bodyPr>
-          <a:lstStyle/>
-          <a:p>
-            <a:r>
-              <a:rPr lang="en-US" sz="2600" b="1" dirty="0">
-                <a:solidFill>
-                  <a:schemeClr val="bg1"/>
-                </a:solidFill>
-                <a:latin typeface="Georgia Pro" panose="02040502050405020303" pitchFamily="18" charset="0"/>
-              </a:rPr>
-              <a:t>References</a:t>
-            </a:r>
-            <a:endParaRPr lang="en-CA" sz="2600" b="1" dirty="0">
-              <a:solidFill>
-                <a:schemeClr val="bg1"/>
-              </a:solidFill>
-              <a:latin typeface="Georgia Pro" panose="02040502050405020303" pitchFamily="18" charset="0"/>
-            </a:endParaRPr>
-          </a:p>
-        </p:txBody>
-      </p:sp>
-      <p:sp>
-        <p:nvSpPr>
-          <p:cNvPr id="2" name="TextBox 1">
-            <a:extLst>
-              <a:ext uri="{FF2B5EF4-FFF2-40B4-BE49-F238E27FC236}">
-                <a16:creationId xmlns:a16="http://schemas.microsoft.com/office/drawing/2014/main" id="{D555B33F-2E1A-FAA4-32B8-ADE7D02D78D0}"/>
-              </a:ext>
-            </a:extLst>
-          </p:cNvPr>
-          <p:cNvSpPr txBox="1"/>
-          <p:nvPr/>
-        </p:nvSpPr>
-        <p:spPr>
-          <a:xfrm>
-            <a:off x="527958" y="1146628"/>
-            <a:ext cx="9363581" cy="3277820"/>
-          </a:xfrm>
-          <a:prstGeom prst="rect">
-            <a:avLst/>
-          </a:prstGeom>
-          <a:noFill/>
-        </p:spPr>
-        <p:txBody>
-          <a:bodyPr wrap="square" rtlCol="0">
-            <a:spAutoFit/>
-          </a:bodyPr>
-          <a:lstStyle/>
-          <a:p>
-            <a:pPr marL="342900" indent="-342900">
-              <a:spcAft>
-                <a:spcPts val="600"/>
-              </a:spcAft>
-              <a:buFont typeface="+mj-lt"/>
-              <a:buAutoNum type="arabicPeriod"/>
-            </a:pPr>
-            <a:r>
-              <a:rPr lang="en-CA" sz="1400" dirty="0">
-                <a:latin typeface="Verdana Pro" panose="020B0604030504040204" pitchFamily="34" charset="0"/>
-              </a:rPr>
-              <a:t>Schaefer M, et al. RNA methylation by Dnmt2 protects transfer RNAs against stress-induced cleavage. Genes Dev. 2010;24:1590–1595. DOI: 10.1101/gad.586710.</a:t>
-            </a:r>
-          </a:p>
-          <a:p>
-            <a:pPr marL="342900" indent="-342900">
-              <a:spcAft>
-                <a:spcPts val="600"/>
-              </a:spcAft>
-              <a:buFont typeface="+mj-lt"/>
-              <a:buAutoNum type="arabicPeriod"/>
-            </a:pPr>
-            <a:r>
-              <a:rPr lang="en-CA" sz="1400" dirty="0">
-                <a:latin typeface="Verdana Pro" panose="020B0604030504040204" pitchFamily="34" charset="0"/>
-              </a:rPr>
-              <a:t>Dev RR, et al. Cytosine methylation by DNMT2 facilitates stability and survival of HIV-1 RNA in the host cell during infection. Biochem J. 2017;474:2009–2026. DOI: 10.1042/BCJ20170258.</a:t>
-            </a:r>
-          </a:p>
-          <a:p>
-            <a:pPr marL="342900" indent="-342900">
-              <a:spcAft>
-                <a:spcPts val="600"/>
-              </a:spcAft>
-              <a:buFont typeface="+mj-lt"/>
-              <a:buAutoNum type="arabicPeriod"/>
-            </a:pPr>
-            <a:r>
-              <a:rPr lang="en-CA" sz="1400" dirty="0">
-                <a:latin typeface="Verdana Pro" panose="020B0604030504040204" pitchFamily="34" charset="0"/>
-              </a:rPr>
-              <a:t>Dong A, et al. Structure of human DNMT2, an enigmatic DNA methyltransferase homolog that displays denaturant-resistant binding to DNA. Nucleic Acids Res. 2001;29:439–448.</a:t>
-            </a:r>
-          </a:p>
-          <a:p>
-            <a:pPr marL="342900" indent="-342900">
-              <a:spcAft>
-                <a:spcPts val="600"/>
-              </a:spcAft>
-              <a:buFont typeface="+mj-lt"/>
-              <a:buAutoNum type="arabicPeriod"/>
-            </a:pPr>
-            <a:r>
-              <a:rPr lang="en-CA" sz="1400" dirty="0">
-                <a:latin typeface="Verdana Pro" panose="020B0604030504040204" pitchFamily="34" charset="0"/>
-              </a:rPr>
-              <a:t>Flodman K, et al. In vitro Type II Restriction of Bacteriophage DNA With Modified Pyrimidines. Front Microbiol. 2020;11:604618. DOI: 10.3389/fmicb.2020.604618</a:t>
-            </a:r>
-          </a:p>
-          <a:p>
-            <a:pPr marL="342900" indent="-342900">
-              <a:spcAft>
-                <a:spcPts val="600"/>
-              </a:spcAft>
-              <a:buFont typeface="+mj-lt"/>
-              <a:buAutoNum type="arabicPeriod"/>
-            </a:pPr>
-            <a:r>
-              <a:rPr lang="en-CA" sz="1400" dirty="0">
-                <a:latin typeface="Verdana Pro" panose="020B0604030504040204" pitchFamily="34" charset="0"/>
-              </a:rPr>
-              <a:t>Chen Z, et al. DDX20 positively regulates the interferon pathway to inhibit viral infection. Antiviral Res. 2024;225:105875. DOI: 10.1016/j.antiviral.2024.105875</a:t>
-            </a:r>
-          </a:p>
-          <a:p>
-            <a:pPr marL="342900" indent="-342900">
-              <a:spcAft>
-                <a:spcPts val="600"/>
-              </a:spcAft>
-              <a:buFont typeface="+mj-lt"/>
-              <a:buAutoNum type="arabicPeriod"/>
-            </a:pPr>
-            <a:r>
-              <a:rPr lang="en-US" sz="1400" dirty="0">
-                <a:latin typeface="Verdana Pro" panose="020B0604030504040204" pitchFamily="34" charset="0"/>
-              </a:rPr>
-              <a:t>Poli MC, et al. Human inborn errors of immunity: 2024 update on the classification from the International Union of Immunological Societies Expert Committee. J Hum Immun. 2025;1:e20250003. DOI: 10.70962/jhi.20250003.</a:t>
-            </a:r>
-            <a:endParaRPr lang="en-CA" sz="1400" dirty="0">
-              <a:latin typeface="Verdana Pro" panose="020B0604030504040204" pitchFamily="34" charset="0"/>
-            </a:endParaRPr>
-          </a:p>
-        </p:txBody>
-      </p:sp>
-      <p:sp>
-        <p:nvSpPr>
-          <p:cNvPr id="3" name="Slide Number Placeholder 2">
-            <a:extLst>
-              <a:ext uri="{FF2B5EF4-FFF2-40B4-BE49-F238E27FC236}">
-                <a16:creationId xmlns:a16="http://schemas.microsoft.com/office/drawing/2014/main" id="{4D718C97-AE4F-2A1A-11B0-A312FAC0FAFA}"/>
-              </a:ext>
-            </a:extLst>
-          </p:cNvPr>
-          <p:cNvSpPr>
-            <a:spLocks noGrp="1"/>
-          </p:cNvSpPr>
-          <p:nvPr>
-            <p:ph type="sldNum" sz="quarter" idx="12"/>
-          </p:nvPr>
-        </p:nvSpPr>
-        <p:spPr/>
-        <p:txBody>
-          <a:bodyPr/>
-          <a:lstStyle/>
-          <a:p>
-            <a:fld id="{D20FA860-28F0-477C-BD76-C96AC22CF614}" type="slidenum">
-              <a:rPr lang="en-CA" smtClean="0"/>
-              <a:t>19</a:t>
-            </a:fld>
-            <a:endParaRPr lang="en-CA"/>
-          </a:p>
-        </p:txBody>
-      </p:sp>
-    </p:spTree>
-    <p:extLst>
-      <p:ext uri="{BB962C8B-B14F-4D97-AF65-F5344CB8AC3E}">
-        <p14:creationId xmlns:p14="http://schemas.microsoft.com/office/powerpoint/2010/main" val="3064083664"/>
       </p:ext>
     </p:extLst>
   </p:cSld>
@@ -12880,6 +13057,387 @@
     <p:extLst>
       <p:ext uri="{BB962C8B-B14F-4D97-AF65-F5344CB8AC3E}">
         <p14:creationId xmlns:p14="http://schemas.microsoft.com/office/powerpoint/2010/main" val="3333967294"/>
+      </p:ext>
+    </p:extLst>
+  </p:cSld>
+  <p:clrMapOvr>
+    <a:masterClrMapping/>
+  </p:clrMapOvr>
+</p:sld>
+</file>
+
+<file path=ppt/slides/slide20.xml><?xml version="1.0" encoding="utf-8"?>
+<p:sld xmlns:a="http://schemas.openxmlformats.org/drawingml/2006/main" xmlns:r="http://schemas.openxmlformats.org/officeDocument/2006/relationships" xmlns:p="http://schemas.openxmlformats.org/presentationml/2006/main">
+  <p:cSld>
+    <p:spTree>
+      <p:nvGrpSpPr>
+        <p:cNvPr id="1" name="">
+          <a:extLst>
+            <a:ext uri="{FF2B5EF4-FFF2-40B4-BE49-F238E27FC236}">
+              <a16:creationId xmlns:a16="http://schemas.microsoft.com/office/drawing/2014/main" id="{5E96BC46-7673-C84B-18B4-63539AA9C004}"/>
+            </a:ext>
+          </a:extLst>
+        </p:cNvPr>
+        <p:cNvGrpSpPr/>
+        <p:nvPr/>
+      </p:nvGrpSpPr>
+      <p:grpSpPr>
+        <a:xfrm>
+          <a:off x="0" y="0"/>
+          <a:ext cx="0" cy="0"/>
+          <a:chOff x="0" y="0"/>
+          <a:chExt cx="0" cy="0"/>
+        </a:xfrm>
+      </p:grpSpPr>
+      <p:sp>
+        <p:nvSpPr>
+          <p:cNvPr id="15" name="Rectangle: Rounded Corners 14">
+            <a:extLst>
+              <a:ext uri="{FF2B5EF4-FFF2-40B4-BE49-F238E27FC236}">
+                <a16:creationId xmlns:a16="http://schemas.microsoft.com/office/drawing/2014/main" id="{7DA48913-4EF7-7226-450E-EB863B768EE5}"/>
+              </a:ext>
+            </a:extLst>
+          </p:cNvPr>
+          <p:cNvSpPr/>
+          <p:nvPr/>
+        </p:nvSpPr>
+        <p:spPr>
+          <a:xfrm>
+            <a:off x="315257" y="8582"/>
+            <a:ext cx="9363581" cy="628742"/>
+          </a:xfrm>
+          <a:prstGeom prst="roundRect">
+            <a:avLst/>
+          </a:prstGeom>
+          <a:solidFill>
+            <a:srgbClr val="0162B3"/>
+          </a:solidFill>
+          <a:ln>
+            <a:solidFill>
+              <a:srgbClr val="0162B3"/>
+            </a:solidFill>
+          </a:ln>
+        </p:spPr>
+        <p:style>
+          <a:lnRef idx="2">
+            <a:schemeClr val="accent1">
+              <a:shade val="50000"/>
+            </a:schemeClr>
+          </a:lnRef>
+          <a:fillRef idx="1">
+            <a:schemeClr val="accent1"/>
+          </a:fillRef>
+          <a:effectRef idx="0">
+            <a:schemeClr val="accent1"/>
+          </a:effectRef>
+          <a:fontRef idx="minor">
+            <a:schemeClr val="lt1"/>
+          </a:fontRef>
+        </p:style>
+        <p:txBody>
+          <a:bodyPr rtlCol="0" anchor="ctr"/>
+          <a:lstStyle>
+            <a:defPPr>
+              <a:defRPr lang="en-US"/>
+            </a:defPPr>
+            <a:lvl1pPr marL="0" algn="l" defTabSz="914400" rtl="0" eaLnBrk="1" latinLnBrk="0" hangingPunct="1">
+              <a:defRPr sz="1800" kern="1200">
+                <a:solidFill>
+                  <a:schemeClr val="lt1"/>
+                </a:solidFill>
+                <a:latin typeface="+mn-lt"/>
+                <a:ea typeface="+mn-ea"/>
+                <a:cs typeface="+mn-cs"/>
+              </a:defRPr>
+            </a:lvl1pPr>
+            <a:lvl2pPr marL="457200" algn="l" defTabSz="914400" rtl="0" eaLnBrk="1" latinLnBrk="0" hangingPunct="1">
+              <a:defRPr sz="1800" kern="1200">
+                <a:solidFill>
+                  <a:schemeClr val="lt1"/>
+                </a:solidFill>
+                <a:latin typeface="+mn-lt"/>
+                <a:ea typeface="+mn-ea"/>
+                <a:cs typeface="+mn-cs"/>
+              </a:defRPr>
+            </a:lvl2pPr>
+            <a:lvl3pPr marL="914400" algn="l" defTabSz="914400" rtl="0" eaLnBrk="1" latinLnBrk="0" hangingPunct="1">
+              <a:defRPr sz="1800" kern="1200">
+                <a:solidFill>
+                  <a:schemeClr val="lt1"/>
+                </a:solidFill>
+                <a:latin typeface="+mn-lt"/>
+                <a:ea typeface="+mn-ea"/>
+                <a:cs typeface="+mn-cs"/>
+              </a:defRPr>
+            </a:lvl3pPr>
+            <a:lvl4pPr marL="1371600" algn="l" defTabSz="914400" rtl="0" eaLnBrk="1" latinLnBrk="0" hangingPunct="1">
+              <a:defRPr sz="1800" kern="1200">
+                <a:solidFill>
+                  <a:schemeClr val="lt1"/>
+                </a:solidFill>
+                <a:latin typeface="+mn-lt"/>
+                <a:ea typeface="+mn-ea"/>
+                <a:cs typeface="+mn-cs"/>
+              </a:defRPr>
+            </a:lvl4pPr>
+            <a:lvl5pPr marL="1828800" algn="l" defTabSz="914400" rtl="0" eaLnBrk="1" latinLnBrk="0" hangingPunct="1">
+              <a:defRPr sz="1800" kern="1200">
+                <a:solidFill>
+                  <a:schemeClr val="lt1"/>
+                </a:solidFill>
+                <a:latin typeface="+mn-lt"/>
+                <a:ea typeface="+mn-ea"/>
+                <a:cs typeface="+mn-cs"/>
+              </a:defRPr>
+            </a:lvl5pPr>
+            <a:lvl6pPr marL="2286000" algn="l" defTabSz="914400" rtl="0" eaLnBrk="1" latinLnBrk="0" hangingPunct="1">
+              <a:defRPr sz="1800" kern="1200">
+                <a:solidFill>
+                  <a:schemeClr val="lt1"/>
+                </a:solidFill>
+                <a:latin typeface="+mn-lt"/>
+                <a:ea typeface="+mn-ea"/>
+                <a:cs typeface="+mn-cs"/>
+              </a:defRPr>
+            </a:lvl6pPr>
+            <a:lvl7pPr marL="2743200" algn="l" defTabSz="914400" rtl="0" eaLnBrk="1" latinLnBrk="0" hangingPunct="1">
+              <a:defRPr sz="1800" kern="1200">
+                <a:solidFill>
+                  <a:schemeClr val="lt1"/>
+                </a:solidFill>
+                <a:latin typeface="+mn-lt"/>
+                <a:ea typeface="+mn-ea"/>
+                <a:cs typeface="+mn-cs"/>
+              </a:defRPr>
+            </a:lvl7pPr>
+            <a:lvl8pPr marL="3200400" algn="l" defTabSz="914400" rtl="0" eaLnBrk="1" latinLnBrk="0" hangingPunct="1">
+              <a:defRPr sz="1800" kern="1200">
+                <a:solidFill>
+                  <a:schemeClr val="lt1"/>
+                </a:solidFill>
+                <a:latin typeface="+mn-lt"/>
+                <a:ea typeface="+mn-ea"/>
+                <a:cs typeface="+mn-cs"/>
+              </a:defRPr>
+            </a:lvl8pPr>
+            <a:lvl9pPr marL="3657600" algn="l" defTabSz="914400" rtl="0" eaLnBrk="1" latinLnBrk="0" hangingPunct="1">
+              <a:defRPr sz="1800" kern="1200">
+                <a:solidFill>
+                  <a:schemeClr val="lt1"/>
+                </a:solidFill>
+                <a:latin typeface="+mn-lt"/>
+                <a:ea typeface="+mn-ea"/>
+                <a:cs typeface="+mn-cs"/>
+              </a:defRPr>
+            </a:lvl9pPr>
+          </a:lstStyle>
+          <a:p>
+            <a:pPr algn="ctr"/>
+            <a:endParaRPr lang="en-CA"/>
+          </a:p>
+        </p:txBody>
+      </p:sp>
+      <p:sp>
+        <p:nvSpPr>
+          <p:cNvPr id="19" name="TextBox 18">
+            <a:extLst>
+              <a:ext uri="{FF2B5EF4-FFF2-40B4-BE49-F238E27FC236}">
+                <a16:creationId xmlns:a16="http://schemas.microsoft.com/office/drawing/2014/main" id="{C3A09E84-A853-2CE4-2353-6F32C167F0F1}"/>
+              </a:ext>
+            </a:extLst>
+          </p:cNvPr>
+          <p:cNvSpPr txBox="1"/>
+          <p:nvPr/>
+        </p:nvSpPr>
+        <p:spPr>
+          <a:xfrm>
+            <a:off x="527959" y="76731"/>
+            <a:ext cx="8710932" cy="492443"/>
+          </a:xfrm>
+          <a:prstGeom prst="rect">
+            <a:avLst/>
+          </a:prstGeom>
+          <a:noFill/>
+        </p:spPr>
+        <p:txBody>
+          <a:bodyPr wrap="square" rtlCol="0">
+            <a:spAutoFit/>
+          </a:bodyPr>
+          <a:lstStyle/>
+          <a:p>
+            <a:r>
+              <a:rPr lang="en-US" sz="2600" b="1" dirty="0">
+                <a:solidFill>
+                  <a:schemeClr val="bg1"/>
+                </a:solidFill>
+                <a:latin typeface="Georgia Pro" panose="02040502050405020303" pitchFamily="18" charset="0"/>
+              </a:rPr>
+              <a:t>References</a:t>
+            </a:r>
+            <a:endParaRPr lang="en-CA" sz="2600" b="1" dirty="0">
+              <a:solidFill>
+                <a:schemeClr val="bg1"/>
+              </a:solidFill>
+              <a:latin typeface="Georgia Pro" panose="02040502050405020303" pitchFamily="18" charset="0"/>
+            </a:endParaRPr>
+          </a:p>
+        </p:txBody>
+      </p:sp>
+      <p:sp>
+        <p:nvSpPr>
+          <p:cNvPr id="2" name="TextBox 1">
+            <a:extLst>
+              <a:ext uri="{FF2B5EF4-FFF2-40B4-BE49-F238E27FC236}">
+                <a16:creationId xmlns:a16="http://schemas.microsoft.com/office/drawing/2014/main" id="{D555B33F-2E1A-FAA4-32B8-ADE7D02D78D0}"/>
+              </a:ext>
+            </a:extLst>
+          </p:cNvPr>
+          <p:cNvSpPr txBox="1"/>
+          <p:nvPr/>
+        </p:nvSpPr>
+        <p:spPr>
+          <a:xfrm>
+            <a:off x="527958" y="1146628"/>
+            <a:ext cx="9363581" cy="3277820"/>
+          </a:xfrm>
+          <a:prstGeom prst="rect">
+            <a:avLst/>
+          </a:prstGeom>
+          <a:noFill/>
+        </p:spPr>
+        <p:txBody>
+          <a:bodyPr wrap="square" rtlCol="0">
+            <a:spAutoFit/>
+          </a:bodyPr>
+          <a:lstStyle/>
+          <a:p>
+            <a:pPr marL="342900" indent="-342900">
+              <a:spcAft>
+                <a:spcPts val="600"/>
+              </a:spcAft>
+              <a:buFont typeface="+mj-lt"/>
+              <a:buAutoNum type="arabicPeriod"/>
+            </a:pPr>
+            <a:r>
+              <a:rPr lang="en-CA" sz="1400" dirty="0">
+                <a:latin typeface="Verdana Pro" panose="020B0604030504040204" pitchFamily="34" charset="0"/>
+              </a:rPr>
+              <a:t>Schaefer M, et al. RNA methylation by Dnmt2 protects transfer RNAs against stress-induced cleavage. Genes Dev. 2010;24:1590–1595. DOI: 10.1101/gad.586710.</a:t>
+            </a:r>
+          </a:p>
+          <a:p>
+            <a:pPr marL="342900" indent="-342900">
+              <a:spcAft>
+                <a:spcPts val="600"/>
+              </a:spcAft>
+              <a:buFont typeface="+mj-lt"/>
+              <a:buAutoNum type="arabicPeriod"/>
+            </a:pPr>
+            <a:r>
+              <a:rPr lang="en-CA" sz="1400" dirty="0">
+                <a:latin typeface="Verdana Pro" panose="020B0604030504040204" pitchFamily="34" charset="0"/>
+              </a:rPr>
+              <a:t>Dev RR, et al. Cytosine methylation by DNMT2 facilitates stability and survival of HIV-1 RNA in the host cell during infection. Biochem J. 2017;474:2009–2026. DOI: 10.1042/BCJ20170258.</a:t>
+            </a:r>
+          </a:p>
+          <a:p>
+            <a:pPr marL="342900" indent="-342900">
+              <a:spcAft>
+                <a:spcPts val="600"/>
+              </a:spcAft>
+              <a:buFont typeface="+mj-lt"/>
+              <a:buAutoNum type="arabicPeriod"/>
+            </a:pPr>
+            <a:r>
+              <a:rPr lang="en-CA" sz="1400" dirty="0">
+                <a:latin typeface="Verdana Pro" panose="020B0604030504040204" pitchFamily="34" charset="0"/>
+              </a:rPr>
+              <a:t>Dong A, et al. Structure of human DNMT2, an enigmatic DNA methyltransferase homolog that displays denaturant-resistant binding to DNA. Nucleic Acids Res. 2001;29:439–448.</a:t>
+            </a:r>
+          </a:p>
+          <a:p>
+            <a:pPr marL="342900" indent="-342900">
+              <a:spcAft>
+                <a:spcPts val="600"/>
+              </a:spcAft>
+              <a:buFont typeface="+mj-lt"/>
+              <a:buAutoNum type="arabicPeriod"/>
+            </a:pPr>
+            <a:r>
+              <a:rPr lang="en-CA" sz="1400" dirty="0">
+                <a:latin typeface="Verdana Pro" panose="020B0604030504040204" pitchFamily="34" charset="0"/>
+              </a:rPr>
+              <a:t>Flodman K, et al. In vitro Type II Restriction of Bacteriophage DNA With Modified Pyrimidines. Front Microbiol. 2020;11:604618. DOI: 10.3389/fmicb.2020.604618</a:t>
+            </a:r>
+          </a:p>
+          <a:p>
+            <a:pPr marL="342900" indent="-342900">
+              <a:spcAft>
+                <a:spcPts val="600"/>
+              </a:spcAft>
+              <a:buFont typeface="+mj-lt"/>
+              <a:buAutoNum type="arabicPeriod"/>
+            </a:pPr>
+            <a:r>
+              <a:rPr lang="en-CA" sz="1400" dirty="0">
+                <a:latin typeface="Verdana Pro" panose="020B0604030504040204" pitchFamily="34" charset="0"/>
+              </a:rPr>
+              <a:t>Chen Z, et al. DDX20 positively regulates the interferon pathway to inhibit viral infection. Antiviral Res. 2024;225:105875. DOI: 10.1016/j.antiviral.2024.105875</a:t>
+            </a:r>
+          </a:p>
+          <a:p>
+            <a:pPr marL="342900" indent="-342900">
+              <a:spcAft>
+                <a:spcPts val="600"/>
+              </a:spcAft>
+              <a:buFont typeface="+mj-lt"/>
+              <a:buAutoNum type="arabicPeriod"/>
+            </a:pPr>
+            <a:r>
+              <a:rPr lang="en-US" sz="1400" dirty="0">
+                <a:latin typeface="Verdana Pro" panose="020B0604030504040204" pitchFamily="34" charset="0"/>
+              </a:rPr>
+              <a:t>Poli MC, et al. Human inborn errors of immunity: 2024 update on the classification from the International Union of Immunological Societies Expert Committee. J Hum Immun. 2025;1:e20250003. DOI: 10.70962/jhi.20250003.</a:t>
+            </a:r>
+            <a:endParaRPr lang="en-CA" sz="1400" dirty="0">
+              <a:latin typeface="Verdana Pro" panose="020B0604030504040204" pitchFamily="34" charset="0"/>
+            </a:endParaRPr>
+          </a:p>
+        </p:txBody>
+      </p:sp>
+      <p:sp>
+        <p:nvSpPr>
+          <p:cNvPr id="3" name="Slide Number Placeholder 2">
+            <a:extLst>
+              <a:ext uri="{FF2B5EF4-FFF2-40B4-BE49-F238E27FC236}">
+                <a16:creationId xmlns:a16="http://schemas.microsoft.com/office/drawing/2014/main" id="{4D718C97-AE4F-2A1A-11B0-A312FAC0FAFA}"/>
+              </a:ext>
+            </a:extLst>
+          </p:cNvPr>
+          <p:cNvSpPr>
+            <a:spLocks noGrp="1"/>
+          </p:cNvSpPr>
+          <p:nvPr>
+            <p:ph type="sldNum" sz="quarter" idx="12"/>
+          </p:nvPr>
+        </p:nvSpPr>
+        <p:spPr/>
+        <p:txBody>
+          <a:bodyPr/>
+          <a:lstStyle/>
+          <a:p>
+            <a:fld id="{D20FA860-28F0-477C-BD76-C96AC22CF614}" type="slidenum">
+              <a:rPr lang="en-CA" smtClean="0"/>
+              <a:t>20</a:t>
+            </a:fld>
+            <a:endParaRPr lang="en-CA"/>
+          </a:p>
+        </p:txBody>
+      </p:sp>
+    </p:spTree>
+    <p:extLst>
+      <p:ext uri="{BB962C8B-B14F-4D97-AF65-F5344CB8AC3E}">
+        <p14:creationId xmlns:p14="http://schemas.microsoft.com/office/powerpoint/2010/main" val="3064083664"/>
       </p:ext>
     </p:extLst>
   </p:cSld>
@@ -18487,8 +19045,8 @@
           </a:p>
         </p:txBody>
       </p:sp>
-      <mc:AlternateContent xmlns:mc="http://schemas.openxmlformats.org/markup-compatibility/2006">
-        <mc:Choice xmlns:a14="http://schemas.microsoft.com/office/drawing/2010/main" Requires="a14">
+      <mc:AlternateContent xmlns:mc="http://schemas.openxmlformats.org/markup-compatibility/2006" xmlns:a14="http://schemas.microsoft.com/office/drawing/2010/main">
+        <mc:Choice Requires="a14">
           <p:sp>
             <p:nvSpPr>
               <p:cNvPr id="47" name="TextBox 46">
@@ -18673,7 +19231,7 @@
             </p:txBody>
           </p:sp>
         </mc:Choice>
-        <mc:Fallback>
+        <mc:Fallback xmlns="">
           <p:sp>
             <p:nvSpPr>
               <p:cNvPr id="47" name="TextBox 46">
@@ -18718,8 +19276,8 @@
           </p:sp>
         </mc:Fallback>
       </mc:AlternateContent>
-      <mc:AlternateContent xmlns:mc="http://schemas.openxmlformats.org/markup-compatibility/2006">
-        <mc:Choice xmlns:a14="http://schemas.microsoft.com/office/drawing/2010/main" Requires="a14">
+      <mc:AlternateContent xmlns:mc="http://schemas.openxmlformats.org/markup-compatibility/2006" xmlns:a14="http://schemas.microsoft.com/office/drawing/2010/main">
+        <mc:Choice Requires="a14">
           <p:sp>
             <p:nvSpPr>
               <p:cNvPr id="51" name="TextBox 50">
@@ -18840,7 +19398,7 @@
             </p:txBody>
           </p:sp>
         </mc:Choice>
-        <mc:Fallback>
+        <mc:Fallback xmlns="">
           <p:sp>
             <p:nvSpPr>
               <p:cNvPr id="51" name="TextBox 50">

</xml_diff>

<commit_message>
Added ImmPort annotations enrichment slide.
</commit_message>
<xml_diff>
--- a/reports/2026-08-28_projectUpdate_3/2026-08-28_projectUpdate_3_jmoran.pptx
+++ b/reports/2026-08-28_projectUpdate_3/2026-08-28_projectUpdate_3_jmoran.pptx
@@ -5,7 +5,7 @@
     <p:sldMasterId id="2147483648" r:id="rId1"/>
   </p:sldMasterIdLst>
   <p:notesMasterIdLst>
-    <p:notesMasterId r:id="rId22"/>
+    <p:notesMasterId r:id="rId23"/>
   </p:notesMasterIdLst>
   <p:sldIdLst>
     <p:sldId id="256" r:id="rId2"/>
@@ -25,9 +25,10 @@
     <p:sldId id="298" r:id="rId16"/>
     <p:sldId id="299" r:id="rId17"/>
     <p:sldId id="302" r:id="rId18"/>
-    <p:sldId id="300" r:id="rId19"/>
-    <p:sldId id="301" r:id="rId20"/>
-    <p:sldId id="296" r:id="rId21"/>
+    <p:sldId id="303" r:id="rId19"/>
+    <p:sldId id="300" r:id="rId20"/>
+    <p:sldId id="301" r:id="rId21"/>
+    <p:sldId id="296" r:id="rId22"/>
   </p:sldIdLst>
   <p:sldSz cx="12192000" cy="6858000"/>
   <p:notesSz cx="6858000" cy="9144000"/>
@@ -12104,7 +12105,7 @@
         </p:nvGrpSpPr>
         <p:grpSpPr>
           <a:xfrm>
-            <a:off x="5350627" y="2911412"/>
+            <a:off x="5350627" y="3411753"/>
             <a:ext cx="4728532" cy="2855343"/>
             <a:chOff x="6668219" y="1992702"/>
             <a:chExt cx="4728532" cy="2855343"/>
@@ -12205,7 +12206,7 @@
         </p:nvSpPr>
         <p:spPr>
           <a:xfrm>
-            <a:off x="5414512" y="1324957"/>
+            <a:off x="5414512" y="1833923"/>
             <a:ext cx="5515155" cy="1677382"/>
           </a:xfrm>
           <a:prstGeom prst="rect">
@@ -12268,6 +12269,51 @@
               </a:spcAft>
             </a:pPr>
             <a:endParaRPr lang="en-CA" sz="1400" dirty="0">
+              <a:latin typeface="Verdana Pro" panose="020B0604030504040204" pitchFamily="34" charset="0"/>
+            </a:endParaRPr>
+          </a:p>
+        </p:txBody>
+      </p:sp>
+      <p:sp>
+        <p:nvSpPr>
+          <p:cNvPr id="21" name="TextBox 20">
+            <a:extLst>
+              <a:ext uri="{FF2B5EF4-FFF2-40B4-BE49-F238E27FC236}">
+                <a16:creationId xmlns:a16="http://schemas.microsoft.com/office/drawing/2014/main" id="{480804E9-437E-274E-6EF4-98356B558E9D}"/>
+              </a:ext>
+            </a:extLst>
+          </p:cNvPr>
+          <p:cNvSpPr txBox="1"/>
+          <p:nvPr/>
+        </p:nvSpPr>
+        <p:spPr>
+          <a:xfrm>
+            <a:off x="5414512" y="1128402"/>
+            <a:ext cx="5515155" cy="369332"/>
+          </a:xfrm>
+          <a:prstGeom prst="rect">
+            <a:avLst/>
+          </a:prstGeom>
+          <a:noFill/>
+        </p:spPr>
+        <p:txBody>
+          <a:bodyPr wrap="square" rtlCol="0">
+            <a:spAutoFit/>
+          </a:bodyPr>
+          <a:lstStyle/>
+          <a:p>
+            <a:pPr>
+              <a:spcAft>
+                <a:spcPts val="600"/>
+              </a:spcAft>
+            </a:pPr>
+            <a:r>
+              <a:rPr lang="en-US" dirty="0">
+                <a:latin typeface="Verdana Pro" panose="020B0604030504040204" pitchFamily="34" charset="0"/>
+              </a:rPr>
+              <a:t>N genes: 1,008</a:t>
+            </a:r>
+            <a:endParaRPr lang="en-CA" dirty="0">
               <a:latin typeface="Verdana Pro" panose="020B0604030504040204" pitchFamily="34" charset="0"/>
             </a:endParaRPr>
           </a:p>
@@ -12287,6 +12333,678 @@
 </file>
 
 <file path=ppt/slides/slide18.xml><?xml version="1.0" encoding="utf-8"?>
+<p:sld xmlns:a="http://schemas.openxmlformats.org/drawingml/2006/main" xmlns:r="http://schemas.openxmlformats.org/officeDocument/2006/relationships" xmlns:p="http://schemas.openxmlformats.org/presentationml/2006/main">
+  <p:cSld>
+    <p:spTree>
+      <p:nvGrpSpPr>
+        <p:cNvPr id="1" name="">
+          <a:extLst>
+            <a:ext uri="{FF2B5EF4-FFF2-40B4-BE49-F238E27FC236}">
+              <a16:creationId xmlns:a16="http://schemas.microsoft.com/office/drawing/2014/main" id="{5B1393E5-75F6-A9EF-165C-C604EB8D1065}"/>
+            </a:ext>
+          </a:extLst>
+        </p:cNvPr>
+        <p:cNvGrpSpPr/>
+        <p:nvPr/>
+      </p:nvGrpSpPr>
+      <p:grpSpPr>
+        <a:xfrm>
+          <a:off x="0" y="0"/>
+          <a:ext cx="0" cy="0"/>
+          <a:chOff x="0" y="0"/>
+          <a:chExt cx="0" cy="0"/>
+        </a:xfrm>
+      </p:grpSpPr>
+      <p:sp>
+        <p:nvSpPr>
+          <p:cNvPr id="6" name="Rectangle: Rounded Corners 5">
+            <a:extLst>
+              <a:ext uri="{FF2B5EF4-FFF2-40B4-BE49-F238E27FC236}">
+                <a16:creationId xmlns:a16="http://schemas.microsoft.com/office/drawing/2014/main" id="{9BD87839-3232-A416-44A9-3F05C0710E39}"/>
+              </a:ext>
+            </a:extLst>
+          </p:cNvPr>
+          <p:cNvSpPr/>
+          <p:nvPr/>
+        </p:nvSpPr>
+        <p:spPr>
+          <a:xfrm>
+            <a:off x="315257" y="-5932"/>
+            <a:ext cx="9363581" cy="628742"/>
+          </a:xfrm>
+          <a:prstGeom prst="roundRect">
+            <a:avLst/>
+          </a:prstGeom>
+          <a:solidFill>
+            <a:srgbClr val="0162B3"/>
+          </a:solidFill>
+          <a:ln>
+            <a:solidFill>
+              <a:srgbClr val="0162B3"/>
+            </a:solidFill>
+          </a:ln>
+        </p:spPr>
+        <p:style>
+          <a:lnRef idx="2">
+            <a:schemeClr val="accent1">
+              <a:shade val="50000"/>
+            </a:schemeClr>
+          </a:lnRef>
+          <a:fillRef idx="1">
+            <a:schemeClr val="accent1"/>
+          </a:fillRef>
+          <a:effectRef idx="0">
+            <a:schemeClr val="accent1"/>
+          </a:effectRef>
+          <a:fontRef idx="minor">
+            <a:schemeClr val="lt1"/>
+          </a:fontRef>
+        </p:style>
+        <p:txBody>
+          <a:bodyPr rtlCol="0" anchor="ctr"/>
+          <a:lstStyle>
+            <a:defPPr>
+              <a:defRPr lang="en-US"/>
+            </a:defPPr>
+            <a:lvl1pPr marL="0" algn="l" defTabSz="914400" rtl="0" eaLnBrk="1" latinLnBrk="0" hangingPunct="1">
+              <a:defRPr sz="1800" kern="1200">
+                <a:solidFill>
+                  <a:schemeClr val="lt1"/>
+                </a:solidFill>
+                <a:latin typeface="+mn-lt"/>
+                <a:ea typeface="+mn-ea"/>
+                <a:cs typeface="+mn-cs"/>
+              </a:defRPr>
+            </a:lvl1pPr>
+            <a:lvl2pPr marL="457200" algn="l" defTabSz="914400" rtl="0" eaLnBrk="1" latinLnBrk="0" hangingPunct="1">
+              <a:defRPr sz="1800" kern="1200">
+                <a:solidFill>
+                  <a:schemeClr val="lt1"/>
+                </a:solidFill>
+                <a:latin typeface="+mn-lt"/>
+                <a:ea typeface="+mn-ea"/>
+                <a:cs typeface="+mn-cs"/>
+              </a:defRPr>
+            </a:lvl2pPr>
+            <a:lvl3pPr marL="914400" algn="l" defTabSz="914400" rtl="0" eaLnBrk="1" latinLnBrk="0" hangingPunct="1">
+              <a:defRPr sz="1800" kern="1200">
+                <a:solidFill>
+                  <a:schemeClr val="lt1"/>
+                </a:solidFill>
+                <a:latin typeface="+mn-lt"/>
+                <a:ea typeface="+mn-ea"/>
+                <a:cs typeface="+mn-cs"/>
+              </a:defRPr>
+            </a:lvl3pPr>
+            <a:lvl4pPr marL="1371600" algn="l" defTabSz="914400" rtl="0" eaLnBrk="1" latinLnBrk="0" hangingPunct="1">
+              <a:defRPr sz="1800" kern="1200">
+                <a:solidFill>
+                  <a:schemeClr val="lt1"/>
+                </a:solidFill>
+                <a:latin typeface="+mn-lt"/>
+                <a:ea typeface="+mn-ea"/>
+                <a:cs typeface="+mn-cs"/>
+              </a:defRPr>
+            </a:lvl4pPr>
+            <a:lvl5pPr marL="1828800" algn="l" defTabSz="914400" rtl="0" eaLnBrk="1" latinLnBrk="0" hangingPunct="1">
+              <a:defRPr sz="1800" kern="1200">
+                <a:solidFill>
+                  <a:schemeClr val="lt1"/>
+                </a:solidFill>
+                <a:latin typeface="+mn-lt"/>
+                <a:ea typeface="+mn-ea"/>
+                <a:cs typeface="+mn-cs"/>
+              </a:defRPr>
+            </a:lvl5pPr>
+            <a:lvl6pPr marL="2286000" algn="l" defTabSz="914400" rtl="0" eaLnBrk="1" latinLnBrk="0" hangingPunct="1">
+              <a:defRPr sz="1800" kern="1200">
+                <a:solidFill>
+                  <a:schemeClr val="lt1"/>
+                </a:solidFill>
+                <a:latin typeface="+mn-lt"/>
+                <a:ea typeface="+mn-ea"/>
+                <a:cs typeface="+mn-cs"/>
+              </a:defRPr>
+            </a:lvl6pPr>
+            <a:lvl7pPr marL="2743200" algn="l" defTabSz="914400" rtl="0" eaLnBrk="1" latinLnBrk="0" hangingPunct="1">
+              <a:defRPr sz="1800" kern="1200">
+                <a:solidFill>
+                  <a:schemeClr val="lt1"/>
+                </a:solidFill>
+                <a:latin typeface="+mn-lt"/>
+                <a:ea typeface="+mn-ea"/>
+                <a:cs typeface="+mn-cs"/>
+              </a:defRPr>
+            </a:lvl7pPr>
+            <a:lvl8pPr marL="3200400" algn="l" defTabSz="914400" rtl="0" eaLnBrk="1" latinLnBrk="0" hangingPunct="1">
+              <a:defRPr sz="1800" kern="1200">
+                <a:solidFill>
+                  <a:schemeClr val="lt1"/>
+                </a:solidFill>
+                <a:latin typeface="+mn-lt"/>
+                <a:ea typeface="+mn-ea"/>
+                <a:cs typeface="+mn-cs"/>
+              </a:defRPr>
+            </a:lvl8pPr>
+            <a:lvl9pPr marL="3657600" algn="l" defTabSz="914400" rtl="0" eaLnBrk="1" latinLnBrk="0" hangingPunct="1">
+              <a:defRPr sz="1800" kern="1200">
+                <a:solidFill>
+                  <a:schemeClr val="lt1"/>
+                </a:solidFill>
+                <a:latin typeface="+mn-lt"/>
+                <a:ea typeface="+mn-ea"/>
+                <a:cs typeface="+mn-cs"/>
+              </a:defRPr>
+            </a:lvl9pPr>
+          </a:lstStyle>
+          <a:p>
+            <a:pPr algn="ctr"/>
+            <a:endParaRPr lang="en-CA">
+              <a:latin typeface="Verdana Pro" panose="020B0604030504040204" pitchFamily="34" charset="0"/>
+            </a:endParaRPr>
+          </a:p>
+        </p:txBody>
+      </p:sp>
+      <p:sp>
+        <p:nvSpPr>
+          <p:cNvPr id="8" name="TextBox 7">
+            <a:extLst>
+              <a:ext uri="{FF2B5EF4-FFF2-40B4-BE49-F238E27FC236}">
+                <a16:creationId xmlns:a16="http://schemas.microsoft.com/office/drawing/2014/main" id="{338AC1E3-465B-AB90-ACA6-89F7CE290AA7}"/>
+              </a:ext>
+            </a:extLst>
+          </p:cNvPr>
+          <p:cNvSpPr txBox="1"/>
+          <p:nvPr/>
+        </p:nvSpPr>
+        <p:spPr>
+          <a:xfrm>
+            <a:off x="527958" y="62217"/>
+            <a:ext cx="9016875" cy="492443"/>
+          </a:xfrm>
+          <a:prstGeom prst="rect">
+            <a:avLst/>
+          </a:prstGeom>
+          <a:noFill/>
+        </p:spPr>
+        <p:txBody>
+          <a:bodyPr wrap="square" rtlCol="0">
+            <a:spAutoFit/>
+          </a:bodyPr>
+          <a:lstStyle/>
+          <a:p>
+            <a:r>
+              <a:rPr lang="en-US" sz="2600" b="1" dirty="0">
+                <a:solidFill>
+                  <a:schemeClr val="bg1"/>
+                </a:solidFill>
+                <a:latin typeface="Georgia Pro" panose="02040502050405020303" pitchFamily="18" charset="0"/>
+              </a:rPr>
+              <a:t>ImmPort annotations enrichment</a:t>
+            </a:r>
+            <a:endParaRPr lang="en-CA" sz="2600" b="1" dirty="0">
+              <a:solidFill>
+                <a:schemeClr val="bg1"/>
+              </a:solidFill>
+              <a:latin typeface="Georgia Pro" panose="02040502050405020303" pitchFamily="18" charset="0"/>
+            </a:endParaRPr>
+          </a:p>
+        </p:txBody>
+      </p:sp>
+      <mc:AlternateContent xmlns:mc="http://schemas.openxmlformats.org/markup-compatibility/2006">
+        <mc:Choice xmlns:a14="http://schemas.microsoft.com/office/drawing/2010/main" Requires="a14">
+          <p:graphicFrame>
+            <p:nvGraphicFramePr>
+              <p:cNvPr id="10" name="Table 9">
+                <a:extLst>
+                  <a:ext uri="{FF2B5EF4-FFF2-40B4-BE49-F238E27FC236}">
+                    <a16:creationId xmlns:a16="http://schemas.microsoft.com/office/drawing/2014/main" id="{58E1901B-717A-335E-DADF-03D4592499FD}"/>
+                  </a:ext>
+                </a:extLst>
+              </p:cNvPr>
+              <p:cNvGraphicFramePr>
+                <a:graphicFrameLocks noGrp="1"/>
+              </p:cNvGraphicFramePr>
+              <p:nvPr>
+                <p:extLst>
+                  <p:ext uri="{D42A27DB-BD31-4B8C-83A1-F6EECF244321}">
+                    <p14:modId xmlns:p14="http://schemas.microsoft.com/office/powerpoint/2010/main" val="3807183921"/>
+                  </p:ext>
+                </p:extLst>
+              </p:nvPr>
+            </p:nvGraphicFramePr>
+            <p:xfrm>
+              <a:off x="8872747" y="2524400"/>
+              <a:ext cx="2841925" cy="1005840"/>
+            </p:xfrm>
+            <a:graphic>
+              <a:graphicData uri="http://schemas.openxmlformats.org/drawingml/2006/table">
+                <a:tbl>
+                  <a:tblPr firstRow="1" bandRow="1">
+                    <a:tableStyleId>{5940675A-B579-460E-94D1-54222C63F5DA}</a:tableStyleId>
+                  </a:tblPr>
+                  <a:tblGrid>
+                    <a:gridCol w="1134019">
+                      <a:extLst>
+                        <a:ext uri="{9D8B030D-6E8A-4147-A177-3AD203B41FA5}">
+                          <a16:colId xmlns:a16="http://schemas.microsoft.com/office/drawing/2014/main" val="2524751995"/>
+                        </a:ext>
+                      </a:extLst>
+                    </a:gridCol>
+                    <a:gridCol w="1707906">
+                      <a:extLst>
+                        <a:ext uri="{9D8B030D-6E8A-4147-A177-3AD203B41FA5}">
+                          <a16:colId xmlns:a16="http://schemas.microsoft.com/office/drawing/2014/main" val="3895262931"/>
+                        </a:ext>
+                      </a:extLst>
+                    </a:gridCol>
+                  </a:tblGrid>
+                  <a:tr h="0">
+                    <a:tc>
+                      <a:txBody>
+                        <a:bodyPr/>
+                        <a:lstStyle/>
+                        <a:p>
+                          <a:r>
+                            <a:rPr lang="en-US" sz="1200" dirty="0">
+                              <a:latin typeface="Verdana Pro" panose="020B0604030504040204" pitchFamily="34" charset="0"/>
+                            </a:rPr>
+                            <a:t>Set</a:t>
+                          </a:r>
+                          <a:endParaRPr lang="en-CA" sz="1200" dirty="0">
+                            <a:latin typeface="Verdana Pro" panose="020B0604030504040204" pitchFamily="34" charset="0"/>
+                          </a:endParaRPr>
+                        </a:p>
+                      </a:txBody>
+                      <a:tcPr/>
+                    </a:tc>
+                    <a:tc>
+                      <a:txBody>
+                        <a:bodyPr/>
+                        <a:lstStyle/>
+                        <a:p>
+                          <a:pPr marL="0" marR="0" lvl="0" indent="0" algn="l" defTabSz="914400" rtl="0" eaLnBrk="1" fontAlgn="auto" latinLnBrk="0" hangingPunct="1">
+                            <a:lnSpc>
+                              <a:spcPct val="100000"/>
+                            </a:lnSpc>
+                            <a:spcBef>
+                              <a:spcPts val="0"/>
+                            </a:spcBef>
+                            <a:spcAft>
+                              <a:spcPts val="0"/>
+                            </a:spcAft>
+                            <a:buClrTx/>
+                            <a:buSzTx/>
+                            <a:buFontTx/>
+                            <a:buNone/>
+                            <a:tabLst/>
+                            <a:defRPr/>
+                          </a:pPr>
+                          <a:r>
+                            <a:rPr lang="en-US" sz="1200" dirty="0">
+                              <a:latin typeface="Verdana Pro" panose="020B0604030504040204" pitchFamily="34" charset="0"/>
+                            </a:rPr>
+                            <a:t>Proportion with ImmPort ann.</a:t>
+                          </a:r>
+                          <a:endParaRPr lang="en-CA" sz="1200" dirty="0">
+                            <a:latin typeface="Verdana Pro" panose="020B0604030504040204" pitchFamily="34" charset="0"/>
+                          </a:endParaRPr>
+                        </a:p>
+                      </a:txBody>
+                      <a:tcPr/>
+                    </a:tc>
+                    <a:extLst>
+                      <a:ext uri="{0D108BD9-81ED-4DB2-BD59-A6C34878D82A}">
+                        <a16:rowId xmlns:a16="http://schemas.microsoft.com/office/drawing/2014/main" val="1389278446"/>
+                      </a:ext>
+                    </a:extLst>
+                  </a:tr>
+                  <a:tr h="0">
+                    <a:tc>
+                      <a:txBody>
+                        <a:bodyPr/>
+                        <a:lstStyle/>
+                        <a:p>
+                          <a14:m>
+                            <m:oMath xmlns:m="http://schemas.openxmlformats.org/officeDocument/2006/math">
+                              <m:r>
+                                <a:rPr lang="en-US" sz="1200" i="1" dirty="0" smtClean="0">
+                                  <a:latin typeface="Cambria Math" panose="02040503050406030204" pitchFamily="18" charset="0"/>
+                                </a:rPr>
+                                <m:t>&gt;=</m:t>
+                              </m:r>
+                            </m:oMath>
+                          </a14:m>
+                          <a:r>
+                            <a:rPr lang="en-CA" sz="1200" dirty="0">
+                              <a:latin typeface="Verdana Pro" panose="020B0604030504040204" pitchFamily="34" charset="0"/>
+                            </a:rPr>
+                            <a:t>0.825</a:t>
+                          </a:r>
+                        </a:p>
+                      </a:txBody>
+                      <a:tcPr/>
+                    </a:tc>
+                    <a:tc>
+                      <a:txBody>
+                        <a:bodyPr/>
+                        <a:lstStyle/>
+                        <a:p>
+                          <a:r>
+                            <a:rPr lang="en-US" sz="1200" dirty="0">
+                              <a:latin typeface="Verdana Pro" panose="020B0604030504040204" pitchFamily="34" charset="0"/>
+                            </a:rPr>
+                            <a:t>0.237</a:t>
+                          </a:r>
+                          <a:endParaRPr lang="en-CA" sz="1200" dirty="0">
+                            <a:latin typeface="Verdana Pro" panose="020B0604030504040204" pitchFamily="34" charset="0"/>
+                          </a:endParaRPr>
+                        </a:p>
+                      </a:txBody>
+                      <a:tcPr/>
+                    </a:tc>
+                    <a:extLst>
+                      <a:ext uri="{0D108BD9-81ED-4DB2-BD59-A6C34878D82A}">
+                        <a16:rowId xmlns:a16="http://schemas.microsoft.com/office/drawing/2014/main" val="1689302623"/>
+                      </a:ext>
+                    </a:extLst>
+                  </a:tr>
+                  <a:tr h="0">
+                    <a:tc>
+                      <a:txBody>
+                        <a:bodyPr/>
+                        <a:lstStyle/>
+                        <a:p>
+                          <a:r>
+                            <a:rPr lang="en-US" sz="1200" dirty="0">
+                              <a:latin typeface="Verdana Pro" panose="020B0604030504040204" pitchFamily="34" charset="0"/>
+                            </a:rPr>
+                            <a:t>Background</a:t>
+                          </a:r>
+                          <a:endParaRPr lang="en-CA" sz="1200" dirty="0">
+                            <a:latin typeface="Verdana Pro" panose="020B0604030504040204" pitchFamily="34" charset="0"/>
+                          </a:endParaRPr>
+                        </a:p>
+                      </a:txBody>
+                      <a:tcPr/>
+                    </a:tc>
+                    <a:tc>
+                      <a:txBody>
+                        <a:bodyPr/>
+                        <a:lstStyle/>
+                        <a:p>
+                          <a:r>
+                            <a:rPr lang="en-US" sz="1200" dirty="0">
+                              <a:latin typeface="Verdana Pro" panose="020B0604030504040204" pitchFamily="34" charset="0"/>
+                            </a:rPr>
+                            <a:t>0.202</a:t>
+                          </a:r>
+                          <a:endParaRPr lang="en-CA" sz="1200" dirty="0">
+                            <a:latin typeface="Verdana Pro" panose="020B0604030504040204" pitchFamily="34" charset="0"/>
+                          </a:endParaRPr>
+                        </a:p>
+                      </a:txBody>
+                      <a:tcPr/>
+                    </a:tc>
+                    <a:extLst>
+                      <a:ext uri="{0D108BD9-81ED-4DB2-BD59-A6C34878D82A}">
+                        <a16:rowId xmlns:a16="http://schemas.microsoft.com/office/drawing/2014/main" val="2686609459"/>
+                      </a:ext>
+                    </a:extLst>
+                  </a:tr>
+                </a:tbl>
+              </a:graphicData>
+            </a:graphic>
+          </p:graphicFrame>
+        </mc:Choice>
+        <mc:Fallback>
+          <p:graphicFrame>
+            <p:nvGraphicFramePr>
+              <p:cNvPr id="10" name="Table 9">
+                <a:extLst>
+                  <a:ext uri="{FF2B5EF4-FFF2-40B4-BE49-F238E27FC236}">
+                    <a16:creationId xmlns:a16="http://schemas.microsoft.com/office/drawing/2014/main" id="{58E1901B-717A-335E-DADF-03D4592499FD}"/>
+                  </a:ext>
+                </a:extLst>
+              </p:cNvPr>
+              <p:cNvGraphicFramePr>
+                <a:graphicFrameLocks noGrp="1"/>
+              </p:cNvGraphicFramePr>
+              <p:nvPr>
+                <p:extLst>
+                  <p:ext uri="{D42A27DB-BD31-4B8C-83A1-F6EECF244321}">
+                    <p14:modId xmlns:p14="http://schemas.microsoft.com/office/powerpoint/2010/main" val="3807183921"/>
+                  </p:ext>
+                </p:extLst>
+              </p:nvPr>
+            </p:nvGraphicFramePr>
+            <p:xfrm>
+              <a:off x="8872747" y="2524400"/>
+              <a:ext cx="2841925" cy="1005840"/>
+            </p:xfrm>
+            <a:graphic>
+              <a:graphicData uri="http://schemas.openxmlformats.org/drawingml/2006/table">
+                <a:tbl>
+                  <a:tblPr firstRow="1" bandRow="1">
+                    <a:tableStyleId>{5940675A-B579-460E-94D1-54222C63F5DA}</a:tableStyleId>
+                  </a:tblPr>
+                  <a:tblGrid>
+                    <a:gridCol w="1134019">
+                      <a:extLst>
+                        <a:ext uri="{9D8B030D-6E8A-4147-A177-3AD203B41FA5}">
+                          <a16:colId xmlns:a16="http://schemas.microsoft.com/office/drawing/2014/main" val="2524751995"/>
+                        </a:ext>
+                      </a:extLst>
+                    </a:gridCol>
+                    <a:gridCol w="1707906">
+                      <a:extLst>
+                        <a:ext uri="{9D8B030D-6E8A-4147-A177-3AD203B41FA5}">
+                          <a16:colId xmlns:a16="http://schemas.microsoft.com/office/drawing/2014/main" val="3895262931"/>
+                        </a:ext>
+                      </a:extLst>
+                    </a:gridCol>
+                  </a:tblGrid>
+                  <a:tr h="457200">
+                    <a:tc>
+                      <a:txBody>
+                        <a:bodyPr/>
+                        <a:lstStyle/>
+                        <a:p>
+                          <a:r>
+                            <a:rPr lang="en-US" sz="1200" dirty="0">
+                              <a:latin typeface="Verdana Pro" panose="020B0604030504040204" pitchFamily="34" charset="0"/>
+                            </a:rPr>
+                            <a:t>Set</a:t>
+                          </a:r>
+                          <a:endParaRPr lang="en-CA" sz="1200" dirty="0">
+                            <a:latin typeface="Verdana Pro" panose="020B0604030504040204" pitchFamily="34" charset="0"/>
+                          </a:endParaRPr>
+                        </a:p>
+                      </a:txBody>
+                      <a:tcPr/>
+                    </a:tc>
+                    <a:tc>
+                      <a:txBody>
+                        <a:bodyPr/>
+                        <a:lstStyle/>
+                        <a:p>
+                          <a:pPr marL="0" marR="0" lvl="0" indent="0" algn="l" defTabSz="914400" rtl="0" eaLnBrk="1" fontAlgn="auto" latinLnBrk="0" hangingPunct="1">
+                            <a:lnSpc>
+                              <a:spcPct val="100000"/>
+                            </a:lnSpc>
+                            <a:spcBef>
+                              <a:spcPts val="0"/>
+                            </a:spcBef>
+                            <a:spcAft>
+                              <a:spcPts val="0"/>
+                            </a:spcAft>
+                            <a:buClrTx/>
+                            <a:buSzTx/>
+                            <a:buFontTx/>
+                            <a:buNone/>
+                            <a:tabLst/>
+                            <a:defRPr/>
+                          </a:pPr>
+                          <a:r>
+                            <a:rPr lang="en-US" sz="1200" dirty="0">
+                              <a:latin typeface="Verdana Pro" panose="020B0604030504040204" pitchFamily="34" charset="0"/>
+                            </a:rPr>
+                            <a:t>Proportion with ImmPort ann.</a:t>
+                          </a:r>
+                          <a:endParaRPr lang="en-CA" sz="1200" dirty="0">
+                            <a:latin typeface="Verdana Pro" panose="020B0604030504040204" pitchFamily="34" charset="0"/>
+                          </a:endParaRPr>
+                        </a:p>
+                      </a:txBody>
+                      <a:tcPr/>
+                    </a:tc>
+                    <a:extLst>
+                      <a:ext uri="{0D108BD9-81ED-4DB2-BD59-A6C34878D82A}">
+                        <a16:rowId xmlns:a16="http://schemas.microsoft.com/office/drawing/2014/main" val="1389278446"/>
+                      </a:ext>
+                    </a:extLst>
+                  </a:tr>
+                  <a:tr h="274320">
+                    <a:tc>
+                      <a:txBody>
+                        <a:bodyPr/>
+                        <a:lstStyle/>
+                        <a:p>
+                          <a:endParaRPr lang="en-US"/>
+                        </a:p>
+                      </a:txBody>
+                      <a:tcPr>
+                        <a:blipFill>
+                          <a:blip r:embed="rId2"/>
+                          <a:stretch>
+                            <a:fillRect l="-538" t="-165217" r="-152151" b="-113043"/>
+                          </a:stretch>
+                        </a:blipFill>
+                      </a:tcPr>
+                    </a:tc>
+                    <a:tc>
+                      <a:txBody>
+                        <a:bodyPr/>
+                        <a:lstStyle/>
+                        <a:p>
+                          <a:r>
+                            <a:rPr lang="en-US" sz="1200" dirty="0">
+                              <a:latin typeface="Verdana Pro" panose="020B0604030504040204" pitchFamily="34" charset="0"/>
+                            </a:rPr>
+                            <a:t>0.237</a:t>
+                          </a:r>
+                          <a:endParaRPr lang="en-CA" sz="1200" dirty="0">
+                            <a:latin typeface="Verdana Pro" panose="020B0604030504040204" pitchFamily="34" charset="0"/>
+                          </a:endParaRPr>
+                        </a:p>
+                      </a:txBody>
+                      <a:tcPr/>
+                    </a:tc>
+                    <a:extLst>
+                      <a:ext uri="{0D108BD9-81ED-4DB2-BD59-A6C34878D82A}">
+                        <a16:rowId xmlns:a16="http://schemas.microsoft.com/office/drawing/2014/main" val="1689302623"/>
+                      </a:ext>
+                    </a:extLst>
+                  </a:tr>
+                  <a:tr h="274320">
+                    <a:tc>
+                      <a:txBody>
+                        <a:bodyPr/>
+                        <a:lstStyle/>
+                        <a:p>
+                          <a:r>
+                            <a:rPr lang="en-US" sz="1200" dirty="0">
+                              <a:latin typeface="Verdana Pro" panose="020B0604030504040204" pitchFamily="34" charset="0"/>
+                            </a:rPr>
+                            <a:t>Background</a:t>
+                          </a:r>
+                          <a:endParaRPr lang="en-CA" sz="1200" dirty="0">
+                            <a:latin typeface="Verdana Pro" panose="020B0604030504040204" pitchFamily="34" charset="0"/>
+                          </a:endParaRPr>
+                        </a:p>
+                      </a:txBody>
+                      <a:tcPr/>
+                    </a:tc>
+                    <a:tc>
+                      <a:txBody>
+                        <a:bodyPr/>
+                        <a:lstStyle/>
+                        <a:p>
+                          <a:r>
+                            <a:rPr lang="en-US" sz="1200" dirty="0">
+                              <a:latin typeface="Verdana Pro" panose="020B0604030504040204" pitchFamily="34" charset="0"/>
+                            </a:rPr>
+                            <a:t>0.202</a:t>
+                          </a:r>
+                          <a:endParaRPr lang="en-CA" sz="1200" dirty="0">
+                            <a:latin typeface="Verdana Pro" panose="020B0604030504040204" pitchFamily="34" charset="0"/>
+                          </a:endParaRPr>
+                        </a:p>
+                      </a:txBody>
+                      <a:tcPr/>
+                    </a:tc>
+                    <a:extLst>
+                      <a:ext uri="{0D108BD9-81ED-4DB2-BD59-A6C34878D82A}">
+                        <a16:rowId xmlns:a16="http://schemas.microsoft.com/office/drawing/2014/main" val="2686609459"/>
+                      </a:ext>
+                    </a:extLst>
+                  </a:tr>
+                </a:tbl>
+              </a:graphicData>
+            </a:graphic>
+          </p:graphicFrame>
+        </mc:Fallback>
+      </mc:AlternateContent>
+      <p:pic>
+        <p:nvPicPr>
+          <p:cNvPr id="12" name="Graphic 11">
+            <a:extLst>
+              <a:ext uri="{FF2B5EF4-FFF2-40B4-BE49-F238E27FC236}">
+                <a16:creationId xmlns:a16="http://schemas.microsoft.com/office/drawing/2014/main" id="{5A4543C6-581B-8FB6-4C97-52D366C2CE00}"/>
+              </a:ext>
+            </a:extLst>
+          </p:cNvPr>
+          <p:cNvPicPr>
+            <a:picLocks noChangeAspect="1"/>
+          </p:cNvPicPr>
+          <p:nvPr/>
+        </p:nvPicPr>
+        <p:blipFill>
+          <a:blip>
+            <a:extLst>
+              <a:ext uri="{96DAC541-7B7A-43D3-8B79-37D633B846F1}">
+                <asvg:svgBlip xmlns:asvg="http://schemas.microsoft.com/office/drawing/2016/SVG/main" r:embed="rId3"/>
+              </a:ext>
+            </a:extLst>
+          </a:blip>
+          <a:stretch>
+            <a:fillRect/>
+          </a:stretch>
+        </p:blipFill>
+        <p:spPr>
+          <a:xfrm>
+            <a:off x="315257" y="1150448"/>
+            <a:ext cx="8419907" cy="5051944"/>
+          </a:xfrm>
+          <a:prstGeom prst="rect">
+            <a:avLst/>
+          </a:prstGeom>
+        </p:spPr>
+      </p:pic>
+    </p:spTree>
+    <p:extLst>
+      <p:ext uri="{BB962C8B-B14F-4D97-AF65-F5344CB8AC3E}">
+        <p14:creationId xmlns:p14="http://schemas.microsoft.com/office/powerpoint/2010/main" val="3635984468"/>
+      </p:ext>
+    </p:extLst>
+  </p:cSld>
+  <p:clrMapOvr>
+    <a:masterClrMapping/>
+  </p:clrMapOvr>
+</p:sld>
+</file>
+
+<file path=ppt/slides/slide19.xml><?xml version="1.0" encoding="utf-8"?>
 <p:sld xmlns:a="http://schemas.openxmlformats.org/drawingml/2006/main" xmlns:r="http://schemas.openxmlformats.org/officeDocument/2006/relationships" xmlns:p="http://schemas.openxmlformats.org/presentationml/2006/main">
   <p:cSld>
     <p:bg>
@@ -12380,7 +13098,7 @@
           <a:p>
             <a:fld id="{D20FA860-28F0-477C-BD76-C96AC22CF614}" type="slidenum">
               <a:rPr lang="en-CA" smtClean="0"/>
-              <a:t>18</a:t>
+              <a:t>19</a:t>
             </a:fld>
             <a:endParaRPr lang="en-CA"/>
           </a:p>
@@ -12548,401 +13266,6 @@
     <p:extLst>
       <p:ext uri="{BB962C8B-B14F-4D97-AF65-F5344CB8AC3E}">
         <p14:creationId xmlns:p14="http://schemas.microsoft.com/office/powerpoint/2010/main" val="576528196"/>
-      </p:ext>
-    </p:extLst>
-  </p:cSld>
-  <p:clrMapOvr>
-    <a:masterClrMapping/>
-  </p:clrMapOvr>
-</p:sld>
-</file>
-
-<file path=ppt/slides/slide19.xml><?xml version="1.0" encoding="utf-8"?>
-<p:sld xmlns:a="http://schemas.openxmlformats.org/drawingml/2006/main" xmlns:r="http://schemas.openxmlformats.org/officeDocument/2006/relationships" xmlns:p="http://schemas.openxmlformats.org/presentationml/2006/main">
-  <p:cSld>
-    <p:spTree>
-      <p:nvGrpSpPr>
-        <p:cNvPr id="1" name="">
-          <a:extLst>
-            <a:ext uri="{FF2B5EF4-FFF2-40B4-BE49-F238E27FC236}">
-              <a16:creationId xmlns:a16="http://schemas.microsoft.com/office/drawing/2014/main" id="{4DDCF993-7558-8DD9-8875-BE65655F7917}"/>
-            </a:ext>
-          </a:extLst>
-        </p:cNvPr>
-        <p:cNvGrpSpPr/>
-        <p:nvPr/>
-      </p:nvGrpSpPr>
-      <p:grpSpPr>
-        <a:xfrm>
-          <a:off x="0" y="0"/>
-          <a:ext cx="0" cy="0"/>
-          <a:chOff x="0" y="0"/>
-          <a:chExt cx="0" cy="0"/>
-        </a:xfrm>
-      </p:grpSpPr>
-      <p:sp>
-        <p:nvSpPr>
-          <p:cNvPr id="15" name="Rectangle: Rounded Corners 14">
-            <a:extLst>
-              <a:ext uri="{FF2B5EF4-FFF2-40B4-BE49-F238E27FC236}">
-                <a16:creationId xmlns:a16="http://schemas.microsoft.com/office/drawing/2014/main" id="{69875721-348E-DD05-25AB-E649F816AC90}"/>
-              </a:ext>
-            </a:extLst>
-          </p:cNvPr>
-          <p:cNvSpPr/>
-          <p:nvPr/>
-        </p:nvSpPr>
-        <p:spPr>
-          <a:xfrm>
-            <a:off x="315257" y="8582"/>
-            <a:ext cx="9363581" cy="628742"/>
-          </a:xfrm>
-          <a:prstGeom prst="roundRect">
-            <a:avLst/>
-          </a:prstGeom>
-          <a:solidFill>
-            <a:srgbClr val="0162B3"/>
-          </a:solidFill>
-          <a:ln>
-            <a:solidFill>
-              <a:srgbClr val="0162B3"/>
-            </a:solidFill>
-          </a:ln>
-        </p:spPr>
-        <p:style>
-          <a:lnRef idx="2">
-            <a:schemeClr val="accent1">
-              <a:shade val="50000"/>
-            </a:schemeClr>
-          </a:lnRef>
-          <a:fillRef idx="1">
-            <a:schemeClr val="accent1"/>
-          </a:fillRef>
-          <a:effectRef idx="0">
-            <a:schemeClr val="accent1"/>
-          </a:effectRef>
-          <a:fontRef idx="minor">
-            <a:schemeClr val="lt1"/>
-          </a:fontRef>
-        </p:style>
-        <p:txBody>
-          <a:bodyPr rtlCol="0" anchor="ctr"/>
-          <a:lstStyle>
-            <a:defPPr>
-              <a:defRPr lang="en-US"/>
-            </a:defPPr>
-            <a:lvl1pPr marL="0" algn="l" defTabSz="914400" rtl="0" eaLnBrk="1" latinLnBrk="0" hangingPunct="1">
-              <a:defRPr sz="1800" kern="1200">
-                <a:solidFill>
-                  <a:schemeClr val="lt1"/>
-                </a:solidFill>
-                <a:latin typeface="+mn-lt"/>
-                <a:ea typeface="+mn-ea"/>
-                <a:cs typeface="+mn-cs"/>
-              </a:defRPr>
-            </a:lvl1pPr>
-            <a:lvl2pPr marL="457200" algn="l" defTabSz="914400" rtl="0" eaLnBrk="1" latinLnBrk="0" hangingPunct="1">
-              <a:defRPr sz="1800" kern="1200">
-                <a:solidFill>
-                  <a:schemeClr val="lt1"/>
-                </a:solidFill>
-                <a:latin typeface="+mn-lt"/>
-                <a:ea typeface="+mn-ea"/>
-                <a:cs typeface="+mn-cs"/>
-              </a:defRPr>
-            </a:lvl2pPr>
-            <a:lvl3pPr marL="914400" algn="l" defTabSz="914400" rtl="0" eaLnBrk="1" latinLnBrk="0" hangingPunct="1">
-              <a:defRPr sz="1800" kern="1200">
-                <a:solidFill>
-                  <a:schemeClr val="lt1"/>
-                </a:solidFill>
-                <a:latin typeface="+mn-lt"/>
-                <a:ea typeface="+mn-ea"/>
-                <a:cs typeface="+mn-cs"/>
-              </a:defRPr>
-            </a:lvl3pPr>
-            <a:lvl4pPr marL="1371600" algn="l" defTabSz="914400" rtl="0" eaLnBrk="1" latinLnBrk="0" hangingPunct="1">
-              <a:defRPr sz="1800" kern="1200">
-                <a:solidFill>
-                  <a:schemeClr val="lt1"/>
-                </a:solidFill>
-                <a:latin typeface="+mn-lt"/>
-                <a:ea typeface="+mn-ea"/>
-                <a:cs typeface="+mn-cs"/>
-              </a:defRPr>
-            </a:lvl4pPr>
-            <a:lvl5pPr marL="1828800" algn="l" defTabSz="914400" rtl="0" eaLnBrk="1" latinLnBrk="0" hangingPunct="1">
-              <a:defRPr sz="1800" kern="1200">
-                <a:solidFill>
-                  <a:schemeClr val="lt1"/>
-                </a:solidFill>
-                <a:latin typeface="+mn-lt"/>
-                <a:ea typeface="+mn-ea"/>
-                <a:cs typeface="+mn-cs"/>
-              </a:defRPr>
-            </a:lvl5pPr>
-            <a:lvl6pPr marL="2286000" algn="l" defTabSz="914400" rtl="0" eaLnBrk="1" latinLnBrk="0" hangingPunct="1">
-              <a:defRPr sz="1800" kern="1200">
-                <a:solidFill>
-                  <a:schemeClr val="lt1"/>
-                </a:solidFill>
-                <a:latin typeface="+mn-lt"/>
-                <a:ea typeface="+mn-ea"/>
-                <a:cs typeface="+mn-cs"/>
-              </a:defRPr>
-            </a:lvl6pPr>
-            <a:lvl7pPr marL="2743200" algn="l" defTabSz="914400" rtl="0" eaLnBrk="1" latinLnBrk="0" hangingPunct="1">
-              <a:defRPr sz="1800" kern="1200">
-                <a:solidFill>
-                  <a:schemeClr val="lt1"/>
-                </a:solidFill>
-                <a:latin typeface="+mn-lt"/>
-                <a:ea typeface="+mn-ea"/>
-                <a:cs typeface="+mn-cs"/>
-              </a:defRPr>
-            </a:lvl7pPr>
-            <a:lvl8pPr marL="3200400" algn="l" defTabSz="914400" rtl="0" eaLnBrk="1" latinLnBrk="0" hangingPunct="1">
-              <a:defRPr sz="1800" kern="1200">
-                <a:solidFill>
-                  <a:schemeClr val="lt1"/>
-                </a:solidFill>
-                <a:latin typeface="+mn-lt"/>
-                <a:ea typeface="+mn-ea"/>
-                <a:cs typeface="+mn-cs"/>
-              </a:defRPr>
-            </a:lvl8pPr>
-            <a:lvl9pPr marL="3657600" algn="l" defTabSz="914400" rtl="0" eaLnBrk="1" latinLnBrk="0" hangingPunct="1">
-              <a:defRPr sz="1800" kern="1200">
-                <a:solidFill>
-                  <a:schemeClr val="lt1"/>
-                </a:solidFill>
-                <a:latin typeface="+mn-lt"/>
-                <a:ea typeface="+mn-ea"/>
-                <a:cs typeface="+mn-cs"/>
-              </a:defRPr>
-            </a:lvl9pPr>
-          </a:lstStyle>
-          <a:p>
-            <a:pPr algn="ctr"/>
-            <a:endParaRPr lang="en-CA"/>
-          </a:p>
-        </p:txBody>
-      </p:sp>
-      <p:sp>
-        <p:nvSpPr>
-          <p:cNvPr id="19" name="TextBox 18">
-            <a:extLst>
-              <a:ext uri="{FF2B5EF4-FFF2-40B4-BE49-F238E27FC236}">
-                <a16:creationId xmlns:a16="http://schemas.microsoft.com/office/drawing/2014/main" id="{D12CEC08-BD14-4E67-D412-32101C458AE1}"/>
-              </a:ext>
-            </a:extLst>
-          </p:cNvPr>
-          <p:cNvSpPr txBox="1"/>
-          <p:nvPr/>
-        </p:nvSpPr>
-        <p:spPr>
-          <a:xfrm>
-            <a:off x="527959" y="76731"/>
-            <a:ext cx="8710932" cy="492443"/>
-          </a:xfrm>
-          <a:prstGeom prst="rect">
-            <a:avLst/>
-          </a:prstGeom>
-          <a:noFill/>
-        </p:spPr>
-        <p:txBody>
-          <a:bodyPr wrap="square" rtlCol="0">
-            <a:spAutoFit/>
-          </a:bodyPr>
-          <a:lstStyle/>
-          <a:p>
-            <a:r>
-              <a:rPr lang="en-US" sz="2600" b="1" dirty="0">
-                <a:solidFill>
-                  <a:schemeClr val="bg1"/>
-                </a:solidFill>
-                <a:latin typeface="Georgia Pro" panose="02040502050405020303" pitchFamily="18" charset="0"/>
-              </a:rPr>
-              <a:t>Acknowledgements</a:t>
-            </a:r>
-            <a:endParaRPr lang="en-CA" sz="2600" b="1" dirty="0">
-              <a:solidFill>
-                <a:schemeClr val="bg1"/>
-              </a:solidFill>
-              <a:latin typeface="Georgia Pro" panose="02040502050405020303" pitchFamily="18" charset="0"/>
-            </a:endParaRPr>
-          </a:p>
-        </p:txBody>
-      </p:sp>
-      <p:sp>
-        <p:nvSpPr>
-          <p:cNvPr id="2" name="TextBox 1">
-            <a:extLst>
-              <a:ext uri="{FF2B5EF4-FFF2-40B4-BE49-F238E27FC236}">
-                <a16:creationId xmlns:a16="http://schemas.microsoft.com/office/drawing/2014/main" id="{4FD08597-320D-3D8D-4678-1F20F3CD6887}"/>
-              </a:ext>
-            </a:extLst>
-          </p:cNvPr>
-          <p:cNvSpPr txBox="1"/>
-          <p:nvPr/>
-        </p:nvSpPr>
-        <p:spPr>
-          <a:xfrm>
-            <a:off x="527958" y="1146628"/>
-            <a:ext cx="9363581" cy="2846933"/>
-          </a:xfrm>
-          <a:prstGeom prst="rect">
-            <a:avLst/>
-          </a:prstGeom>
-          <a:noFill/>
-        </p:spPr>
-        <p:txBody>
-          <a:bodyPr wrap="square" rtlCol="0">
-            <a:spAutoFit/>
-          </a:bodyPr>
-          <a:lstStyle/>
-          <a:p>
-            <a:pPr>
-              <a:spcAft>
-                <a:spcPts val="600"/>
-              </a:spcAft>
-            </a:pPr>
-            <a:r>
-              <a:rPr lang="en-US" dirty="0">
-                <a:latin typeface="Georgia Pro" panose="02040502050405020303" pitchFamily="18" charset="0"/>
-              </a:rPr>
-              <a:t>Vinicius Furlan</a:t>
-            </a:r>
-          </a:p>
-          <a:p>
-            <a:pPr>
-              <a:spcAft>
-                <a:spcPts val="600"/>
-              </a:spcAft>
-            </a:pPr>
-            <a:r>
-              <a:rPr lang="en-US" dirty="0">
-                <a:latin typeface="Georgia Pro" panose="02040502050405020303" pitchFamily="18" charset="0"/>
-              </a:rPr>
-              <a:t>Anjali Jain</a:t>
-            </a:r>
-          </a:p>
-          <a:p>
-            <a:pPr>
-              <a:spcAft>
-                <a:spcPts val="600"/>
-              </a:spcAft>
-            </a:pPr>
-            <a:r>
-              <a:rPr lang="en-US" dirty="0">
-                <a:latin typeface="Georgia Pro" panose="02040502050405020303" pitchFamily="18" charset="0"/>
-              </a:rPr>
-              <a:t>Andy Wang</a:t>
-            </a:r>
-          </a:p>
-          <a:p>
-            <a:pPr>
-              <a:spcAft>
-                <a:spcPts val="600"/>
-              </a:spcAft>
-            </a:pPr>
-            <a:r>
-              <a:rPr lang="en-US" dirty="0">
-                <a:latin typeface="Georgia Pro" panose="02040502050405020303" pitchFamily="18" charset="0"/>
-              </a:rPr>
-              <a:t>Matthew Uchmanowicz</a:t>
-            </a:r>
-          </a:p>
-          <a:p>
-            <a:pPr>
-              <a:spcAft>
-                <a:spcPts val="600"/>
-              </a:spcAft>
-            </a:pPr>
-            <a:r>
-              <a:rPr lang="en-US" dirty="0">
-                <a:latin typeface="Georgia Pro" panose="02040502050405020303" pitchFamily="18" charset="0"/>
-              </a:rPr>
-              <a:t>Dr. Chantel Trost</a:t>
-            </a:r>
-          </a:p>
-          <a:p>
-            <a:pPr>
-              <a:spcAft>
-                <a:spcPts val="600"/>
-              </a:spcAft>
-            </a:pPr>
-            <a:r>
-              <a:rPr lang="en-US" dirty="0">
-                <a:latin typeface="Georgia Pro" panose="02040502050405020303" pitchFamily="18" charset="0"/>
-              </a:rPr>
-              <a:t>Dr. Christian Marshall</a:t>
-            </a:r>
-          </a:p>
-          <a:p>
-            <a:pPr>
-              <a:spcAft>
-                <a:spcPts val="600"/>
-              </a:spcAft>
-            </a:pPr>
-            <a:r>
-              <a:rPr lang="en-US" dirty="0">
-                <a:latin typeface="Georgia Pro" panose="02040502050405020303" pitchFamily="18" charset="0"/>
-              </a:rPr>
-              <a:t>Dr. Stephen Scherer</a:t>
-            </a:r>
-          </a:p>
-          <a:p>
-            <a:pPr>
-              <a:spcAft>
-                <a:spcPts val="600"/>
-              </a:spcAft>
-            </a:pPr>
-            <a:r>
-              <a:rPr lang="en-US" dirty="0">
-                <a:latin typeface="Georgia Pro" panose="02040502050405020303" pitchFamily="18" charset="0"/>
-              </a:rPr>
-              <a:t>Centre for Computational Medicine</a:t>
-            </a:r>
-            <a:endParaRPr lang="en-CA" dirty="0">
-              <a:latin typeface="Georgia Pro" panose="02040502050405020303" pitchFamily="18" charset="0"/>
-            </a:endParaRPr>
-          </a:p>
-        </p:txBody>
-      </p:sp>
-      <p:sp>
-        <p:nvSpPr>
-          <p:cNvPr id="3" name="Slide Number Placeholder 2">
-            <a:extLst>
-              <a:ext uri="{FF2B5EF4-FFF2-40B4-BE49-F238E27FC236}">
-                <a16:creationId xmlns:a16="http://schemas.microsoft.com/office/drawing/2014/main" id="{C2541BCD-C37C-9A51-8EA7-F038561CD42E}"/>
-              </a:ext>
-            </a:extLst>
-          </p:cNvPr>
-          <p:cNvSpPr>
-            <a:spLocks noGrp="1"/>
-          </p:cNvSpPr>
-          <p:nvPr>
-            <p:ph type="sldNum" sz="quarter" idx="12"/>
-          </p:nvPr>
-        </p:nvSpPr>
-        <p:spPr/>
-        <p:txBody>
-          <a:bodyPr/>
-          <a:lstStyle/>
-          <a:p>
-            <a:fld id="{D20FA860-28F0-477C-BD76-C96AC22CF614}" type="slidenum">
-              <a:rPr lang="en-CA" smtClean="0"/>
-              <a:t>19</a:t>
-            </a:fld>
-            <a:endParaRPr lang="en-CA"/>
-          </a:p>
-        </p:txBody>
-      </p:sp>
-    </p:spTree>
-    <p:extLst>
-      <p:ext uri="{BB962C8B-B14F-4D97-AF65-F5344CB8AC3E}">
-        <p14:creationId xmlns:p14="http://schemas.microsoft.com/office/powerpoint/2010/main" val="659556371"/>
       </p:ext>
     </p:extLst>
   </p:cSld>
@@ -13074,7 +13397,7 @@
         <p:cNvPr id="1" name="">
           <a:extLst>
             <a:ext uri="{FF2B5EF4-FFF2-40B4-BE49-F238E27FC236}">
-              <a16:creationId xmlns:a16="http://schemas.microsoft.com/office/drawing/2014/main" id="{5E96BC46-7673-C84B-18B4-63539AA9C004}"/>
+              <a16:creationId xmlns:a16="http://schemas.microsoft.com/office/drawing/2014/main" id="{4DDCF993-7558-8DD9-8875-BE65655F7917}"/>
             </a:ext>
           </a:extLst>
         </p:cNvPr>
@@ -13094,7 +13417,7 @@
           <p:cNvPr id="15" name="Rectangle: Rounded Corners 14">
             <a:extLst>
               <a:ext uri="{FF2B5EF4-FFF2-40B4-BE49-F238E27FC236}">
-                <a16:creationId xmlns:a16="http://schemas.microsoft.com/office/drawing/2014/main" id="{7DA48913-4EF7-7226-450E-EB863B768EE5}"/>
+                <a16:creationId xmlns:a16="http://schemas.microsoft.com/office/drawing/2014/main" id="{69875721-348E-DD05-25AB-E649F816AC90}"/>
               </a:ext>
             </a:extLst>
           </p:cNvPr>
@@ -13242,7 +13565,7 @@
           <p:cNvPr id="19" name="TextBox 18">
             <a:extLst>
               <a:ext uri="{FF2B5EF4-FFF2-40B4-BE49-F238E27FC236}">
-                <a16:creationId xmlns:a16="http://schemas.microsoft.com/office/drawing/2014/main" id="{C3A09E84-A853-2CE4-2353-6F32C167F0F1}"/>
+                <a16:creationId xmlns:a16="http://schemas.microsoft.com/office/drawing/2014/main" id="{D12CEC08-BD14-4E67-D412-32101C458AE1}"/>
               </a:ext>
             </a:extLst>
           </p:cNvPr>
@@ -13272,6 +13595,401 @@
                 </a:solidFill>
                 <a:latin typeface="Georgia Pro" panose="02040502050405020303" pitchFamily="18" charset="0"/>
               </a:rPr>
+              <a:t>Acknowledgements</a:t>
+            </a:r>
+            <a:endParaRPr lang="en-CA" sz="2600" b="1" dirty="0">
+              <a:solidFill>
+                <a:schemeClr val="bg1"/>
+              </a:solidFill>
+              <a:latin typeface="Georgia Pro" panose="02040502050405020303" pitchFamily="18" charset="0"/>
+            </a:endParaRPr>
+          </a:p>
+        </p:txBody>
+      </p:sp>
+      <p:sp>
+        <p:nvSpPr>
+          <p:cNvPr id="2" name="TextBox 1">
+            <a:extLst>
+              <a:ext uri="{FF2B5EF4-FFF2-40B4-BE49-F238E27FC236}">
+                <a16:creationId xmlns:a16="http://schemas.microsoft.com/office/drawing/2014/main" id="{4FD08597-320D-3D8D-4678-1F20F3CD6887}"/>
+              </a:ext>
+            </a:extLst>
+          </p:cNvPr>
+          <p:cNvSpPr txBox="1"/>
+          <p:nvPr/>
+        </p:nvSpPr>
+        <p:spPr>
+          <a:xfrm>
+            <a:off x="527958" y="1146628"/>
+            <a:ext cx="9363581" cy="2846933"/>
+          </a:xfrm>
+          <a:prstGeom prst="rect">
+            <a:avLst/>
+          </a:prstGeom>
+          <a:noFill/>
+        </p:spPr>
+        <p:txBody>
+          <a:bodyPr wrap="square" rtlCol="0">
+            <a:spAutoFit/>
+          </a:bodyPr>
+          <a:lstStyle/>
+          <a:p>
+            <a:pPr>
+              <a:spcAft>
+                <a:spcPts val="600"/>
+              </a:spcAft>
+            </a:pPr>
+            <a:r>
+              <a:rPr lang="en-US" dirty="0">
+                <a:latin typeface="Georgia Pro" panose="02040502050405020303" pitchFamily="18" charset="0"/>
+              </a:rPr>
+              <a:t>Vinicius Furlan</a:t>
+            </a:r>
+          </a:p>
+          <a:p>
+            <a:pPr>
+              <a:spcAft>
+                <a:spcPts val="600"/>
+              </a:spcAft>
+            </a:pPr>
+            <a:r>
+              <a:rPr lang="en-US" dirty="0">
+                <a:latin typeface="Georgia Pro" panose="02040502050405020303" pitchFamily="18" charset="0"/>
+              </a:rPr>
+              <a:t>Anjali Jain</a:t>
+            </a:r>
+          </a:p>
+          <a:p>
+            <a:pPr>
+              <a:spcAft>
+                <a:spcPts val="600"/>
+              </a:spcAft>
+            </a:pPr>
+            <a:r>
+              <a:rPr lang="en-US" dirty="0">
+                <a:latin typeface="Georgia Pro" panose="02040502050405020303" pitchFamily="18" charset="0"/>
+              </a:rPr>
+              <a:t>Andy Wang</a:t>
+            </a:r>
+          </a:p>
+          <a:p>
+            <a:pPr>
+              <a:spcAft>
+                <a:spcPts val="600"/>
+              </a:spcAft>
+            </a:pPr>
+            <a:r>
+              <a:rPr lang="en-US" dirty="0">
+                <a:latin typeface="Georgia Pro" panose="02040502050405020303" pitchFamily="18" charset="0"/>
+              </a:rPr>
+              <a:t>Matthew Uchmanowicz</a:t>
+            </a:r>
+          </a:p>
+          <a:p>
+            <a:pPr>
+              <a:spcAft>
+                <a:spcPts val="600"/>
+              </a:spcAft>
+            </a:pPr>
+            <a:r>
+              <a:rPr lang="en-US" dirty="0">
+                <a:latin typeface="Georgia Pro" panose="02040502050405020303" pitchFamily="18" charset="0"/>
+              </a:rPr>
+              <a:t>Dr. Chantel Trost</a:t>
+            </a:r>
+          </a:p>
+          <a:p>
+            <a:pPr>
+              <a:spcAft>
+                <a:spcPts val="600"/>
+              </a:spcAft>
+            </a:pPr>
+            <a:r>
+              <a:rPr lang="en-US" dirty="0">
+                <a:latin typeface="Georgia Pro" panose="02040502050405020303" pitchFamily="18" charset="0"/>
+              </a:rPr>
+              <a:t>Dr. Christian Marshall</a:t>
+            </a:r>
+          </a:p>
+          <a:p>
+            <a:pPr>
+              <a:spcAft>
+                <a:spcPts val="600"/>
+              </a:spcAft>
+            </a:pPr>
+            <a:r>
+              <a:rPr lang="en-US" dirty="0">
+                <a:latin typeface="Georgia Pro" panose="02040502050405020303" pitchFamily="18" charset="0"/>
+              </a:rPr>
+              <a:t>Dr. Stephen Scherer</a:t>
+            </a:r>
+          </a:p>
+          <a:p>
+            <a:pPr>
+              <a:spcAft>
+                <a:spcPts val="600"/>
+              </a:spcAft>
+            </a:pPr>
+            <a:r>
+              <a:rPr lang="en-US" dirty="0">
+                <a:latin typeface="Georgia Pro" panose="02040502050405020303" pitchFamily="18" charset="0"/>
+              </a:rPr>
+              <a:t>Centre for Computational Medicine</a:t>
+            </a:r>
+            <a:endParaRPr lang="en-CA" dirty="0">
+              <a:latin typeface="Georgia Pro" panose="02040502050405020303" pitchFamily="18" charset="0"/>
+            </a:endParaRPr>
+          </a:p>
+        </p:txBody>
+      </p:sp>
+      <p:sp>
+        <p:nvSpPr>
+          <p:cNvPr id="3" name="Slide Number Placeholder 2">
+            <a:extLst>
+              <a:ext uri="{FF2B5EF4-FFF2-40B4-BE49-F238E27FC236}">
+                <a16:creationId xmlns:a16="http://schemas.microsoft.com/office/drawing/2014/main" id="{C2541BCD-C37C-9A51-8EA7-F038561CD42E}"/>
+              </a:ext>
+            </a:extLst>
+          </p:cNvPr>
+          <p:cNvSpPr>
+            <a:spLocks noGrp="1"/>
+          </p:cNvSpPr>
+          <p:nvPr>
+            <p:ph type="sldNum" sz="quarter" idx="12"/>
+          </p:nvPr>
+        </p:nvSpPr>
+        <p:spPr/>
+        <p:txBody>
+          <a:bodyPr/>
+          <a:lstStyle/>
+          <a:p>
+            <a:fld id="{D20FA860-28F0-477C-BD76-C96AC22CF614}" type="slidenum">
+              <a:rPr lang="en-CA" smtClean="0"/>
+              <a:t>20</a:t>
+            </a:fld>
+            <a:endParaRPr lang="en-CA"/>
+          </a:p>
+        </p:txBody>
+      </p:sp>
+    </p:spTree>
+    <p:extLst>
+      <p:ext uri="{BB962C8B-B14F-4D97-AF65-F5344CB8AC3E}">
+        <p14:creationId xmlns:p14="http://schemas.microsoft.com/office/powerpoint/2010/main" val="659556371"/>
+      </p:ext>
+    </p:extLst>
+  </p:cSld>
+  <p:clrMapOvr>
+    <a:masterClrMapping/>
+  </p:clrMapOvr>
+</p:sld>
+</file>
+
+<file path=ppt/slides/slide21.xml><?xml version="1.0" encoding="utf-8"?>
+<p:sld xmlns:a="http://schemas.openxmlformats.org/drawingml/2006/main" xmlns:r="http://schemas.openxmlformats.org/officeDocument/2006/relationships" xmlns:p="http://schemas.openxmlformats.org/presentationml/2006/main">
+  <p:cSld>
+    <p:spTree>
+      <p:nvGrpSpPr>
+        <p:cNvPr id="1" name="">
+          <a:extLst>
+            <a:ext uri="{FF2B5EF4-FFF2-40B4-BE49-F238E27FC236}">
+              <a16:creationId xmlns:a16="http://schemas.microsoft.com/office/drawing/2014/main" id="{5E96BC46-7673-C84B-18B4-63539AA9C004}"/>
+            </a:ext>
+          </a:extLst>
+        </p:cNvPr>
+        <p:cNvGrpSpPr/>
+        <p:nvPr/>
+      </p:nvGrpSpPr>
+      <p:grpSpPr>
+        <a:xfrm>
+          <a:off x="0" y="0"/>
+          <a:ext cx="0" cy="0"/>
+          <a:chOff x="0" y="0"/>
+          <a:chExt cx="0" cy="0"/>
+        </a:xfrm>
+      </p:grpSpPr>
+      <p:sp>
+        <p:nvSpPr>
+          <p:cNvPr id="15" name="Rectangle: Rounded Corners 14">
+            <a:extLst>
+              <a:ext uri="{FF2B5EF4-FFF2-40B4-BE49-F238E27FC236}">
+                <a16:creationId xmlns:a16="http://schemas.microsoft.com/office/drawing/2014/main" id="{7DA48913-4EF7-7226-450E-EB863B768EE5}"/>
+              </a:ext>
+            </a:extLst>
+          </p:cNvPr>
+          <p:cNvSpPr/>
+          <p:nvPr/>
+        </p:nvSpPr>
+        <p:spPr>
+          <a:xfrm>
+            <a:off x="315257" y="8582"/>
+            <a:ext cx="9363581" cy="628742"/>
+          </a:xfrm>
+          <a:prstGeom prst="roundRect">
+            <a:avLst/>
+          </a:prstGeom>
+          <a:solidFill>
+            <a:srgbClr val="0162B3"/>
+          </a:solidFill>
+          <a:ln>
+            <a:solidFill>
+              <a:srgbClr val="0162B3"/>
+            </a:solidFill>
+          </a:ln>
+        </p:spPr>
+        <p:style>
+          <a:lnRef idx="2">
+            <a:schemeClr val="accent1">
+              <a:shade val="50000"/>
+            </a:schemeClr>
+          </a:lnRef>
+          <a:fillRef idx="1">
+            <a:schemeClr val="accent1"/>
+          </a:fillRef>
+          <a:effectRef idx="0">
+            <a:schemeClr val="accent1"/>
+          </a:effectRef>
+          <a:fontRef idx="minor">
+            <a:schemeClr val="lt1"/>
+          </a:fontRef>
+        </p:style>
+        <p:txBody>
+          <a:bodyPr rtlCol="0" anchor="ctr"/>
+          <a:lstStyle>
+            <a:defPPr>
+              <a:defRPr lang="en-US"/>
+            </a:defPPr>
+            <a:lvl1pPr marL="0" algn="l" defTabSz="914400" rtl="0" eaLnBrk="1" latinLnBrk="0" hangingPunct="1">
+              <a:defRPr sz="1800" kern="1200">
+                <a:solidFill>
+                  <a:schemeClr val="lt1"/>
+                </a:solidFill>
+                <a:latin typeface="+mn-lt"/>
+                <a:ea typeface="+mn-ea"/>
+                <a:cs typeface="+mn-cs"/>
+              </a:defRPr>
+            </a:lvl1pPr>
+            <a:lvl2pPr marL="457200" algn="l" defTabSz="914400" rtl="0" eaLnBrk="1" latinLnBrk="0" hangingPunct="1">
+              <a:defRPr sz="1800" kern="1200">
+                <a:solidFill>
+                  <a:schemeClr val="lt1"/>
+                </a:solidFill>
+                <a:latin typeface="+mn-lt"/>
+                <a:ea typeface="+mn-ea"/>
+                <a:cs typeface="+mn-cs"/>
+              </a:defRPr>
+            </a:lvl2pPr>
+            <a:lvl3pPr marL="914400" algn="l" defTabSz="914400" rtl="0" eaLnBrk="1" latinLnBrk="0" hangingPunct="1">
+              <a:defRPr sz="1800" kern="1200">
+                <a:solidFill>
+                  <a:schemeClr val="lt1"/>
+                </a:solidFill>
+                <a:latin typeface="+mn-lt"/>
+                <a:ea typeface="+mn-ea"/>
+                <a:cs typeface="+mn-cs"/>
+              </a:defRPr>
+            </a:lvl3pPr>
+            <a:lvl4pPr marL="1371600" algn="l" defTabSz="914400" rtl="0" eaLnBrk="1" latinLnBrk="0" hangingPunct="1">
+              <a:defRPr sz="1800" kern="1200">
+                <a:solidFill>
+                  <a:schemeClr val="lt1"/>
+                </a:solidFill>
+                <a:latin typeface="+mn-lt"/>
+                <a:ea typeface="+mn-ea"/>
+                <a:cs typeface="+mn-cs"/>
+              </a:defRPr>
+            </a:lvl4pPr>
+            <a:lvl5pPr marL="1828800" algn="l" defTabSz="914400" rtl="0" eaLnBrk="1" latinLnBrk="0" hangingPunct="1">
+              <a:defRPr sz="1800" kern="1200">
+                <a:solidFill>
+                  <a:schemeClr val="lt1"/>
+                </a:solidFill>
+                <a:latin typeface="+mn-lt"/>
+                <a:ea typeface="+mn-ea"/>
+                <a:cs typeface="+mn-cs"/>
+              </a:defRPr>
+            </a:lvl5pPr>
+            <a:lvl6pPr marL="2286000" algn="l" defTabSz="914400" rtl="0" eaLnBrk="1" latinLnBrk="0" hangingPunct="1">
+              <a:defRPr sz="1800" kern="1200">
+                <a:solidFill>
+                  <a:schemeClr val="lt1"/>
+                </a:solidFill>
+                <a:latin typeface="+mn-lt"/>
+                <a:ea typeface="+mn-ea"/>
+                <a:cs typeface="+mn-cs"/>
+              </a:defRPr>
+            </a:lvl6pPr>
+            <a:lvl7pPr marL="2743200" algn="l" defTabSz="914400" rtl="0" eaLnBrk="1" latinLnBrk="0" hangingPunct="1">
+              <a:defRPr sz="1800" kern="1200">
+                <a:solidFill>
+                  <a:schemeClr val="lt1"/>
+                </a:solidFill>
+                <a:latin typeface="+mn-lt"/>
+                <a:ea typeface="+mn-ea"/>
+                <a:cs typeface="+mn-cs"/>
+              </a:defRPr>
+            </a:lvl7pPr>
+            <a:lvl8pPr marL="3200400" algn="l" defTabSz="914400" rtl="0" eaLnBrk="1" latinLnBrk="0" hangingPunct="1">
+              <a:defRPr sz="1800" kern="1200">
+                <a:solidFill>
+                  <a:schemeClr val="lt1"/>
+                </a:solidFill>
+                <a:latin typeface="+mn-lt"/>
+                <a:ea typeface="+mn-ea"/>
+                <a:cs typeface="+mn-cs"/>
+              </a:defRPr>
+            </a:lvl8pPr>
+            <a:lvl9pPr marL="3657600" algn="l" defTabSz="914400" rtl="0" eaLnBrk="1" latinLnBrk="0" hangingPunct="1">
+              <a:defRPr sz="1800" kern="1200">
+                <a:solidFill>
+                  <a:schemeClr val="lt1"/>
+                </a:solidFill>
+                <a:latin typeface="+mn-lt"/>
+                <a:ea typeface="+mn-ea"/>
+                <a:cs typeface="+mn-cs"/>
+              </a:defRPr>
+            </a:lvl9pPr>
+          </a:lstStyle>
+          <a:p>
+            <a:pPr algn="ctr"/>
+            <a:endParaRPr lang="en-CA"/>
+          </a:p>
+        </p:txBody>
+      </p:sp>
+      <p:sp>
+        <p:nvSpPr>
+          <p:cNvPr id="19" name="TextBox 18">
+            <a:extLst>
+              <a:ext uri="{FF2B5EF4-FFF2-40B4-BE49-F238E27FC236}">
+                <a16:creationId xmlns:a16="http://schemas.microsoft.com/office/drawing/2014/main" id="{C3A09E84-A853-2CE4-2353-6F32C167F0F1}"/>
+              </a:ext>
+            </a:extLst>
+          </p:cNvPr>
+          <p:cNvSpPr txBox="1"/>
+          <p:nvPr/>
+        </p:nvSpPr>
+        <p:spPr>
+          <a:xfrm>
+            <a:off x="527959" y="76731"/>
+            <a:ext cx="8710932" cy="492443"/>
+          </a:xfrm>
+          <a:prstGeom prst="rect">
+            <a:avLst/>
+          </a:prstGeom>
+          <a:noFill/>
+        </p:spPr>
+        <p:txBody>
+          <a:bodyPr wrap="square" rtlCol="0">
+            <a:spAutoFit/>
+          </a:bodyPr>
+          <a:lstStyle/>
+          <a:p>
+            <a:r>
+              <a:rPr lang="en-US" sz="2600" b="1" dirty="0">
+                <a:solidFill>
+                  <a:schemeClr val="bg1"/>
+                </a:solidFill>
+                <a:latin typeface="Georgia Pro" panose="02040502050405020303" pitchFamily="18" charset="0"/>
+              </a:rPr>
               <a:t>References</a:t>
             </a:r>
             <a:endParaRPr lang="en-CA" sz="2600" b="1" dirty="0">
@@ -13428,7 +14146,7 @@
           <a:p>
             <a:fld id="{D20FA860-28F0-477C-BD76-C96AC22CF614}" type="slidenum">
               <a:rPr lang="en-CA" smtClean="0"/>
-              <a:t>20</a:t>
+              <a:t>21</a:t>
             </a:fld>
             <a:endParaRPr lang="en-CA"/>
           </a:p>

</xml_diff>

<commit_message>
Added version of pie plot that does not perform compound annotation splitting such that 2 + 3 = 5.
</commit_message>
<xml_diff>
--- a/reports/2026-08-28_projectUpdate_3/2026-08-28_projectUpdate_3_jmoran.pptx
+++ b/reports/2026-08-28_projectUpdate_3/2026-08-28_projectUpdate_3_jmoran.pptx
@@ -25,8 +25,8 @@
     <p:sldId id="298" r:id="rId16"/>
     <p:sldId id="299" r:id="rId17"/>
     <p:sldId id="302" r:id="rId18"/>
-    <p:sldId id="303" r:id="rId19"/>
-    <p:sldId id="300" r:id="rId20"/>
+    <p:sldId id="300" r:id="rId19"/>
+    <p:sldId id="303" r:id="rId20"/>
     <p:sldId id="301" r:id="rId21"/>
     <p:sldId id="296" r:id="rId22"/>
   </p:sldIdLst>
@@ -12335,6 +12335,277 @@
 <file path=ppt/slides/slide18.xml><?xml version="1.0" encoding="utf-8"?>
 <p:sld xmlns:a="http://schemas.openxmlformats.org/drawingml/2006/main" xmlns:r="http://schemas.openxmlformats.org/officeDocument/2006/relationships" xmlns:p="http://schemas.openxmlformats.org/presentationml/2006/main">
   <p:cSld>
+    <p:bg>
+      <p:bgPr>
+        <a:solidFill>
+          <a:srgbClr val="0162B3"/>
+        </a:solidFill>
+        <a:effectLst/>
+      </p:bgPr>
+    </p:bg>
+    <p:spTree>
+      <p:nvGrpSpPr>
+        <p:cNvPr id="1" name="">
+          <a:extLst>
+            <a:ext uri="{FF2B5EF4-FFF2-40B4-BE49-F238E27FC236}">
+              <a16:creationId xmlns:a16="http://schemas.microsoft.com/office/drawing/2014/main" id="{3DECA242-476F-CD63-C2D3-63C2D2E4EA4E}"/>
+            </a:ext>
+          </a:extLst>
+        </p:cNvPr>
+        <p:cNvGrpSpPr/>
+        <p:nvPr/>
+      </p:nvGrpSpPr>
+      <p:grpSpPr>
+        <a:xfrm>
+          <a:off x="0" y="0"/>
+          <a:ext cx="0" cy="0"/>
+          <a:chOff x="0" y="0"/>
+          <a:chExt cx="0" cy="0"/>
+        </a:xfrm>
+      </p:grpSpPr>
+      <p:sp>
+        <p:nvSpPr>
+          <p:cNvPr id="5" name="TextBox 4">
+            <a:extLst>
+              <a:ext uri="{FF2B5EF4-FFF2-40B4-BE49-F238E27FC236}">
+                <a16:creationId xmlns:a16="http://schemas.microsoft.com/office/drawing/2014/main" id="{BC46E6E4-646B-2D17-ACF9-CBF07B2773AB}"/>
+              </a:ext>
+            </a:extLst>
+          </p:cNvPr>
+          <p:cNvSpPr txBox="1"/>
+          <p:nvPr/>
+        </p:nvSpPr>
+        <p:spPr>
+          <a:xfrm>
+            <a:off x="679162" y="632668"/>
+            <a:ext cx="4154878" cy="492443"/>
+          </a:xfrm>
+          <a:prstGeom prst="rect">
+            <a:avLst/>
+          </a:prstGeom>
+          <a:noFill/>
+        </p:spPr>
+        <p:txBody>
+          <a:bodyPr wrap="square" rtlCol="0">
+            <a:spAutoFit/>
+          </a:bodyPr>
+          <a:lstStyle/>
+          <a:p>
+            <a:r>
+              <a:rPr lang="en-US" sz="2600" b="1" dirty="0">
+                <a:solidFill>
+                  <a:schemeClr val="bg1"/>
+                </a:solidFill>
+                <a:latin typeface="Georgia Pro" panose="02040502050405020303" pitchFamily="18" charset="0"/>
+              </a:rPr>
+              <a:t>Conclusions</a:t>
+            </a:r>
+          </a:p>
+        </p:txBody>
+      </p:sp>
+      <p:sp>
+        <p:nvSpPr>
+          <p:cNvPr id="2" name="Slide Number Placeholder 1">
+            <a:extLst>
+              <a:ext uri="{FF2B5EF4-FFF2-40B4-BE49-F238E27FC236}">
+                <a16:creationId xmlns:a16="http://schemas.microsoft.com/office/drawing/2014/main" id="{7D1FB7BB-1F32-C312-9404-8F1B28C82CD3}"/>
+              </a:ext>
+            </a:extLst>
+          </p:cNvPr>
+          <p:cNvSpPr>
+            <a:spLocks noGrp="1"/>
+          </p:cNvSpPr>
+          <p:nvPr>
+            <p:ph type="sldNum" sz="quarter" idx="12"/>
+          </p:nvPr>
+        </p:nvSpPr>
+        <p:spPr/>
+        <p:txBody>
+          <a:bodyPr/>
+          <a:lstStyle/>
+          <a:p>
+            <a:fld id="{D20FA860-28F0-477C-BD76-C96AC22CF614}" type="slidenum">
+              <a:rPr lang="en-CA" smtClean="0"/>
+              <a:t>18</a:t>
+            </a:fld>
+            <a:endParaRPr lang="en-CA"/>
+          </a:p>
+        </p:txBody>
+      </p:sp>
+      <p:sp>
+        <p:nvSpPr>
+          <p:cNvPr id="3" name="TextBox 2">
+            <a:extLst>
+              <a:ext uri="{FF2B5EF4-FFF2-40B4-BE49-F238E27FC236}">
+                <a16:creationId xmlns:a16="http://schemas.microsoft.com/office/drawing/2014/main" id="{BA299718-BBFE-DF8E-81D7-1AA6D24C799B}"/>
+              </a:ext>
+            </a:extLst>
+          </p:cNvPr>
+          <p:cNvSpPr txBox="1"/>
+          <p:nvPr/>
+        </p:nvSpPr>
+        <p:spPr>
+          <a:xfrm>
+            <a:off x="826716" y="1459282"/>
+            <a:ext cx="8805799" cy="4031873"/>
+          </a:xfrm>
+          <a:prstGeom prst="rect">
+            <a:avLst/>
+          </a:prstGeom>
+          <a:noFill/>
+        </p:spPr>
+        <p:txBody>
+          <a:bodyPr wrap="square" rtlCol="0">
+            <a:spAutoFit/>
+          </a:bodyPr>
+          <a:lstStyle/>
+          <a:p>
+            <a:pPr marL="342900" indent="-342900">
+              <a:spcAft>
+                <a:spcPts val="600"/>
+              </a:spcAft>
+              <a:buFont typeface="+mj-lt"/>
+              <a:buAutoNum type="arabicPeriod"/>
+            </a:pPr>
+            <a:r>
+              <a:rPr lang="en-US" dirty="0">
+                <a:solidFill>
+                  <a:schemeClr val="bg1"/>
+                </a:solidFill>
+                <a:latin typeface="Verdana Pro" panose="020B0604030504040204" pitchFamily="34" charset="0"/>
+              </a:rPr>
+              <a:t>IEI_BISSH pipeline annotates protein pairs with a composite score that encapsulates strength of evidence for structural homology</a:t>
+            </a:r>
+          </a:p>
+          <a:p>
+            <a:pPr marL="800100" lvl="1" indent="-342900">
+              <a:spcAft>
+                <a:spcPts val="600"/>
+              </a:spcAft>
+              <a:buFont typeface="Arial" panose="020B0604020202020204" pitchFamily="34" charset="0"/>
+              <a:buChar char="•"/>
+            </a:pPr>
+            <a:r>
+              <a:rPr lang="en-US" dirty="0">
+                <a:solidFill>
+                  <a:schemeClr val="bg1"/>
+                </a:solidFill>
+                <a:latin typeface="Verdana Pro" panose="020B0604030504040204" pitchFamily="34" charset="0"/>
+              </a:rPr>
+              <a:t>examples of known homologous proteins as per literature have high composite score</a:t>
+            </a:r>
+          </a:p>
+          <a:p>
+            <a:pPr marL="800100" lvl="1" indent="-342900">
+              <a:spcAft>
+                <a:spcPts val="600"/>
+              </a:spcAft>
+              <a:buFont typeface="Arial" panose="020B0604020202020204" pitchFamily="34" charset="0"/>
+              <a:buChar char="•"/>
+            </a:pPr>
+            <a:r>
+              <a:rPr lang="en-US" dirty="0">
+                <a:solidFill>
+                  <a:schemeClr val="bg1"/>
+                </a:solidFill>
+                <a:latin typeface="Verdana Pro" panose="020B0604030504040204" pitchFamily="34" charset="0"/>
+              </a:rPr>
+              <a:t>IUIS-IEI genes in pipeline output have significantly greater composite score than background</a:t>
+            </a:r>
+          </a:p>
+          <a:p>
+            <a:pPr marL="800100" lvl="1" indent="-342900">
+              <a:spcAft>
+                <a:spcPts val="600"/>
+              </a:spcAft>
+              <a:buFont typeface="Arial" panose="020B0604020202020204" pitchFamily="34" charset="0"/>
+              <a:buChar char="•"/>
+            </a:pPr>
+            <a:r>
+              <a:rPr lang="en-US" dirty="0">
+                <a:solidFill>
+                  <a:schemeClr val="bg1"/>
+                </a:solidFill>
+                <a:latin typeface="Verdana Pro" panose="020B0604030504040204" pitchFamily="34" charset="0"/>
+              </a:rPr>
+              <a:t>examples of </a:t>
+            </a:r>
+            <a:r>
+              <a:rPr lang="en-US" i="1" dirty="0">
+                <a:solidFill>
+                  <a:schemeClr val="bg1"/>
+                </a:solidFill>
+                <a:latin typeface="Verdana Pro" panose="020B0604030504040204" pitchFamily="34" charset="0"/>
+              </a:rPr>
+              <a:t>H. sapiens</a:t>
+            </a:r>
+            <a:r>
+              <a:rPr lang="en-US" dirty="0">
+                <a:solidFill>
+                  <a:schemeClr val="bg1"/>
+                </a:solidFill>
+                <a:latin typeface="Verdana Pro" panose="020B0604030504040204" pitchFamily="34" charset="0"/>
+              </a:rPr>
+              <a:t> proteins in top-scoring pairs have documented antiviral roles in humans</a:t>
+            </a:r>
+          </a:p>
+          <a:p>
+            <a:pPr marL="800100" lvl="1" indent="-342900">
+              <a:spcAft>
+                <a:spcPts val="2400"/>
+              </a:spcAft>
+              <a:buFont typeface="Arial" panose="020B0604020202020204" pitchFamily="34" charset="0"/>
+              <a:buChar char="•"/>
+            </a:pPr>
+            <a:r>
+              <a:rPr lang="en-US" dirty="0">
+                <a:solidFill>
+                  <a:schemeClr val="bg1"/>
+                </a:solidFill>
+                <a:latin typeface="Verdana Pro" panose="020B0604030504040204" pitchFamily="34" charset="0"/>
+              </a:rPr>
+              <a:t>composite score threshold can be used to compile a gene list for clinical genetics applications</a:t>
+            </a:r>
+          </a:p>
+          <a:p>
+            <a:pPr marL="342900" indent="-342900">
+              <a:buFont typeface="+mj-lt"/>
+              <a:buAutoNum type="arabicPeriod"/>
+            </a:pPr>
+            <a:r>
+              <a:rPr lang="en-US" dirty="0">
+                <a:solidFill>
+                  <a:schemeClr val="bg1"/>
+                </a:solidFill>
+                <a:latin typeface="Verdana Pro" panose="020B0604030504040204" pitchFamily="34" charset="0"/>
+              </a:rPr>
+              <a:t>IEI_BISSH pipeline elucidates human-bacteria protein homology that is not discernible from sequence homology alone</a:t>
+            </a:r>
+            <a:endParaRPr lang="en-CA" dirty="0">
+              <a:solidFill>
+                <a:schemeClr val="bg1"/>
+              </a:solidFill>
+              <a:latin typeface="Verdana Pro" panose="020B0604030504040204" pitchFamily="34" charset="0"/>
+            </a:endParaRPr>
+          </a:p>
+        </p:txBody>
+      </p:sp>
+    </p:spTree>
+    <p:extLst>
+      <p:ext uri="{BB962C8B-B14F-4D97-AF65-F5344CB8AC3E}">
+        <p14:creationId xmlns:p14="http://schemas.microsoft.com/office/powerpoint/2010/main" val="576528196"/>
+      </p:ext>
+    </p:extLst>
+  </p:cSld>
+  <p:clrMapOvr>
+    <a:masterClrMapping/>
+  </p:clrMapOvr>
+</p:sld>
+</file>
+
+<file path=ppt/slides/slide19.xml><?xml version="1.0" encoding="utf-8"?>
+<p:sld xmlns:a="http://schemas.openxmlformats.org/drawingml/2006/main" xmlns:r="http://schemas.openxmlformats.org/officeDocument/2006/relationships" xmlns:p="http://schemas.openxmlformats.org/presentationml/2006/main">
+  <p:cSld>
     <p:spTree>
       <p:nvGrpSpPr>
         <p:cNvPr id="1" name="">
@@ -12995,277 +13266,6 @@
     <p:extLst>
       <p:ext uri="{BB962C8B-B14F-4D97-AF65-F5344CB8AC3E}">
         <p14:creationId xmlns:p14="http://schemas.microsoft.com/office/powerpoint/2010/main" val="3635984468"/>
-      </p:ext>
-    </p:extLst>
-  </p:cSld>
-  <p:clrMapOvr>
-    <a:masterClrMapping/>
-  </p:clrMapOvr>
-</p:sld>
-</file>
-
-<file path=ppt/slides/slide19.xml><?xml version="1.0" encoding="utf-8"?>
-<p:sld xmlns:a="http://schemas.openxmlformats.org/drawingml/2006/main" xmlns:r="http://schemas.openxmlformats.org/officeDocument/2006/relationships" xmlns:p="http://schemas.openxmlformats.org/presentationml/2006/main">
-  <p:cSld>
-    <p:bg>
-      <p:bgPr>
-        <a:solidFill>
-          <a:srgbClr val="0162B3"/>
-        </a:solidFill>
-        <a:effectLst/>
-      </p:bgPr>
-    </p:bg>
-    <p:spTree>
-      <p:nvGrpSpPr>
-        <p:cNvPr id="1" name="">
-          <a:extLst>
-            <a:ext uri="{FF2B5EF4-FFF2-40B4-BE49-F238E27FC236}">
-              <a16:creationId xmlns:a16="http://schemas.microsoft.com/office/drawing/2014/main" id="{3DECA242-476F-CD63-C2D3-63C2D2E4EA4E}"/>
-            </a:ext>
-          </a:extLst>
-        </p:cNvPr>
-        <p:cNvGrpSpPr/>
-        <p:nvPr/>
-      </p:nvGrpSpPr>
-      <p:grpSpPr>
-        <a:xfrm>
-          <a:off x="0" y="0"/>
-          <a:ext cx="0" cy="0"/>
-          <a:chOff x="0" y="0"/>
-          <a:chExt cx="0" cy="0"/>
-        </a:xfrm>
-      </p:grpSpPr>
-      <p:sp>
-        <p:nvSpPr>
-          <p:cNvPr id="5" name="TextBox 4">
-            <a:extLst>
-              <a:ext uri="{FF2B5EF4-FFF2-40B4-BE49-F238E27FC236}">
-                <a16:creationId xmlns:a16="http://schemas.microsoft.com/office/drawing/2014/main" id="{BC46E6E4-646B-2D17-ACF9-CBF07B2773AB}"/>
-              </a:ext>
-            </a:extLst>
-          </p:cNvPr>
-          <p:cNvSpPr txBox="1"/>
-          <p:nvPr/>
-        </p:nvSpPr>
-        <p:spPr>
-          <a:xfrm>
-            <a:off x="679162" y="632668"/>
-            <a:ext cx="4154878" cy="492443"/>
-          </a:xfrm>
-          <a:prstGeom prst="rect">
-            <a:avLst/>
-          </a:prstGeom>
-          <a:noFill/>
-        </p:spPr>
-        <p:txBody>
-          <a:bodyPr wrap="square" rtlCol="0">
-            <a:spAutoFit/>
-          </a:bodyPr>
-          <a:lstStyle/>
-          <a:p>
-            <a:r>
-              <a:rPr lang="en-US" sz="2600" b="1" dirty="0">
-                <a:solidFill>
-                  <a:schemeClr val="bg1"/>
-                </a:solidFill>
-                <a:latin typeface="Georgia Pro" panose="02040502050405020303" pitchFamily="18" charset="0"/>
-              </a:rPr>
-              <a:t>Conclusions</a:t>
-            </a:r>
-          </a:p>
-        </p:txBody>
-      </p:sp>
-      <p:sp>
-        <p:nvSpPr>
-          <p:cNvPr id="2" name="Slide Number Placeholder 1">
-            <a:extLst>
-              <a:ext uri="{FF2B5EF4-FFF2-40B4-BE49-F238E27FC236}">
-                <a16:creationId xmlns:a16="http://schemas.microsoft.com/office/drawing/2014/main" id="{7D1FB7BB-1F32-C312-9404-8F1B28C82CD3}"/>
-              </a:ext>
-            </a:extLst>
-          </p:cNvPr>
-          <p:cNvSpPr>
-            <a:spLocks noGrp="1"/>
-          </p:cNvSpPr>
-          <p:nvPr>
-            <p:ph type="sldNum" sz="quarter" idx="12"/>
-          </p:nvPr>
-        </p:nvSpPr>
-        <p:spPr/>
-        <p:txBody>
-          <a:bodyPr/>
-          <a:lstStyle/>
-          <a:p>
-            <a:fld id="{D20FA860-28F0-477C-BD76-C96AC22CF614}" type="slidenum">
-              <a:rPr lang="en-CA" smtClean="0"/>
-              <a:t>19</a:t>
-            </a:fld>
-            <a:endParaRPr lang="en-CA"/>
-          </a:p>
-        </p:txBody>
-      </p:sp>
-      <p:sp>
-        <p:nvSpPr>
-          <p:cNvPr id="3" name="TextBox 2">
-            <a:extLst>
-              <a:ext uri="{FF2B5EF4-FFF2-40B4-BE49-F238E27FC236}">
-                <a16:creationId xmlns:a16="http://schemas.microsoft.com/office/drawing/2014/main" id="{BA299718-BBFE-DF8E-81D7-1AA6D24C799B}"/>
-              </a:ext>
-            </a:extLst>
-          </p:cNvPr>
-          <p:cNvSpPr txBox="1"/>
-          <p:nvPr/>
-        </p:nvSpPr>
-        <p:spPr>
-          <a:xfrm>
-            <a:off x="826716" y="1459282"/>
-            <a:ext cx="8805799" cy="4031873"/>
-          </a:xfrm>
-          <a:prstGeom prst="rect">
-            <a:avLst/>
-          </a:prstGeom>
-          <a:noFill/>
-        </p:spPr>
-        <p:txBody>
-          <a:bodyPr wrap="square" rtlCol="0">
-            <a:spAutoFit/>
-          </a:bodyPr>
-          <a:lstStyle/>
-          <a:p>
-            <a:pPr marL="342900" indent="-342900">
-              <a:spcAft>
-                <a:spcPts val="600"/>
-              </a:spcAft>
-              <a:buFont typeface="+mj-lt"/>
-              <a:buAutoNum type="arabicPeriod"/>
-            </a:pPr>
-            <a:r>
-              <a:rPr lang="en-US" dirty="0">
-                <a:solidFill>
-                  <a:schemeClr val="bg1"/>
-                </a:solidFill>
-                <a:latin typeface="Verdana Pro" panose="020B0604030504040204" pitchFamily="34" charset="0"/>
-              </a:rPr>
-              <a:t>IEI_BISSH pipeline annotates protein pairs with a composite score that encapsulates strength of evidence for structural homology</a:t>
-            </a:r>
-          </a:p>
-          <a:p>
-            <a:pPr marL="800100" lvl="1" indent="-342900">
-              <a:spcAft>
-                <a:spcPts val="600"/>
-              </a:spcAft>
-              <a:buFont typeface="Arial" panose="020B0604020202020204" pitchFamily="34" charset="0"/>
-              <a:buChar char="•"/>
-            </a:pPr>
-            <a:r>
-              <a:rPr lang="en-US" dirty="0">
-                <a:solidFill>
-                  <a:schemeClr val="bg1"/>
-                </a:solidFill>
-                <a:latin typeface="Verdana Pro" panose="020B0604030504040204" pitchFamily="34" charset="0"/>
-              </a:rPr>
-              <a:t>examples of known homologous proteins as per literature have high composite score</a:t>
-            </a:r>
-          </a:p>
-          <a:p>
-            <a:pPr marL="800100" lvl="1" indent="-342900">
-              <a:spcAft>
-                <a:spcPts val="600"/>
-              </a:spcAft>
-              <a:buFont typeface="Arial" panose="020B0604020202020204" pitchFamily="34" charset="0"/>
-              <a:buChar char="•"/>
-            </a:pPr>
-            <a:r>
-              <a:rPr lang="en-US" dirty="0">
-                <a:solidFill>
-                  <a:schemeClr val="bg1"/>
-                </a:solidFill>
-                <a:latin typeface="Verdana Pro" panose="020B0604030504040204" pitchFamily="34" charset="0"/>
-              </a:rPr>
-              <a:t>IUIS-IEI genes in pipeline output have significantly greater composite score than background</a:t>
-            </a:r>
-          </a:p>
-          <a:p>
-            <a:pPr marL="800100" lvl="1" indent="-342900">
-              <a:spcAft>
-                <a:spcPts val="600"/>
-              </a:spcAft>
-              <a:buFont typeface="Arial" panose="020B0604020202020204" pitchFamily="34" charset="0"/>
-              <a:buChar char="•"/>
-            </a:pPr>
-            <a:r>
-              <a:rPr lang="en-US" dirty="0">
-                <a:solidFill>
-                  <a:schemeClr val="bg1"/>
-                </a:solidFill>
-                <a:latin typeface="Verdana Pro" panose="020B0604030504040204" pitchFamily="34" charset="0"/>
-              </a:rPr>
-              <a:t>examples of </a:t>
-            </a:r>
-            <a:r>
-              <a:rPr lang="en-US" i="1" dirty="0">
-                <a:solidFill>
-                  <a:schemeClr val="bg1"/>
-                </a:solidFill>
-                <a:latin typeface="Verdana Pro" panose="020B0604030504040204" pitchFamily="34" charset="0"/>
-              </a:rPr>
-              <a:t>H. sapiens</a:t>
-            </a:r>
-            <a:r>
-              <a:rPr lang="en-US" dirty="0">
-                <a:solidFill>
-                  <a:schemeClr val="bg1"/>
-                </a:solidFill>
-                <a:latin typeface="Verdana Pro" panose="020B0604030504040204" pitchFamily="34" charset="0"/>
-              </a:rPr>
-              <a:t> proteins in top-scoring pairs have documented antiviral roles in humans</a:t>
-            </a:r>
-          </a:p>
-          <a:p>
-            <a:pPr marL="800100" lvl="1" indent="-342900">
-              <a:spcAft>
-                <a:spcPts val="2400"/>
-              </a:spcAft>
-              <a:buFont typeface="Arial" panose="020B0604020202020204" pitchFamily="34" charset="0"/>
-              <a:buChar char="•"/>
-            </a:pPr>
-            <a:r>
-              <a:rPr lang="en-US" dirty="0">
-                <a:solidFill>
-                  <a:schemeClr val="bg1"/>
-                </a:solidFill>
-                <a:latin typeface="Verdana Pro" panose="020B0604030504040204" pitchFamily="34" charset="0"/>
-              </a:rPr>
-              <a:t>composite score threshold can be used to compile a gene list for clinical genetics applications</a:t>
-            </a:r>
-          </a:p>
-          <a:p>
-            <a:pPr marL="342900" indent="-342900">
-              <a:buFont typeface="+mj-lt"/>
-              <a:buAutoNum type="arabicPeriod"/>
-            </a:pPr>
-            <a:r>
-              <a:rPr lang="en-US" dirty="0">
-                <a:solidFill>
-                  <a:schemeClr val="bg1"/>
-                </a:solidFill>
-                <a:latin typeface="Verdana Pro" panose="020B0604030504040204" pitchFamily="34" charset="0"/>
-              </a:rPr>
-              <a:t>IEI_BISSH pipeline elucidates human-bacteria protein homology that is not discernible from sequence homology alone</a:t>
-            </a:r>
-            <a:endParaRPr lang="en-CA" dirty="0">
-              <a:solidFill>
-                <a:schemeClr val="bg1"/>
-              </a:solidFill>
-              <a:latin typeface="Verdana Pro" panose="020B0604030504040204" pitchFamily="34" charset="0"/>
-            </a:endParaRPr>
-          </a:p>
-        </p:txBody>
-      </p:sp>
-    </p:spTree>
-    <p:extLst>
-      <p:ext uri="{BB962C8B-B14F-4D97-AF65-F5344CB8AC3E}">
-        <p14:creationId xmlns:p14="http://schemas.microsoft.com/office/powerpoint/2010/main" val="576528196"/>
       </p:ext>
     </p:extLst>
   </p:cSld>

</xml_diff>

<commit_message>
Updated slides to show less misleading plots.
</commit_message>
<xml_diff>
--- a/reports/2026-08-28_projectUpdate_3/2026-08-28_projectUpdate_3_jmoran.pptx
+++ b/reports/2026-08-28_projectUpdate_3/2026-08-28_projectUpdate_3_jmoran.pptx
@@ -11788,6 +11788,43 @@
           <a:chExt cx="0" cy="0"/>
         </a:xfrm>
       </p:grpSpPr>
+      <p:pic>
+        <p:nvPicPr>
+          <p:cNvPr id="25" name="Graphic 24">
+            <a:extLst>
+              <a:ext uri="{FF2B5EF4-FFF2-40B4-BE49-F238E27FC236}">
+                <a16:creationId xmlns:a16="http://schemas.microsoft.com/office/drawing/2014/main" id="{FD4E93F6-70AC-CCE9-4AE2-19946633EC72}"/>
+              </a:ext>
+            </a:extLst>
+          </p:cNvPr>
+          <p:cNvPicPr>
+            <a:picLocks noChangeAspect="1"/>
+          </p:cNvPicPr>
+          <p:nvPr/>
+        </p:nvPicPr>
+        <p:blipFill>
+          <a:blip>
+            <a:extLst>
+              <a:ext uri="{96DAC541-7B7A-43D3-8B79-37D633B846F1}">
+                <asvg:svgBlip xmlns:asvg="http://schemas.microsoft.com/office/drawing/2016/SVG/main" r:embed="rId2"/>
+              </a:ext>
+            </a:extLst>
+          </a:blip>
+          <a:srcRect l="62689" t="25061" b="25061"/>
+          <a:stretch>
+            <a:fillRect/>
+          </a:stretch>
+        </p:blipFill>
+        <p:spPr>
+          <a:xfrm>
+            <a:off x="5169745" y="3157268"/>
+            <a:ext cx="5404284" cy="2572330"/>
+          </a:xfrm>
+          <a:prstGeom prst="rect">
+            <a:avLst/>
+          </a:prstGeom>
+        </p:spPr>
+      </p:pic>
       <p:sp>
         <p:nvSpPr>
           <p:cNvPr id="6" name="Rectangle: Rounded Corners 5">
@@ -11984,214 +12021,6 @@
           </a:p>
         </p:txBody>
       </p:sp>
-      <p:grpSp>
-        <p:nvGrpSpPr>
-          <p:cNvPr id="18" name="Group 17">
-            <a:extLst>
-              <a:ext uri="{FF2B5EF4-FFF2-40B4-BE49-F238E27FC236}">
-                <a16:creationId xmlns:a16="http://schemas.microsoft.com/office/drawing/2014/main" id="{44D1C052-910F-B676-F3E1-28310C7A9E0B}"/>
-              </a:ext>
-            </a:extLst>
-          </p:cNvPr>
-          <p:cNvGrpSpPr/>
-          <p:nvPr/>
-        </p:nvGrpSpPr>
-        <p:grpSpPr>
-          <a:xfrm>
-            <a:off x="621102" y="1509623"/>
-            <a:ext cx="4071668" cy="4037163"/>
-            <a:chOff x="457200" y="1570008"/>
-            <a:chExt cx="4071668" cy="4037163"/>
-          </a:xfrm>
-        </p:grpSpPr>
-        <p:pic>
-          <p:nvPicPr>
-            <p:cNvPr id="3" name="Graphic 2">
-              <a:extLst>
-                <a:ext uri="{FF2B5EF4-FFF2-40B4-BE49-F238E27FC236}">
-                  <a16:creationId xmlns:a16="http://schemas.microsoft.com/office/drawing/2014/main" id="{A3F1735D-EB76-444F-1A6C-8C6CFB6F2D3D}"/>
-                </a:ext>
-              </a:extLst>
-            </p:cNvPr>
-            <p:cNvPicPr>
-              <a:picLocks noChangeAspect="1"/>
-            </p:cNvPicPr>
-            <p:nvPr/>
-          </p:nvPicPr>
-          <p:blipFill>
-            <a:blip>
-              <a:extLst>
-                <a:ext uri="{96DAC541-7B7A-43D3-8B79-37D633B846F1}">
-                  <asvg:svgBlip xmlns:asvg="http://schemas.microsoft.com/office/drawing/2016/SVG/main" r:embed="rId2"/>
-                </a:ext>
-              </a:extLst>
-            </a:blip>
-            <a:srcRect l="2371" t="5391" r="52868" b="4428"/>
-            <a:stretch>
-              <a:fillRect/>
-            </a:stretch>
-          </p:blipFill>
-          <p:spPr>
-            <a:xfrm>
-              <a:off x="457200" y="1570008"/>
-              <a:ext cx="4071668" cy="4037163"/>
-            </a:xfrm>
-            <a:prstGeom prst="rect">
-              <a:avLst/>
-            </a:prstGeom>
-          </p:spPr>
-        </p:pic>
-        <p:sp>
-          <p:nvSpPr>
-            <p:cNvPr id="4" name="TextBox 3">
-              <a:extLst>
-                <a:ext uri="{FF2B5EF4-FFF2-40B4-BE49-F238E27FC236}">
-                  <a16:creationId xmlns:a16="http://schemas.microsoft.com/office/drawing/2014/main" id="{A14F3DEA-1231-4BEF-A74A-E08B8A03D02E}"/>
-                </a:ext>
-              </a:extLst>
-            </p:cNvPr>
-            <p:cNvSpPr txBox="1"/>
-            <p:nvPr/>
-          </p:nvSpPr>
-          <p:spPr>
-            <a:xfrm>
-              <a:off x="901460" y="3670539"/>
-              <a:ext cx="914400" cy="276999"/>
-            </a:xfrm>
-            <a:prstGeom prst="rect">
-              <a:avLst/>
-            </a:prstGeom>
-            <a:solidFill>
-              <a:srgbClr val="333336"/>
-            </a:solidFill>
-          </p:spPr>
-          <p:txBody>
-            <a:bodyPr wrap="square" rtlCol="0">
-              <a:spAutoFit/>
-            </a:bodyPr>
-            <a:lstStyle/>
-            <a:p>
-              <a:pPr algn="ctr"/>
-              <a:r>
-                <a:rPr lang="en-US" sz="1200" dirty="0">
-                  <a:solidFill>
-                    <a:schemeClr val="bg1"/>
-                  </a:solidFill>
-                  <a:latin typeface="Verdana Pro" panose="020B0604030504040204" pitchFamily="34" charset="0"/>
-                </a:rPr>
-                <a:t>57.3%</a:t>
-              </a:r>
-              <a:endParaRPr lang="en-CA" sz="1200" dirty="0">
-                <a:solidFill>
-                  <a:schemeClr val="bg1"/>
-                </a:solidFill>
-                <a:latin typeface="Verdana Pro" panose="020B0604030504040204" pitchFamily="34" charset="0"/>
-              </a:endParaRPr>
-            </a:p>
-          </p:txBody>
-        </p:sp>
-      </p:grpSp>
-      <p:grpSp>
-        <p:nvGrpSpPr>
-          <p:cNvPr id="17" name="Group 16">
-            <a:extLst>
-              <a:ext uri="{FF2B5EF4-FFF2-40B4-BE49-F238E27FC236}">
-                <a16:creationId xmlns:a16="http://schemas.microsoft.com/office/drawing/2014/main" id="{3F4CD489-DBBD-AEFE-9EFE-F3F5783E5F04}"/>
-              </a:ext>
-            </a:extLst>
-          </p:cNvPr>
-          <p:cNvGrpSpPr/>
-          <p:nvPr/>
-        </p:nvGrpSpPr>
-        <p:grpSpPr>
-          <a:xfrm>
-            <a:off x="5350627" y="3411753"/>
-            <a:ext cx="4728532" cy="2855343"/>
-            <a:chOff x="6668219" y="1992702"/>
-            <a:chExt cx="4728532" cy="2855343"/>
-          </a:xfrm>
-        </p:grpSpPr>
-        <p:pic>
-          <p:nvPicPr>
-            <p:cNvPr id="15" name="Graphic 14">
-              <a:extLst>
-                <a:ext uri="{FF2B5EF4-FFF2-40B4-BE49-F238E27FC236}">
-                  <a16:creationId xmlns:a16="http://schemas.microsoft.com/office/drawing/2014/main" id="{A6461EC0-AD35-7CE5-29EB-92C6A716520F}"/>
-                </a:ext>
-              </a:extLst>
-            </p:cNvPr>
-            <p:cNvPicPr>
-              <a:picLocks noChangeAspect="1"/>
-            </p:cNvPicPr>
-            <p:nvPr/>
-          </p:nvPicPr>
-          <p:blipFill>
-            <a:blip>
-              <a:extLst>
-                <a:ext uri="{96DAC541-7B7A-43D3-8B79-37D633B846F1}">
-                  <asvg:svgBlip xmlns:asvg="http://schemas.microsoft.com/office/drawing/2016/SVG/main" r:embed="rId2"/>
-                </a:ext>
-              </a:extLst>
-            </a:blip>
-            <a:srcRect l="48017" t="18399" b="17819"/>
-            <a:stretch>
-              <a:fillRect/>
-            </a:stretch>
-          </p:blipFill>
-          <p:spPr>
-            <a:xfrm>
-              <a:off x="6668219" y="1992702"/>
-              <a:ext cx="4728532" cy="2855343"/>
-            </a:xfrm>
-            <a:prstGeom prst="rect">
-              <a:avLst/>
-            </a:prstGeom>
-          </p:spPr>
-        </p:pic>
-        <p:sp>
-          <p:nvSpPr>
-            <p:cNvPr id="16" name="TextBox 15">
-              <a:extLst>
-                <a:ext uri="{FF2B5EF4-FFF2-40B4-BE49-F238E27FC236}">
-                  <a16:creationId xmlns:a16="http://schemas.microsoft.com/office/drawing/2014/main" id="{4EBB48B9-4792-792E-773D-2B6C192A2174}"/>
-                </a:ext>
-              </a:extLst>
-            </p:cNvPr>
-            <p:cNvSpPr txBox="1"/>
-            <p:nvPr/>
-          </p:nvSpPr>
-          <p:spPr>
-            <a:xfrm>
-              <a:off x="7571116" y="2152289"/>
-              <a:ext cx="2898476" cy="276999"/>
-            </a:xfrm>
-            <a:prstGeom prst="rect">
-              <a:avLst/>
-            </a:prstGeom>
-            <a:solidFill>
-              <a:schemeClr val="bg1"/>
-            </a:solidFill>
-          </p:spPr>
-          <p:txBody>
-            <a:bodyPr wrap="square" rtlCol="0">
-              <a:spAutoFit/>
-            </a:bodyPr>
-            <a:lstStyle/>
-            <a:p>
-              <a:pPr algn="ctr"/>
-              <a:r>
-                <a:rPr lang="en-US" sz="1200" dirty="0">
-                  <a:latin typeface="Verdana Pro" panose="020B0604030504040204" pitchFamily="34" charset="0"/>
-                </a:rPr>
-                <a:t>ImmPort pathway annotation</a:t>
-              </a:r>
-              <a:endParaRPr lang="en-CA" sz="1200" dirty="0">
-                <a:latin typeface="Verdana Pro" panose="020B0604030504040204" pitchFamily="34" charset="0"/>
-              </a:endParaRPr>
-            </a:p>
-          </p:txBody>
-        </p:sp>
-      </p:grpSp>
       <p:sp>
         <p:nvSpPr>
           <p:cNvPr id="19" name="TextBox 18">
@@ -12288,7 +12117,91 @@
         </p:nvSpPr>
         <p:spPr>
           <a:xfrm>
-            <a:off x="5414512" y="1128402"/>
+            <a:off x="6386523" y="3405185"/>
+            <a:ext cx="2823715" cy="307777"/>
+          </a:xfrm>
+          <a:prstGeom prst="rect">
+            <a:avLst/>
+          </a:prstGeom>
+          <a:solidFill>
+            <a:schemeClr val="bg1"/>
+          </a:solidFill>
+        </p:spPr>
+        <p:txBody>
+          <a:bodyPr wrap="square" rtlCol="0">
+            <a:spAutoFit/>
+          </a:bodyPr>
+          <a:lstStyle/>
+          <a:p>
+            <a:pPr algn="ctr">
+              <a:spcAft>
+                <a:spcPts val="600"/>
+              </a:spcAft>
+            </a:pPr>
+            <a:r>
+              <a:rPr lang="en-US" sz="1400" dirty="0">
+                <a:latin typeface="Verdana Pro" panose="020B0604030504040204" pitchFamily="34" charset="0"/>
+              </a:rPr>
+              <a:t>ImmPort annotations</a:t>
+            </a:r>
+            <a:endParaRPr lang="en-CA" sz="1400" dirty="0">
+              <a:latin typeface="Verdana Pro" panose="020B0604030504040204" pitchFamily="34" charset="0"/>
+            </a:endParaRPr>
+          </a:p>
+        </p:txBody>
+      </p:sp>
+      <p:pic>
+        <p:nvPicPr>
+          <p:cNvPr id="23" name="Graphic 22">
+            <a:extLst>
+              <a:ext uri="{FF2B5EF4-FFF2-40B4-BE49-F238E27FC236}">
+                <a16:creationId xmlns:a16="http://schemas.microsoft.com/office/drawing/2014/main" id="{E3B6632D-DEE0-D6EA-4CF6-F8D4CEB27291}"/>
+              </a:ext>
+            </a:extLst>
+          </p:cNvPr>
+          <p:cNvPicPr>
+            <a:picLocks noChangeAspect="1"/>
+          </p:cNvPicPr>
+          <p:nvPr/>
+        </p:nvPicPr>
+        <p:blipFill>
+          <a:blip>
+            <a:extLst>
+              <a:ext uri="{96DAC541-7B7A-43D3-8B79-37D633B846F1}">
+                <asvg:svgBlip xmlns:asvg="http://schemas.microsoft.com/office/drawing/2016/SVG/main" r:embed="rId2"/>
+              </a:ext>
+            </a:extLst>
+          </a:blip>
+          <a:srcRect l="3396" r="52523"/>
+          <a:stretch>
+            <a:fillRect/>
+          </a:stretch>
+        </p:blipFill>
+        <p:spPr>
+          <a:xfrm>
+            <a:off x="232913" y="1833923"/>
+            <a:ext cx="4945217" cy="3994531"/>
+          </a:xfrm>
+          <a:prstGeom prst="rect">
+            <a:avLst/>
+          </a:prstGeom>
+        </p:spPr>
+      </p:pic>
+      <p:sp>
+        <p:nvSpPr>
+          <p:cNvPr id="27" name="TextBox 26">
+            <a:extLst>
+              <a:ext uri="{FF2B5EF4-FFF2-40B4-BE49-F238E27FC236}">
+                <a16:creationId xmlns:a16="http://schemas.microsoft.com/office/drawing/2014/main" id="{3B93D7BA-4807-592D-5790-DE7FFED54BF2}"/>
+              </a:ext>
+            </a:extLst>
+          </p:cNvPr>
+          <p:cNvSpPr txBox="1"/>
+          <p:nvPr/>
+        </p:nvSpPr>
+        <p:spPr>
+          <a:xfrm>
+            <a:off x="5414511" y="1294474"/>
             <a:ext cx="5515155" cy="369332"/>
           </a:xfrm>
           <a:prstGeom prst="rect">
@@ -12839,14 +12752,14 @@
               <p:nvPr>
                 <p:extLst>
                   <p:ext uri="{D42A27DB-BD31-4B8C-83A1-F6EECF244321}">
-                    <p14:modId xmlns:p14="http://schemas.microsoft.com/office/powerpoint/2010/main" val="3807183921"/>
+                    <p14:modId xmlns:p14="http://schemas.microsoft.com/office/powerpoint/2010/main" val="1895619930"/>
                   </p:ext>
                 </p:extLst>
               </p:nvPr>
             </p:nvGraphicFramePr>
             <p:xfrm>
-              <a:off x="8872747" y="2524400"/>
-              <a:ext cx="2841925" cy="1005840"/>
+              <a:off x="8539372" y="2076725"/>
+              <a:ext cx="3537251" cy="1371600"/>
             </p:xfrm>
             <a:graphic>
               <a:graphicData uri="http://schemas.openxmlformats.org/drawingml/2006/table">
@@ -12855,17 +12768,24 @@
                     <a:tableStyleId>{5940675A-B579-460E-94D1-54222C63F5DA}</a:tableStyleId>
                   </a:tblPr>
                   <a:tblGrid>
-                    <a:gridCol w="1134019">
+                    <a:gridCol w="1128503">
                       <a:extLst>
                         <a:ext uri="{9D8B030D-6E8A-4147-A177-3AD203B41FA5}">
                           <a16:colId xmlns:a16="http://schemas.microsoft.com/office/drawing/2014/main" val="2524751995"/>
                         </a:ext>
                       </a:extLst>
                     </a:gridCol>
-                    <a:gridCol w="1707906">
+                    <a:gridCol w="1080942">
                       <a:extLst>
                         <a:ext uri="{9D8B030D-6E8A-4147-A177-3AD203B41FA5}">
                           <a16:colId xmlns:a16="http://schemas.microsoft.com/office/drawing/2014/main" val="3895262931"/>
+                        </a:ext>
+                      </a:extLst>
+                    </a:gridCol>
+                    <a:gridCol w="1327806">
+                      <a:extLst>
+                        <a:ext uri="{9D8B030D-6E8A-4147-A177-3AD203B41FA5}">
+                          <a16:colId xmlns:a16="http://schemas.microsoft.com/office/drawing/2014/main" val="1685863581"/>
                         </a:ext>
                       </a:extLst>
                     </a:gridCol>
@@ -12924,6 +12844,41 @@
                       </a:txBody>
                       <a:tcPr/>
                     </a:tc>
+                    <a:tc>
+                      <a:txBody>
+                        <a:bodyPr/>
+                        <a:lstStyle/>
+                        <a:p>
+                          <a:pPr marL="0" marR="0" lvl="0" indent="0" algn="l" defTabSz="914400" rtl="0" eaLnBrk="1" fontAlgn="auto" latinLnBrk="0" hangingPunct="1">
+                            <a:lnSpc>
+                              <a:spcPct val="100000"/>
+                            </a:lnSpc>
+                            <a:spcBef>
+                              <a:spcPts val="0"/>
+                            </a:spcBef>
+                            <a:spcAft>
+                              <a:spcPts val="0"/>
+                            </a:spcAft>
+                            <a:buClrTx/>
+                            <a:buSzTx/>
+                            <a:buFontTx/>
+                            <a:buNone/>
+                            <a:tabLst/>
+                            <a:defRPr/>
+                          </a:pPr>
+                          <a:r>
+                            <a:rPr lang="en-US" sz="1200" dirty="0">
+                              <a:latin typeface="Verdana Pro" panose="020B0604030504040204" pitchFamily="34" charset="0"/>
+                            </a:rPr>
+                            <a:t>Size</a:t>
+                          </a:r>
+                          <a:endParaRPr lang="en-CA" sz="1200" dirty="0">
+                            <a:latin typeface="Verdana Pro" panose="020B0604030504040204" pitchFamily="34" charset="0"/>
+                          </a:endParaRPr>
+                        </a:p>
+                      </a:txBody>
+                      <a:tcPr/>
+                    </a:tc>
                     <a:extLst>
                       <a:ext uri="{0D108BD9-81ED-4DB2-BD59-A6C34878D82A}">
                         <a16:rowId xmlns:a16="http://schemas.microsoft.com/office/drawing/2014/main" val="1389278446"/>
@@ -12965,7 +12920,25 @@
                             <a:rPr lang="en-US" sz="1200" dirty="0">
                               <a:latin typeface="Verdana Pro" panose="020B0604030504040204" pitchFamily="34" charset="0"/>
                             </a:rPr>
-                            <a:t>0.237</a:t>
+                            <a:t>0.177</a:t>
+                          </a:r>
+                          <a:endParaRPr lang="en-CA" sz="1200" dirty="0">
+                            <a:latin typeface="Verdana Pro" panose="020B0604030504040204" pitchFamily="34" charset="0"/>
+                          </a:endParaRPr>
+                        </a:p>
+                      </a:txBody>
+                      <a:tcPr/>
+                    </a:tc>
+                    <a:tc>
+                      <a:txBody>
+                        <a:bodyPr/>
+                        <a:lstStyle/>
+                        <a:p>
+                          <a:r>
+                            <a:rPr lang="en-US" sz="1200" dirty="0">
+                              <a:latin typeface="Verdana Pro" panose="020B0604030504040204" pitchFamily="34" charset="0"/>
+                            </a:rPr>
+                            <a:t>1,008</a:t>
                           </a:r>
                           <a:endParaRPr lang="en-CA" sz="1200" dirty="0">
                             <a:latin typeface="Verdana Pro" panose="020B0604030504040204" pitchFamily="34" charset="0"/>
@@ -13008,7 +12981,25 @@
                             <a:rPr lang="en-US" sz="1200" dirty="0">
                               <a:latin typeface="Verdana Pro" panose="020B0604030504040204" pitchFamily="34" charset="0"/>
                             </a:rPr>
-                            <a:t>0.202</a:t>
+                            <a:t>0.175</a:t>
+                          </a:r>
+                          <a:endParaRPr lang="en-CA" sz="1200" dirty="0">
+                            <a:latin typeface="Verdana Pro" panose="020B0604030504040204" pitchFamily="34" charset="0"/>
+                          </a:endParaRPr>
+                        </a:p>
+                      </a:txBody>
+                      <a:tcPr/>
+                    </a:tc>
+                    <a:tc>
+                      <a:txBody>
+                        <a:bodyPr/>
+                        <a:lstStyle/>
+                        <a:p>
+                          <a:r>
+                            <a:rPr lang="en-US" sz="1200" dirty="0">
+                              <a:latin typeface="Verdana Pro" panose="020B0604030504040204" pitchFamily="34" charset="0"/>
+                            </a:rPr>
+                            <a:t>3,660</a:t>
                           </a:r>
                           <a:endParaRPr lang="en-CA" sz="1200" dirty="0">
                             <a:latin typeface="Verdana Pro" panose="020B0604030504040204" pitchFamily="34" charset="0"/>
@@ -13044,14 +13035,14 @@
               <p:nvPr>
                 <p:extLst>
                   <p:ext uri="{D42A27DB-BD31-4B8C-83A1-F6EECF244321}">
-                    <p14:modId xmlns:p14="http://schemas.microsoft.com/office/powerpoint/2010/main" val="3807183921"/>
+                    <p14:modId xmlns:p14="http://schemas.microsoft.com/office/powerpoint/2010/main" val="1895619930"/>
                   </p:ext>
                 </p:extLst>
               </p:nvPr>
             </p:nvGraphicFramePr>
             <p:xfrm>
-              <a:off x="8872747" y="2524400"/>
-              <a:ext cx="2841925" cy="1005840"/>
+              <a:off x="8539372" y="2076725"/>
+              <a:ext cx="3537251" cy="1371600"/>
             </p:xfrm>
             <a:graphic>
               <a:graphicData uri="http://schemas.openxmlformats.org/drawingml/2006/table">
@@ -13060,22 +13051,29 @@
                     <a:tableStyleId>{5940675A-B579-460E-94D1-54222C63F5DA}</a:tableStyleId>
                   </a:tblPr>
                   <a:tblGrid>
-                    <a:gridCol w="1134019">
+                    <a:gridCol w="1128503">
                       <a:extLst>
                         <a:ext uri="{9D8B030D-6E8A-4147-A177-3AD203B41FA5}">
                           <a16:colId xmlns:a16="http://schemas.microsoft.com/office/drawing/2014/main" val="2524751995"/>
                         </a:ext>
                       </a:extLst>
                     </a:gridCol>
-                    <a:gridCol w="1707906">
+                    <a:gridCol w="1080942">
                       <a:extLst>
                         <a:ext uri="{9D8B030D-6E8A-4147-A177-3AD203B41FA5}">
                           <a16:colId xmlns:a16="http://schemas.microsoft.com/office/drawing/2014/main" val="3895262931"/>
                         </a:ext>
                       </a:extLst>
                     </a:gridCol>
+                    <a:gridCol w="1327806">
+                      <a:extLst>
+                        <a:ext uri="{9D8B030D-6E8A-4147-A177-3AD203B41FA5}">
+                          <a16:colId xmlns:a16="http://schemas.microsoft.com/office/drawing/2014/main" val="1685863581"/>
+                        </a:ext>
+                      </a:extLst>
+                    </a:gridCol>
                   </a:tblGrid>
-                  <a:tr h="457200">
+                  <a:tr h="822960">
                     <a:tc>
                       <a:txBody>
                         <a:bodyPr/>
@@ -13129,6 +13127,41 @@
                       </a:txBody>
                       <a:tcPr/>
                     </a:tc>
+                    <a:tc>
+                      <a:txBody>
+                        <a:bodyPr/>
+                        <a:lstStyle/>
+                        <a:p>
+                          <a:pPr marL="0" marR="0" lvl="0" indent="0" algn="l" defTabSz="914400" rtl="0" eaLnBrk="1" fontAlgn="auto" latinLnBrk="0" hangingPunct="1">
+                            <a:lnSpc>
+                              <a:spcPct val="100000"/>
+                            </a:lnSpc>
+                            <a:spcBef>
+                              <a:spcPts val="0"/>
+                            </a:spcBef>
+                            <a:spcAft>
+                              <a:spcPts val="0"/>
+                            </a:spcAft>
+                            <a:buClrTx/>
+                            <a:buSzTx/>
+                            <a:buFontTx/>
+                            <a:buNone/>
+                            <a:tabLst/>
+                            <a:defRPr/>
+                          </a:pPr>
+                          <a:r>
+                            <a:rPr lang="en-US" sz="1200" dirty="0">
+                              <a:latin typeface="Verdana Pro" panose="020B0604030504040204" pitchFamily="34" charset="0"/>
+                            </a:rPr>
+                            <a:t>Size</a:t>
+                          </a:r>
+                          <a:endParaRPr lang="en-CA" sz="1200" dirty="0">
+                            <a:latin typeface="Verdana Pro" panose="020B0604030504040204" pitchFamily="34" charset="0"/>
+                          </a:endParaRPr>
+                        </a:p>
+                      </a:txBody>
+                      <a:tcPr/>
+                    </a:tc>
                     <a:extLst>
                       <a:ext uri="{0D108BD9-81ED-4DB2-BD59-A6C34878D82A}">
                         <a16:rowId xmlns:a16="http://schemas.microsoft.com/office/drawing/2014/main" val="1389278446"/>
@@ -13148,7 +13181,7 @@
                         <a:blipFill>
                           <a:blip r:embed="rId2"/>
                           <a:stretch>
-                            <a:fillRect l="-538" t="-165217" r="-152151" b="-113043"/>
+                            <a:fillRect l="-538" t="-304444" r="-213978" b="-117778"/>
                           </a:stretch>
                         </a:blipFill>
                       </a:tcPr>
@@ -13162,7 +13195,25 @@
                             <a:rPr lang="en-US" sz="1200" dirty="0">
                               <a:latin typeface="Verdana Pro" panose="020B0604030504040204" pitchFamily="34" charset="0"/>
                             </a:rPr>
-                            <a:t>0.237</a:t>
+                            <a:t>0.177</a:t>
+                          </a:r>
+                          <a:endParaRPr lang="en-CA" sz="1200" dirty="0">
+                            <a:latin typeface="Verdana Pro" panose="020B0604030504040204" pitchFamily="34" charset="0"/>
+                          </a:endParaRPr>
+                        </a:p>
+                      </a:txBody>
+                      <a:tcPr/>
+                    </a:tc>
+                    <a:tc>
+                      <a:txBody>
+                        <a:bodyPr/>
+                        <a:lstStyle/>
+                        <a:p>
+                          <a:r>
+                            <a:rPr lang="en-US" sz="1200" dirty="0">
+                              <a:latin typeface="Verdana Pro" panose="020B0604030504040204" pitchFamily="34" charset="0"/>
+                            </a:rPr>
+                            <a:t>1,008</a:t>
                           </a:r>
                           <a:endParaRPr lang="en-CA" sz="1200" dirty="0">
                             <a:latin typeface="Verdana Pro" panose="020B0604030504040204" pitchFamily="34" charset="0"/>
@@ -13205,7 +13256,25 @@
                             <a:rPr lang="en-US" sz="1200" dirty="0">
                               <a:latin typeface="Verdana Pro" panose="020B0604030504040204" pitchFamily="34" charset="0"/>
                             </a:rPr>
-                            <a:t>0.202</a:t>
+                            <a:t>0.175</a:t>
+                          </a:r>
+                          <a:endParaRPr lang="en-CA" sz="1200" dirty="0">
+                            <a:latin typeface="Verdana Pro" panose="020B0604030504040204" pitchFamily="34" charset="0"/>
+                          </a:endParaRPr>
+                        </a:p>
+                      </a:txBody>
+                      <a:tcPr/>
+                    </a:tc>
+                    <a:tc>
+                      <a:txBody>
+                        <a:bodyPr/>
+                        <a:lstStyle/>
+                        <a:p>
+                          <a:r>
+                            <a:rPr lang="en-US" sz="1200" dirty="0">
+                              <a:latin typeface="Verdana Pro" panose="020B0604030504040204" pitchFamily="34" charset="0"/>
+                            </a:rPr>
+                            <a:t>3,660</a:t>
                           </a:r>
                           <a:endParaRPr lang="en-CA" sz="1200" dirty="0">
                             <a:latin typeface="Verdana Pro" panose="020B0604030504040204" pitchFamily="34" charset="0"/>
@@ -13228,10 +13297,10 @@
       </mc:AlternateContent>
       <p:pic>
         <p:nvPicPr>
-          <p:cNvPr id="12" name="Graphic 11">
-            <a:extLst>
-              <a:ext uri="{FF2B5EF4-FFF2-40B4-BE49-F238E27FC236}">
-                <a16:creationId xmlns:a16="http://schemas.microsoft.com/office/drawing/2014/main" id="{5A4543C6-581B-8FB6-4C97-52D366C2CE00}"/>
+          <p:cNvPr id="14" name="Graphic 13">
+            <a:extLst>
+              <a:ext uri="{FF2B5EF4-FFF2-40B4-BE49-F238E27FC236}">
+                <a16:creationId xmlns:a16="http://schemas.microsoft.com/office/drawing/2014/main" id="{8EBCCE77-B5E6-8268-BEFE-1896FA40DFE1}"/>
               </a:ext>
             </a:extLst>
           </p:cNvPr>
@@ -13254,8 +13323,8 @@
         </p:blipFill>
         <p:spPr>
           <a:xfrm>
-            <a:off x="315257" y="1150448"/>
-            <a:ext cx="8419907" cy="5051944"/>
+            <a:off x="115378" y="1038500"/>
+            <a:ext cx="8305800" cy="4983480"/>
           </a:xfrm>
           <a:prstGeom prst="rect">
             <a:avLst/>

</xml_diff>